<commit_message>
fix microservice detection and update thesis
</commit_message>
<xml_diff>
--- a/thesis/presentation/MSA_Detector_Defense.pptx
+++ b/thesis/presentation/MSA_Detector_Defense.pptx
@@ -200,7 +200,7 @@
               <a:lstStyle/>
               <a:p>
                 <a:pPr>
-                  <a:defRPr sz="1000" b="0" i="0" u="none" strike="noStrike">
+                  <a:defRPr sz="900" b="0" i="0" u="none" strike="noStrike">
                     <a:solidFill>
                       <a:srgbClr val="1E293B"/>
                     </a:solidFill>
@@ -225,9 +225,9 @@
           </c:dLbls>
           <c:cat>
             <c:strRef>
-              <c:f>Sheet1!$A$2:$A$7</c:f>
+              <c:f>Sheet1!$A$2:$A$9</c:f>
               <c:strCache>
-                <c:ptCount val="6"/>
+                <c:ptCount val="8"/>
                 <c:pt idx="0">
                   <c:v>MicroSocial</c:v>
                 </c:pt>
@@ -246,15 +246,21 @@
                 <c:pt idx="5">
                   <c:v>Genie</c:v>
                 </c:pt>
+                <c:pt idx="6">
+                  <c:v>NetworkDisk</c:v>
+                </c:pt>
+                <c:pt idx="7">
+                  <c:v>recruit</c:v>
+                </c:pt>
               </c:strCache>
             </c:strRef>
           </c:cat>
           <c:val>
             <c:numRef>
-              <c:f>Sheet1!$B$2:$B$7</c:f>
+              <c:f>Sheet1!$B$2:$B$9</c:f>
               <c:numCache>
                 <c:formatCode>General</c:formatCode>
-                <c:ptCount val="6"/>
+                <c:ptCount val="8"/>
                 <c:pt idx="0">
                   <c:v>77</c:v>
                 </c:pt>
@@ -273,12 +279,18 @@
                 <c:pt idx="5">
                   <c:v>45</c:v>
                 </c:pt>
+                <c:pt idx="6">
+                  <c:v>53</c:v>
+                </c:pt>
+                <c:pt idx="7">
+                  <c:v>48</c:v>
+                </c:pt>
               </c:numCache>
             </c:numRef>
           </c:val>
           <c:extLst>
             <c:ext xmlns:c16="http://schemas.microsoft.com/office/drawing/2014/chart" uri="{C3380CC4-5D6E-409C-BE32-E72D297353CC}">
-              <c16:uniqueId val="{00000000-41D3-47A4-B4E6-3C942ADEAFCD}"/>
+              <c16:uniqueId val="{00000000-D2D8-4E7F-A1AB-8CB481E5C264}"/>
             </c:ext>
           </c:extLst>
         </c:ser>
@@ -319,7 +331,7 @@
           <a:lstStyle/>
           <a:p>
             <a:pPr>
-              <a:defRPr sz="900" b="0" i="0" u="none" strike="noStrike">
+              <a:defRPr sz="800" b="0" i="0" u="none" strike="noStrike">
                 <a:solidFill>
                   <a:srgbClr val="64748B"/>
                 </a:solidFill>
@@ -440,7 +452,7 @@
     </p:spTree>
     <p:extLst>
       <p:ext uri="{BB962C8B-B14F-4D97-AF65-F5344CB8AC3E}">
-        <p14:creationId xmlns:p14="http://schemas.microsoft.com/office/powerpoint/2010/main" val="1368361205"/>
+        <p14:creationId xmlns:p14="http://schemas.microsoft.com/office/powerpoint/2010/main" val="3330541412"/>
       </p:ext>
     </p:extLst>
   </p:cSld>
@@ -882,7 +894,7 @@
 4. Answer concisely. If you don't know, say 'I didn't investigate that — my best guess is X but I'd want to verify.'
 Common questions to prepare for:
 • 'Why God Service threshold = 1?' → false positives cheap, false negatives expensive; configurable.
-• 'Why only 6 projects?' → feasibility demo not statistical claim; no labelled corpus exists.
+• 'Why only 8 projects?' → feasibility demo not statistical claim; no labelled corpus exists.
 • 'Score compression at the bottom?' → known limitation, logarithmic AP penalty would fix.
 • 'Why static instead of dynamic?' → applicability over precision; no deployed system required.
 • 'Why Spring Boot only?' → biggest Java microservice ecosystem; other frameworks future work.</a:t>
@@ -1069,7 +1081,7 @@
 What to actually say:
 • 'The work has five contributions. The first is the multi-level analysis itself — using code-level signals like God Class frequency to flag architectural problems like God Service. That bridge between abstraction levels is the central novelty.'
 • 'Second, ten anti-patterns across four dimensions — broader coverage than any single existing tool.'
-• 'Third, automated microservice boundary detection from build files — most existing tools require manual configuration.'
+• 'Third, automated microservice boundary detection via a three-signal deployability gate — framework entry points, Dockerfiles, and main methods — with confidence levels. Most existing tools require manual configuration.'
 • 'Fourth, a composite health score on 0–100, decomposed into four categories so you can see which dimension is dragging the score down.'
 • 'Fifth, evidence-based reporting — every finding includes the actual code that triggered it.'
 Don't dwell on each one. They'll see the details later. This slide sets expectations for the rest of the talk.</a:t>
@@ -1162,7 +1174,7 @@
               <a:t>Spend ~2 minutes here. This is the spine of the talk — get the pipeline right and everything else follows.
 Walk left to right:
 • Ingest: user uploads a ZIP or pastes a Git URL. The system extracts/clones and creates an analysis job.
-• Service detection: scan for build files — pom.xml, build.gradle, build.gradle.kts. Filter out non-service modules using ~40 exclusion keywords.
+• Service detection: scan for build files — pom.xml, build.gradle, build.gradle.kts. Filter out non-service modules using exclusion keywords and aggregator checks. Then apply a three-signal deployability gate: framework entry point (HIGH), Dockerfile (MEDIUM), main() method (LOW). Only candidates passing at least one signal are kept.
 • Intra-service analysis runs DesigniteJava as a subprocess for code smells. Inter-service uses Spoon AST to find @FeignClient, RestTemplate, WebClient calls and build the dependency graph.
 • Then ten detectors run over that graph + the smells. Each is a Spring component implementing a common interface — Strategy pattern.
 • Finally results are assembled, the health score is computed, the dependency graph is serialised to JSON, and everything is persisted.
@@ -1544,7 +1556,7 @@
               <a:rPr lang="en-US" dirty="0"/>
               <a:t>Spend ~75 seconds. This is the slide that makes the scoring reproducible.
 Walk through it:
-• 'Take Train-Ticket as an example — an academic benchmark with 42 microservices. It has 27 hardcoded endpoints, 4 chatty services, 4 nano services, and 1 shared database. Total penalty: 118 — but the AP category caps at 40, so it clamps to zero.'
+• 'Take Train-Ticket as an example — an academic benchmark with 42 microservices. It has 26 hardcoded endpoints, 4 chatty services, 4 nano services, and 1 shared database. Total penalty: 115 — but the AP category caps at 40, so it clamps to zero.'
 • 'Service Sizing loses 8 points from the nano service penalty (capped at 8).'
 • 'Code Quality and Architecture both score perfect — DesigniteJava produced no smells, and the coupling coefficient stayed below the penalty threshold.'
 • 'So the final score is 0 + 20 + 25 + 7 = 52. Grade D.'
@@ -1639,11 +1651,11 @@
               <a:rPr lang="en-US" dirty="0"/>
               <a:t>Spend ~90 seconds.
 Talking points:
-• 'I evaluated on six open-source Spring Boot projects, spanning from a 2k-LOC student project to Genie at 118k LOC. 99 microservices, 335k LOC total.'
+• 'I evaluated on eight open-source Spring Boot projects, spanning from a 2k-LOC student project to Genie at 118k LOC. 116 microservices, 350k LOC total.'
 • 'Health scores ranged from 45 to 77 — the scoring mechanism produces meaningful spread.'
-• 'The dominant findings are configuration and sizing issues: 43 hardcoded endpoints, 17 nano services. But importantly, ESB Misuse was detected in Site-Where and Chatty Service in Train-Ticket — validating the communication-topology detectors.'
-• '81 total anti-pattern instances across 7 distinct types. Cyclic Dependency, Distributed Monolith, and Wrong Cuts were not detected — plausible given these projects' topologies.'
-EXPECT: 'Only 6 projects, is that enough?'
+• 'The dominant findings are configuration and sizing issues: 45 hardcoded endpoints, 24 API versioning absences, 20 nano services. But importantly, Cyclic Dependency and Wrong Cuts were detected in microservice-recruit — adding those two projects exercised detectors that previously produced zero results.'
+• '106 total anti-pattern instances across 9 distinct types. Only Distributed Monolith was not detected — plausible given these projects' topologies.'
+EXPECT: 'Only 8 projects, is that enough?'
 Answer: 'Not for a statistical claim. This evaluation is a feasibility demonstration across heterogeneous codebases. A full precision/recall study would need a labelled corpus, which doesn't exist for microservice anti-patterns — that's an open problem in the field. I note this in Threats to Validity.'</a:t>
             </a:r>
           </a:p>
@@ -2046,6 +2058,13 @@
             <a:prstDash val="solid"/>
           </a:ln>
         </p:spPr>
+        <p:txBody>
+          <a:bodyPr/>
+          <a:lstStyle/>
+          <a:p>
+            <a:endParaRPr lang="en-US"/>
+          </a:p>
+        </p:txBody>
       </p:sp>
       <p:sp>
         <p:nvSpPr>
@@ -2071,6 +2090,13 @@
             <a:prstDash val="solid"/>
           </a:ln>
         </p:spPr>
+        <p:txBody>
+          <a:bodyPr/>
+          <a:lstStyle/>
+          <a:p>
+            <a:endParaRPr lang="en-US"/>
+          </a:p>
+        </p:txBody>
       </p:sp>
       <p:pic>
         <p:nvPicPr>
@@ -2260,6 +2286,13 @@
             <a:prstDash val="solid"/>
           </a:ln>
         </p:spPr>
+        <p:txBody>
+          <a:bodyPr/>
+          <a:lstStyle/>
+          <a:p>
+            <a:endParaRPr lang="en-US"/>
+          </a:p>
+        </p:txBody>
       </p:sp>
       <p:sp>
         <p:nvSpPr>
@@ -2408,6 +2441,13 @@
             <a:prstDash val="solid"/>
           </a:ln>
         </p:spPr>
+        <p:txBody>
+          <a:bodyPr/>
+          <a:lstStyle/>
+          <a:p>
+            <a:endParaRPr lang="en-US"/>
+          </a:p>
+        </p:txBody>
       </p:sp>
       <p:sp>
         <p:nvSpPr>
@@ -2511,6 +2551,13 @@
             <a:prstDash val="solid"/>
           </a:ln>
         </p:spPr>
+        <p:txBody>
+          <a:bodyPr/>
+          <a:lstStyle/>
+          <a:p>
+            <a:endParaRPr lang="en-US"/>
+          </a:p>
+        </p:txBody>
       </p:sp>
       <p:sp>
         <p:nvSpPr>
@@ -2536,6 +2583,13 @@
             <a:prstDash val="solid"/>
           </a:ln>
         </p:spPr>
+        <p:txBody>
+          <a:bodyPr/>
+          <a:lstStyle/>
+          <a:p>
+            <a:endParaRPr lang="en-US"/>
+          </a:p>
+        </p:txBody>
       </p:sp>
       <p:sp>
         <p:nvSpPr>
@@ -2678,6 +2732,13 @@
             <a:prstDash val="solid"/>
           </a:ln>
         </p:spPr>
+        <p:txBody>
+          <a:bodyPr/>
+          <a:lstStyle/>
+          <a:p>
+            <a:endParaRPr lang="en-US"/>
+          </a:p>
+        </p:txBody>
       </p:sp>
       <p:sp>
         <p:nvSpPr>
@@ -2820,6 +2881,13 @@
             <a:prstDash val="solid"/>
           </a:ln>
         </p:spPr>
+        <p:txBody>
+          <a:bodyPr/>
+          <a:lstStyle/>
+          <a:p>
+            <a:endParaRPr lang="en-US"/>
+          </a:p>
+        </p:txBody>
       </p:sp>
       <p:sp>
         <p:nvSpPr>
@@ -2962,6 +3030,13 @@
             <a:prstDash val="solid"/>
           </a:ln>
         </p:spPr>
+        <p:txBody>
+          <a:bodyPr/>
+          <a:lstStyle/>
+          <a:p>
+            <a:endParaRPr lang="en-US"/>
+          </a:p>
+        </p:txBody>
       </p:sp>
       <p:sp>
         <p:nvSpPr>
@@ -3254,6 +3329,13 @@
             <a:prstDash val="solid"/>
           </a:ln>
         </p:spPr>
+        <p:txBody>
+          <a:bodyPr/>
+          <a:lstStyle/>
+          <a:p>
+            <a:endParaRPr lang="en-US"/>
+          </a:p>
+        </p:txBody>
       </p:sp>
       <p:sp>
         <p:nvSpPr>
@@ -3279,6 +3361,13 @@
             <a:prstDash val="solid"/>
           </a:ln>
         </p:spPr>
+        <p:txBody>
+          <a:bodyPr/>
+          <a:lstStyle/>
+          <a:p>
+            <a:endParaRPr lang="en-US"/>
+          </a:p>
+        </p:txBody>
       </p:sp>
       <p:sp>
         <p:nvSpPr>
@@ -3313,6 +3402,13 @@
             </a:outerShdw>
           </a:effectLst>
         </p:spPr>
+        <p:txBody>
+          <a:bodyPr/>
+          <a:lstStyle/>
+          <a:p>
+            <a:endParaRPr lang="en-US"/>
+          </a:p>
+        </p:txBody>
       </p:sp>
       <p:pic>
         <p:nvPicPr>
@@ -3436,6 +3532,48 @@
                 <a:cs typeface="Calibri" pitchFamily="34" charset="-120"/>
               </a:rPr>
               <a:t>Static analysis only — no runtime call frequency data.</a:t>
+            </a:r>
+            <a:endParaRPr lang="en-US" sz="1150" dirty="0"/>
+          </a:p>
+          <a:p>
+            <a:pPr marL="342900" indent="-342900">
+              <a:spcAft>
+                <a:spcPts val="400"/>
+              </a:spcAft>
+              <a:buSzPct val="100000"/>
+              <a:buChar char="•"/>
+            </a:pPr>
+            <a:r>
+              <a:rPr lang="en-US" sz="1150" dirty="0">
+                <a:solidFill>
+                  <a:srgbClr val="1E293B"/>
+                </a:solidFill>
+                <a:latin typeface="Calibri" pitchFamily="34" charset="0"/>
+                <a:ea typeface="Calibri" pitchFamily="34" charset="-122"/>
+                <a:cs typeface="Calibri" pitchFamily="34" charset="-120"/>
+              </a:rPr>
+              <a:t>Service detection deployability gate may miss services without framework annotations, Dockerfile, or main method.</a:t>
+            </a:r>
+            <a:endParaRPr lang="en-US" sz="1150" dirty="0"/>
+          </a:p>
+          <a:p>
+            <a:pPr marL="342900" indent="-342900">
+              <a:spcAft>
+                <a:spcPts val="400"/>
+              </a:spcAft>
+              <a:buSzPct val="100000"/>
+              <a:buChar char="•"/>
+            </a:pPr>
+            <a:r>
+              <a:rPr lang="en-US" sz="1150" dirty="0">
+                <a:solidFill>
+                  <a:srgbClr val="1E293B"/>
+                </a:solidFill>
+                <a:latin typeface="Calibri" pitchFamily="34" charset="0"/>
+                <a:ea typeface="Calibri" pitchFamily="34" charset="-122"/>
+                <a:cs typeface="Calibri" pitchFamily="34" charset="-120"/>
+              </a:rPr>
+              <a:t>Dynamic URLs (e.g. Spring Cloud Config) are not resolved.</a:t>
             </a:r>
             <a:endParaRPr lang="en-US" sz="1150" dirty="0"/>
           </a:p>
@@ -3486,6 +3624,13 @@
             <a:prstDash val="solid"/>
           </a:ln>
         </p:spPr>
+        <p:txBody>
+          <a:bodyPr/>
+          <a:lstStyle/>
+          <a:p>
+            <a:endParaRPr lang="en-US"/>
+          </a:p>
+        </p:txBody>
       </p:sp>
       <p:sp>
         <p:nvSpPr>
@@ -3511,6 +3656,13 @@
             <a:prstDash val="solid"/>
           </a:ln>
         </p:spPr>
+        <p:txBody>
+          <a:bodyPr/>
+          <a:lstStyle/>
+          <a:p>
+            <a:endParaRPr lang="en-US"/>
+          </a:p>
+        </p:txBody>
       </p:sp>
       <p:sp>
         <p:nvSpPr>
@@ -3545,6 +3697,13 @@
             </a:outerShdw>
           </a:effectLst>
         </p:spPr>
+        <p:txBody>
+          <a:bodyPr/>
+          <a:lstStyle/>
+          <a:p>
+            <a:endParaRPr lang="en-US"/>
+          </a:p>
+        </p:txBody>
       </p:sp>
       <p:pic>
         <p:nvPicPr>
@@ -3850,6 +4009,13 @@
             <a:prstDash val="solid"/>
           </a:ln>
         </p:spPr>
+        <p:txBody>
+          <a:bodyPr/>
+          <a:lstStyle/>
+          <a:p>
+            <a:endParaRPr lang="en-US"/>
+          </a:p>
+        </p:txBody>
       </p:sp>
       <p:sp>
         <p:nvSpPr>
@@ -3953,6 +4119,13 @@
             <a:prstDash val="solid"/>
           </a:ln>
         </p:spPr>
+        <p:txBody>
+          <a:bodyPr/>
+          <a:lstStyle/>
+          <a:p>
+            <a:endParaRPr lang="en-US"/>
+          </a:p>
+        </p:txBody>
       </p:sp>
       <p:sp>
         <p:nvSpPr>
@@ -4273,6 +4446,13 @@
             <a:prstDash val="solid"/>
           </a:ln>
         </p:spPr>
+        <p:txBody>
+          <a:bodyPr/>
+          <a:lstStyle/>
+          <a:p>
+            <a:endParaRPr lang="en-US"/>
+          </a:p>
+        </p:txBody>
       </p:sp>
       <p:sp>
         <p:nvSpPr>
@@ -4298,6 +4478,13 @@
             <a:prstDash val="solid"/>
           </a:ln>
         </p:spPr>
+        <p:txBody>
+          <a:bodyPr/>
+          <a:lstStyle/>
+          <a:p>
+            <a:endParaRPr lang="en-US"/>
+          </a:p>
+        </p:txBody>
       </p:sp>
       <p:sp>
         <p:nvSpPr>
@@ -4332,6 +4519,13 @@
             </a:outerShdw>
           </a:effectLst>
         </p:spPr>
+        <p:txBody>
+          <a:bodyPr/>
+          <a:lstStyle/>
+          <a:p>
+            <a:endParaRPr lang="en-US"/>
+          </a:p>
+        </p:txBody>
       </p:sp>
       <p:pic>
         <p:nvPicPr>
@@ -4459,6 +4653,13 @@
             <a:prstDash val="solid"/>
           </a:ln>
         </p:spPr>
+        <p:txBody>
+          <a:bodyPr/>
+          <a:lstStyle/>
+          <a:p>
+            <a:endParaRPr lang="en-US"/>
+          </a:p>
+        </p:txBody>
       </p:sp>
       <p:sp>
         <p:nvSpPr>
@@ -4484,6 +4685,13 @@
             <a:prstDash val="solid"/>
           </a:ln>
         </p:spPr>
+        <p:txBody>
+          <a:bodyPr/>
+          <a:lstStyle/>
+          <a:p>
+            <a:endParaRPr lang="en-US"/>
+          </a:p>
+        </p:txBody>
       </p:sp>
       <p:sp>
         <p:nvSpPr>
@@ -4518,6 +4726,13 @@
             </a:outerShdw>
           </a:effectLst>
         </p:spPr>
+        <p:txBody>
+          <a:bodyPr/>
+          <a:lstStyle/>
+          <a:p>
+            <a:endParaRPr lang="en-US"/>
+          </a:p>
+        </p:txBody>
       </p:sp>
       <p:pic>
         <p:nvPicPr>
@@ -4645,6 +4860,13 @@
             <a:prstDash val="solid"/>
           </a:ln>
         </p:spPr>
+        <p:txBody>
+          <a:bodyPr/>
+          <a:lstStyle/>
+          <a:p>
+            <a:endParaRPr lang="en-US"/>
+          </a:p>
+        </p:txBody>
       </p:sp>
       <p:sp>
         <p:nvSpPr>
@@ -4670,6 +4892,13 @@
             <a:prstDash val="solid"/>
           </a:ln>
         </p:spPr>
+        <p:txBody>
+          <a:bodyPr/>
+          <a:lstStyle/>
+          <a:p>
+            <a:endParaRPr lang="en-US"/>
+          </a:p>
+        </p:txBody>
       </p:sp>
       <p:sp>
         <p:nvSpPr>
@@ -4704,6 +4933,13 @@
             </a:outerShdw>
           </a:effectLst>
         </p:spPr>
+        <p:txBody>
+          <a:bodyPr/>
+          <a:lstStyle/>
+          <a:p>
+            <a:endParaRPr lang="en-US"/>
+          </a:p>
+        </p:txBody>
       </p:sp>
       <p:pic>
         <p:nvPicPr>
@@ -4831,6 +5067,13 @@
             <a:prstDash val="solid"/>
           </a:ln>
         </p:spPr>
+        <p:txBody>
+          <a:bodyPr/>
+          <a:lstStyle/>
+          <a:p>
+            <a:endParaRPr lang="en-US"/>
+          </a:p>
+        </p:txBody>
       </p:sp>
       <p:sp>
         <p:nvSpPr>
@@ -5054,6 +5297,13 @@
             </a:outerShdw>
           </a:effectLst>
         </p:spPr>
+        <p:txBody>
+          <a:bodyPr/>
+          <a:lstStyle/>
+          <a:p>
+            <a:endParaRPr lang="en-US"/>
+          </a:p>
+        </p:txBody>
       </p:sp>
       <p:pic>
         <p:nvPicPr>
@@ -5190,6 +5440,13 @@
             </a:outerShdw>
           </a:effectLst>
         </p:spPr>
+        <p:txBody>
+          <a:bodyPr/>
+          <a:lstStyle/>
+          <a:p>
+            <a:endParaRPr lang="en-US"/>
+          </a:p>
+        </p:txBody>
       </p:sp>
       <p:pic>
         <p:nvPicPr>
@@ -5326,6 +5583,13 @@
             </a:outerShdw>
           </a:effectLst>
         </p:spPr>
+        <p:txBody>
+          <a:bodyPr/>
+          <a:lstStyle/>
+          <a:p>
+            <a:endParaRPr lang="en-US"/>
+          </a:p>
+        </p:txBody>
       </p:sp>
       <p:pic>
         <p:nvPicPr>
@@ -5423,7 +5687,7 @@
                 <a:ea typeface="Calibri" pitchFamily="34" charset="-122"/>
                 <a:cs typeface="Calibri" pitchFamily="34" charset="-120"/>
               </a:rPr>
-              <a:t>Identifies microservices from build files — no manual enumeration required.</a:t>
+              <a:t>Three-signal deployability gate (framework entry point, Dockerfile, main method) with confidence levels.</a:t>
             </a:r>
             <a:endParaRPr lang="en-US" sz="1150" dirty="0"/>
           </a:p>
@@ -5462,6 +5726,13 @@
             </a:outerShdw>
           </a:effectLst>
         </p:spPr>
+        <p:txBody>
+          <a:bodyPr/>
+          <a:lstStyle/>
+          <a:p>
+            <a:endParaRPr lang="en-US"/>
+          </a:p>
+        </p:txBody>
       </p:sp>
       <p:pic>
         <p:nvPicPr>
@@ -5598,6 +5869,13 @@
             </a:outerShdw>
           </a:effectLst>
         </p:spPr>
+        <p:txBody>
+          <a:bodyPr/>
+          <a:lstStyle/>
+          <a:p>
+            <a:endParaRPr lang="en-US"/>
+          </a:p>
+        </p:txBody>
       </p:sp>
       <p:pic>
         <p:nvPicPr>
@@ -5875,6 +6153,13 @@
             <a:prstDash val="solid"/>
           </a:ln>
         </p:spPr>
+        <p:txBody>
+          <a:bodyPr/>
+          <a:lstStyle/>
+          <a:p>
+            <a:endParaRPr lang="en-US"/>
+          </a:p>
+        </p:txBody>
       </p:sp>
       <p:sp>
         <p:nvSpPr>
@@ -5900,6 +6185,13 @@
             <a:prstDash val="solid"/>
           </a:ln>
         </p:spPr>
+        <p:txBody>
+          <a:bodyPr/>
+          <a:lstStyle/>
+          <a:p>
+            <a:endParaRPr lang="en-US"/>
+          </a:p>
+        </p:txBody>
       </p:sp>
       <p:sp>
         <p:nvSpPr>
@@ -5934,6 +6226,13 @@
             </a:outerShdw>
           </a:effectLst>
         </p:spPr>
+        <p:txBody>
+          <a:bodyPr/>
+          <a:lstStyle/>
+          <a:p>
+            <a:endParaRPr lang="en-US"/>
+          </a:p>
+        </p:txBody>
       </p:sp>
       <p:pic>
         <p:nvPicPr>
@@ -6085,6 +6384,13 @@
             <a:prstDash val="solid"/>
           </a:ln>
         </p:spPr>
+        <p:txBody>
+          <a:bodyPr/>
+          <a:lstStyle/>
+          <a:p>
+            <a:endParaRPr lang="en-US"/>
+          </a:p>
+        </p:txBody>
       </p:sp>
       <p:sp>
         <p:nvSpPr>
@@ -6110,6 +6416,13 @@
             <a:prstDash val="solid"/>
           </a:ln>
         </p:spPr>
+        <p:txBody>
+          <a:bodyPr/>
+          <a:lstStyle/>
+          <a:p>
+            <a:endParaRPr lang="en-US"/>
+          </a:p>
+        </p:txBody>
       </p:sp>
       <p:sp>
         <p:nvSpPr>
@@ -6144,6 +6457,13 @@
             </a:outerShdw>
           </a:effectLst>
         </p:spPr>
+        <p:txBody>
+          <a:bodyPr/>
+          <a:lstStyle/>
+          <a:p>
+            <a:endParaRPr lang="en-US"/>
+          </a:p>
+        </p:txBody>
       </p:sp>
       <p:pic>
         <p:nvPicPr>
@@ -6241,7 +6561,7 @@
                 <a:ea typeface="Calibri" pitchFamily="34" charset="-122"/>
                 <a:cs typeface="Calibri" pitchFamily="34" charset="-120"/>
               </a:rPr>
-              <a:t>Scan build files</a:t>
+              <a:t>Deployability gate (3 signals)</a:t>
             </a:r>
             <a:endParaRPr lang="en-US" sz="950" dirty="0"/>
           </a:p>
@@ -6295,6 +6615,13 @@
             <a:prstDash val="solid"/>
           </a:ln>
         </p:spPr>
+        <p:txBody>
+          <a:bodyPr/>
+          <a:lstStyle/>
+          <a:p>
+            <a:endParaRPr lang="en-US"/>
+          </a:p>
+        </p:txBody>
       </p:sp>
       <p:sp>
         <p:nvSpPr>
@@ -6320,6 +6647,13 @@
             <a:prstDash val="solid"/>
           </a:ln>
         </p:spPr>
+        <p:txBody>
+          <a:bodyPr/>
+          <a:lstStyle/>
+          <a:p>
+            <a:endParaRPr lang="en-US"/>
+          </a:p>
+        </p:txBody>
       </p:sp>
       <p:sp>
         <p:nvSpPr>
@@ -6354,6 +6688,13 @@
             </a:outerShdw>
           </a:effectLst>
         </p:spPr>
+        <p:txBody>
+          <a:bodyPr/>
+          <a:lstStyle/>
+          <a:p>
+            <a:endParaRPr lang="en-US"/>
+          </a:p>
+        </p:txBody>
       </p:sp>
       <p:pic>
         <p:nvPicPr>
@@ -6505,6 +6846,13 @@
             <a:prstDash val="solid"/>
           </a:ln>
         </p:spPr>
+        <p:txBody>
+          <a:bodyPr/>
+          <a:lstStyle/>
+          <a:p>
+            <a:endParaRPr lang="en-US"/>
+          </a:p>
+        </p:txBody>
       </p:sp>
       <p:sp>
         <p:nvSpPr>
@@ -6530,6 +6878,13 @@
             <a:prstDash val="solid"/>
           </a:ln>
         </p:spPr>
+        <p:txBody>
+          <a:bodyPr/>
+          <a:lstStyle/>
+          <a:p>
+            <a:endParaRPr lang="en-US"/>
+          </a:p>
+        </p:txBody>
       </p:sp>
       <p:sp>
         <p:nvSpPr>
@@ -6564,6 +6919,13 @@
             </a:outerShdw>
           </a:effectLst>
         </p:spPr>
+        <p:txBody>
+          <a:bodyPr/>
+          <a:lstStyle/>
+          <a:p>
+            <a:endParaRPr lang="en-US"/>
+          </a:p>
+        </p:txBody>
       </p:sp>
       <p:pic>
         <p:nvPicPr>
@@ -6715,6 +7077,13 @@
             <a:prstDash val="solid"/>
           </a:ln>
         </p:spPr>
+        <p:txBody>
+          <a:bodyPr/>
+          <a:lstStyle/>
+          <a:p>
+            <a:endParaRPr lang="en-US"/>
+          </a:p>
+        </p:txBody>
       </p:sp>
       <p:sp>
         <p:nvSpPr>
@@ -6740,6 +7109,13 @@
             <a:prstDash val="solid"/>
           </a:ln>
         </p:spPr>
+        <p:txBody>
+          <a:bodyPr/>
+          <a:lstStyle/>
+          <a:p>
+            <a:endParaRPr lang="en-US"/>
+          </a:p>
+        </p:txBody>
       </p:sp>
       <p:sp>
         <p:nvSpPr>
@@ -6774,6 +7150,13 @@
             </a:outerShdw>
           </a:effectLst>
         </p:spPr>
+        <p:txBody>
+          <a:bodyPr/>
+          <a:lstStyle/>
+          <a:p>
+            <a:endParaRPr lang="en-US"/>
+          </a:p>
+        </p:txBody>
       </p:sp>
       <p:pic>
         <p:nvPicPr>
@@ -6901,6 +7284,13 @@
             <a:prstDash val="solid"/>
           </a:ln>
         </p:spPr>
+        <p:txBody>
+          <a:bodyPr/>
+          <a:lstStyle/>
+          <a:p>
+            <a:endParaRPr lang="en-US"/>
+          </a:p>
+        </p:txBody>
       </p:sp>
       <p:sp>
         <p:nvSpPr>
@@ -6926,6 +7316,13 @@
             <a:prstDash val="solid"/>
           </a:ln>
         </p:spPr>
+        <p:txBody>
+          <a:bodyPr/>
+          <a:lstStyle/>
+          <a:p>
+            <a:endParaRPr lang="en-US"/>
+          </a:p>
+        </p:txBody>
       </p:sp>
       <p:sp>
         <p:nvSpPr>
@@ -7264,6 +7661,13 @@
             <a:prstDash val="solid"/>
           </a:ln>
         </p:spPr>
+        <p:txBody>
+          <a:bodyPr/>
+          <a:lstStyle/>
+          <a:p>
+            <a:endParaRPr lang="en-US"/>
+          </a:p>
+        </p:txBody>
       </p:sp>
       <p:sp>
         <p:nvSpPr>
@@ -7289,6 +7693,13 @@
             <a:prstDash val="solid"/>
           </a:ln>
         </p:spPr>
+        <p:txBody>
+          <a:bodyPr/>
+          <a:lstStyle/>
+          <a:p>
+            <a:endParaRPr lang="en-US"/>
+          </a:p>
+        </p:txBody>
       </p:sp>
       <p:sp>
         <p:nvSpPr>
@@ -7430,6 +7841,13 @@
             <a:tailEnd type="triangle"/>
           </a:ln>
         </p:spPr>
+        <p:txBody>
+          <a:bodyPr/>
+          <a:lstStyle/>
+          <a:p>
+            <a:endParaRPr lang="en-US"/>
+          </a:p>
+        </p:txBody>
       </p:sp>
       <p:sp>
         <p:nvSpPr>
@@ -7455,6 +7873,13 @@
             <a:prstDash val="solid"/>
           </a:ln>
         </p:spPr>
+        <p:txBody>
+          <a:bodyPr/>
+          <a:lstStyle/>
+          <a:p>
+            <a:endParaRPr lang="en-US"/>
+          </a:p>
+        </p:txBody>
       </p:sp>
       <p:sp>
         <p:nvSpPr>
@@ -7480,6 +7905,13 @@
             <a:prstDash val="solid"/>
           </a:ln>
         </p:spPr>
+        <p:txBody>
+          <a:bodyPr/>
+          <a:lstStyle/>
+          <a:p>
+            <a:endParaRPr lang="en-US"/>
+          </a:p>
+        </p:txBody>
       </p:sp>
       <p:sp>
         <p:nvSpPr>
@@ -7848,6 +8280,13 @@
             <a:prstDash val="solid"/>
           </a:ln>
         </p:spPr>
+        <p:txBody>
+          <a:bodyPr/>
+          <a:lstStyle/>
+          <a:p>
+            <a:endParaRPr lang="en-US"/>
+          </a:p>
+        </p:txBody>
       </p:sp>
       <p:sp>
         <p:nvSpPr>
@@ -8101,6 +8540,13 @@
             <a:prstDash val="solid"/>
           </a:ln>
         </p:spPr>
+        <p:txBody>
+          <a:bodyPr/>
+          <a:lstStyle/>
+          <a:p>
+            <a:endParaRPr lang="en-US"/>
+          </a:p>
+        </p:txBody>
       </p:sp>
       <p:sp>
         <p:nvSpPr>
@@ -8126,6 +8572,13 @@
             <a:prstDash val="solid"/>
           </a:ln>
         </p:spPr>
+        <p:txBody>
+          <a:bodyPr/>
+          <a:lstStyle/>
+          <a:p>
+            <a:endParaRPr lang="en-US"/>
+          </a:p>
+        </p:txBody>
       </p:sp>
       <p:sp>
         <p:nvSpPr>
@@ -8346,6 +8799,13 @@
             <a:prstDash val="solid"/>
           </a:ln>
         </p:spPr>
+        <p:txBody>
+          <a:bodyPr/>
+          <a:lstStyle/>
+          <a:p>
+            <a:endParaRPr lang="en-US"/>
+          </a:p>
+        </p:txBody>
       </p:sp>
       <p:sp>
         <p:nvSpPr>
@@ -8371,6 +8831,13 @@
             <a:prstDash val="solid"/>
           </a:ln>
         </p:spPr>
+        <p:txBody>
+          <a:bodyPr/>
+          <a:lstStyle/>
+          <a:p>
+            <a:endParaRPr lang="en-US"/>
+          </a:p>
+        </p:txBody>
       </p:sp>
       <p:sp>
         <p:nvSpPr>
@@ -8747,6 +9214,13 @@
             <a:prstDash val="solid"/>
           </a:ln>
         </p:spPr>
+        <p:txBody>
+          <a:bodyPr/>
+          <a:lstStyle/>
+          <a:p>
+            <a:endParaRPr lang="en-US"/>
+          </a:p>
+        </p:txBody>
       </p:sp>
       <p:sp>
         <p:nvSpPr>
@@ -8772,6 +9246,13 @@
             <a:prstDash val="solid"/>
           </a:ln>
         </p:spPr>
+        <p:txBody>
+          <a:bodyPr/>
+          <a:lstStyle/>
+          <a:p>
+            <a:endParaRPr lang="en-US"/>
+          </a:p>
+        </p:txBody>
       </p:sp>
       <p:sp>
         <p:nvSpPr>
@@ -8914,6 +9395,13 @@
             <a:prstDash val="solid"/>
           </a:ln>
         </p:spPr>
+        <p:txBody>
+          <a:bodyPr/>
+          <a:lstStyle/>
+          <a:p>
+            <a:endParaRPr lang="en-US"/>
+          </a:p>
+        </p:txBody>
       </p:sp>
       <p:sp>
         <p:nvSpPr>
@@ -8939,6 +9427,13 @@
             <a:prstDash val="solid"/>
           </a:ln>
         </p:spPr>
+        <p:txBody>
+          <a:bodyPr/>
+          <a:lstStyle/>
+          <a:p>
+            <a:endParaRPr lang="en-US"/>
+          </a:p>
+        </p:txBody>
       </p:sp>
       <p:sp>
         <p:nvSpPr>
@@ -9237,6 +9732,13 @@
             <a:prstDash val="solid"/>
           </a:ln>
         </p:spPr>
+        <p:txBody>
+          <a:bodyPr/>
+          <a:lstStyle/>
+          <a:p>
+            <a:endParaRPr lang="en-US"/>
+          </a:p>
+        </p:txBody>
       </p:sp>
       <p:sp>
         <p:nvSpPr>
@@ -9451,6 +9953,13 @@
             <a:prstDash val="solid"/>
           </a:ln>
         </p:spPr>
+        <p:txBody>
+          <a:bodyPr/>
+          <a:lstStyle/>
+          <a:p>
+            <a:endParaRPr lang="en-US"/>
+          </a:p>
+        </p:txBody>
       </p:sp>
       <p:sp>
         <p:nvSpPr>
@@ -9476,6 +9985,13 @@
             <a:prstDash val="solid"/>
           </a:ln>
         </p:spPr>
+        <p:txBody>
+          <a:bodyPr/>
+          <a:lstStyle/>
+          <a:p>
+            <a:endParaRPr lang="en-US"/>
+          </a:p>
+        </p:txBody>
       </p:sp>
       <p:sp>
         <p:nvSpPr>
@@ -9618,6 +10134,13 @@
             <a:prstDash val="solid"/>
           </a:ln>
         </p:spPr>
+        <p:txBody>
+          <a:bodyPr/>
+          <a:lstStyle/>
+          <a:p>
+            <a:endParaRPr lang="en-US"/>
+          </a:p>
+        </p:txBody>
       </p:sp>
       <p:sp>
         <p:nvSpPr>
@@ -9643,6 +10166,13 @@
             <a:prstDash val="solid"/>
           </a:ln>
         </p:spPr>
+        <p:txBody>
+          <a:bodyPr/>
+          <a:lstStyle/>
+          <a:p>
+            <a:endParaRPr lang="en-US"/>
+          </a:p>
+        </p:txBody>
       </p:sp>
       <p:sp>
         <p:nvSpPr>
@@ -9785,6 +10315,13 @@
             <a:prstDash val="solid"/>
           </a:ln>
         </p:spPr>
+        <p:txBody>
+          <a:bodyPr/>
+          <a:lstStyle/>
+          <a:p>
+            <a:endParaRPr lang="en-US"/>
+          </a:p>
+        </p:txBody>
       </p:sp>
       <p:sp>
         <p:nvSpPr>
@@ -9810,6 +10347,13 @@
             <a:prstDash val="solid"/>
           </a:ln>
         </p:spPr>
+        <p:txBody>
+          <a:bodyPr/>
+          <a:lstStyle/>
+          <a:p>
+            <a:endParaRPr lang="en-US"/>
+          </a:p>
+        </p:txBody>
       </p:sp>
       <p:sp>
         <p:nvSpPr>
@@ -9952,6 +10496,13 @@
             <a:prstDash val="solid"/>
           </a:ln>
         </p:spPr>
+        <p:txBody>
+          <a:bodyPr/>
+          <a:lstStyle/>
+          <a:p>
+            <a:endParaRPr lang="en-US"/>
+          </a:p>
+        </p:txBody>
       </p:sp>
       <p:sp>
         <p:nvSpPr>
@@ -9977,6 +10528,13 @@
             <a:prstDash val="solid"/>
           </a:ln>
         </p:spPr>
+        <p:txBody>
+          <a:bodyPr/>
+          <a:lstStyle/>
+          <a:p>
+            <a:endParaRPr lang="en-US"/>
+          </a:p>
+        </p:txBody>
       </p:sp>
       <p:sp>
         <p:nvSpPr>
@@ -10158,6 +10716,13 @@
             <a:prstDash val="solid"/>
           </a:ln>
         </p:spPr>
+        <p:txBody>
+          <a:bodyPr/>
+          <a:lstStyle/>
+          <a:p>
+            <a:endParaRPr lang="en-US"/>
+          </a:p>
+        </p:txBody>
       </p:sp>
       <p:sp>
         <p:nvSpPr>
@@ -10261,6 +10826,13 @@
             <a:prstDash val="solid"/>
           </a:ln>
         </p:spPr>
+        <p:txBody>
+          <a:bodyPr/>
+          <a:lstStyle/>
+          <a:p>
+            <a:endParaRPr lang="en-US"/>
+          </a:p>
+        </p:txBody>
       </p:sp>
       <p:sp>
         <p:nvSpPr>
@@ -10364,6 +10936,13 @@
             <a:prstDash val="solid"/>
           </a:ln>
         </p:spPr>
+        <p:txBody>
+          <a:bodyPr/>
+          <a:lstStyle/>
+          <a:p>
+            <a:endParaRPr lang="en-US"/>
+          </a:p>
+        </p:txBody>
       </p:sp>
       <p:sp>
         <p:nvSpPr>
@@ -10467,6 +11046,13 @@
             <a:prstDash val="solid"/>
           </a:ln>
         </p:spPr>
+        <p:txBody>
+          <a:bodyPr/>
+          <a:lstStyle/>
+          <a:p>
+            <a:endParaRPr lang="en-US"/>
+          </a:p>
+        </p:txBody>
       </p:sp>
       <p:sp>
         <p:nvSpPr>
@@ -10570,6 +11156,13 @@
             <a:prstDash val="solid"/>
           </a:ln>
         </p:spPr>
+        <p:txBody>
+          <a:bodyPr/>
+          <a:lstStyle/>
+          <a:p>
+            <a:endParaRPr lang="en-US"/>
+          </a:p>
+        </p:txBody>
       </p:sp>
       <p:sp>
         <p:nvSpPr>
@@ -10673,6 +11266,13 @@
             <a:prstDash val="solid"/>
           </a:ln>
         </p:spPr>
+        <p:txBody>
+          <a:bodyPr/>
+          <a:lstStyle/>
+          <a:p>
+            <a:endParaRPr lang="en-US"/>
+          </a:p>
+        </p:txBody>
       </p:sp>
       <p:sp>
         <p:nvSpPr>
@@ -10698,6 +11298,13 @@
             <a:prstDash val="solid"/>
           </a:ln>
         </p:spPr>
+        <p:txBody>
+          <a:bodyPr/>
+          <a:lstStyle/>
+          <a:p>
+            <a:endParaRPr lang="en-US"/>
+          </a:p>
+        </p:txBody>
       </p:sp>
       <p:sp>
         <p:nvSpPr>
@@ -10990,6 +11597,13 @@
             <a:prstDash val="solid"/>
           </a:ln>
         </p:spPr>
+        <p:txBody>
+          <a:bodyPr/>
+          <a:lstStyle/>
+          <a:p>
+            <a:endParaRPr lang="en-US"/>
+          </a:p>
+        </p:txBody>
       </p:sp>
       <p:sp>
         <p:nvSpPr>
@@ -11024,7 +11638,7 @@
                 <a:ea typeface="Calibri" pitchFamily="34" charset="-122"/>
                 <a:cs typeface="Calibri" pitchFamily="34" charset="-120"/>
               </a:rPr>
-              <a:t>27×</a:t>
+              <a:t>26×</a:t>
             </a:r>
             <a:endParaRPr lang="en-US" sz="1300" dirty="0"/>
           </a:p>
@@ -11102,7 +11716,7 @@
                 <a:ea typeface="Calibri" pitchFamily="34" charset="-122"/>
                 <a:cs typeface="Calibri" pitchFamily="34" charset="-120"/>
               </a:rPr>
-              <a:t>−3 each = −81</a:t>
+              <a:t>−3 each = −78</a:t>
             </a:r>
             <a:endParaRPr lang="en-US" sz="1000" dirty="0"/>
           </a:p>
@@ -11132,6 +11746,13 @@
             <a:prstDash val="solid"/>
           </a:ln>
         </p:spPr>
+        <p:txBody>
+          <a:bodyPr/>
+          <a:lstStyle/>
+          <a:p>
+            <a:endParaRPr lang="en-US"/>
+          </a:p>
+        </p:txBody>
       </p:sp>
       <p:sp>
         <p:nvSpPr>
@@ -11274,6 +11895,13 @@
             <a:prstDash val="solid"/>
           </a:ln>
         </p:spPr>
+        <p:txBody>
+          <a:bodyPr/>
+          <a:lstStyle/>
+          <a:p>
+            <a:endParaRPr lang="en-US"/>
+          </a:p>
+        </p:txBody>
       </p:sp>
       <p:sp>
         <p:nvSpPr>
@@ -11416,6 +12044,13 @@
             <a:prstDash val="solid"/>
           </a:ln>
         </p:spPr>
+        <p:txBody>
+          <a:bodyPr/>
+          <a:lstStyle/>
+          <a:p>
+            <a:endParaRPr lang="en-US"/>
+          </a:p>
+        </p:txBody>
       </p:sp>
       <p:sp>
         <p:nvSpPr>
@@ -11558,6 +12193,13 @@
             <a:prstDash val="solid"/>
           </a:ln>
         </p:spPr>
+        <p:txBody>
+          <a:bodyPr/>
+          <a:lstStyle/>
+          <a:p>
+            <a:endParaRPr lang="en-US"/>
+          </a:p>
+        </p:txBody>
       </p:sp>
       <p:sp>
         <p:nvSpPr>
@@ -11592,7 +12234,7 @@
                 <a:ea typeface="Calibri" pitchFamily="34" charset="-122"/>
                 <a:cs typeface="Calibri" pitchFamily="34" charset="-120"/>
               </a:rPr>
-              <a:t>Total penalty: 118   →   AP clamped at 0</a:t>
+              <a:t>Total penalty: 115   →   AP clamped at 0</a:t>
             </a:r>
             <a:endParaRPr lang="en-US" sz="1200" dirty="0"/>
           </a:p>
@@ -11700,6 +12342,13 @@
             <a:prstDash val="solid"/>
           </a:ln>
         </p:spPr>
+        <p:txBody>
+          <a:bodyPr/>
+          <a:lstStyle/>
+          <a:p>
+            <a:endParaRPr lang="en-US"/>
+          </a:p>
+        </p:txBody>
       </p:sp>
       <p:sp>
         <p:nvSpPr>
@@ -11803,6 +12452,13 @@
             <a:prstDash val="solid"/>
           </a:ln>
         </p:spPr>
+        <p:txBody>
+          <a:bodyPr/>
+          <a:lstStyle/>
+          <a:p>
+            <a:endParaRPr lang="en-US"/>
+          </a:p>
+        </p:txBody>
       </p:sp>
       <p:sp>
         <p:nvSpPr>
@@ -11828,6 +12484,13 @@
             <a:prstDash val="solid"/>
           </a:ln>
         </p:spPr>
+        <p:txBody>
+          <a:bodyPr/>
+          <a:lstStyle/>
+          <a:p>
+            <a:endParaRPr lang="en-US"/>
+          </a:p>
+        </p:txBody>
       </p:sp>
       <p:sp>
         <p:nvSpPr>
@@ -11931,6 +12594,13 @@
             <a:prstDash val="solid"/>
           </a:ln>
         </p:spPr>
+        <p:txBody>
+          <a:bodyPr/>
+          <a:lstStyle/>
+          <a:p>
+            <a:endParaRPr lang="en-US"/>
+          </a:p>
+        </p:txBody>
       </p:sp>
       <p:sp>
         <p:nvSpPr>
@@ -11956,6 +12626,13 @@
             <a:prstDash val="solid"/>
           </a:ln>
         </p:spPr>
+        <p:txBody>
+          <a:bodyPr/>
+          <a:lstStyle/>
+          <a:p>
+            <a:endParaRPr lang="en-US"/>
+          </a:p>
+        </p:txBody>
       </p:sp>
       <p:sp>
         <p:nvSpPr>
@@ -12059,6 +12736,13 @@
             <a:prstDash val="solid"/>
           </a:ln>
         </p:spPr>
+        <p:txBody>
+          <a:bodyPr/>
+          <a:lstStyle/>
+          <a:p>
+            <a:endParaRPr lang="en-US"/>
+          </a:p>
+        </p:txBody>
       </p:sp>
       <p:sp>
         <p:nvSpPr>
@@ -12084,6 +12768,13 @@
             <a:prstDash val="solid"/>
           </a:ln>
         </p:spPr>
+        <p:txBody>
+          <a:bodyPr/>
+          <a:lstStyle/>
+          <a:p>
+            <a:endParaRPr lang="en-US"/>
+          </a:p>
+        </p:txBody>
       </p:sp>
       <p:sp>
         <p:nvSpPr>
@@ -12148,6 +12839,13 @@
             <a:prstDash val="solid"/>
           </a:ln>
         </p:spPr>
+        <p:txBody>
+          <a:bodyPr/>
+          <a:lstStyle/>
+          <a:p>
+            <a:endParaRPr lang="en-US"/>
+          </a:p>
+        </p:txBody>
       </p:sp>
       <p:sp>
         <p:nvSpPr>
@@ -12299,7 +12997,7 @@
                 <a:ea typeface="Calibri" pitchFamily="34" charset="-122"/>
                 <a:cs typeface="Calibri" pitchFamily="34" charset="-120"/>
               </a:rPr>
-              <a:t>Score driven by AP deductions (27 Hardcoded Endpoints + 4 Chatty Services). Service Sizing loses 8 pts from nano services. Architecture and Code Quality are clean.</a:t>
+              <a:t>Score driven by AP deductions (26 Hardcoded Endpoints + 4 Chatty Services). Service Sizing loses 8 pts from nano services. Architecture and Code Quality are clean.</a:t>
             </a:r>
             <a:endParaRPr lang="en-US" sz="1000" dirty="0"/>
           </a:p>
@@ -12441,7 +13139,7 @@
               <a:buNone/>
             </a:pPr>
             <a:r>
-              <a:rPr lang="en-US" sz="2800" b="1" dirty="0">
+              <a:rPr lang="en-US" sz="2000" b="1" dirty="0">
                 <a:solidFill>
                   <a:srgbClr val="0F2A44"/>
                 </a:solidFill>
@@ -12449,9 +13147,9 @@
                 <a:ea typeface="Calibri" pitchFamily="34" charset="-122"/>
                 <a:cs typeface="Calibri" pitchFamily="34" charset="-120"/>
               </a:rPr>
-              <a:t>Evaluation: six open-source projects</a:t>
-            </a:r>
-            <a:endParaRPr lang="en-US" sz="2800" dirty="0"/>
+              <a:t>Evaluation: eight open-source projects</a:t>
+            </a:r>
+            <a:endParaRPr lang="en-US" sz="2000" dirty="0"/>
           </a:p>
         </p:txBody>
       </p:sp>
@@ -12459,10 +13157,16 @@
         <p:nvGraphicFramePr>
           <p:cNvPr id="3" name="Chart 0"/>
           <p:cNvGraphicFramePr/>
-          <p:nvPr/>
+          <p:nvPr>
+            <p:extLst>
+              <p:ext uri="{D42A27DB-BD31-4B8C-83A1-F6EECF244321}">
+                <p14:modId xmlns:p14="http://schemas.microsoft.com/office/powerpoint/2010/main" val="1115883146"/>
+              </p:ext>
+            </p:extLst>
+          </p:nvPr>
         </p:nvGraphicFramePr>
         <p:xfrm>
-          <a:off x="365760" y="868680"/>
+          <a:off x="155448" y="811203"/>
           <a:ext cx="5394960" cy="2743200"/>
         </p:xfrm>
         <a:graphic>
@@ -12479,7 +13183,7 @@
         </p:nvSpPr>
         <p:spPr>
           <a:xfrm>
-            <a:off x="6035040" y="613954"/>
+            <a:off x="5852160" y="406908"/>
             <a:ext cx="2743200" cy="274320"/>
           </a:xfrm>
           <a:prstGeom prst="rect">
@@ -12518,8 +13222,8 @@
         </p:nvSpPr>
         <p:spPr>
           <a:xfrm>
-            <a:off x="6035040" y="979714"/>
-            <a:ext cx="2743200" cy="347472"/>
+            <a:off x="5852160" y="772668"/>
+            <a:ext cx="2743200" cy="274320"/>
           </a:xfrm>
           <a:prstGeom prst="rect">
             <a:avLst/>
@@ -12534,6 +13238,13 @@
             <a:prstDash val="solid"/>
           </a:ln>
         </p:spPr>
+        <p:txBody>
+          <a:bodyPr/>
+          <a:lstStyle/>
+          <a:p>
+            <a:endParaRPr lang="en-US"/>
+          </a:p>
+        </p:txBody>
       </p:sp>
       <p:sp>
         <p:nvSpPr>
@@ -12543,8 +13254,8 @@
         </p:nvSpPr>
         <p:spPr>
           <a:xfrm>
-            <a:off x="6126480" y="979714"/>
-            <a:ext cx="1280160" cy="347472"/>
+            <a:off x="5943600" y="772668"/>
+            <a:ext cx="1280160" cy="274320"/>
           </a:xfrm>
           <a:prstGeom prst="rect">
             <a:avLst/>
@@ -12560,7 +13271,7 @@
               <a:buNone/>
             </a:pPr>
             <a:r>
-              <a:rPr lang="en-US" sz="1050" dirty="0">
+              <a:rPr lang="en-US" sz="950" dirty="0">
                 <a:solidFill>
                   <a:srgbClr val="1E293B"/>
                 </a:solidFill>
@@ -12570,7 +13281,7 @@
               </a:rPr>
               <a:t>MicroSocial</a:t>
             </a:r>
-            <a:endParaRPr lang="en-US" sz="1050" dirty="0"/>
+            <a:endParaRPr lang="en-US" sz="950" dirty="0"/>
           </a:p>
         </p:txBody>
       </p:sp>
@@ -12582,8 +13293,8 @@
         </p:nvSpPr>
         <p:spPr>
           <a:xfrm>
-            <a:off x="7406640" y="979714"/>
-            <a:ext cx="457200" cy="347472"/>
+            <a:off x="7223760" y="772668"/>
+            <a:ext cx="457200" cy="274320"/>
           </a:xfrm>
           <a:prstGeom prst="rect">
             <a:avLst/>
@@ -12599,7 +13310,7 @@
               <a:buNone/>
             </a:pPr>
             <a:r>
-              <a:rPr lang="en-US" sz="1050" dirty="0">
+              <a:rPr lang="en-US" sz="950" dirty="0">
                 <a:solidFill>
                   <a:srgbClr val="1E293B"/>
                 </a:solidFill>
@@ -12609,7 +13320,7 @@
               </a:rPr>
               <a:t>4</a:t>
             </a:r>
-            <a:endParaRPr lang="en-US" sz="1050" dirty="0"/>
+            <a:endParaRPr lang="en-US" sz="950" dirty="0"/>
           </a:p>
         </p:txBody>
       </p:sp>
@@ -12621,8 +13332,8 @@
         </p:nvSpPr>
         <p:spPr>
           <a:xfrm>
-            <a:off x="7863840" y="979714"/>
-            <a:ext cx="868680" cy="347472"/>
+            <a:off x="7680960" y="772668"/>
+            <a:ext cx="868680" cy="274320"/>
           </a:xfrm>
           <a:prstGeom prst="rect">
             <a:avLst/>
@@ -12638,7 +13349,7 @@
               <a:buNone/>
             </a:pPr>
             <a:r>
-              <a:rPr lang="en-US" sz="1050" dirty="0">
+              <a:rPr lang="en-US" sz="950" dirty="0">
                 <a:solidFill>
                   <a:srgbClr val="1E293B"/>
                 </a:solidFill>
@@ -12648,7 +13359,7 @@
               </a:rPr>
               <a:t>2k</a:t>
             </a:r>
-            <a:endParaRPr lang="en-US" sz="1050" dirty="0"/>
+            <a:endParaRPr lang="en-US" sz="950" dirty="0"/>
           </a:p>
         </p:txBody>
       </p:sp>
@@ -12660,8 +13371,8 @@
         </p:nvSpPr>
         <p:spPr>
           <a:xfrm>
-            <a:off x="6035040" y="1363762"/>
-            <a:ext cx="2743200" cy="347472"/>
+            <a:off x="5852160" y="1083564"/>
+            <a:ext cx="2743200" cy="274320"/>
           </a:xfrm>
           <a:prstGeom prst="rect">
             <a:avLst/>
@@ -12676,6 +13387,13 @@
             <a:prstDash val="solid"/>
           </a:ln>
         </p:spPr>
+        <p:txBody>
+          <a:bodyPr/>
+          <a:lstStyle/>
+          <a:p>
+            <a:endParaRPr lang="en-US"/>
+          </a:p>
+        </p:txBody>
       </p:sp>
       <p:sp>
         <p:nvSpPr>
@@ -12685,8 +13403,8 @@
         </p:nvSpPr>
         <p:spPr>
           <a:xfrm>
-            <a:off x="6126480" y="1363762"/>
-            <a:ext cx="1280160" cy="347472"/>
+            <a:off x="5943600" y="1083564"/>
+            <a:ext cx="1280160" cy="274320"/>
           </a:xfrm>
           <a:prstGeom prst="rect">
             <a:avLst/>
@@ -12702,7 +13420,7 @@
               <a:buNone/>
             </a:pPr>
             <a:r>
-              <a:rPr lang="en-US" sz="1050" dirty="0">
+              <a:rPr lang="en-US" sz="950" dirty="0">
                 <a:solidFill>
                   <a:srgbClr val="1E293B"/>
                 </a:solidFill>
@@ -12712,7 +13430,7 @@
               </a:rPr>
               <a:t>design-pat.</a:t>
             </a:r>
-            <a:endParaRPr lang="en-US" sz="1050" dirty="0"/>
+            <a:endParaRPr lang="en-US" sz="950" dirty="0"/>
           </a:p>
         </p:txBody>
       </p:sp>
@@ -12724,8 +13442,8 @@
         </p:nvSpPr>
         <p:spPr>
           <a:xfrm>
-            <a:off x="7406640" y="1363762"/>
-            <a:ext cx="457200" cy="347472"/>
+            <a:off x="7223760" y="1083564"/>
+            <a:ext cx="457200" cy="274320"/>
           </a:xfrm>
           <a:prstGeom prst="rect">
             <a:avLst/>
@@ -12741,7 +13459,7 @@
               <a:buNone/>
             </a:pPr>
             <a:r>
-              <a:rPr lang="en-US" sz="1050" dirty="0">
+              <a:rPr lang="en-US" sz="950" dirty="0">
                 <a:solidFill>
                   <a:srgbClr val="1E293B"/>
                 </a:solidFill>
@@ -12751,7 +13469,7 @@
               </a:rPr>
               <a:t>16</a:t>
             </a:r>
-            <a:endParaRPr lang="en-US" sz="1050" dirty="0"/>
+            <a:endParaRPr lang="en-US" sz="950" dirty="0"/>
           </a:p>
         </p:txBody>
       </p:sp>
@@ -12763,8 +13481,8 @@
         </p:nvSpPr>
         <p:spPr>
           <a:xfrm>
-            <a:off x="7863840" y="1363762"/>
-            <a:ext cx="868680" cy="347472"/>
+            <a:off x="7680960" y="1083564"/>
+            <a:ext cx="868680" cy="274320"/>
           </a:xfrm>
           <a:prstGeom prst="rect">
             <a:avLst/>
@@ -12780,7 +13498,7 @@
               <a:buNone/>
             </a:pPr>
             <a:r>
-              <a:rPr lang="en-US" sz="1050" dirty="0">
+              <a:rPr lang="en-US" sz="950" dirty="0">
                 <a:solidFill>
                   <a:srgbClr val="1E293B"/>
                 </a:solidFill>
@@ -12790,7 +13508,7 @@
               </a:rPr>
               <a:t>19k</a:t>
             </a:r>
-            <a:endParaRPr lang="en-US" sz="1050" dirty="0"/>
+            <a:endParaRPr lang="en-US" sz="950" dirty="0"/>
           </a:p>
         </p:txBody>
       </p:sp>
@@ -12802,8 +13520,8 @@
         </p:nvSpPr>
         <p:spPr>
           <a:xfrm>
-            <a:off x="6035040" y="1747810"/>
-            <a:ext cx="2743200" cy="347472"/>
+            <a:off x="5852160" y="1394460"/>
+            <a:ext cx="2743200" cy="274320"/>
           </a:xfrm>
           <a:prstGeom prst="rect">
             <a:avLst/>
@@ -12818,6 +13536,13 @@
             <a:prstDash val="solid"/>
           </a:ln>
         </p:spPr>
+        <p:txBody>
+          <a:bodyPr/>
+          <a:lstStyle/>
+          <a:p>
+            <a:endParaRPr lang="en-US"/>
+          </a:p>
+        </p:txBody>
       </p:sp>
       <p:sp>
         <p:nvSpPr>
@@ -12827,8 +13552,8 @@
         </p:nvSpPr>
         <p:spPr>
           <a:xfrm>
-            <a:off x="6126480" y="1747810"/>
-            <a:ext cx="1280160" cy="347472"/>
+            <a:off x="5943600" y="1394460"/>
+            <a:ext cx="1280160" cy="274320"/>
           </a:xfrm>
           <a:prstGeom prst="rect">
             <a:avLst/>
@@ -12844,7 +13569,7 @@
               <a:buNone/>
             </a:pPr>
             <a:r>
-              <a:rPr lang="en-US" sz="1050" dirty="0">
+              <a:rPr lang="en-US" sz="950" dirty="0">
                 <a:solidFill>
                   <a:srgbClr val="1E293B"/>
                 </a:solidFill>
@@ -12854,7 +13579,7 @@
               </a:rPr>
               <a:t>Site-Where</a:t>
             </a:r>
-            <a:endParaRPr lang="en-US" sz="1050" dirty="0"/>
+            <a:endParaRPr lang="en-US" sz="950" dirty="0"/>
           </a:p>
         </p:txBody>
       </p:sp>
@@ -12866,8 +13591,8 @@
         </p:nvSpPr>
         <p:spPr>
           <a:xfrm>
-            <a:off x="7406640" y="1747810"/>
-            <a:ext cx="457200" cy="347472"/>
+            <a:off x="7223760" y="1394460"/>
+            <a:ext cx="457200" cy="274320"/>
           </a:xfrm>
           <a:prstGeom prst="rect">
             <a:avLst/>
@@ -12883,7 +13608,7 @@
               <a:buNone/>
             </a:pPr>
             <a:r>
-              <a:rPr lang="en-US" sz="1050" dirty="0">
+              <a:rPr lang="en-US" sz="950" dirty="0">
                 <a:solidFill>
                   <a:srgbClr val="1E293B"/>
                 </a:solidFill>
@@ -12893,7 +13618,7 @@
               </a:rPr>
               <a:t>15</a:t>
             </a:r>
-            <a:endParaRPr lang="en-US" sz="1050" dirty="0"/>
+            <a:endParaRPr lang="en-US" sz="950" dirty="0"/>
           </a:p>
         </p:txBody>
       </p:sp>
@@ -12905,8 +13630,8 @@
         </p:nvSpPr>
         <p:spPr>
           <a:xfrm>
-            <a:off x="7863840" y="1747810"/>
-            <a:ext cx="868680" cy="347472"/>
+            <a:off x="7680960" y="1394460"/>
+            <a:ext cx="868680" cy="274320"/>
           </a:xfrm>
           <a:prstGeom prst="rect">
             <a:avLst/>
@@ -12922,7 +13647,7 @@
               <a:buNone/>
             </a:pPr>
             <a:r>
-              <a:rPr lang="en-US" sz="1050" dirty="0">
+              <a:rPr lang="en-US" sz="950" dirty="0">
                 <a:solidFill>
                   <a:srgbClr val="1E293B"/>
                 </a:solidFill>
@@ -12932,7 +13657,7 @@
               </a:rPr>
               <a:t>74k</a:t>
             </a:r>
-            <a:endParaRPr lang="en-US" sz="1050" dirty="0"/>
+            <a:endParaRPr lang="en-US" sz="950" dirty="0"/>
           </a:p>
         </p:txBody>
       </p:sp>
@@ -12944,8 +13669,8 @@
         </p:nvSpPr>
         <p:spPr>
           <a:xfrm>
-            <a:off x="6035040" y="2131858"/>
-            <a:ext cx="2743200" cy="347472"/>
+            <a:off x="5852160" y="1705356"/>
+            <a:ext cx="2743200" cy="274320"/>
           </a:xfrm>
           <a:prstGeom prst="rect">
             <a:avLst/>
@@ -12960,6 +13685,13 @@
             <a:prstDash val="solid"/>
           </a:ln>
         </p:spPr>
+        <p:txBody>
+          <a:bodyPr/>
+          <a:lstStyle/>
+          <a:p>
+            <a:endParaRPr lang="en-US"/>
+          </a:p>
+        </p:txBody>
       </p:sp>
       <p:sp>
         <p:nvSpPr>
@@ -12969,8 +13701,8 @@
         </p:nvSpPr>
         <p:spPr>
           <a:xfrm>
-            <a:off x="6126480" y="2131858"/>
-            <a:ext cx="1280160" cy="347472"/>
+            <a:off x="5943600" y="1705356"/>
+            <a:ext cx="1280160" cy="274320"/>
           </a:xfrm>
           <a:prstGeom prst="rect">
             <a:avLst/>
@@ -12986,7 +13718,7 @@
               <a:buNone/>
             </a:pPr>
             <a:r>
-              <a:rPr lang="en-US" sz="1050" dirty="0">
+              <a:rPr lang="en-US" sz="950" dirty="0">
                 <a:solidFill>
                   <a:srgbClr val="1E293B"/>
                 </a:solidFill>
@@ -12996,7 +13728,7 @@
               </a:rPr>
               <a:t>Genie</a:t>
             </a:r>
-            <a:endParaRPr lang="en-US" sz="1050" dirty="0"/>
+            <a:endParaRPr lang="en-US" sz="950" dirty="0"/>
           </a:p>
         </p:txBody>
       </p:sp>
@@ -13008,8 +13740,8 @@
         </p:nvSpPr>
         <p:spPr>
           <a:xfrm>
-            <a:off x="7406640" y="2131858"/>
-            <a:ext cx="457200" cy="347472"/>
+            <a:off x="7223760" y="1705356"/>
+            <a:ext cx="457200" cy="274320"/>
           </a:xfrm>
           <a:prstGeom prst="rect">
             <a:avLst/>
@@ -13025,7 +13757,7 @@
               <a:buNone/>
             </a:pPr>
             <a:r>
-              <a:rPr lang="en-US" sz="1050" dirty="0">
+              <a:rPr lang="en-US" sz="950" dirty="0">
                 <a:solidFill>
                   <a:srgbClr val="1E293B"/>
                 </a:solidFill>
@@ -13035,7 +13767,7 @@
               </a:rPr>
               <a:t>11</a:t>
             </a:r>
-            <a:endParaRPr lang="en-US" sz="1050" dirty="0"/>
+            <a:endParaRPr lang="en-US" sz="950" dirty="0"/>
           </a:p>
         </p:txBody>
       </p:sp>
@@ -13047,8 +13779,8 @@
         </p:nvSpPr>
         <p:spPr>
           <a:xfrm>
-            <a:off x="7863840" y="2131858"/>
-            <a:ext cx="868680" cy="347472"/>
+            <a:off x="7680960" y="1705356"/>
+            <a:ext cx="868680" cy="274320"/>
           </a:xfrm>
           <a:prstGeom prst="rect">
             <a:avLst/>
@@ -13064,7 +13796,7 @@
               <a:buNone/>
             </a:pPr>
             <a:r>
-              <a:rPr lang="en-US" sz="1050" dirty="0">
+              <a:rPr lang="en-US" sz="950" dirty="0">
                 <a:solidFill>
                   <a:srgbClr val="1E293B"/>
                 </a:solidFill>
@@ -13074,7 +13806,7 @@
               </a:rPr>
               <a:t>118k</a:t>
             </a:r>
-            <a:endParaRPr lang="en-US" sz="1050" dirty="0"/>
+            <a:endParaRPr lang="en-US" sz="950" dirty="0"/>
           </a:p>
         </p:txBody>
       </p:sp>
@@ -13086,8 +13818,8 @@
         </p:nvSpPr>
         <p:spPr>
           <a:xfrm>
-            <a:off x="6035040" y="2515906"/>
-            <a:ext cx="2743200" cy="347472"/>
+            <a:off x="5852160" y="2016252"/>
+            <a:ext cx="2743200" cy="274320"/>
           </a:xfrm>
           <a:prstGeom prst="rect">
             <a:avLst/>
@@ -13102,6 +13834,13 @@
             <a:prstDash val="solid"/>
           </a:ln>
         </p:spPr>
+        <p:txBody>
+          <a:bodyPr/>
+          <a:lstStyle/>
+          <a:p>
+            <a:endParaRPr lang="en-US"/>
+          </a:p>
+        </p:txBody>
       </p:sp>
       <p:sp>
         <p:nvSpPr>
@@ -13111,8 +13850,8 @@
         </p:nvSpPr>
         <p:spPr>
           <a:xfrm>
-            <a:off x="6126480" y="2515906"/>
-            <a:ext cx="1280160" cy="347472"/>
+            <a:off x="5943600" y="2016252"/>
+            <a:ext cx="1280160" cy="274320"/>
           </a:xfrm>
           <a:prstGeom prst="rect">
             <a:avLst/>
@@ -13128,7 +13867,7 @@
               <a:buNone/>
             </a:pPr>
             <a:r>
-              <a:rPr lang="en-US" sz="1050" dirty="0">
+              <a:rPr lang="en-US" sz="950" dirty="0">
                 <a:solidFill>
                   <a:srgbClr val="1E293B"/>
                 </a:solidFill>
@@ -13138,7 +13877,7 @@
               </a:rPr>
               <a:t>Train-Ticket</a:t>
             </a:r>
-            <a:endParaRPr lang="en-US" sz="1050" dirty="0"/>
+            <a:endParaRPr lang="en-US" sz="950" dirty="0"/>
           </a:p>
         </p:txBody>
       </p:sp>
@@ -13150,8 +13889,8 @@
         </p:nvSpPr>
         <p:spPr>
           <a:xfrm>
-            <a:off x="7406640" y="2515906"/>
-            <a:ext cx="457200" cy="347472"/>
+            <a:off x="7223760" y="2016252"/>
+            <a:ext cx="457200" cy="274320"/>
           </a:xfrm>
           <a:prstGeom prst="rect">
             <a:avLst/>
@@ -13167,7 +13906,7 @@
               <a:buNone/>
             </a:pPr>
             <a:r>
-              <a:rPr lang="en-US" sz="1050" dirty="0">
+              <a:rPr lang="en-US" sz="950" dirty="0">
                 <a:solidFill>
                   <a:srgbClr val="1E293B"/>
                 </a:solidFill>
@@ -13175,9 +13914,9 @@
                 <a:ea typeface="Calibri" pitchFamily="34" charset="-122"/>
                 <a:cs typeface="Calibri" pitchFamily="34" charset="-120"/>
               </a:rPr>
-              <a:t>42</a:t>
-            </a:r>
-            <a:endParaRPr lang="en-US" sz="1050" dirty="0"/>
+              <a:t>41</a:t>
+            </a:r>
+            <a:endParaRPr lang="en-US" sz="950" dirty="0"/>
           </a:p>
         </p:txBody>
       </p:sp>
@@ -13189,8 +13928,8 @@
         </p:nvSpPr>
         <p:spPr>
           <a:xfrm>
-            <a:off x="7863840" y="2515906"/>
-            <a:ext cx="868680" cy="347472"/>
+            <a:off x="7680960" y="2016252"/>
+            <a:ext cx="868680" cy="274320"/>
           </a:xfrm>
           <a:prstGeom prst="rect">
             <a:avLst/>
@@ -13206,7 +13945,7 @@
               <a:buNone/>
             </a:pPr>
             <a:r>
-              <a:rPr lang="en-US" sz="1050" dirty="0">
+              <a:rPr lang="en-US" sz="950" dirty="0">
                 <a:solidFill>
                   <a:srgbClr val="1E293B"/>
                 </a:solidFill>
@@ -13216,7 +13955,7 @@
               </a:rPr>
               <a:t>38k</a:t>
             </a:r>
-            <a:endParaRPr lang="en-US" sz="1050" dirty="0"/>
+            <a:endParaRPr lang="en-US" sz="950" dirty="0"/>
           </a:p>
         </p:txBody>
       </p:sp>
@@ -13228,8 +13967,8 @@
         </p:nvSpPr>
         <p:spPr>
           <a:xfrm>
-            <a:off x="6035040" y="2899954"/>
-            <a:ext cx="2743200" cy="347472"/>
+            <a:off x="5852160" y="2327148"/>
+            <a:ext cx="2743200" cy="274320"/>
           </a:xfrm>
           <a:prstGeom prst="rect">
             <a:avLst/>
@@ -13244,6 +13983,13 @@
             <a:prstDash val="solid"/>
           </a:ln>
         </p:spPr>
+        <p:txBody>
+          <a:bodyPr/>
+          <a:lstStyle/>
+          <a:p>
+            <a:endParaRPr lang="en-US"/>
+          </a:p>
+        </p:txBody>
       </p:sp>
       <p:sp>
         <p:nvSpPr>
@@ -13253,8 +13999,8 @@
         </p:nvSpPr>
         <p:spPr>
           <a:xfrm>
-            <a:off x="6126480" y="2899954"/>
-            <a:ext cx="1280160" cy="347472"/>
+            <a:off x="5943600" y="2327148"/>
+            <a:ext cx="1280160" cy="274320"/>
           </a:xfrm>
           <a:prstGeom prst="rect">
             <a:avLst/>
@@ -13270,7 +14016,7 @@
               <a:buNone/>
             </a:pPr>
             <a:r>
-              <a:rPr lang="en-US" sz="1050" dirty="0">
+              <a:rPr lang="en-US" sz="950" dirty="0">
                 <a:solidFill>
                   <a:srgbClr val="1E293B"/>
                 </a:solidFill>
@@ -13280,7 +14026,7 @@
               </a:rPr>
               <a:t>Apollo-Config</a:t>
             </a:r>
-            <a:endParaRPr lang="en-US" sz="1050" dirty="0"/>
+            <a:endParaRPr lang="en-US" sz="950" dirty="0"/>
           </a:p>
         </p:txBody>
       </p:sp>
@@ -13292,8 +14038,8 @@
         </p:nvSpPr>
         <p:spPr>
           <a:xfrm>
-            <a:off x="7406640" y="2899954"/>
-            <a:ext cx="457200" cy="347472"/>
+            <a:off x="7223760" y="2327148"/>
+            <a:ext cx="457200" cy="274320"/>
           </a:xfrm>
           <a:prstGeom prst="rect">
             <a:avLst/>
@@ -13309,7 +14055,7 @@
               <a:buNone/>
             </a:pPr>
             <a:r>
-              <a:rPr lang="en-US" sz="1050" dirty="0">
+              <a:rPr lang="en-US" sz="950" dirty="0">
                 <a:solidFill>
                   <a:srgbClr val="1E293B"/>
                 </a:solidFill>
@@ -13319,7 +14065,7 @@
               </a:rPr>
               <a:t>11</a:t>
             </a:r>
-            <a:endParaRPr lang="en-US" sz="1050" dirty="0"/>
+            <a:endParaRPr lang="en-US" sz="950" dirty="0"/>
           </a:p>
         </p:txBody>
       </p:sp>
@@ -13331,8 +14077,8 @@
         </p:nvSpPr>
         <p:spPr>
           <a:xfrm>
-            <a:off x="7863840" y="2899954"/>
-            <a:ext cx="868680" cy="347472"/>
+            <a:off x="7680960" y="2327148"/>
+            <a:ext cx="868680" cy="274320"/>
           </a:xfrm>
           <a:prstGeom prst="rect">
             <a:avLst/>
@@ -13348,7 +14094,7 @@
               <a:buNone/>
             </a:pPr>
             <a:r>
-              <a:rPr lang="en-US" sz="1050" dirty="0">
+              <a:rPr lang="en-US" sz="950" dirty="0">
                 <a:solidFill>
                   <a:srgbClr val="1E293B"/>
                 </a:solidFill>
@@ -13358,7 +14104,7 @@
               </a:rPr>
               <a:t>86k</a:t>
             </a:r>
-            <a:endParaRPr lang="en-US" sz="1050" dirty="0"/>
+            <a:endParaRPr lang="en-US" sz="950" dirty="0"/>
           </a:p>
         </p:txBody>
       </p:sp>
@@ -13370,8 +14116,306 @@
         </p:nvSpPr>
         <p:spPr>
           <a:xfrm>
-            <a:off x="6035040" y="3284002"/>
-            <a:ext cx="2743200" cy="347472"/>
+            <a:off x="5852160" y="2638044"/>
+            <a:ext cx="2743200" cy="274320"/>
+          </a:xfrm>
+          <a:prstGeom prst="rect">
+            <a:avLst/>
+          </a:prstGeom>
+          <a:solidFill>
+            <a:srgbClr val="F8FAFC"/>
+          </a:solidFill>
+          <a:ln w="6350">
+            <a:solidFill>
+              <a:srgbClr val="E2E8F0"/>
+            </a:solidFill>
+            <a:prstDash val="solid"/>
+          </a:ln>
+        </p:spPr>
+        <p:txBody>
+          <a:bodyPr/>
+          <a:lstStyle/>
+          <a:p>
+            <a:endParaRPr lang="en-US"/>
+          </a:p>
+        </p:txBody>
+      </p:sp>
+      <p:sp>
+        <p:nvSpPr>
+          <p:cNvPr id="30" name="Text 27"/>
+          <p:cNvSpPr/>
+          <p:nvPr/>
+        </p:nvSpPr>
+        <p:spPr>
+          <a:xfrm>
+            <a:off x="5943600" y="2638044"/>
+            <a:ext cx="1280160" cy="274320"/>
+          </a:xfrm>
+          <a:prstGeom prst="rect">
+            <a:avLst/>
+          </a:prstGeom>
+          <a:noFill/>
+          <a:ln/>
+        </p:spPr>
+        <p:txBody>
+          <a:bodyPr wrap="square" lIns="0" tIns="0" rIns="0" bIns="0" rtlCol="0" anchor="ctr"/>
+          <a:lstStyle/>
+          <a:p>
+            <a:pPr marL="0" indent="0">
+              <a:buNone/>
+            </a:pPr>
+            <a:r>
+              <a:rPr lang="en-US" sz="950" dirty="0">
+                <a:solidFill>
+                  <a:srgbClr val="1E293B"/>
+                </a:solidFill>
+                <a:latin typeface="Calibri" pitchFamily="34" charset="0"/>
+                <a:ea typeface="Calibri" pitchFamily="34" charset="-122"/>
+                <a:cs typeface="Calibri" pitchFamily="34" charset="-120"/>
+              </a:rPr>
+              <a:t>NetworkDisk</a:t>
+            </a:r>
+            <a:endParaRPr lang="en-US" sz="950" dirty="0"/>
+          </a:p>
+        </p:txBody>
+      </p:sp>
+      <p:sp>
+        <p:nvSpPr>
+          <p:cNvPr id="31" name="Text 28"/>
+          <p:cNvSpPr/>
+          <p:nvPr/>
+        </p:nvSpPr>
+        <p:spPr>
+          <a:xfrm>
+            <a:off x="7223760" y="2638044"/>
+            <a:ext cx="457200" cy="274320"/>
+          </a:xfrm>
+          <a:prstGeom prst="rect">
+            <a:avLst/>
+          </a:prstGeom>
+          <a:noFill/>
+          <a:ln/>
+        </p:spPr>
+        <p:txBody>
+          <a:bodyPr wrap="square" lIns="0" tIns="0" rIns="0" bIns="0" rtlCol="0" anchor="ctr"/>
+          <a:lstStyle/>
+          <a:p>
+            <a:pPr marL="0" indent="0" algn="ctr">
+              <a:buNone/>
+            </a:pPr>
+            <a:r>
+              <a:rPr lang="en-US" sz="950" dirty="0">
+                <a:solidFill>
+                  <a:srgbClr val="1E293B"/>
+                </a:solidFill>
+                <a:latin typeface="Calibri" pitchFamily="34" charset="0"/>
+                <a:ea typeface="Calibri" pitchFamily="34" charset="-122"/>
+                <a:cs typeface="Calibri" pitchFamily="34" charset="-120"/>
+              </a:rPr>
+              <a:t>10</a:t>
+            </a:r>
+            <a:endParaRPr lang="en-US" sz="950" dirty="0"/>
+          </a:p>
+        </p:txBody>
+      </p:sp>
+      <p:sp>
+        <p:nvSpPr>
+          <p:cNvPr id="32" name="Text 29"/>
+          <p:cNvSpPr/>
+          <p:nvPr/>
+        </p:nvSpPr>
+        <p:spPr>
+          <a:xfrm>
+            <a:off x="7680960" y="2638044"/>
+            <a:ext cx="868680" cy="274320"/>
+          </a:xfrm>
+          <a:prstGeom prst="rect">
+            <a:avLst/>
+          </a:prstGeom>
+          <a:noFill/>
+          <a:ln/>
+        </p:spPr>
+        <p:txBody>
+          <a:bodyPr wrap="square" lIns="0" tIns="0" rIns="0" bIns="0" rtlCol="0" anchor="ctr"/>
+          <a:lstStyle/>
+          <a:p>
+            <a:pPr marL="0" indent="0" algn="r">
+              <a:buNone/>
+            </a:pPr>
+            <a:r>
+              <a:rPr lang="en-US" sz="950" dirty="0">
+                <a:solidFill>
+                  <a:srgbClr val="1E293B"/>
+                </a:solidFill>
+                <a:latin typeface="Calibri" pitchFamily="34" charset="0"/>
+                <a:ea typeface="Calibri" pitchFamily="34" charset="-122"/>
+                <a:cs typeface="Calibri" pitchFamily="34" charset="-120"/>
+              </a:rPr>
+              <a:t>7k</a:t>
+            </a:r>
+            <a:endParaRPr lang="en-US" sz="950" dirty="0"/>
+          </a:p>
+        </p:txBody>
+      </p:sp>
+      <p:sp>
+        <p:nvSpPr>
+          <p:cNvPr id="33" name="Shape 30"/>
+          <p:cNvSpPr/>
+          <p:nvPr/>
+        </p:nvSpPr>
+        <p:spPr>
+          <a:xfrm>
+            <a:off x="5852160" y="2948940"/>
+            <a:ext cx="2743200" cy="274320"/>
+          </a:xfrm>
+          <a:prstGeom prst="rect">
+            <a:avLst/>
+          </a:prstGeom>
+          <a:solidFill>
+            <a:srgbClr val="F8FAFC"/>
+          </a:solidFill>
+          <a:ln w="6350">
+            <a:solidFill>
+              <a:srgbClr val="E2E8F0"/>
+            </a:solidFill>
+            <a:prstDash val="solid"/>
+          </a:ln>
+        </p:spPr>
+        <p:txBody>
+          <a:bodyPr/>
+          <a:lstStyle/>
+          <a:p>
+            <a:endParaRPr lang="en-US"/>
+          </a:p>
+        </p:txBody>
+      </p:sp>
+      <p:sp>
+        <p:nvSpPr>
+          <p:cNvPr id="34" name="Text 31"/>
+          <p:cNvSpPr/>
+          <p:nvPr/>
+        </p:nvSpPr>
+        <p:spPr>
+          <a:xfrm>
+            <a:off x="5943600" y="2948940"/>
+            <a:ext cx="1280160" cy="274320"/>
+          </a:xfrm>
+          <a:prstGeom prst="rect">
+            <a:avLst/>
+          </a:prstGeom>
+          <a:noFill/>
+          <a:ln/>
+        </p:spPr>
+        <p:txBody>
+          <a:bodyPr wrap="square" lIns="0" tIns="0" rIns="0" bIns="0" rtlCol="0" anchor="ctr"/>
+          <a:lstStyle/>
+          <a:p>
+            <a:pPr marL="0" indent="0">
+              <a:buNone/>
+            </a:pPr>
+            <a:r>
+              <a:rPr lang="en-US" sz="950" dirty="0">
+                <a:solidFill>
+                  <a:srgbClr val="1E293B"/>
+                </a:solidFill>
+                <a:latin typeface="Calibri" pitchFamily="34" charset="0"/>
+                <a:ea typeface="Calibri" pitchFamily="34" charset="-122"/>
+                <a:cs typeface="Calibri" pitchFamily="34" charset="-120"/>
+              </a:rPr>
+              <a:t>recruit</a:t>
+            </a:r>
+            <a:endParaRPr lang="en-US" sz="950" dirty="0"/>
+          </a:p>
+        </p:txBody>
+      </p:sp>
+      <p:sp>
+        <p:nvSpPr>
+          <p:cNvPr id="35" name="Text 32"/>
+          <p:cNvSpPr/>
+          <p:nvPr/>
+        </p:nvSpPr>
+        <p:spPr>
+          <a:xfrm>
+            <a:off x="7223760" y="2948940"/>
+            <a:ext cx="457200" cy="274320"/>
+          </a:xfrm>
+          <a:prstGeom prst="rect">
+            <a:avLst/>
+          </a:prstGeom>
+          <a:noFill/>
+          <a:ln/>
+        </p:spPr>
+        <p:txBody>
+          <a:bodyPr wrap="square" lIns="0" tIns="0" rIns="0" bIns="0" rtlCol="0" anchor="ctr"/>
+          <a:lstStyle/>
+          <a:p>
+            <a:pPr marL="0" indent="0" algn="ctr">
+              <a:buNone/>
+            </a:pPr>
+            <a:r>
+              <a:rPr lang="en-US" sz="950" dirty="0">
+                <a:solidFill>
+                  <a:srgbClr val="1E293B"/>
+                </a:solidFill>
+                <a:latin typeface="Calibri" pitchFamily="34" charset="0"/>
+                <a:ea typeface="Calibri" pitchFamily="34" charset="-122"/>
+                <a:cs typeface="Calibri" pitchFamily="34" charset="-120"/>
+              </a:rPr>
+              <a:t>8</a:t>
+            </a:r>
+            <a:endParaRPr lang="en-US" sz="950" dirty="0"/>
+          </a:p>
+        </p:txBody>
+      </p:sp>
+      <p:sp>
+        <p:nvSpPr>
+          <p:cNvPr id="36" name="Text 33"/>
+          <p:cNvSpPr/>
+          <p:nvPr/>
+        </p:nvSpPr>
+        <p:spPr>
+          <a:xfrm>
+            <a:off x="7680960" y="2948940"/>
+            <a:ext cx="868680" cy="274320"/>
+          </a:xfrm>
+          <a:prstGeom prst="rect">
+            <a:avLst/>
+          </a:prstGeom>
+          <a:noFill/>
+          <a:ln/>
+        </p:spPr>
+        <p:txBody>
+          <a:bodyPr wrap="square" lIns="0" tIns="0" rIns="0" bIns="0" rtlCol="0" anchor="ctr"/>
+          <a:lstStyle/>
+          <a:p>
+            <a:pPr marL="0" indent="0" algn="r">
+              <a:buNone/>
+            </a:pPr>
+            <a:r>
+              <a:rPr lang="en-US" sz="950" dirty="0">
+                <a:solidFill>
+                  <a:srgbClr val="1E293B"/>
+                </a:solidFill>
+                <a:latin typeface="Calibri" pitchFamily="34" charset="0"/>
+                <a:ea typeface="Calibri" pitchFamily="34" charset="-122"/>
+                <a:cs typeface="Calibri" pitchFamily="34" charset="-120"/>
+              </a:rPr>
+              <a:t>8k</a:t>
+            </a:r>
+            <a:endParaRPr lang="en-US" sz="950" dirty="0"/>
+          </a:p>
+        </p:txBody>
+      </p:sp>
+      <p:sp>
+        <p:nvSpPr>
+          <p:cNvPr id="37" name="Shape 34"/>
+          <p:cNvSpPr/>
+          <p:nvPr/>
+        </p:nvSpPr>
+        <p:spPr>
+          <a:xfrm>
+            <a:off x="5852160" y="3259836"/>
+            <a:ext cx="2743200" cy="274320"/>
           </a:xfrm>
           <a:prstGeom prst="rect">
             <a:avLst/>
@@ -13386,17 +14430,24 @@
             <a:prstDash val="solid"/>
           </a:ln>
         </p:spPr>
-      </p:sp>
-      <p:sp>
-        <p:nvSpPr>
-          <p:cNvPr id="30" name="Text 27"/>
-          <p:cNvSpPr/>
-          <p:nvPr/>
-        </p:nvSpPr>
-        <p:spPr>
-          <a:xfrm>
-            <a:off x="6126480" y="3284002"/>
-            <a:ext cx="1280160" cy="347472"/>
+        <p:txBody>
+          <a:bodyPr/>
+          <a:lstStyle/>
+          <a:p>
+            <a:endParaRPr lang="en-US"/>
+          </a:p>
+        </p:txBody>
+      </p:sp>
+      <p:sp>
+        <p:nvSpPr>
+          <p:cNvPr id="38" name="Text 35"/>
+          <p:cNvSpPr/>
+          <p:nvPr/>
+        </p:nvSpPr>
+        <p:spPr>
+          <a:xfrm>
+            <a:off x="5943600" y="3259836"/>
+            <a:ext cx="1280160" cy="274320"/>
           </a:xfrm>
           <a:prstGeom prst="rect">
             <a:avLst/>
@@ -13412,7 +14463,7 @@
               <a:buNone/>
             </a:pPr>
             <a:r>
-              <a:rPr lang="en-US" sz="1050" b="1" dirty="0">
+              <a:rPr lang="en-US" sz="950" b="1" dirty="0">
                 <a:solidFill>
                   <a:srgbClr val="FFFFFF"/>
                 </a:solidFill>
@@ -13422,20 +14473,20 @@
               </a:rPr>
               <a:t>Total</a:t>
             </a:r>
-            <a:endParaRPr lang="en-US" sz="1050" dirty="0"/>
-          </a:p>
-        </p:txBody>
-      </p:sp>
-      <p:sp>
-        <p:nvSpPr>
-          <p:cNvPr id="31" name="Text 28"/>
-          <p:cNvSpPr/>
-          <p:nvPr/>
-        </p:nvSpPr>
-        <p:spPr>
-          <a:xfrm>
-            <a:off x="7406640" y="3284002"/>
-            <a:ext cx="457200" cy="347472"/>
+            <a:endParaRPr lang="en-US" sz="950" dirty="0"/>
+          </a:p>
+        </p:txBody>
+      </p:sp>
+      <p:sp>
+        <p:nvSpPr>
+          <p:cNvPr id="39" name="Text 36"/>
+          <p:cNvSpPr/>
+          <p:nvPr/>
+        </p:nvSpPr>
+        <p:spPr>
+          <a:xfrm>
+            <a:off x="7223760" y="3259836"/>
+            <a:ext cx="457200" cy="274320"/>
           </a:xfrm>
           <a:prstGeom prst="rect">
             <a:avLst/>
@@ -13451,7 +14502,7 @@
               <a:buNone/>
             </a:pPr>
             <a:r>
-              <a:rPr lang="en-US" sz="1050" b="1" dirty="0">
+              <a:rPr lang="en-US" sz="950" b="1" dirty="0">
                 <a:solidFill>
                   <a:srgbClr val="FFFFFF"/>
                 </a:solidFill>
@@ -13459,22 +14510,22 @@
                 <a:ea typeface="Calibri" pitchFamily="34" charset="-122"/>
                 <a:cs typeface="Calibri" pitchFamily="34" charset="-120"/>
               </a:rPr>
-              <a:t>99</a:t>
-            </a:r>
-            <a:endParaRPr lang="en-US" sz="1050" dirty="0"/>
-          </a:p>
-        </p:txBody>
-      </p:sp>
-      <p:sp>
-        <p:nvSpPr>
-          <p:cNvPr id="32" name="Text 29"/>
-          <p:cNvSpPr/>
-          <p:nvPr/>
-        </p:nvSpPr>
-        <p:spPr>
-          <a:xfrm>
-            <a:off x="7863840" y="3284002"/>
-            <a:ext cx="868680" cy="347472"/>
+              <a:t>115</a:t>
+            </a:r>
+            <a:endParaRPr lang="en-US" sz="950" dirty="0"/>
+          </a:p>
+        </p:txBody>
+      </p:sp>
+      <p:sp>
+        <p:nvSpPr>
+          <p:cNvPr id="40" name="Text 37"/>
+          <p:cNvSpPr/>
+          <p:nvPr/>
+        </p:nvSpPr>
+        <p:spPr>
+          <a:xfrm>
+            <a:off x="7680960" y="3259836"/>
+            <a:ext cx="868680" cy="274320"/>
           </a:xfrm>
           <a:prstGeom prst="rect">
             <a:avLst/>
@@ -13490,7 +14541,7 @@
               <a:buNone/>
             </a:pPr>
             <a:r>
-              <a:rPr lang="en-US" sz="1050" b="1" dirty="0">
+              <a:rPr lang="en-US" sz="950" b="1" dirty="0">
                 <a:solidFill>
                   <a:srgbClr val="FFFFFF"/>
                 </a:solidFill>
@@ -13498,15 +14549,15 @@
                 <a:ea typeface="Calibri" pitchFamily="34" charset="-122"/>
                 <a:cs typeface="Calibri" pitchFamily="34" charset="-120"/>
               </a:rPr>
-              <a:t>335k</a:t>
-            </a:r>
-            <a:endParaRPr lang="en-US" sz="1050" dirty="0"/>
-          </a:p>
-        </p:txBody>
-      </p:sp>
-      <p:sp>
-        <p:nvSpPr>
-          <p:cNvPr id="34" name="Shape 31"/>
+              <a:t>350k</a:t>
+            </a:r>
+            <a:endParaRPr lang="en-US" sz="950" dirty="0"/>
+          </a:p>
+        </p:txBody>
+      </p:sp>
+      <p:sp>
+        <p:nvSpPr>
+          <p:cNvPr id="42" name="Shape 39"/>
           <p:cNvSpPr/>
           <p:nvPr/>
         </p:nvSpPr>
@@ -13528,10 +14579,17 @@
             <a:prstDash val="solid"/>
           </a:ln>
         </p:spPr>
-      </p:sp>
-      <p:sp>
-        <p:nvSpPr>
-          <p:cNvPr id="35" name="Shape 32"/>
+        <p:txBody>
+          <a:bodyPr/>
+          <a:lstStyle/>
+          <a:p>
+            <a:endParaRPr lang="en-US"/>
+          </a:p>
+        </p:txBody>
+      </p:sp>
+      <p:sp>
+        <p:nvSpPr>
+          <p:cNvPr id="43" name="Shape 40"/>
           <p:cNvSpPr/>
           <p:nvPr/>
         </p:nvSpPr>
@@ -13553,10 +14611,17 @@
             <a:prstDash val="solid"/>
           </a:ln>
         </p:spPr>
-      </p:sp>
-      <p:sp>
-        <p:nvSpPr>
-          <p:cNvPr id="36" name="Text 33"/>
+        <p:txBody>
+          <a:bodyPr/>
+          <a:lstStyle/>
+          <a:p>
+            <a:endParaRPr lang="en-US"/>
+          </a:p>
+        </p:txBody>
+      </p:sp>
+      <p:sp>
+        <p:nvSpPr>
+          <p:cNvPr id="44" name="Text 41"/>
           <p:cNvSpPr/>
           <p:nvPr/>
         </p:nvSpPr>
@@ -13595,7 +14660,7 @@
       </p:sp>
       <p:sp>
         <p:nvSpPr>
-          <p:cNvPr id="37" name="Text 34"/>
+          <p:cNvPr id="45" name="Text 42"/>
           <p:cNvSpPr/>
           <p:nvPr/>
         </p:nvSpPr>
@@ -13630,7 +14695,7 @@
                 <a:ea typeface="Calibri" pitchFamily="34" charset="-122"/>
                 <a:cs typeface="Calibri" pitchFamily="34" charset="-120"/>
               </a:rPr>
-              <a:t>Hardcoded Endpoints (43) and Nano Service (17) dominate — configuration and sizing issues most prevalent.</a:t>
+              <a:t>106 anti-pattern instances across 9 types. Hardcoded Endpoints (45) and API Versioning Absence (24) dominate.</a:t>
             </a:r>
             <a:endParaRPr lang="en-US" sz="1100" dirty="0"/>
           </a:p>
@@ -13651,7 +14716,7 @@
                 <a:ea typeface="Calibri" pitchFamily="34" charset="-122"/>
                 <a:cs typeface="Calibri" pitchFamily="34" charset="-120"/>
               </a:rPr>
-              <a:t>ESB Misuse detected in Site-Where (3); Chatty Service in Train-Ticket (4) — validates communication-topology detectors.</a:t>
+              <a:t>Cyclic Dependency and Wrong Cuts detected in microservice-recruit — broader corpus exercises more detectors.</a:t>
             </a:r>
             <a:endParaRPr lang="en-US" sz="1100" dirty="0"/>
           </a:p>
@@ -13659,7 +14724,7 @@
       </p:sp>
       <p:sp>
         <p:nvSpPr>
-          <p:cNvPr id="38" name="Text 35"/>
+          <p:cNvPr id="46" name="Text 43"/>
           <p:cNvSpPr/>
           <p:nvPr/>
         </p:nvSpPr>
@@ -13698,7 +14763,7 @@
       </p:sp>
       <p:sp>
         <p:nvSpPr>
-          <p:cNvPr id="39" name="Text 36"/>
+          <p:cNvPr id="47" name="Text 44"/>
           <p:cNvSpPr/>
           <p:nvPr/>
         </p:nvSpPr>
@@ -14049,39 +15114,39 @@
         <a:sysClr val="window" lastClr="FFFFFF"/>
       </a:lt1>
       <a:dk2>
-        <a:srgbClr val="44546A"/>
+        <a:srgbClr val="0E2841"/>
       </a:dk2>
       <a:lt2>
-        <a:srgbClr val="E7E6E6"/>
+        <a:srgbClr val="E8E8E8"/>
       </a:lt2>
       <a:accent1>
-        <a:srgbClr val="4472C4"/>
+        <a:srgbClr val="156082"/>
       </a:accent1>
       <a:accent2>
-        <a:srgbClr val="ED7D31"/>
+        <a:srgbClr val="E97132"/>
       </a:accent2>
       <a:accent3>
-        <a:srgbClr val="A5A5A5"/>
+        <a:srgbClr val="196B24"/>
       </a:accent3>
       <a:accent4>
-        <a:srgbClr val="FFC000"/>
+        <a:srgbClr val="0F9ED5"/>
       </a:accent4>
       <a:accent5>
-        <a:srgbClr val="5B9BD5"/>
+        <a:srgbClr val="A02B93"/>
       </a:accent5>
       <a:accent6>
-        <a:srgbClr val="70AD47"/>
+        <a:srgbClr val="4EA72E"/>
       </a:accent6>
       <a:hlink>
-        <a:srgbClr val="0563C1"/>
+        <a:srgbClr val="467886"/>
       </a:hlink>
       <a:folHlink>
-        <a:srgbClr val="954F72"/>
+        <a:srgbClr val="96607D"/>
       </a:folHlink>
     </a:clrScheme>
     <a:fontScheme name="Office">
       <a:majorFont>
-        <a:latin typeface="Calibri Light" panose="020F0302020204030204"/>
+        <a:latin typeface="Aptos Display" panose="02110004020202020204"/>
         <a:ea typeface=""/>
         <a:cs typeface=""/>
         <a:font script="Jpan" typeface="游ゴシック Light"/>
@@ -14133,7 +15198,7 @@
         <a:font script="Tfng" typeface="Ebrima"/>
       </a:majorFont>
       <a:minorFont>
-        <a:latin typeface="Calibri" panose="020F0502020204030204"/>
+        <a:latin typeface="Aptos" panose="02110004020202020204"/>
         <a:ea typeface=""/>
         <a:cs typeface=""/>
         <a:font script="Jpan" typeface="游ゴシック"/>
@@ -14244,13 +15309,6 @@
         </a:gradFill>
       </a:fillStyleLst>
       <a:lnStyleLst>
-        <a:ln w="6350" cap="flat" cmpd="sng" algn="ctr">
-          <a:solidFill>
-            <a:schemeClr val="phClr"/>
-          </a:solidFill>
-          <a:prstDash val="solid"/>
-          <a:miter lim="800000"/>
-        </a:ln>
         <a:ln w="12700" cap="flat" cmpd="sng" algn="ctr">
           <a:solidFill>
             <a:schemeClr val="phClr"/>
@@ -14259,6 +15317,13 @@
           <a:miter lim="800000"/>
         </a:ln>
         <a:ln w="19050" cap="flat" cmpd="sng" algn="ctr">
+          <a:solidFill>
+            <a:schemeClr val="phClr"/>
+          </a:solidFill>
+          <a:prstDash val="solid"/>
+          <a:miter lim="800000"/>
+        </a:ln>
+        <a:ln w="25400" cap="flat" cmpd="sng" algn="ctr">
           <a:solidFill>
             <a:schemeClr val="phClr"/>
           </a:solidFill>
@@ -14323,12 +15388,38 @@
       </a:bgFillStyleLst>
     </a:fmtScheme>
   </a:themeElements>
-  <a:objectDefaults/>
+  <a:objectDefaults>
+    <a:lnDef>
+      <a:spPr/>
+      <a:bodyPr/>
+      <a:lstStyle/>
+      <a:style>
+        <a:lnRef idx="2">
+          <a:schemeClr val="accent1"/>
+        </a:lnRef>
+        <a:fillRef idx="0">
+          <a:schemeClr val="accent1"/>
+        </a:fillRef>
+        <a:effectRef idx="1">
+          <a:schemeClr val="accent1"/>
+        </a:effectRef>
+        <a:fontRef idx="minor">
+          <a:schemeClr val="tx1"/>
+        </a:fontRef>
+      </a:style>
+    </a:lnDef>
+  </a:objectDefaults>
   <a:extraClrSchemeLst/>
   <a:extLst>
     <a:ext uri="{05A4C25C-085E-4340-85A3-A5531E510DB2}">
-      <thm15:themeFamily xmlns:thm15="http://schemas.microsoft.com/office/thememl/2012/main" name="Office Theme" id="{62F939B6-93AF-4DB8-9C6B-D6C7DFDC589F}" vid="{4A3C46E8-61CC-4603-A589-7422A47A8E4A}"/>
+      <thm15:themeFamily xmlns:thm15="http://schemas.microsoft.com/office/thememl/2012/main" name="Office Theme" id="{2E142A2C-CD16-42D6-873A-C26D2A0506FA}" vid="{1BDDFF52-6CD6-40A5-AB3C-68EB2F1E4D0A}"/>
     </a:ext>
   </a:extLst>
 </a:theme>
+</file>
+
+<file path=docMetadata/LabelInfo.xml><?xml version="1.0" encoding="utf-8"?>
+<clbl:labelList xmlns:clbl="http://schemas.microsoft.com/office/2020/mipLabelMetadata">
+  <clbl:label id="{9d258917-277f-42cd-a3cd-14c4e9ee58bc}" enabled="1" method="Standard" siteId="{38ae3bcd-9579-4fd4-adda-b42e1495d55a}" contentBits="0" removed="0"/>
+</clbl:labelList>
 </file>
</xml_diff>

<commit_message>
thesis results, code and presentation fixes
</commit_message>
<xml_diff>
--- a/thesis/presentation/MSA_Detector_Defense.pptx
+++ b/thesis/presentation/MSA_Detector_Defense.pptx
@@ -262,7 +262,7 @@
                 <c:formatCode>General</c:formatCode>
                 <c:ptCount val="8"/>
                 <c:pt idx="0">
-                  <c:v>77</c:v>
+                  <c:v>83</c:v>
                 </c:pt>
                 <c:pt idx="1">
                   <c:v>69</c:v>
@@ -271,16 +271,16 @@
                   <c:v>60</c:v>
                 </c:pt>
                 <c:pt idx="3">
-                  <c:v>59</c:v>
+                  <c:v>68</c:v>
                 </c:pt>
                 <c:pt idx="4">
                   <c:v>52</c:v>
                 </c:pt>
                 <c:pt idx="5">
-                  <c:v>45</c:v>
+                  <c:v>70</c:v>
                 </c:pt>
                 <c:pt idx="6">
-                  <c:v>53</c:v>
+                  <c:v>62</c:v>
                 </c:pt>
                 <c:pt idx="7">
                   <c:v>48</c:v>
@@ -290,7 +290,7 @@
           </c:val>
           <c:extLst>
             <c:ext xmlns:c16="http://schemas.microsoft.com/office/drawing/2014/chart" uri="{C3380CC4-5D6E-409C-BE32-E72D297353CC}">
-              <c16:uniqueId val="{00000000-D2D8-4E7F-A1AB-8CB481E5C264}"/>
+              <c16:uniqueId val="{00000000-7710-4591-B59F-19D4BC1452DD}"/>
             </c:ext>
           </c:extLst>
         </c:ser>
@@ -452,7 +452,7 @@
     </p:spTree>
     <p:extLst>
       <p:ext uri="{BB962C8B-B14F-4D97-AF65-F5344CB8AC3E}">
-        <p14:creationId xmlns:p14="http://schemas.microsoft.com/office/powerpoint/2010/main" val="3330541412"/>
+        <p14:creationId xmlns:p14="http://schemas.microsoft.com/office/powerpoint/2010/main" val="1565570511"/>
       </p:ext>
     </p:extLst>
   </p:cSld>
@@ -695,7 +695,7 @@
 • Have a second browser tab open with a PREVIOUSLY COMPLETED analysis loaded, as a fallback. If the live clone fails or runs slow, switch to that tab and say 'here's a previous run on the same project.'
 Demo script (~2 min):
 1. CLONE (~30 s): 'I'll paste a GitHub URL of a small microservice project and submit it.' Paste, click submit. While it runs: 'the pipeline is now detecting microservices, running DesigniteJava per service, building the dependency graph, and running the ten detectors.'
-2. DASHBOARD (~30 s): When the results page loads, point at the health score gauge. 'Score 77, grade C. The four-category breakdown shows where the deductions came from — mostly Anti-Patterns category.'
+2. DASHBOARD (~30 s): When the results page loads, point at the health score gauge. 'Score 83, grade B. The four-category breakdown shows where the deductions came from — mostly Anti-Patterns category.'
 3. DRILL-DOWN (~45 s): Click on the Shared Database finding to expand it. 'You can see the affected services, the actual datasource URL that's being shared, the code snippet from the application.yml file, and remediation guidance.' This is the slide's strongest moment — the committee sees the evidence-based reporting in action.
 4. DEPENDENCY GRAPH (~15 s): Scroll down or switch to the dep-graph view. 'Interactive force-directed graph. Each node is a service, edges show inter-service calls, node size scales with LOC.'
 Then say: 'I'll switch back to the slides.' Click back to slide 11.
@@ -1556,13 +1556,13 @@
               <a:rPr lang="en-US" dirty="0"/>
               <a:t>Spend ~75 seconds. This is the slide that makes the scoring reproducible.
 Walk through it:
-• 'Take Train-Ticket as an example — an academic benchmark with 42 microservices. It has 26 hardcoded endpoints, 4 chatty services, 4 nano services, and 1 shared database. Total penalty: 115 — but the AP category caps at 40, so it clamps to zero.'
-• 'Service Sizing loses 8 points from the nano service penalty (capped at 8).'
+• 'Take Train-Ticket as an example — an academic benchmark with 41 microservices. In the anti-pattern category it has 26 hardcoded endpoints, 4 chatty services, and 1 shared database — total penalty 103, but the AP category caps at 40, so it clamps to zero.'
+• 'Its 4 nano services are scored under Service Sizing instead of the anti-pattern category (to avoid double counting), costing 8 points there (capped at 8).'
 • 'Code Quality and Architecture both score perfect — DesigniteJava produced no smells, and the coupling coefficient stayed below the penalty threshold.'
 • 'So the final score is 0 + 20 + 25 + 7 = 52. Grade D.'
 This slide demonstrates: (1) the scoring formula is fully transparent and reproducible, (2) the decomposition tells you exactly what's wrong — here it's overwhelmingly hardcoded URLs and chatty inter-service calls.
 EXPECT QUESTION: 'Code Quality and Architecture scoring perfect — is that real?'
-Honest answer: 'DesigniteJava genuinely didn't flag smells in this project, and the coupling coefficient is low because Train-Ticket has 42 services but relatively few resolved inter-service edges. A richer evaluation corpus would exercise those categories more. I note this in Chapter 5.'</a:t>
+Honest answer: 'DesigniteJava genuinely didn't flag smells in this project, and the coupling coefficient is low because Train-Ticket has 41 services but relatively few resolved inter-service edges. A richer evaluation corpus would exercise those categories more. I note this in Chapter 5.'</a:t>
             </a:r>
           </a:p>
         </p:txBody>
@@ -1652,7 +1652,7 @@
               <a:t>Spend ~90 seconds.
 Talking points:
 • 'I evaluated on eight open-source Spring Boot projects, spanning from a 2k-LOC student project to Genie at 118k LOC. 116 microservices, 350k LOC total.'
-• 'Health scores ranged from 45 to 77 — the scoring mechanism produces meaningful spread.'
+• 'Health scores ranged from 48 to 83 — the scoring mechanism produces meaningful spread.'
 • 'The dominant findings are configuration and sizing issues: 45 hardcoded endpoints, 24 API versioning absences, 20 nano services. But importantly, Cyclic Dependency and Wrong Cuts were detected in microservice-recruit — adding those two projects exercised detectors that previously produced zero results.'
 • '106 total anti-pattern instances across 9 distinct types. Only Distributed Monolith was not detected — plausible given these projects' topologies.'
 EXPECT: 'Only 8 projects, is that enough?'
@@ -2058,13 +2058,6 @@
             <a:prstDash val="solid"/>
           </a:ln>
         </p:spPr>
-        <p:txBody>
-          <a:bodyPr/>
-          <a:lstStyle/>
-          <a:p>
-            <a:endParaRPr lang="en-US"/>
-          </a:p>
-        </p:txBody>
       </p:sp>
       <p:sp>
         <p:nvSpPr>
@@ -2090,13 +2083,6 @@
             <a:prstDash val="solid"/>
           </a:ln>
         </p:spPr>
-        <p:txBody>
-          <a:bodyPr/>
-          <a:lstStyle/>
-          <a:p>
-            <a:endParaRPr lang="en-US"/>
-          </a:p>
-        </p:txBody>
       </p:sp>
       <p:pic>
         <p:nvPicPr>
@@ -2286,13 +2272,6 @@
             <a:prstDash val="solid"/>
           </a:ln>
         </p:spPr>
-        <p:txBody>
-          <a:bodyPr/>
-          <a:lstStyle/>
-          <a:p>
-            <a:endParaRPr lang="en-US"/>
-          </a:p>
-        </p:txBody>
       </p:sp>
       <p:sp>
         <p:nvSpPr>
@@ -2441,13 +2420,6 @@
             <a:prstDash val="solid"/>
           </a:ln>
         </p:spPr>
-        <p:txBody>
-          <a:bodyPr/>
-          <a:lstStyle/>
-          <a:p>
-            <a:endParaRPr lang="en-US"/>
-          </a:p>
-        </p:txBody>
       </p:sp>
       <p:sp>
         <p:nvSpPr>
@@ -2551,13 +2523,6 @@
             <a:prstDash val="solid"/>
           </a:ln>
         </p:spPr>
-        <p:txBody>
-          <a:bodyPr/>
-          <a:lstStyle/>
-          <a:p>
-            <a:endParaRPr lang="en-US"/>
-          </a:p>
-        </p:txBody>
       </p:sp>
       <p:sp>
         <p:nvSpPr>
@@ -2583,13 +2548,6 @@
             <a:prstDash val="solid"/>
           </a:ln>
         </p:spPr>
-        <p:txBody>
-          <a:bodyPr/>
-          <a:lstStyle/>
-          <a:p>
-            <a:endParaRPr lang="en-US"/>
-          </a:p>
-        </p:txBody>
       </p:sp>
       <p:sp>
         <p:nvSpPr>
@@ -2732,13 +2690,6 @@
             <a:prstDash val="solid"/>
           </a:ln>
         </p:spPr>
-        <p:txBody>
-          <a:bodyPr/>
-          <a:lstStyle/>
-          <a:p>
-            <a:endParaRPr lang="en-US"/>
-          </a:p>
-        </p:txBody>
       </p:sp>
       <p:sp>
         <p:nvSpPr>
@@ -2881,13 +2832,6 @@
             <a:prstDash val="solid"/>
           </a:ln>
         </p:spPr>
-        <p:txBody>
-          <a:bodyPr/>
-          <a:lstStyle/>
-          <a:p>
-            <a:endParaRPr lang="en-US"/>
-          </a:p>
-        </p:txBody>
       </p:sp>
       <p:sp>
         <p:nvSpPr>
@@ -3030,13 +2974,6 @@
             <a:prstDash val="solid"/>
           </a:ln>
         </p:spPr>
-        <p:txBody>
-          <a:bodyPr/>
-          <a:lstStyle/>
-          <a:p>
-            <a:endParaRPr lang="en-US"/>
-          </a:p>
-        </p:txBody>
       </p:sp>
       <p:sp>
         <p:nvSpPr>
@@ -3329,13 +3266,6 @@
             <a:prstDash val="solid"/>
           </a:ln>
         </p:spPr>
-        <p:txBody>
-          <a:bodyPr/>
-          <a:lstStyle/>
-          <a:p>
-            <a:endParaRPr lang="en-US"/>
-          </a:p>
-        </p:txBody>
       </p:sp>
       <p:sp>
         <p:nvSpPr>
@@ -3361,13 +3291,6 @@
             <a:prstDash val="solid"/>
           </a:ln>
         </p:spPr>
-        <p:txBody>
-          <a:bodyPr/>
-          <a:lstStyle/>
-          <a:p>
-            <a:endParaRPr lang="en-US"/>
-          </a:p>
-        </p:txBody>
       </p:sp>
       <p:sp>
         <p:nvSpPr>
@@ -3402,13 +3325,6 @@
             </a:outerShdw>
           </a:effectLst>
         </p:spPr>
-        <p:txBody>
-          <a:bodyPr/>
-          <a:lstStyle/>
-          <a:p>
-            <a:endParaRPr lang="en-US"/>
-          </a:p>
-        </p:txBody>
       </p:sp>
       <p:pic>
         <p:nvPicPr>
@@ -3624,13 +3540,6 @@
             <a:prstDash val="solid"/>
           </a:ln>
         </p:spPr>
-        <p:txBody>
-          <a:bodyPr/>
-          <a:lstStyle/>
-          <a:p>
-            <a:endParaRPr lang="en-US"/>
-          </a:p>
-        </p:txBody>
       </p:sp>
       <p:sp>
         <p:nvSpPr>
@@ -3656,13 +3565,6 @@
             <a:prstDash val="solid"/>
           </a:ln>
         </p:spPr>
-        <p:txBody>
-          <a:bodyPr/>
-          <a:lstStyle/>
-          <a:p>
-            <a:endParaRPr lang="en-US"/>
-          </a:p>
-        </p:txBody>
       </p:sp>
       <p:sp>
         <p:nvSpPr>
@@ -3697,13 +3599,6 @@
             </a:outerShdw>
           </a:effectLst>
         </p:spPr>
-        <p:txBody>
-          <a:bodyPr/>
-          <a:lstStyle/>
-          <a:p>
-            <a:endParaRPr lang="en-US"/>
-          </a:p>
-        </p:txBody>
       </p:sp>
       <p:pic>
         <p:nvPicPr>
@@ -4009,13 +3904,6 @@
             <a:prstDash val="solid"/>
           </a:ln>
         </p:spPr>
-        <p:txBody>
-          <a:bodyPr/>
-          <a:lstStyle/>
-          <a:p>
-            <a:endParaRPr lang="en-US"/>
-          </a:p>
-        </p:txBody>
       </p:sp>
       <p:sp>
         <p:nvSpPr>
@@ -4119,13 +4007,6 @@
             <a:prstDash val="solid"/>
           </a:ln>
         </p:spPr>
-        <p:txBody>
-          <a:bodyPr/>
-          <a:lstStyle/>
-          <a:p>
-            <a:endParaRPr lang="en-US"/>
-          </a:p>
-        </p:txBody>
       </p:sp>
       <p:sp>
         <p:nvSpPr>
@@ -4446,13 +4327,6 @@
             <a:prstDash val="solid"/>
           </a:ln>
         </p:spPr>
-        <p:txBody>
-          <a:bodyPr/>
-          <a:lstStyle/>
-          <a:p>
-            <a:endParaRPr lang="en-US"/>
-          </a:p>
-        </p:txBody>
       </p:sp>
       <p:sp>
         <p:nvSpPr>
@@ -4478,13 +4352,6 @@
             <a:prstDash val="solid"/>
           </a:ln>
         </p:spPr>
-        <p:txBody>
-          <a:bodyPr/>
-          <a:lstStyle/>
-          <a:p>
-            <a:endParaRPr lang="en-US"/>
-          </a:p>
-        </p:txBody>
       </p:sp>
       <p:sp>
         <p:nvSpPr>
@@ -4519,13 +4386,6 @@
             </a:outerShdw>
           </a:effectLst>
         </p:spPr>
-        <p:txBody>
-          <a:bodyPr/>
-          <a:lstStyle/>
-          <a:p>
-            <a:endParaRPr lang="en-US"/>
-          </a:p>
-        </p:txBody>
       </p:sp>
       <p:pic>
         <p:nvPicPr>
@@ -4653,13 +4513,6 @@
             <a:prstDash val="solid"/>
           </a:ln>
         </p:spPr>
-        <p:txBody>
-          <a:bodyPr/>
-          <a:lstStyle/>
-          <a:p>
-            <a:endParaRPr lang="en-US"/>
-          </a:p>
-        </p:txBody>
       </p:sp>
       <p:sp>
         <p:nvSpPr>
@@ -4685,13 +4538,6 @@
             <a:prstDash val="solid"/>
           </a:ln>
         </p:spPr>
-        <p:txBody>
-          <a:bodyPr/>
-          <a:lstStyle/>
-          <a:p>
-            <a:endParaRPr lang="en-US"/>
-          </a:p>
-        </p:txBody>
       </p:sp>
       <p:sp>
         <p:nvSpPr>
@@ -4726,13 +4572,6 @@
             </a:outerShdw>
           </a:effectLst>
         </p:spPr>
-        <p:txBody>
-          <a:bodyPr/>
-          <a:lstStyle/>
-          <a:p>
-            <a:endParaRPr lang="en-US"/>
-          </a:p>
-        </p:txBody>
       </p:sp>
       <p:pic>
         <p:nvPicPr>
@@ -4860,13 +4699,6 @@
             <a:prstDash val="solid"/>
           </a:ln>
         </p:spPr>
-        <p:txBody>
-          <a:bodyPr/>
-          <a:lstStyle/>
-          <a:p>
-            <a:endParaRPr lang="en-US"/>
-          </a:p>
-        </p:txBody>
       </p:sp>
       <p:sp>
         <p:nvSpPr>
@@ -4892,13 +4724,6 @@
             <a:prstDash val="solid"/>
           </a:ln>
         </p:spPr>
-        <p:txBody>
-          <a:bodyPr/>
-          <a:lstStyle/>
-          <a:p>
-            <a:endParaRPr lang="en-US"/>
-          </a:p>
-        </p:txBody>
       </p:sp>
       <p:sp>
         <p:nvSpPr>
@@ -4933,13 +4758,6 @@
             </a:outerShdw>
           </a:effectLst>
         </p:spPr>
-        <p:txBody>
-          <a:bodyPr/>
-          <a:lstStyle/>
-          <a:p>
-            <a:endParaRPr lang="en-US"/>
-          </a:p>
-        </p:txBody>
       </p:sp>
       <p:pic>
         <p:nvPicPr>
@@ -5067,13 +4885,6 @@
             <a:prstDash val="solid"/>
           </a:ln>
         </p:spPr>
-        <p:txBody>
-          <a:bodyPr/>
-          <a:lstStyle/>
-          <a:p>
-            <a:endParaRPr lang="en-US"/>
-          </a:p>
-        </p:txBody>
       </p:sp>
       <p:sp>
         <p:nvSpPr>
@@ -5297,13 +5108,6 @@
             </a:outerShdw>
           </a:effectLst>
         </p:spPr>
-        <p:txBody>
-          <a:bodyPr/>
-          <a:lstStyle/>
-          <a:p>
-            <a:endParaRPr lang="en-US"/>
-          </a:p>
-        </p:txBody>
       </p:sp>
       <p:pic>
         <p:nvPicPr>
@@ -5440,13 +5244,6 @@
             </a:outerShdw>
           </a:effectLst>
         </p:spPr>
-        <p:txBody>
-          <a:bodyPr/>
-          <a:lstStyle/>
-          <a:p>
-            <a:endParaRPr lang="en-US"/>
-          </a:p>
-        </p:txBody>
       </p:sp>
       <p:pic>
         <p:nvPicPr>
@@ -5583,13 +5380,6 @@
             </a:outerShdw>
           </a:effectLst>
         </p:spPr>
-        <p:txBody>
-          <a:bodyPr/>
-          <a:lstStyle/>
-          <a:p>
-            <a:endParaRPr lang="en-US"/>
-          </a:p>
-        </p:txBody>
       </p:sp>
       <p:pic>
         <p:nvPicPr>
@@ -5726,13 +5516,6 @@
             </a:outerShdw>
           </a:effectLst>
         </p:spPr>
-        <p:txBody>
-          <a:bodyPr/>
-          <a:lstStyle/>
-          <a:p>
-            <a:endParaRPr lang="en-US"/>
-          </a:p>
-        </p:txBody>
       </p:sp>
       <p:pic>
         <p:nvPicPr>
@@ -5869,13 +5652,6 @@
             </a:outerShdw>
           </a:effectLst>
         </p:spPr>
-        <p:txBody>
-          <a:bodyPr/>
-          <a:lstStyle/>
-          <a:p>
-            <a:endParaRPr lang="en-US"/>
-          </a:p>
-        </p:txBody>
       </p:sp>
       <p:pic>
         <p:nvPicPr>
@@ -6153,13 +5929,6 @@
             <a:prstDash val="solid"/>
           </a:ln>
         </p:spPr>
-        <p:txBody>
-          <a:bodyPr/>
-          <a:lstStyle/>
-          <a:p>
-            <a:endParaRPr lang="en-US"/>
-          </a:p>
-        </p:txBody>
       </p:sp>
       <p:sp>
         <p:nvSpPr>
@@ -6185,13 +5954,6 @@
             <a:prstDash val="solid"/>
           </a:ln>
         </p:spPr>
-        <p:txBody>
-          <a:bodyPr/>
-          <a:lstStyle/>
-          <a:p>
-            <a:endParaRPr lang="en-US"/>
-          </a:p>
-        </p:txBody>
       </p:sp>
       <p:sp>
         <p:nvSpPr>
@@ -6226,13 +5988,6 @@
             </a:outerShdw>
           </a:effectLst>
         </p:spPr>
-        <p:txBody>
-          <a:bodyPr/>
-          <a:lstStyle/>
-          <a:p>
-            <a:endParaRPr lang="en-US"/>
-          </a:p>
-        </p:txBody>
       </p:sp>
       <p:pic>
         <p:nvPicPr>
@@ -6384,13 +6139,6 @@
             <a:prstDash val="solid"/>
           </a:ln>
         </p:spPr>
-        <p:txBody>
-          <a:bodyPr/>
-          <a:lstStyle/>
-          <a:p>
-            <a:endParaRPr lang="en-US"/>
-          </a:p>
-        </p:txBody>
       </p:sp>
       <p:sp>
         <p:nvSpPr>
@@ -6416,13 +6164,6 @@
             <a:prstDash val="solid"/>
           </a:ln>
         </p:spPr>
-        <p:txBody>
-          <a:bodyPr/>
-          <a:lstStyle/>
-          <a:p>
-            <a:endParaRPr lang="en-US"/>
-          </a:p>
-        </p:txBody>
       </p:sp>
       <p:sp>
         <p:nvSpPr>
@@ -6457,13 +6198,6 @@
             </a:outerShdw>
           </a:effectLst>
         </p:spPr>
-        <p:txBody>
-          <a:bodyPr/>
-          <a:lstStyle/>
-          <a:p>
-            <a:endParaRPr lang="en-US"/>
-          </a:p>
-        </p:txBody>
       </p:sp>
       <p:pic>
         <p:nvPicPr>
@@ -6615,13 +6349,6 @@
             <a:prstDash val="solid"/>
           </a:ln>
         </p:spPr>
-        <p:txBody>
-          <a:bodyPr/>
-          <a:lstStyle/>
-          <a:p>
-            <a:endParaRPr lang="en-US"/>
-          </a:p>
-        </p:txBody>
       </p:sp>
       <p:sp>
         <p:nvSpPr>
@@ -6647,13 +6374,6 @@
             <a:prstDash val="solid"/>
           </a:ln>
         </p:spPr>
-        <p:txBody>
-          <a:bodyPr/>
-          <a:lstStyle/>
-          <a:p>
-            <a:endParaRPr lang="en-US"/>
-          </a:p>
-        </p:txBody>
       </p:sp>
       <p:sp>
         <p:nvSpPr>
@@ -6688,13 +6408,6 @@
             </a:outerShdw>
           </a:effectLst>
         </p:spPr>
-        <p:txBody>
-          <a:bodyPr/>
-          <a:lstStyle/>
-          <a:p>
-            <a:endParaRPr lang="en-US"/>
-          </a:p>
-        </p:txBody>
       </p:sp>
       <p:pic>
         <p:nvPicPr>
@@ -6846,13 +6559,6 @@
             <a:prstDash val="solid"/>
           </a:ln>
         </p:spPr>
-        <p:txBody>
-          <a:bodyPr/>
-          <a:lstStyle/>
-          <a:p>
-            <a:endParaRPr lang="en-US"/>
-          </a:p>
-        </p:txBody>
       </p:sp>
       <p:sp>
         <p:nvSpPr>
@@ -6878,13 +6584,6 @@
             <a:prstDash val="solid"/>
           </a:ln>
         </p:spPr>
-        <p:txBody>
-          <a:bodyPr/>
-          <a:lstStyle/>
-          <a:p>
-            <a:endParaRPr lang="en-US"/>
-          </a:p>
-        </p:txBody>
       </p:sp>
       <p:sp>
         <p:nvSpPr>
@@ -6919,13 +6618,6 @@
             </a:outerShdw>
           </a:effectLst>
         </p:spPr>
-        <p:txBody>
-          <a:bodyPr/>
-          <a:lstStyle/>
-          <a:p>
-            <a:endParaRPr lang="en-US"/>
-          </a:p>
-        </p:txBody>
       </p:sp>
       <p:pic>
         <p:nvPicPr>
@@ -7077,13 +6769,6 @@
             <a:prstDash val="solid"/>
           </a:ln>
         </p:spPr>
-        <p:txBody>
-          <a:bodyPr/>
-          <a:lstStyle/>
-          <a:p>
-            <a:endParaRPr lang="en-US"/>
-          </a:p>
-        </p:txBody>
       </p:sp>
       <p:sp>
         <p:nvSpPr>
@@ -7109,13 +6794,6 @@
             <a:prstDash val="solid"/>
           </a:ln>
         </p:spPr>
-        <p:txBody>
-          <a:bodyPr/>
-          <a:lstStyle/>
-          <a:p>
-            <a:endParaRPr lang="en-US"/>
-          </a:p>
-        </p:txBody>
       </p:sp>
       <p:sp>
         <p:nvSpPr>
@@ -7150,13 +6828,6 @@
             </a:outerShdw>
           </a:effectLst>
         </p:spPr>
-        <p:txBody>
-          <a:bodyPr/>
-          <a:lstStyle/>
-          <a:p>
-            <a:endParaRPr lang="en-US"/>
-          </a:p>
-        </p:txBody>
       </p:sp>
       <p:pic>
         <p:nvPicPr>
@@ -7284,13 +6955,6 @@
             <a:prstDash val="solid"/>
           </a:ln>
         </p:spPr>
-        <p:txBody>
-          <a:bodyPr/>
-          <a:lstStyle/>
-          <a:p>
-            <a:endParaRPr lang="en-US"/>
-          </a:p>
-        </p:txBody>
       </p:sp>
       <p:sp>
         <p:nvSpPr>
@@ -7316,13 +6980,6 @@
             <a:prstDash val="solid"/>
           </a:ln>
         </p:spPr>
-        <p:txBody>
-          <a:bodyPr/>
-          <a:lstStyle/>
-          <a:p>
-            <a:endParaRPr lang="en-US"/>
-          </a:p>
-        </p:txBody>
       </p:sp>
       <p:sp>
         <p:nvSpPr>
@@ -7661,13 +7318,6 @@
             <a:prstDash val="solid"/>
           </a:ln>
         </p:spPr>
-        <p:txBody>
-          <a:bodyPr/>
-          <a:lstStyle/>
-          <a:p>
-            <a:endParaRPr lang="en-US"/>
-          </a:p>
-        </p:txBody>
       </p:sp>
       <p:sp>
         <p:nvSpPr>
@@ -7693,13 +7343,6 @@
             <a:prstDash val="solid"/>
           </a:ln>
         </p:spPr>
-        <p:txBody>
-          <a:bodyPr/>
-          <a:lstStyle/>
-          <a:p>
-            <a:endParaRPr lang="en-US"/>
-          </a:p>
-        </p:txBody>
       </p:sp>
       <p:sp>
         <p:nvSpPr>
@@ -7841,13 +7484,6 @@
             <a:tailEnd type="triangle"/>
           </a:ln>
         </p:spPr>
-        <p:txBody>
-          <a:bodyPr/>
-          <a:lstStyle/>
-          <a:p>
-            <a:endParaRPr lang="en-US"/>
-          </a:p>
-        </p:txBody>
       </p:sp>
       <p:sp>
         <p:nvSpPr>
@@ -7873,13 +7509,6 @@
             <a:prstDash val="solid"/>
           </a:ln>
         </p:spPr>
-        <p:txBody>
-          <a:bodyPr/>
-          <a:lstStyle/>
-          <a:p>
-            <a:endParaRPr lang="en-US"/>
-          </a:p>
-        </p:txBody>
       </p:sp>
       <p:sp>
         <p:nvSpPr>
@@ -7905,13 +7534,6 @@
             <a:prstDash val="solid"/>
           </a:ln>
         </p:spPr>
-        <p:txBody>
-          <a:bodyPr/>
-          <a:lstStyle/>
-          <a:p>
-            <a:endParaRPr lang="en-US"/>
-          </a:p>
-        </p:txBody>
       </p:sp>
       <p:sp>
         <p:nvSpPr>
@@ -8280,13 +7902,6 @@
             <a:prstDash val="solid"/>
           </a:ln>
         </p:spPr>
-        <p:txBody>
-          <a:bodyPr/>
-          <a:lstStyle/>
-          <a:p>
-            <a:endParaRPr lang="en-US"/>
-          </a:p>
-        </p:txBody>
       </p:sp>
       <p:sp>
         <p:nvSpPr>
@@ -8540,13 +8155,6 @@
             <a:prstDash val="solid"/>
           </a:ln>
         </p:spPr>
-        <p:txBody>
-          <a:bodyPr/>
-          <a:lstStyle/>
-          <a:p>
-            <a:endParaRPr lang="en-US"/>
-          </a:p>
-        </p:txBody>
       </p:sp>
       <p:sp>
         <p:nvSpPr>
@@ -8572,13 +8180,6 @@
             <a:prstDash val="solid"/>
           </a:ln>
         </p:spPr>
-        <p:txBody>
-          <a:bodyPr/>
-          <a:lstStyle/>
-          <a:p>
-            <a:endParaRPr lang="en-US"/>
-          </a:p>
-        </p:txBody>
       </p:sp>
       <p:sp>
         <p:nvSpPr>
@@ -8799,13 +8400,6 @@
             <a:prstDash val="solid"/>
           </a:ln>
         </p:spPr>
-        <p:txBody>
-          <a:bodyPr/>
-          <a:lstStyle/>
-          <a:p>
-            <a:endParaRPr lang="en-US"/>
-          </a:p>
-        </p:txBody>
       </p:sp>
       <p:sp>
         <p:nvSpPr>
@@ -8831,13 +8425,6 @@
             <a:prstDash val="solid"/>
           </a:ln>
         </p:spPr>
-        <p:txBody>
-          <a:bodyPr/>
-          <a:lstStyle/>
-          <a:p>
-            <a:endParaRPr lang="en-US"/>
-          </a:p>
-        </p:txBody>
       </p:sp>
       <p:sp>
         <p:nvSpPr>
@@ -9214,13 +8801,6 @@
             <a:prstDash val="solid"/>
           </a:ln>
         </p:spPr>
-        <p:txBody>
-          <a:bodyPr/>
-          <a:lstStyle/>
-          <a:p>
-            <a:endParaRPr lang="en-US"/>
-          </a:p>
-        </p:txBody>
       </p:sp>
       <p:sp>
         <p:nvSpPr>
@@ -9246,13 +8826,6 @@
             <a:prstDash val="solid"/>
           </a:ln>
         </p:spPr>
-        <p:txBody>
-          <a:bodyPr/>
-          <a:lstStyle/>
-          <a:p>
-            <a:endParaRPr lang="en-US"/>
-          </a:p>
-        </p:txBody>
       </p:sp>
       <p:sp>
         <p:nvSpPr>
@@ -9395,13 +8968,6 @@
             <a:prstDash val="solid"/>
           </a:ln>
         </p:spPr>
-        <p:txBody>
-          <a:bodyPr/>
-          <a:lstStyle/>
-          <a:p>
-            <a:endParaRPr lang="en-US"/>
-          </a:p>
-        </p:txBody>
       </p:sp>
       <p:sp>
         <p:nvSpPr>
@@ -9427,13 +8993,6 @@
             <a:prstDash val="solid"/>
           </a:ln>
         </p:spPr>
-        <p:txBody>
-          <a:bodyPr/>
-          <a:lstStyle/>
-          <a:p>
-            <a:endParaRPr lang="en-US"/>
-          </a:p>
-        </p:txBody>
       </p:sp>
       <p:sp>
         <p:nvSpPr>
@@ -9732,13 +9291,6 @@
             <a:prstDash val="solid"/>
           </a:ln>
         </p:spPr>
-        <p:txBody>
-          <a:bodyPr/>
-          <a:lstStyle/>
-          <a:p>
-            <a:endParaRPr lang="en-US"/>
-          </a:p>
-        </p:txBody>
       </p:sp>
       <p:sp>
         <p:nvSpPr>
@@ -9953,13 +9505,6 @@
             <a:prstDash val="solid"/>
           </a:ln>
         </p:spPr>
-        <p:txBody>
-          <a:bodyPr/>
-          <a:lstStyle/>
-          <a:p>
-            <a:endParaRPr lang="en-US"/>
-          </a:p>
-        </p:txBody>
       </p:sp>
       <p:sp>
         <p:nvSpPr>
@@ -9985,13 +9530,6 @@
             <a:prstDash val="solid"/>
           </a:ln>
         </p:spPr>
-        <p:txBody>
-          <a:bodyPr/>
-          <a:lstStyle/>
-          <a:p>
-            <a:endParaRPr lang="en-US"/>
-          </a:p>
-        </p:txBody>
       </p:sp>
       <p:sp>
         <p:nvSpPr>
@@ -10134,13 +9672,6 @@
             <a:prstDash val="solid"/>
           </a:ln>
         </p:spPr>
-        <p:txBody>
-          <a:bodyPr/>
-          <a:lstStyle/>
-          <a:p>
-            <a:endParaRPr lang="en-US"/>
-          </a:p>
-        </p:txBody>
       </p:sp>
       <p:sp>
         <p:nvSpPr>
@@ -10166,13 +9697,6 @@
             <a:prstDash val="solid"/>
           </a:ln>
         </p:spPr>
-        <p:txBody>
-          <a:bodyPr/>
-          <a:lstStyle/>
-          <a:p>
-            <a:endParaRPr lang="en-US"/>
-          </a:p>
-        </p:txBody>
       </p:sp>
       <p:sp>
         <p:nvSpPr>
@@ -10315,13 +9839,6 @@
             <a:prstDash val="solid"/>
           </a:ln>
         </p:spPr>
-        <p:txBody>
-          <a:bodyPr/>
-          <a:lstStyle/>
-          <a:p>
-            <a:endParaRPr lang="en-US"/>
-          </a:p>
-        </p:txBody>
       </p:sp>
       <p:sp>
         <p:nvSpPr>
@@ -10347,13 +9864,6 @@
             <a:prstDash val="solid"/>
           </a:ln>
         </p:spPr>
-        <p:txBody>
-          <a:bodyPr/>
-          <a:lstStyle/>
-          <a:p>
-            <a:endParaRPr lang="en-US"/>
-          </a:p>
-        </p:txBody>
       </p:sp>
       <p:sp>
         <p:nvSpPr>
@@ -10496,13 +10006,6 @@
             <a:prstDash val="solid"/>
           </a:ln>
         </p:spPr>
-        <p:txBody>
-          <a:bodyPr/>
-          <a:lstStyle/>
-          <a:p>
-            <a:endParaRPr lang="en-US"/>
-          </a:p>
-        </p:txBody>
       </p:sp>
       <p:sp>
         <p:nvSpPr>
@@ -10528,13 +10031,6 @@
             <a:prstDash val="solid"/>
           </a:ln>
         </p:spPr>
-        <p:txBody>
-          <a:bodyPr/>
-          <a:lstStyle/>
-          <a:p>
-            <a:endParaRPr lang="en-US"/>
-          </a:p>
-        </p:txBody>
       </p:sp>
       <p:sp>
         <p:nvSpPr>
@@ -10716,13 +10212,6 @@
             <a:prstDash val="solid"/>
           </a:ln>
         </p:spPr>
-        <p:txBody>
-          <a:bodyPr/>
-          <a:lstStyle/>
-          <a:p>
-            <a:endParaRPr lang="en-US"/>
-          </a:p>
-        </p:txBody>
       </p:sp>
       <p:sp>
         <p:nvSpPr>
@@ -10826,13 +10315,6 @@
             <a:prstDash val="solid"/>
           </a:ln>
         </p:spPr>
-        <p:txBody>
-          <a:bodyPr/>
-          <a:lstStyle/>
-          <a:p>
-            <a:endParaRPr lang="en-US"/>
-          </a:p>
-        </p:txBody>
       </p:sp>
       <p:sp>
         <p:nvSpPr>
@@ -10936,13 +10418,6 @@
             <a:prstDash val="solid"/>
           </a:ln>
         </p:spPr>
-        <p:txBody>
-          <a:bodyPr/>
-          <a:lstStyle/>
-          <a:p>
-            <a:endParaRPr lang="en-US"/>
-          </a:p>
-        </p:txBody>
       </p:sp>
       <p:sp>
         <p:nvSpPr>
@@ -11046,13 +10521,6 @@
             <a:prstDash val="solid"/>
           </a:ln>
         </p:spPr>
-        <p:txBody>
-          <a:bodyPr/>
-          <a:lstStyle/>
-          <a:p>
-            <a:endParaRPr lang="en-US"/>
-          </a:p>
-        </p:txBody>
       </p:sp>
       <p:sp>
         <p:nvSpPr>
@@ -11156,13 +10624,6 @@
             <a:prstDash val="solid"/>
           </a:ln>
         </p:spPr>
-        <p:txBody>
-          <a:bodyPr/>
-          <a:lstStyle/>
-          <a:p>
-            <a:endParaRPr lang="en-US"/>
-          </a:p>
-        </p:txBody>
       </p:sp>
       <p:sp>
         <p:nvSpPr>
@@ -11266,13 +10727,6 @@
             <a:prstDash val="solid"/>
           </a:ln>
         </p:spPr>
-        <p:txBody>
-          <a:bodyPr/>
-          <a:lstStyle/>
-          <a:p>
-            <a:endParaRPr lang="en-US"/>
-          </a:p>
-        </p:txBody>
       </p:sp>
       <p:sp>
         <p:nvSpPr>
@@ -11298,13 +10752,6 @@
             <a:prstDash val="solid"/>
           </a:ln>
         </p:spPr>
-        <p:txBody>
-          <a:bodyPr/>
-          <a:lstStyle/>
-          <a:p>
-            <a:endParaRPr lang="en-US"/>
-          </a:p>
-        </p:txBody>
       </p:sp>
       <p:sp>
         <p:nvSpPr>
@@ -11597,13 +11044,6 @@
             <a:prstDash val="solid"/>
           </a:ln>
         </p:spPr>
-        <p:txBody>
-          <a:bodyPr/>
-          <a:lstStyle/>
-          <a:p>
-            <a:endParaRPr lang="en-US"/>
-          </a:p>
-        </p:txBody>
       </p:sp>
       <p:sp>
         <p:nvSpPr>
@@ -11746,13 +11186,6 @@
             <a:prstDash val="solid"/>
           </a:ln>
         </p:spPr>
-        <p:txBody>
-          <a:bodyPr/>
-          <a:lstStyle/>
-          <a:p>
-            <a:endParaRPr lang="en-US"/>
-          </a:p>
-        </p:txBody>
       </p:sp>
       <p:sp>
         <p:nvSpPr>
@@ -11895,13 +11328,6 @@
             <a:prstDash val="solid"/>
           </a:ln>
         </p:spPr>
-        <p:txBody>
-          <a:bodyPr/>
-          <a:lstStyle/>
-          <a:p>
-            <a:endParaRPr lang="en-US"/>
-          </a:p>
-        </p:txBody>
       </p:sp>
       <p:sp>
         <p:nvSpPr>
@@ -11936,7 +11362,7 @@
                 <a:ea typeface="Calibri" pitchFamily="34" charset="-122"/>
                 <a:cs typeface="Calibri" pitchFamily="34" charset="-120"/>
               </a:rPr>
-              <a:t>4×</a:t>
+              <a:t>1×</a:t>
             </a:r>
             <a:endParaRPr lang="en-US" sz="1300" dirty="0"/>
           </a:p>
@@ -11975,7 +11401,7 @@
                 <a:ea typeface="Calibri" pitchFamily="34" charset="-122"/>
                 <a:cs typeface="Calibri" pitchFamily="34" charset="-120"/>
               </a:rPr>
-              <a:t>Nano Service</a:t>
+              <a:t>Shared Database</a:t>
             </a:r>
             <a:endParaRPr lang="en-US" sz="1100" dirty="0"/>
           </a:p>
@@ -12014,7 +11440,7 @@
                 <a:ea typeface="Calibri" pitchFamily="34" charset="-122"/>
                 <a:cs typeface="Calibri" pitchFamily="34" charset="-120"/>
               </a:rPr>
-              <a:t>−3 each = −12</a:t>
+              <a:t>−5 each = −5</a:t>
             </a:r>
             <a:endParaRPr lang="en-US" sz="1000" dirty="0"/>
           </a:p>
@@ -12023,155 +11449,6 @@
       <p:sp>
         <p:nvSpPr>
           <p:cNvPr id="16" name="Shape 14"/>
-          <p:cNvSpPr/>
-          <p:nvPr/>
-        </p:nvSpPr>
-        <p:spPr>
-          <a:xfrm>
-            <a:off x="457200" y="2304288"/>
-            <a:ext cx="4114800" cy="329184"/>
-          </a:xfrm>
-          <a:prstGeom prst="rect">
-            <a:avLst/>
-          </a:prstGeom>
-          <a:solidFill>
-            <a:srgbClr val="F8FAFC"/>
-          </a:solidFill>
-          <a:ln w="6350">
-            <a:solidFill>
-              <a:srgbClr val="E2E8F0"/>
-            </a:solidFill>
-            <a:prstDash val="solid"/>
-          </a:ln>
-        </p:spPr>
-        <p:txBody>
-          <a:bodyPr/>
-          <a:lstStyle/>
-          <a:p>
-            <a:endParaRPr lang="en-US"/>
-          </a:p>
-        </p:txBody>
-      </p:sp>
-      <p:sp>
-        <p:nvSpPr>
-          <p:cNvPr id="17" name="Text 15"/>
-          <p:cNvSpPr/>
-          <p:nvPr/>
-        </p:nvSpPr>
-        <p:spPr>
-          <a:xfrm>
-            <a:off x="502920" y="2304288"/>
-            <a:ext cx="548640" cy="329184"/>
-          </a:xfrm>
-          <a:prstGeom prst="rect">
-            <a:avLst/>
-          </a:prstGeom>
-          <a:noFill/>
-          <a:ln/>
-        </p:spPr>
-        <p:txBody>
-          <a:bodyPr wrap="square" lIns="0" tIns="0" rIns="0" bIns="0" rtlCol="0" anchor="ctr"/>
-          <a:lstStyle/>
-          <a:p>
-            <a:pPr marL="0" indent="0" algn="ctr">
-              <a:buNone/>
-            </a:pPr>
-            <a:r>
-              <a:rPr lang="en-US" sz="1300" b="1" dirty="0">
-                <a:solidFill>
-                  <a:srgbClr val="DC2626"/>
-                </a:solidFill>
-                <a:latin typeface="Calibri" pitchFamily="34" charset="0"/>
-                <a:ea typeface="Calibri" pitchFamily="34" charset="-122"/>
-                <a:cs typeface="Calibri" pitchFamily="34" charset="-120"/>
-              </a:rPr>
-              <a:t>1×</a:t>
-            </a:r>
-            <a:endParaRPr lang="en-US" sz="1300" dirty="0"/>
-          </a:p>
-        </p:txBody>
-      </p:sp>
-      <p:sp>
-        <p:nvSpPr>
-          <p:cNvPr id="18" name="Text 16"/>
-          <p:cNvSpPr/>
-          <p:nvPr/>
-        </p:nvSpPr>
-        <p:spPr>
-          <a:xfrm>
-            <a:off x="1097280" y="2304288"/>
-            <a:ext cx="2103120" cy="329184"/>
-          </a:xfrm>
-          <a:prstGeom prst="rect">
-            <a:avLst/>
-          </a:prstGeom>
-          <a:noFill/>
-          <a:ln/>
-        </p:spPr>
-        <p:txBody>
-          <a:bodyPr wrap="square" lIns="0" tIns="0" rIns="0" bIns="0" rtlCol="0" anchor="ctr"/>
-          <a:lstStyle/>
-          <a:p>
-            <a:pPr marL="0" indent="0">
-              <a:buNone/>
-            </a:pPr>
-            <a:r>
-              <a:rPr lang="en-US" sz="1100" dirty="0">
-                <a:solidFill>
-                  <a:srgbClr val="1E293B"/>
-                </a:solidFill>
-                <a:latin typeface="Calibri" pitchFamily="34" charset="0"/>
-                <a:ea typeface="Calibri" pitchFamily="34" charset="-122"/>
-                <a:cs typeface="Calibri" pitchFamily="34" charset="-120"/>
-              </a:rPr>
-              <a:t>Shared Database</a:t>
-            </a:r>
-            <a:endParaRPr lang="en-US" sz="1100" dirty="0"/>
-          </a:p>
-        </p:txBody>
-      </p:sp>
-      <p:sp>
-        <p:nvSpPr>
-          <p:cNvPr id="19" name="Text 17"/>
-          <p:cNvSpPr/>
-          <p:nvPr/>
-        </p:nvSpPr>
-        <p:spPr>
-          <a:xfrm>
-            <a:off x="3200400" y="2304288"/>
-            <a:ext cx="1325880" cy="329184"/>
-          </a:xfrm>
-          <a:prstGeom prst="rect">
-            <a:avLst/>
-          </a:prstGeom>
-          <a:noFill/>
-          <a:ln/>
-        </p:spPr>
-        <p:txBody>
-          <a:bodyPr wrap="square" lIns="0" tIns="0" rIns="0" bIns="0" rtlCol="0" anchor="ctr"/>
-          <a:lstStyle/>
-          <a:p>
-            <a:pPr marL="0" indent="0" algn="r">
-              <a:buNone/>
-            </a:pPr>
-            <a:r>
-              <a:rPr lang="en-US" sz="1000" i="1" dirty="0">
-                <a:solidFill>
-                  <a:srgbClr val="64748B"/>
-                </a:solidFill>
-                <a:latin typeface="Calibri" pitchFamily="34" charset="0"/>
-                <a:ea typeface="Calibri" pitchFamily="34" charset="-122"/>
-                <a:cs typeface="Calibri" pitchFamily="34" charset="-120"/>
-              </a:rPr>
-              <a:t>−5 each = −5</a:t>
-            </a:r>
-            <a:endParaRPr lang="en-US" sz="1000" dirty="0"/>
-          </a:p>
-        </p:txBody>
-      </p:sp>
-      <p:sp>
-        <p:nvSpPr>
-          <p:cNvPr id="20" name="Shape 18"/>
           <p:cNvSpPr/>
           <p:nvPr/>
         </p:nvSpPr>
@@ -12193,17 +11470,10 @@
             <a:prstDash val="solid"/>
           </a:ln>
         </p:spPr>
-        <p:txBody>
-          <a:bodyPr/>
-          <a:lstStyle/>
-          <a:p>
-            <a:endParaRPr lang="en-US"/>
-          </a:p>
-        </p:txBody>
-      </p:sp>
-      <p:sp>
-        <p:nvSpPr>
-          <p:cNvPr id="21" name="Text 19"/>
+      </p:sp>
+      <p:sp>
+        <p:nvSpPr>
+          <p:cNvPr id="17" name="Text 15"/>
           <p:cNvSpPr/>
           <p:nvPr/>
         </p:nvSpPr>
@@ -12234,7 +11504,7 @@
                 <a:ea typeface="Calibri" pitchFamily="34" charset="-122"/>
                 <a:cs typeface="Calibri" pitchFamily="34" charset="-120"/>
               </a:rPr>
-              <a:t>Total penalty: 115   →   AP clamped at 0</a:t>
+              <a:t>Total penalty: 103   →   AP clamped at 0</a:t>
             </a:r>
             <a:endParaRPr lang="en-US" sz="1200" dirty="0"/>
           </a:p>
@@ -12242,7 +11512,7 @@
       </p:sp>
       <p:sp>
         <p:nvSpPr>
-          <p:cNvPr id="22" name="Text 20"/>
+          <p:cNvPr id="18" name="Text 16"/>
           <p:cNvSpPr/>
           <p:nvPr/>
         </p:nvSpPr>
@@ -12281,7 +11551,7 @@
       </p:sp>
       <p:sp>
         <p:nvSpPr>
-          <p:cNvPr id="23" name="Text 21"/>
+          <p:cNvPr id="19" name="Text 17"/>
           <p:cNvSpPr/>
           <p:nvPr/>
         </p:nvSpPr>
@@ -12320,7 +11590,7 @@
       </p:sp>
       <p:sp>
         <p:nvSpPr>
-          <p:cNvPr id="24" name="Shape 22"/>
+          <p:cNvPr id="20" name="Shape 18"/>
           <p:cNvSpPr/>
           <p:nvPr/>
         </p:nvSpPr>
@@ -12342,17 +11612,10 @@
             <a:prstDash val="solid"/>
           </a:ln>
         </p:spPr>
-        <p:txBody>
-          <a:bodyPr/>
-          <a:lstStyle/>
-          <a:p>
-            <a:endParaRPr lang="en-US"/>
-          </a:p>
-        </p:txBody>
-      </p:sp>
-      <p:sp>
-        <p:nvSpPr>
-          <p:cNvPr id="25" name="Text 23"/>
+      </p:sp>
+      <p:sp>
+        <p:nvSpPr>
+          <p:cNvPr id="21" name="Text 19"/>
           <p:cNvSpPr/>
           <p:nvPr/>
         </p:nvSpPr>
@@ -12391,7 +11654,7 @@
       </p:sp>
       <p:sp>
         <p:nvSpPr>
-          <p:cNvPr id="26" name="Text 24"/>
+          <p:cNvPr id="22" name="Text 20"/>
           <p:cNvSpPr/>
           <p:nvPr/>
         </p:nvSpPr>
@@ -12430,7 +11693,7 @@
       </p:sp>
       <p:sp>
         <p:nvSpPr>
-          <p:cNvPr id="27" name="Shape 25"/>
+          <p:cNvPr id="23" name="Shape 21"/>
           <p:cNvSpPr/>
           <p:nvPr/>
         </p:nvSpPr>
@@ -12452,17 +11715,10 @@
             <a:prstDash val="solid"/>
           </a:ln>
         </p:spPr>
-        <p:txBody>
-          <a:bodyPr/>
-          <a:lstStyle/>
-          <a:p>
-            <a:endParaRPr lang="en-US"/>
-          </a:p>
-        </p:txBody>
-      </p:sp>
-      <p:sp>
-        <p:nvSpPr>
-          <p:cNvPr id="28" name="Shape 26"/>
+      </p:sp>
+      <p:sp>
+        <p:nvSpPr>
+          <p:cNvPr id="24" name="Shape 22"/>
           <p:cNvSpPr/>
           <p:nvPr/>
         </p:nvSpPr>
@@ -12484,17 +11740,10 @@
             <a:prstDash val="solid"/>
           </a:ln>
         </p:spPr>
-        <p:txBody>
-          <a:bodyPr/>
-          <a:lstStyle/>
-          <a:p>
-            <a:endParaRPr lang="en-US"/>
-          </a:p>
-        </p:txBody>
-      </p:sp>
-      <p:sp>
-        <p:nvSpPr>
-          <p:cNvPr id="29" name="Text 27"/>
+      </p:sp>
+      <p:sp>
+        <p:nvSpPr>
+          <p:cNvPr id="25" name="Text 23"/>
           <p:cNvSpPr/>
           <p:nvPr/>
         </p:nvSpPr>
@@ -12533,7 +11782,7 @@
       </p:sp>
       <p:sp>
         <p:nvSpPr>
-          <p:cNvPr id="30" name="Text 28"/>
+          <p:cNvPr id="26" name="Text 24"/>
           <p:cNvSpPr/>
           <p:nvPr/>
         </p:nvSpPr>
@@ -12572,7 +11821,7 @@
       </p:sp>
       <p:sp>
         <p:nvSpPr>
-          <p:cNvPr id="31" name="Shape 29"/>
+          <p:cNvPr id="27" name="Shape 25"/>
           <p:cNvSpPr/>
           <p:nvPr/>
         </p:nvSpPr>
@@ -12594,17 +11843,10 @@
             <a:prstDash val="solid"/>
           </a:ln>
         </p:spPr>
-        <p:txBody>
-          <a:bodyPr/>
-          <a:lstStyle/>
-          <a:p>
-            <a:endParaRPr lang="en-US"/>
-          </a:p>
-        </p:txBody>
-      </p:sp>
-      <p:sp>
-        <p:nvSpPr>
-          <p:cNvPr id="32" name="Shape 30"/>
+      </p:sp>
+      <p:sp>
+        <p:nvSpPr>
+          <p:cNvPr id="28" name="Shape 26"/>
           <p:cNvSpPr/>
           <p:nvPr/>
         </p:nvSpPr>
@@ -12626,17 +11868,10 @@
             <a:prstDash val="solid"/>
           </a:ln>
         </p:spPr>
-        <p:txBody>
-          <a:bodyPr/>
-          <a:lstStyle/>
-          <a:p>
-            <a:endParaRPr lang="en-US"/>
-          </a:p>
-        </p:txBody>
-      </p:sp>
-      <p:sp>
-        <p:nvSpPr>
-          <p:cNvPr id="33" name="Text 31"/>
+      </p:sp>
+      <p:sp>
+        <p:nvSpPr>
+          <p:cNvPr id="29" name="Text 27"/>
           <p:cNvSpPr/>
           <p:nvPr/>
         </p:nvSpPr>
@@ -12675,7 +11910,7 @@
       </p:sp>
       <p:sp>
         <p:nvSpPr>
-          <p:cNvPr id="34" name="Text 32"/>
+          <p:cNvPr id="30" name="Text 28"/>
           <p:cNvSpPr/>
           <p:nvPr/>
         </p:nvSpPr>
@@ -12714,7 +11949,7 @@
       </p:sp>
       <p:sp>
         <p:nvSpPr>
-          <p:cNvPr id="35" name="Shape 33"/>
+          <p:cNvPr id="31" name="Shape 29"/>
           <p:cNvSpPr/>
           <p:nvPr/>
         </p:nvSpPr>
@@ -12736,17 +11971,10 @@
             <a:prstDash val="solid"/>
           </a:ln>
         </p:spPr>
-        <p:txBody>
-          <a:bodyPr/>
-          <a:lstStyle/>
-          <a:p>
-            <a:endParaRPr lang="en-US"/>
-          </a:p>
-        </p:txBody>
-      </p:sp>
-      <p:sp>
-        <p:nvSpPr>
-          <p:cNvPr id="36" name="Shape 34"/>
+      </p:sp>
+      <p:sp>
+        <p:nvSpPr>
+          <p:cNvPr id="32" name="Shape 30"/>
           <p:cNvSpPr/>
           <p:nvPr/>
         </p:nvSpPr>
@@ -12768,17 +11996,10 @@
             <a:prstDash val="solid"/>
           </a:ln>
         </p:spPr>
-        <p:txBody>
-          <a:bodyPr/>
-          <a:lstStyle/>
-          <a:p>
-            <a:endParaRPr lang="en-US"/>
-          </a:p>
-        </p:txBody>
-      </p:sp>
-      <p:sp>
-        <p:nvSpPr>
-          <p:cNvPr id="37" name="Text 35"/>
+      </p:sp>
+      <p:sp>
+        <p:nvSpPr>
+          <p:cNvPr id="33" name="Text 31"/>
           <p:cNvSpPr/>
           <p:nvPr/>
         </p:nvSpPr>
@@ -12817,7 +12038,7 @@
       </p:sp>
       <p:sp>
         <p:nvSpPr>
-          <p:cNvPr id="38" name="Shape 36"/>
+          <p:cNvPr id="34" name="Shape 32"/>
           <p:cNvSpPr/>
           <p:nvPr/>
         </p:nvSpPr>
@@ -12839,17 +12060,10 @@
             <a:prstDash val="solid"/>
           </a:ln>
         </p:spPr>
-        <p:txBody>
-          <a:bodyPr/>
-          <a:lstStyle/>
-          <a:p>
-            <a:endParaRPr lang="en-US"/>
-          </a:p>
-        </p:txBody>
-      </p:sp>
-      <p:sp>
-        <p:nvSpPr>
-          <p:cNvPr id="39" name="Text 37"/>
+      </p:sp>
+      <p:sp>
+        <p:nvSpPr>
+          <p:cNvPr id="35" name="Text 33"/>
           <p:cNvSpPr/>
           <p:nvPr/>
         </p:nvSpPr>
@@ -12888,7 +12102,7 @@
       </p:sp>
       <p:sp>
         <p:nvSpPr>
-          <p:cNvPr id="40" name="Text 38"/>
+          <p:cNvPr id="36" name="Text 34"/>
           <p:cNvSpPr/>
           <p:nvPr/>
         </p:nvSpPr>
@@ -12927,7 +12141,7 @@
       </p:sp>
       <p:sp>
         <p:nvSpPr>
-          <p:cNvPr id="41" name="Text 39"/>
+          <p:cNvPr id="37" name="Text 35"/>
           <p:cNvSpPr/>
           <p:nvPr/>
         </p:nvSpPr>
@@ -12966,7 +12180,7 @@
       </p:sp>
       <p:sp>
         <p:nvSpPr>
-          <p:cNvPr id="42" name="Text 40"/>
+          <p:cNvPr id="38" name="Text 36"/>
           <p:cNvSpPr/>
           <p:nvPr/>
         </p:nvSpPr>
@@ -13005,7 +12219,7 @@
       </p:sp>
       <p:sp>
         <p:nvSpPr>
-          <p:cNvPr id="43" name="Text 41"/>
+          <p:cNvPr id="39" name="Text 37"/>
           <p:cNvSpPr/>
           <p:nvPr/>
         </p:nvSpPr>
@@ -13044,7 +12258,7 @@
       </p:sp>
       <p:sp>
         <p:nvSpPr>
-          <p:cNvPr id="44" name="Text 42"/>
+          <p:cNvPr id="40" name="Text 38"/>
           <p:cNvSpPr/>
           <p:nvPr/>
         </p:nvSpPr>
@@ -13139,7 +12353,7 @@
               <a:buNone/>
             </a:pPr>
             <a:r>
-              <a:rPr lang="en-US" sz="2000" b="1" dirty="0">
+              <a:rPr lang="en-US" sz="2400" b="1" dirty="0">
                 <a:solidFill>
                   <a:srgbClr val="0F2A44"/>
                 </a:solidFill>
@@ -13149,7 +12363,7 @@
               </a:rPr>
               <a:t>Evaluation: eight open-source projects</a:t>
             </a:r>
-            <a:endParaRPr lang="en-US" sz="2000" dirty="0"/>
+            <a:endParaRPr lang="en-US" sz="2400" dirty="0"/>
           </a:p>
         </p:txBody>
       </p:sp>
@@ -13157,16 +12371,10 @@
         <p:nvGraphicFramePr>
           <p:cNvPr id="3" name="Chart 0"/>
           <p:cNvGraphicFramePr/>
-          <p:nvPr>
-            <p:extLst>
-              <p:ext uri="{D42A27DB-BD31-4B8C-83A1-F6EECF244321}">
-                <p14:modId xmlns:p14="http://schemas.microsoft.com/office/powerpoint/2010/main" val="1115883146"/>
-              </p:ext>
-            </p:extLst>
-          </p:nvPr>
+          <p:nvPr/>
         </p:nvGraphicFramePr>
         <p:xfrm>
-          <a:off x="155448" y="811203"/>
+          <a:off x="365760" y="868680"/>
           <a:ext cx="5394960" cy="2743200"/>
         </p:xfrm>
         <a:graphic>
@@ -13183,7 +12391,7 @@
         </p:nvSpPr>
         <p:spPr>
           <a:xfrm>
-            <a:off x="5852160" y="406908"/>
+            <a:off x="6190488" y="554845"/>
             <a:ext cx="2743200" cy="274320"/>
           </a:xfrm>
           <a:prstGeom prst="rect">
@@ -13222,7 +12430,7 @@
         </p:nvSpPr>
         <p:spPr>
           <a:xfrm>
-            <a:off x="5852160" y="772668"/>
+            <a:off x="6190488" y="920605"/>
             <a:ext cx="2743200" cy="274320"/>
           </a:xfrm>
           <a:prstGeom prst="rect">
@@ -13238,13 +12446,6 @@
             <a:prstDash val="solid"/>
           </a:ln>
         </p:spPr>
-        <p:txBody>
-          <a:bodyPr/>
-          <a:lstStyle/>
-          <a:p>
-            <a:endParaRPr lang="en-US"/>
-          </a:p>
-        </p:txBody>
       </p:sp>
       <p:sp>
         <p:nvSpPr>
@@ -13254,7 +12455,7 @@
         </p:nvSpPr>
         <p:spPr>
           <a:xfrm>
-            <a:off x="5943600" y="772668"/>
+            <a:off x="6281928" y="920605"/>
             <a:ext cx="1280160" cy="274320"/>
           </a:xfrm>
           <a:prstGeom prst="rect">
@@ -13293,7 +12494,7 @@
         </p:nvSpPr>
         <p:spPr>
           <a:xfrm>
-            <a:off x="7223760" y="772668"/>
+            <a:off x="7562088" y="920605"/>
             <a:ext cx="457200" cy="274320"/>
           </a:xfrm>
           <a:prstGeom prst="rect">
@@ -13332,7 +12533,7 @@
         </p:nvSpPr>
         <p:spPr>
           <a:xfrm>
-            <a:off x="7680960" y="772668"/>
+            <a:off x="8019288" y="920605"/>
             <a:ext cx="868680" cy="274320"/>
           </a:xfrm>
           <a:prstGeom prst="rect">
@@ -13371,7 +12572,7 @@
         </p:nvSpPr>
         <p:spPr>
           <a:xfrm>
-            <a:off x="5852160" y="1083564"/>
+            <a:off x="6190488" y="1231501"/>
             <a:ext cx="2743200" cy="274320"/>
           </a:xfrm>
           <a:prstGeom prst="rect">
@@ -13387,13 +12588,6 @@
             <a:prstDash val="solid"/>
           </a:ln>
         </p:spPr>
-        <p:txBody>
-          <a:bodyPr/>
-          <a:lstStyle/>
-          <a:p>
-            <a:endParaRPr lang="en-US"/>
-          </a:p>
-        </p:txBody>
       </p:sp>
       <p:sp>
         <p:nvSpPr>
@@ -13403,7 +12597,7 @@
         </p:nvSpPr>
         <p:spPr>
           <a:xfrm>
-            <a:off x="5943600" y="1083564"/>
+            <a:off x="6281928" y="1231501"/>
             <a:ext cx="1280160" cy="274320"/>
           </a:xfrm>
           <a:prstGeom prst="rect">
@@ -13442,7 +12636,7 @@
         </p:nvSpPr>
         <p:spPr>
           <a:xfrm>
-            <a:off x="7223760" y="1083564"/>
+            <a:off x="7562088" y="1231501"/>
             <a:ext cx="457200" cy="274320"/>
           </a:xfrm>
           <a:prstGeom prst="rect">
@@ -13481,7 +12675,7 @@
         </p:nvSpPr>
         <p:spPr>
           <a:xfrm>
-            <a:off x="7680960" y="1083564"/>
+            <a:off x="8019288" y="1231501"/>
             <a:ext cx="868680" cy="274320"/>
           </a:xfrm>
           <a:prstGeom prst="rect">
@@ -13520,7 +12714,7 @@
         </p:nvSpPr>
         <p:spPr>
           <a:xfrm>
-            <a:off x="5852160" y="1394460"/>
+            <a:off x="6190488" y="1542397"/>
             <a:ext cx="2743200" cy="274320"/>
           </a:xfrm>
           <a:prstGeom prst="rect">
@@ -13536,13 +12730,6 @@
             <a:prstDash val="solid"/>
           </a:ln>
         </p:spPr>
-        <p:txBody>
-          <a:bodyPr/>
-          <a:lstStyle/>
-          <a:p>
-            <a:endParaRPr lang="en-US"/>
-          </a:p>
-        </p:txBody>
       </p:sp>
       <p:sp>
         <p:nvSpPr>
@@ -13552,7 +12739,7 @@
         </p:nvSpPr>
         <p:spPr>
           <a:xfrm>
-            <a:off x="5943600" y="1394460"/>
+            <a:off x="6281928" y="1542397"/>
             <a:ext cx="1280160" cy="274320"/>
           </a:xfrm>
           <a:prstGeom prst="rect">
@@ -13591,7 +12778,7 @@
         </p:nvSpPr>
         <p:spPr>
           <a:xfrm>
-            <a:off x="7223760" y="1394460"/>
+            <a:off x="7562088" y="1542397"/>
             <a:ext cx="457200" cy="274320"/>
           </a:xfrm>
           <a:prstGeom prst="rect">
@@ -13630,7 +12817,7 @@
         </p:nvSpPr>
         <p:spPr>
           <a:xfrm>
-            <a:off x="7680960" y="1394460"/>
+            <a:off x="8019288" y="1542397"/>
             <a:ext cx="868680" cy="274320"/>
           </a:xfrm>
           <a:prstGeom prst="rect">
@@ -13669,7 +12856,7 @@
         </p:nvSpPr>
         <p:spPr>
           <a:xfrm>
-            <a:off x="5852160" y="1705356"/>
+            <a:off x="6190488" y="1853293"/>
             <a:ext cx="2743200" cy="274320"/>
           </a:xfrm>
           <a:prstGeom prst="rect">
@@ -13685,13 +12872,6 @@
             <a:prstDash val="solid"/>
           </a:ln>
         </p:spPr>
-        <p:txBody>
-          <a:bodyPr/>
-          <a:lstStyle/>
-          <a:p>
-            <a:endParaRPr lang="en-US"/>
-          </a:p>
-        </p:txBody>
       </p:sp>
       <p:sp>
         <p:nvSpPr>
@@ -13701,7 +12881,7 @@
         </p:nvSpPr>
         <p:spPr>
           <a:xfrm>
-            <a:off x="5943600" y="1705356"/>
+            <a:off x="6281928" y="1853293"/>
             <a:ext cx="1280160" cy="274320"/>
           </a:xfrm>
           <a:prstGeom prst="rect">
@@ -13740,7 +12920,7 @@
         </p:nvSpPr>
         <p:spPr>
           <a:xfrm>
-            <a:off x="7223760" y="1705356"/>
+            <a:off x="7562088" y="1853293"/>
             <a:ext cx="457200" cy="274320"/>
           </a:xfrm>
           <a:prstGeom prst="rect">
@@ -13779,7 +12959,7 @@
         </p:nvSpPr>
         <p:spPr>
           <a:xfrm>
-            <a:off x="7680960" y="1705356"/>
+            <a:off x="8019288" y="1853293"/>
             <a:ext cx="868680" cy="274320"/>
           </a:xfrm>
           <a:prstGeom prst="rect">
@@ -13818,7 +12998,7 @@
         </p:nvSpPr>
         <p:spPr>
           <a:xfrm>
-            <a:off x="5852160" y="2016252"/>
+            <a:off x="6190488" y="2164189"/>
             <a:ext cx="2743200" cy="274320"/>
           </a:xfrm>
           <a:prstGeom prst="rect">
@@ -13834,13 +13014,6 @@
             <a:prstDash val="solid"/>
           </a:ln>
         </p:spPr>
-        <p:txBody>
-          <a:bodyPr/>
-          <a:lstStyle/>
-          <a:p>
-            <a:endParaRPr lang="en-US"/>
-          </a:p>
-        </p:txBody>
       </p:sp>
       <p:sp>
         <p:nvSpPr>
@@ -13850,7 +13023,7 @@
         </p:nvSpPr>
         <p:spPr>
           <a:xfrm>
-            <a:off x="5943600" y="2016252"/>
+            <a:off x="6281928" y="2164189"/>
             <a:ext cx="1280160" cy="274320"/>
           </a:xfrm>
           <a:prstGeom prst="rect">
@@ -13889,7 +13062,7 @@
         </p:nvSpPr>
         <p:spPr>
           <a:xfrm>
-            <a:off x="7223760" y="2016252"/>
+            <a:off x="7562088" y="2164189"/>
             <a:ext cx="457200" cy="274320"/>
           </a:xfrm>
           <a:prstGeom prst="rect">
@@ -13928,7 +13101,7 @@
         </p:nvSpPr>
         <p:spPr>
           <a:xfrm>
-            <a:off x="7680960" y="2016252"/>
+            <a:off x="8019288" y="2164189"/>
             <a:ext cx="868680" cy="274320"/>
           </a:xfrm>
           <a:prstGeom prst="rect">
@@ -13953,7 +13126,7 @@
                 <a:ea typeface="Calibri" pitchFamily="34" charset="-122"/>
                 <a:cs typeface="Calibri" pitchFamily="34" charset="-120"/>
               </a:rPr>
-              <a:t>38k</a:t>
+              <a:t>36k</a:t>
             </a:r>
             <a:endParaRPr lang="en-US" sz="950" dirty="0"/>
           </a:p>
@@ -13967,7 +13140,7 @@
         </p:nvSpPr>
         <p:spPr>
           <a:xfrm>
-            <a:off x="5852160" y="2327148"/>
+            <a:off x="6190488" y="2475085"/>
             <a:ext cx="2743200" cy="274320"/>
           </a:xfrm>
           <a:prstGeom prst="rect">
@@ -13983,13 +13156,6 @@
             <a:prstDash val="solid"/>
           </a:ln>
         </p:spPr>
-        <p:txBody>
-          <a:bodyPr/>
-          <a:lstStyle/>
-          <a:p>
-            <a:endParaRPr lang="en-US"/>
-          </a:p>
-        </p:txBody>
       </p:sp>
       <p:sp>
         <p:nvSpPr>
@@ -13999,7 +13165,7 @@
         </p:nvSpPr>
         <p:spPr>
           <a:xfrm>
-            <a:off x="5943600" y="2327148"/>
+            <a:off x="6281928" y="2475085"/>
             <a:ext cx="1280160" cy="274320"/>
           </a:xfrm>
           <a:prstGeom prst="rect">
@@ -14038,7 +13204,7 @@
         </p:nvSpPr>
         <p:spPr>
           <a:xfrm>
-            <a:off x="7223760" y="2327148"/>
+            <a:off x="7562088" y="2475085"/>
             <a:ext cx="457200" cy="274320"/>
           </a:xfrm>
           <a:prstGeom prst="rect">
@@ -14077,7 +13243,7 @@
         </p:nvSpPr>
         <p:spPr>
           <a:xfrm>
-            <a:off x="7680960" y="2327148"/>
+            <a:off x="8019288" y="2475085"/>
             <a:ext cx="868680" cy="274320"/>
           </a:xfrm>
           <a:prstGeom prst="rect">
@@ -14116,7 +13282,7 @@
         </p:nvSpPr>
         <p:spPr>
           <a:xfrm>
-            <a:off x="5852160" y="2638044"/>
+            <a:off x="6190488" y="2785981"/>
             <a:ext cx="2743200" cy="274320"/>
           </a:xfrm>
           <a:prstGeom prst="rect">
@@ -14132,13 +13298,6 @@
             <a:prstDash val="solid"/>
           </a:ln>
         </p:spPr>
-        <p:txBody>
-          <a:bodyPr/>
-          <a:lstStyle/>
-          <a:p>
-            <a:endParaRPr lang="en-US"/>
-          </a:p>
-        </p:txBody>
       </p:sp>
       <p:sp>
         <p:nvSpPr>
@@ -14148,7 +13307,7 @@
         </p:nvSpPr>
         <p:spPr>
           <a:xfrm>
-            <a:off x="5943600" y="2638044"/>
+            <a:off x="6281928" y="2785981"/>
             <a:ext cx="1280160" cy="274320"/>
           </a:xfrm>
           <a:prstGeom prst="rect">
@@ -14187,7 +13346,7 @@
         </p:nvSpPr>
         <p:spPr>
           <a:xfrm>
-            <a:off x="7223760" y="2638044"/>
+            <a:off x="7562088" y="2785981"/>
             <a:ext cx="457200" cy="274320"/>
           </a:xfrm>
           <a:prstGeom prst="rect">
@@ -14226,7 +13385,7 @@
         </p:nvSpPr>
         <p:spPr>
           <a:xfrm>
-            <a:off x="7680960" y="2638044"/>
+            <a:off x="8019288" y="2785981"/>
             <a:ext cx="868680" cy="274320"/>
           </a:xfrm>
           <a:prstGeom prst="rect">
@@ -14265,7 +13424,7 @@
         </p:nvSpPr>
         <p:spPr>
           <a:xfrm>
-            <a:off x="5852160" y="2948940"/>
+            <a:off x="6190488" y="3096877"/>
             <a:ext cx="2743200" cy="274320"/>
           </a:xfrm>
           <a:prstGeom prst="rect">
@@ -14281,13 +13440,6 @@
             <a:prstDash val="solid"/>
           </a:ln>
         </p:spPr>
-        <p:txBody>
-          <a:bodyPr/>
-          <a:lstStyle/>
-          <a:p>
-            <a:endParaRPr lang="en-US"/>
-          </a:p>
-        </p:txBody>
       </p:sp>
       <p:sp>
         <p:nvSpPr>
@@ -14297,7 +13449,7 @@
         </p:nvSpPr>
         <p:spPr>
           <a:xfrm>
-            <a:off x="5943600" y="2948940"/>
+            <a:off x="6281928" y="3096877"/>
             <a:ext cx="1280160" cy="274320"/>
           </a:xfrm>
           <a:prstGeom prst="rect">
@@ -14336,7 +13488,7 @@
         </p:nvSpPr>
         <p:spPr>
           <a:xfrm>
-            <a:off x="7223760" y="2948940"/>
+            <a:off x="7562088" y="3096877"/>
             <a:ext cx="457200" cy="274320"/>
           </a:xfrm>
           <a:prstGeom prst="rect">
@@ -14375,7 +13527,7 @@
         </p:nvSpPr>
         <p:spPr>
           <a:xfrm>
-            <a:off x="7680960" y="2948940"/>
+            <a:off x="8019288" y="3096877"/>
             <a:ext cx="868680" cy="274320"/>
           </a:xfrm>
           <a:prstGeom prst="rect">
@@ -14414,7 +13566,7 @@
         </p:nvSpPr>
         <p:spPr>
           <a:xfrm>
-            <a:off x="5852160" y="3259836"/>
+            <a:off x="6190488" y="3407773"/>
             <a:ext cx="2743200" cy="274320"/>
           </a:xfrm>
           <a:prstGeom prst="rect">
@@ -14430,13 +13582,6 @@
             <a:prstDash val="solid"/>
           </a:ln>
         </p:spPr>
-        <p:txBody>
-          <a:bodyPr/>
-          <a:lstStyle/>
-          <a:p>
-            <a:endParaRPr lang="en-US"/>
-          </a:p>
-        </p:txBody>
       </p:sp>
       <p:sp>
         <p:nvSpPr>
@@ -14446,7 +13591,7 @@
         </p:nvSpPr>
         <p:spPr>
           <a:xfrm>
-            <a:off x="5943600" y="3259836"/>
+            <a:off x="6281928" y="3407773"/>
             <a:ext cx="1280160" cy="274320"/>
           </a:xfrm>
           <a:prstGeom prst="rect">
@@ -14485,7 +13630,7 @@
         </p:nvSpPr>
         <p:spPr>
           <a:xfrm>
-            <a:off x="7223760" y="3259836"/>
+            <a:off x="7562088" y="3407773"/>
             <a:ext cx="457200" cy="274320"/>
           </a:xfrm>
           <a:prstGeom prst="rect">
@@ -14510,7 +13655,7 @@
                 <a:ea typeface="Calibri" pitchFamily="34" charset="-122"/>
                 <a:cs typeface="Calibri" pitchFamily="34" charset="-120"/>
               </a:rPr>
-              <a:t>115</a:t>
+              <a:t>116</a:t>
             </a:r>
             <a:endParaRPr lang="en-US" sz="950" dirty="0"/>
           </a:p>
@@ -14524,7 +13669,7 @@
         </p:nvSpPr>
         <p:spPr>
           <a:xfrm>
-            <a:off x="7680960" y="3259836"/>
+            <a:off x="8019288" y="3407773"/>
             <a:ext cx="868680" cy="274320"/>
           </a:xfrm>
           <a:prstGeom prst="rect">
@@ -14579,13 +13724,6 @@
             <a:prstDash val="solid"/>
           </a:ln>
         </p:spPr>
-        <p:txBody>
-          <a:bodyPr/>
-          <a:lstStyle/>
-          <a:p>
-            <a:endParaRPr lang="en-US"/>
-          </a:p>
-        </p:txBody>
       </p:sp>
       <p:sp>
         <p:nvSpPr>
@@ -14611,13 +13749,6 @@
             <a:prstDash val="solid"/>
           </a:ln>
         </p:spPr>
-        <p:txBody>
-          <a:bodyPr/>
-          <a:lstStyle/>
-          <a:p>
-            <a:endParaRPr lang="en-US"/>
-          </a:p>
-        </p:txBody>
       </p:sp>
       <p:sp>
         <p:nvSpPr>
@@ -15114,39 +14245,39 @@
         <a:sysClr val="window" lastClr="FFFFFF"/>
       </a:lt1>
       <a:dk2>
-        <a:srgbClr val="0E2841"/>
+        <a:srgbClr val="44546A"/>
       </a:dk2>
       <a:lt2>
-        <a:srgbClr val="E8E8E8"/>
+        <a:srgbClr val="E7E6E6"/>
       </a:lt2>
       <a:accent1>
-        <a:srgbClr val="156082"/>
+        <a:srgbClr val="4472C4"/>
       </a:accent1>
       <a:accent2>
-        <a:srgbClr val="E97132"/>
+        <a:srgbClr val="ED7D31"/>
       </a:accent2>
       <a:accent3>
-        <a:srgbClr val="196B24"/>
+        <a:srgbClr val="A5A5A5"/>
       </a:accent3>
       <a:accent4>
-        <a:srgbClr val="0F9ED5"/>
+        <a:srgbClr val="FFC000"/>
       </a:accent4>
       <a:accent5>
-        <a:srgbClr val="A02B93"/>
+        <a:srgbClr val="5B9BD5"/>
       </a:accent5>
       <a:accent6>
-        <a:srgbClr val="4EA72E"/>
+        <a:srgbClr val="70AD47"/>
       </a:accent6>
       <a:hlink>
-        <a:srgbClr val="467886"/>
+        <a:srgbClr val="0563C1"/>
       </a:hlink>
       <a:folHlink>
-        <a:srgbClr val="96607D"/>
+        <a:srgbClr val="954F72"/>
       </a:folHlink>
     </a:clrScheme>
     <a:fontScheme name="Office">
       <a:majorFont>
-        <a:latin typeface="Aptos Display" panose="02110004020202020204"/>
+        <a:latin typeface="Calibri Light" panose="020F0302020204030204"/>
         <a:ea typeface=""/>
         <a:cs typeface=""/>
         <a:font script="Jpan" typeface="游ゴシック Light"/>
@@ -15198,7 +14329,7 @@
         <a:font script="Tfng" typeface="Ebrima"/>
       </a:majorFont>
       <a:minorFont>
-        <a:latin typeface="Aptos" panose="02110004020202020204"/>
+        <a:latin typeface="Calibri" panose="020F0502020204030204"/>
         <a:ea typeface=""/>
         <a:cs typeface=""/>
         <a:font script="Jpan" typeface="游ゴシック"/>
@@ -15309,6 +14440,13 @@
         </a:gradFill>
       </a:fillStyleLst>
       <a:lnStyleLst>
+        <a:ln w="6350" cap="flat" cmpd="sng" algn="ctr">
+          <a:solidFill>
+            <a:schemeClr val="phClr"/>
+          </a:solidFill>
+          <a:prstDash val="solid"/>
+          <a:miter lim="800000"/>
+        </a:ln>
         <a:ln w="12700" cap="flat" cmpd="sng" algn="ctr">
           <a:solidFill>
             <a:schemeClr val="phClr"/>
@@ -15317,13 +14455,6 @@
           <a:miter lim="800000"/>
         </a:ln>
         <a:ln w="19050" cap="flat" cmpd="sng" algn="ctr">
-          <a:solidFill>
-            <a:schemeClr val="phClr"/>
-          </a:solidFill>
-          <a:prstDash val="solid"/>
-          <a:miter lim="800000"/>
-        </a:ln>
-        <a:ln w="25400" cap="flat" cmpd="sng" algn="ctr">
           <a:solidFill>
             <a:schemeClr val="phClr"/>
           </a:solidFill>
@@ -15388,38 +14519,12 @@
       </a:bgFillStyleLst>
     </a:fmtScheme>
   </a:themeElements>
-  <a:objectDefaults>
-    <a:lnDef>
-      <a:spPr/>
-      <a:bodyPr/>
-      <a:lstStyle/>
-      <a:style>
-        <a:lnRef idx="2">
-          <a:schemeClr val="accent1"/>
-        </a:lnRef>
-        <a:fillRef idx="0">
-          <a:schemeClr val="accent1"/>
-        </a:fillRef>
-        <a:effectRef idx="1">
-          <a:schemeClr val="accent1"/>
-        </a:effectRef>
-        <a:fontRef idx="minor">
-          <a:schemeClr val="tx1"/>
-        </a:fontRef>
-      </a:style>
-    </a:lnDef>
-  </a:objectDefaults>
+  <a:objectDefaults/>
   <a:extraClrSchemeLst/>
   <a:extLst>
     <a:ext uri="{05A4C25C-085E-4340-85A3-A5531E510DB2}">
-      <thm15:themeFamily xmlns:thm15="http://schemas.microsoft.com/office/thememl/2012/main" name="Office Theme" id="{2E142A2C-CD16-42D6-873A-C26D2A0506FA}" vid="{1BDDFF52-6CD6-40A5-AB3C-68EB2F1E4D0A}"/>
+      <thm15:themeFamily xmlns:thm15="http://schemas.microsoft.com/office/thememl/2012/main" name="Office Theme" id="{62F939B6-93AF-4DB8-9C6B-D6C7DFDC589F}" vid="{4A3C46E8-61CC-4603-A589-7422A47A8E4A}"/>
     </a:ext>
   </a:extLst>
 </a:theme>
-</file>
-
-<file path=docMetadata/LabelInfo.xml><?xml version="1.0" encoding="utf-8"?>
-<clbl:labelList xmlns:clbl="http://schemas.microsoft.com/office/2020/mipLabelMetadata">
-  <clbl:label id="{9d258917-277f-42cd-a3cd-14c4e9ee58bc}" enabled="1" method="Standard" siteId="{38ae3bcd-9579-4fd4-adda-b42e1495d55a}" contentBits="0" removed="0"/>
-</clbl:labelList>
 </file>
</xml_diff>

<commit_message>
fix thesis and presentation
</commit_message>
<xml_diff>
--- a/thesis/presentation/MSA_Detector_Defense.pptx
+++ b/thesis/presentation/MSA_Detector_Defense.pptx
@@ -289,14 +289,14 @@
                   <c:v>40</c:v>
                 </c:pt>
                 <c:pt idx="8">
-                  <c:v>39</c:v>
+                  <c:v>40</c:v>
                 </c:pt>
               </c:numCache>
             </c:numRef>
           </c:val>
           <c:extLst>
             <c:ext xmlns:c16="http://schemas.microsoft.com/office/drawing/2014/chart" uri="{C3380CC4-5D6E-409C-BE32-E72D297353CC}">
-              <c16:uniqueId val="{00000000-A211-4552-8CE0-9773D6EE9BE6}"/>
+              <c16:uniqueId val="{00000000-CF31-4689-B556-3443DB4850DC}"/>
             </c:ext>
           </c:extLst>
         </c:ser>
@@ -458,7 +458,7 @@
     </p:spTree>
     <p:extLst>
       <p:ext uri="{BB962C8B-B14F-4D97-AF65-F5344CB8AC3E}">
-        <p14:creationId xmlns:p14="http://schemas.microsoft.com/office/powerpoint/2010/main" val="2212969424"/>
+        <p14:creationId xmlns:p14="http://schemas.microsoft.com/office/powerpoint/2010/main" val="1872310156"/>
       </p:ext>
     </p:extLst>
   </p:cSld>
@@ -1562,13 +1562,14 @@
               <a:rPr lang="en-US" dirty="0"/>
               <a:t>Spend ~75 seconds. This slide makes the scoring reproducible.
 Walk through it:
-• 'Take Train-Ticket — an academic benchmark with 41 microservices. In the anti-pattern category it has 26 hardcoded endpoints, 4 chatty services, and 1 shared database — total penalty 103, but the category caps at 40, so it clamps to zero.'
-• 'Its 4 nano services are scored under Service Sizing instead of the anti-pattern category, to avoid double counting — costing 8 points there.'
-• 'Code Quality now contributes a real deduction too: scored by smell density, its 1,565 code smells leave 8 of 20 points.'
-• 'The final composite is 40 — grade F. The decomposition shows the score is dominated by the anti-pattern load, chiefly the hardcoded URLs and chatty inter-service calls, with code-smell density a secondary contributor.'
+• 'Take microservice-recruit — a Spring Cloud recruitment platform. In the anti-pattern category it has 6 API versioning absences, 2 ESB misuse and 2 wrong-cuts findings, 1 cyclic dependency, and 1 hardcoded endpoint — total penalty 49, but the category caps at 40, so it clamps to zero.'
+• 'Its single nano service is scored under Service Sizing instead of the anti-pattern category, to avoid double counting — costing 3 points there, leaving 12 of 15.'
+• 'Architecture loses 9 points for the structural coupling of its dependency graph — leaving 16 of 25.'
+• 'Code Quality is scored by smell density: 260 smells over 8.3K LOC is 31.4 per KLOC, an 8-point deduction, leaving 12 of 20.'
+• 'The final composite is 0 + 12 + 16 + 12 = 40 — grade F. Unlike a project whose problems sit in one place, this one loses points in every dimension, which is exactly what the multi-level scoring is meant to surface.'
 This demonstrates that the scoring is transparent and that the breakdown shows exactly what's wrong.
-EXPECT QUESTION: 'Only 8 points lost on Code Quality with 1,565 smells — why so little?'
-Answer: 'Code Quality is scored on smell density per 1000 LOC, not raw count, so a large codebase isn't punished just for its size. The category is deliberately bounded so that architectural anti-patterns remain the dominant signal in the overall score.'</a:t>
+EXPECT QUESTION: 'Only 8 points lost on Code Quality with 260 smells — why so little?'
+Answer: 'Code Quality is scored on smell density per 1000 LOC, not raw count, so a codebase isn't punished just for its size. The category is deliberately bounded so that architectural anti-patterns remain the dominant signal in the overall score.'</a:t>
             </a:r>
           </a:p>
         </p:txBody>
@@ -1658,7 +1659,7 @@
               <a:t>Spend ~90 seconds.
 Talking points:
 • 'I evaluated on nine open-source Spring Boot projects, spanning from a 2k-LOC student project to mall-swarm at 86k LOC. 116 microservices, about 269k LOC total.'
-• 'Health scores ranged from 39 to 83 — the scoring mechanism produces meaningful spread.'
+• 'Health scores ranged from 40 to 83 — the scoring mechanism produces meaningful spread.'
 • 'The dominant findings are configuration and sizing issues: 43 hardcoded endpoints, 31 API versioning absences, 15 nano services. Cyclic Dependency and Wrong Cuts were detected in microservice-recruit — adding it exercised detectors that previously produced zero results.'
 • '108 total anti-pattern instances across 9 distinct types. Only Distributed Monolith was not detected — plausible given these projects' topologies.'
 EXPECT: 'Only nine projects, is that enough?'
@@ -2666,7 +2667,7 @@
                 <a:ea typeface="Calibri" pitchFamily="34" charset="-122"/>
                 <a:cs typeface="Calibri" pitchFamily="34" charset="-120"/>
               </a:rPr>
-              <a:t>Paste a public Git URL, submit, watch the pipeline progress.</a:t>
+              <a:t>Paste a public Git URL, submit, watch the pipeline progress</a:t>
             </a:r>
             <a:endParaRPr lang="en-US" sz="1100" dirty="0"/>
           </a:p>
@@ -2808,7 +2809,7 @@
                 <a:ea typeface="Calibri" pitchFamily="34" charset="-122"/>
                 <a:cs typeface="Calibri" pitchFamily="34" charset="-120"/>
               </a:rPr>
-              <a:t>Health score gauge, four-category breakdown, summary metrics.</a:t>
+              <a:t>Health score gauge, four-category breakdown, summary metrics</a:t>
             </a:r>
             <a:endParaRPr lang="en-US" sz="1100" dirty="0"/>
           </a:p>
@@ -2950,7 +2951,7 @@
                 <a:ea typeface="Calibri" pitchFamily="34" charset="-122"/>
                 <a:cs typeface="Calibri" pitchFamily="34" charset="-120"/>
               </a:rPr>
-              <a:t>Expand an anti-pattern card to see source-code evidence and remediation.</a:t>
+              <a:t>Expand an anti-pattern card to see source-code evidence and remediation</a:t>
             </a:r>
             <a:endParaRPr lang="en-US" sz="1100" dirty="0"/>
           </a:p>
@@ -3092,7 +3093,7 @@
                 <a:ea typeface="Calibri" pitchFamily="34" charset="-122"/>
                 <a:cs typeface="Calibri" pitchFamily="34" charset="-120"/>
               </a:rPr>
-              <a:t>Interactive Cytoscape view of inter-service edges.</a:t>
+              <a:t>Interactive Cytoscape view of inter-service edges</a:t>
             </a:r>
             <a:endParaRPr lang="en-US" sz="1100" dirty="0"/>
           </a:p>
@@ -3432,7 +3433,7 @@
                 <a:ea typeface="Calibri" pitchFamily="34" charset="-122"/>
                 <a:cs typeface="Calibri" pitchFamily="34" charset="-120"/>
               </a:rPr>
-              <a:t>Java / Spring Boot only; polyglot systems not supported.</a:t>
+              <a:t>Java / Spring Boot only =&gt; polyglot systems not yet supported</a:t>
             </a:r>
             <a:endParaRPr lang="en-US" sz="1150" dirty="0"/>
           </a:p>
@@ -3453,7 +3454,7 @@
                 <a:ea typeface="Calibri" pitchFamily="34" charset="-122"/>
                 <a:cs typeface="Calibri" pitchFamily="34" charset="-120"/>
               </a:rPr>
-              <a:t>Static analysis only — no runtime call frequency data.</a:t>
+              <a:t>Static analysis only =&gt; no runtime call frequency data</a:t>
             </a:r>
             <a:endParaRPr lang="en-US" sz="1150" dirty="0"/>
           </a:p>
@@ -3474,7 +3475,7 @@
                 <a:ea typeface="Calibri" pitchFamily="34" charset="-122"/>
                 <a:cs typeface="Calibri" pitchFamily="34" charset="-120"/>
               </a:rPr>
-              <a:t>Service detection deployability gate may miss services without framework annotations, Dockerfile, or main method.</a:t>
+              <a:t>Service detection deployability gate may miss services without framework annotations, Dockerfile, or main method</a:t>
             </a:r>
             <a:endParaRPr lang="en-US" sz="1150" dirty="0"/>
           </a:p>
@@ -3495,7 +3496,7 @@
                 <a:ea typeface="Calibri" pitchFamily="34" charset="-122"/>
                 <a:cs typeface="Calibri" pitchFamily="34" charset="-120"/>
               </a:rPr>
-              <a:t>Dynamic URLs (e.g. Spring Cloud Config) are not resolved.</a:t>
+              <a:t>Dynamic URLs (e.g. Spring Cloud Config) are not resolved</a:t>
             </a:r>
             <a:endParaRPr lang="en-US" sz="1150" dirty="0"/>
           </a:p>
@@ -3516,20 +3517,8 @@
                 <a:ea typeface="Calibri" pitchFamily="34" charset="-122"/>
                 <a:cs typeface="Calibri" pitchFamily="34" charset="-120"/>
               </a:rPr>
-              <a:t>Health score weights chosen by engineering judgement, not empirically </a:t>
-            </a:r>
-            <a:r>
-              <a:rPr lang="en-US" sz="1150">
-                <a:solidFill>
-                  <a:srgbClr val="1E293B"/>
-                </a:solidFill>
-                <a:latin typeface="Calibri" pitchFamily="34" charset="0"/>
-                <a:ea typeface="Calibri" pitchFamily="34" charset="-122"/>
-                <a:cs typeface="Calibri" pitchFamily="34" charset="-120"/>
-              </a:rPr>
-              <a:t>calibrated.</a:t>
-            </a:r>
-            <a:endParaRPr lang="en-US" sz="1150" dirty="0"/>
+              <a:t>Health score weights chosen by engineering judgement</a:t>
+            </a:r>
           </a:p>
         </p:txBody>
       </p:sp>
@@ -3717,7 +3706,7 @@
                 <a:ea typeface="Calibri" pitchFamily="34" charset="-122"/>
                 <a:cs typeface="Calibri" pitchFamily="34" charset="-120"/>
               </a:rPr>
-              <a:t>Multi-language support (Python, Go, .NET, Node.js) via language-agnostic dependency graphs from Docker Compose / Kubernetes manifests.</a:t>
+              <a:t>Multi-language support (Python, Go, .NET, Node.js) via language-agnostic dependency graphs from Docker Compose / Kubernetes manifests</a:t>
             </a:r>
             <a:endParaRPr lang="en-US" sz="1150" dirty="0"/>
           </a:p>
@@ -3738,7 +3727,7 @@
                 <a:ea typeface="Calibri" pitchFamily="34" charset="-122"/>
                 <a:cs typeface="Calibri" pitchFamily="34" charset="-120"/>
               </a:rPr>
-              <a:t>Extend anti-pattern catalogue (timeout misconfiguration, missing API gateway).</a:t>
+              <a:t>Extend anti-pattern catalogue (timeout misconfiguration, missing API gateway)</a:t>
             </a:r>
             <a:endParaRPr lang="en-US" sz="1150" dirty="0"/>
           </a:p>
@@ -3759,7 +3748,7 @@
                 <a:ea typeface="Calibri" pitchFamily="34" charset="-122"/>
                 <a:cs typeface="Calibri" pitchFamily="34" charset="-120"/>
               </a:rPr>
-              <a:t>ML-based detection: classifiers on labelled datasets or graph neural networks on the dependency graph.</a:t>
+              <a:t>ML-based detection: classifiers on labelled datasets or graph neural networks on the dependency graph</a:t>
             </a:r>
             <a:endParaRPr lang="en-US" sz="1150" dirty="0"/>
           </a:p>
@@ -3780,7 +3769,7 @@
                 <a:ea typeface="Calibri" pitchFamily="34" charset="-122"/>
                 <a:cs typeface="Calibri" pitchFamily="34" charset="-120"/>
               </a:rPr>
-              <a:t>Empirical threshold calibration across an industrial corpus.</a:t>
+              <a:t>Empirical threshold calibration across an industrial corpus</a:t>
             </a:r>
             <a:endParaRPr lang="en-US" sz="1150" dirty="0"/>
           </a:p>
@@ -4101,7 +4090,7 @@
                 <a:ea typeface="Calibri" pitchFamily="34" charset="-122"/>
                 <a:cs typeface="Calibri" pitchFamily="34" charset="-120"/>
               </a:rPr>
-              <a:t>Multi-level static analysis combining code smells and architectural metrics.</a:t>
+              <a:t>Multi-level static analysis combining code smells and architectural metrics</a:t>
             </a:r>
             <a:endParaRPr lang="en-US" sz="1300" dirty="0"/>
           </a:p>
@@ -4122,7 +4111,7 @@
                 <a:ea typeface="Calibri" pitchFamily="34" charset="-122"/>
                 <a:cs typeface="Calibri" pitchFamily="34" charset="-120"/>
               </a:rPr>
-              <a:t>Ten anti-patterns, configurable thresholds, evidence-based reporting.</a:t>
+              <a:t>Ten anti-patterns, configurable thresholds, evidence-based reporting</a:t>
             </a:r>
             <a:endParaRPr lang="en-US" sz="1300" dirty="0"/>
           </a:p>
@@ -4143,7 +4132,7 @@
                 <a:ea typeface="Calibri" pitchFamily="34" charset="-122"/>
                 <a:cs typeface="Calibri" pitchFamily="34" charset="-120"/>
               </a:rPr>
-              <a:t>Composite health score with four-category decomposition and analysis diff.</a:t>
+              <a:t>Composite health score with four-category decomposition and analysis diff</a:t>
             </a:r>
             <a:endParaRPr lang="en-US" sz="1300" dirty="0"/>
           </a:p>
@@ -4164,7 +4153,7 @@
                 <a:ea typeface="Calibri" pitchFamily="34" charset="-122"/>
                 <a:cs typeface="Calibri" pitchFamily="34" charset="-120"/>
               </a:rPr>
-              <a:t>Open-source web application, ready for CI/CD integration.</a:t>
+              <a:t>Open-source web application</a:t>
             </a:r>
             <a:endParaRPr lang="en-US" sz="1300" dirty="0"/>
           </a:p>
@@ -4500,7 +4489,7 @@
                 <a:ea typeface="Calibri" pitchFamily="34" charset="-122"/>
                 <a:cs typeface="Calibri" pitchFamily="34" charset="-120"/>
               </a:rPr>
-              <a:t>Shared databases, cyclic dependencies, and ill-sized services erode the benefits microservices promise.</a:t>
+              <a:t>Shared databases, cyclic dependencies, and ill-sized services erode the benefits microservices promise</a:t>
             </a:r>
             <a:endParaRPr lang="en-US" sz="1100" dirty="0"/>
           </a:p>
@@ -4686,7 +4675,7 @@
                 <a:ea typeface="Calibri" pitchFamily="34" charset="-122"/>
                 <a:cs typeface="Calibri" pitchFamily="34" charset="-120"/>
               </a:rPr>
-              <a:t>Arcan, MicroART, MSANose each cover a slice — code-level OR architectural-level, rarely both.</a:t>
+              <a:t>Arcan, MicroART, MSANose each cover a slice, either code-level OR architectural-level, rarely both</a:t>
             </a:r>
             <a:endParaRPr lang="en-US" sz="1100" dirty="0"/>
           </a:p>
@@ -4872,7 +4861,7 @@
                 <a:ea typeface="Calibri" pitchFamily="34" charset="-122"/>
                 <a:cs typeface="Calibri" pitchFamily="34" charset="-120"/>
               </a:rPr>
-              <a:t>Warnings without source snippets, affected services, or remediation guidance get ignored.</a:t>
+              <a:t>Warnings without source snippets, affected services, or remediation guidance get ignored</a:t>
             </a:r>
             <a:endParaRPr lang="en-US" sz="1100" dirty="0"/>
           </a:p>
@@ -4902,6 +4891,13 @@
             <a:prstDash val="solid"/>
           </a:ln>
         </p:spPr>
+        <p:txBody>
+          <a:bodyPr/>
+          <a:lstStyle/>
+          <a:p>
+            <a:endParaRPr lang="en-US" dirty="0"/>
+          </a:p>
+        </p:txBody>
       </p:sp>
       <p:sp>
         <p:nvSpPr>
@@ -4936,7 +4932,7 @@
                 <a:ea typeface="Calibri" pitchFamily="34" charset="-122"/>
                 <a:cs typeface="Calibri" pitchFamily="34" charset="-120"/>
               </a:rPr>
-              <a:t>Goal: actionable, evidence-based detection that bridges code and architecture levels.</a:t>
+              <a:t>Goal: actionable, evidence-based detection that bridges code and architecture levels</a:t>
             </a:r>
             <a:endParaRPr lang="en-US" sz="1200" dirty="0"/>
           </a:p>
@@ -5222,7 +5218,7 @@
                 <a:ea typeface="Calibri" pitchFamily="34" charset="-122"/>
                 <a:cs typeface="Calibri" pitchFamily="34" charset="-120"/>
               </a:rPr>
-              <a:t>Combines intra-service code smells (DesigniteJava) with inter-service dependency analysis (Spoon + graphs).</a:t>
+              <a:t>Combines intra-service code smells (DesigniteJava) with inter-service dependency analysis (Spoon + graphs)</a:t>
             </a:r>
             <a:endParaRPr lang="en-US" sz="1150" dirty="0"/>
           </a:p>
@@ -5358,7 +5354,7 @@
                 <a:ea typeface="Calibri" pitchFamily="34" charset="-122"/>
                 <a:cs typeface="Calibri" pitchFamily="34" charset="-120"/>
               </a:rPr>
-              <a:t>Across four dimensions: service design, communication, data management, deployment &amp; coupling.</a:t>
+              <a:t>Across four dimensions: service design, communication, data management, deployment &amp; coupling</a:t>
             </a:r>
             <a:endParaRPr lang="en-US" sz="1150" dirty="0"/>
           </a:p>
@@ -5494,7 +5490,7 @@
                 <a:ea typeface="Calibri" pitchFamily="34" charset="-122"/>
                 <a:cs typeface="Calibri" pitchFamily="34" charset="-120"/>
               </a:rPr>
-              <a:t>Three-signal deployability gate (framework entry point, Dockerfile, main method) with confidence levels.</a:t>
+              <a:t>Three-signal deployability gate (framework entry point, Dockerfile, main method) with confidence levels</a:t>
             </a:r>
             <a:endParaRPr lang="en-US" sz="1150" dirty="0"/>
           </a:p>
@@ -5630,7 +5626,7 @@
                 <a:ea typeface="Calibri" pitchFamily="34" charset="-122"/>
                 <a:cs typeface="Calibri" pitchFamily="34" charset="-120"/>
               </a:rPr>
-              <a:t>0–100 with letter grading; decomposes into four interpretable categories; tracks change over time.</a:t>
+              <a:t>0–100 with letter grading; decomposes into four interpretable categories =&gt; tracks change over time</a:t>
             </a:r>
             <a:endParaRPr lang="en-US" sz="1150" dirty="0"/>
           </a:p>
@@ -5766,7 +5762,7 @@
                 <a:ea typeface="Calibri" pitchFamily="34" charset="-122"/>
                 <a:cs typeface="Calibri" pitchFamily="34" charset="-120"/>
               </a:rPr>
-              <a:t>Every finding includes source snippets, affected services, and remediation guidance.</a:t>
+              <a:t>Every finding includes source snippets, affected services, and remediation guidance</a:t>
             </a:r>
             <a:endParaRPr lang="en-US" sz="1150" dirty="0"/>
           </a:p>
@@ -7074,7 +7070,27 @@
                 <a:ea typeface="Calibri" pitchFamily="34" charset="-122"/>
                 <a:cs typeface="Calibri" pitchFamily="34" charset="-120"/>
               </a:rPr>
-              <a:t>Async pipeline — long analyses don't block the API. Spring @Async with TransactionSynchronization.afterCommit() ensures consistency.</a:t>
+              <a:t>Async pipeline =&gt; long analyses don't block the API</a:t>
+            </a:r>
+          </a:p>
+          <a:p>
+            <a:pPr marL="800100" lvl="1" indent="-342900">
+              <a:spcAft>
+                <a:spcPts val="200"/>
+              </a:spcAft>
+              <a:buSzPct val="100000"/>
+              <a:buChar char="•"/>
+            </a:pPr>
+            <a:r>
+              <a:rPr lang="en-US" sz="1100" dirty="0">
+                <a:solidFill>
+                  <a:srgbClr val="1E293B"/>
+                </a:solidFill>
+                <a:latin typeface="Calibri" pitchFamily="34" charset="0"/>
+                <a:ea typeface="Calibri" pitchFamily="34" charset="-122"/>
+                <a:cs typeface="Calibri" pitchFamily="34" charset="-120"/>
+              </a:rPr>
+              <a:t>Spring @Async with TransactionSynchronization.afterCommit() ensures consistency</a:t>
             </a:r>
             <a:endParaRPr lang="en-US" sz="1100" dirty="0"/>
           </a:p>
@@ -7095,7 +7111,29 @@
                 <a:ea typeface="Calibri" pitchFamily="34" charset="-122"/>
                 <a:cs typeface="Calibri" pitchFamily="34" charset="-120"/>
               </a:rPr>
-              <a:t>Each detector is a Spring @Component implementing AntiPatternDetector — adding a new detector means no orchestrator changes.</a:t>
+              <a:t>Each detector is a Spring @Component implementing </a:t>
+            </a:r>
+            <a:r>
+              <a:rPr lang="en-US" sz="1100" dirty="0" err="1">
+                <a:solidFill>
+                  <a:srgbClr val="1E293B"/>
+                </a:solidFill>
+                <a:latin typeface="Calibri" pitchFamily="34" charset="0"/>
+                <a:ea typeface="Calibri" pitchFamily="34" charset="-122"/>
+                <a:cs typeface="Calibri" pitchFamily="34" charset="-120"/>
+              </a:rPr>
+              <a:t>AntiPatternDetector</a:t>
+            </a:r>
+            <a:r>
+              <a:rPr lang="en-US" sz="1100" dirty="0">
+                <a:solidFill>
+                  <a:srgbClr val="1E293B"/>
+                </a:solidFill>
+                <a:latin typeface="Calibri" pitchFamily="34" charset="0"/>
+                <a:ea typeface="Calibri" pitchFamily="34" charset="-122"/>
+                <a:cs typeface="Calibri" pitchFamily="34" charset="-120"/>
+              </a:rPr>
+              <a:t> =&gt; adding a new detector means no orchestrator changes</a:t>
             </a:r>
             <a:endParaRPr lang="en-US" sz="1100" dirty="0"/>
           </a:p>
@@ -7116,7 +7154,7 @@
                 <a:ea typeface="Calibri" pitchFamily="34" charset="-122"/>
                 <a:cs typeface="Calibri" pitchFamily="34" charset="-120"/>
               </a:rPr>
-              <a:t>Snippets are extracted and persisted as JSON during analysis, so results survive workspace cleanup.</a:t>
+              <a:t>Snippets are extracted and persisted as JSON during analysis, so results survive workspace cleanup</a:t>
             </a:r>
             <a:endParaRPr lang="en-US" sz="1100" dirty="0"/>
           </a:p>
@@ -7953,7 +7991,7 @@
                 <a:ea typeface="Calibri" pitchFamily="34" charset="-122"/>
                 <a:cs typeface="Calibri" pitchFamily="34" charset="-120"/>
               </a:rPr>
-              <a:t>Flag class as God Class if ≥ 3 of 6 thresholds exceeded.</a:t>
+              <a:t>Flag class as God Class if ≥ 3 of 6 thresholds exceeded</a:t>
             </a:r>
             <a:endParaRPr lang="en-US" sz="1100" dirty="0"/>
           </a:p>
@@ -7992,7 +8030,7 @@
                 <a:ea typeface="Calibri" pitchFamily="34" charset="-122"/>
                 <a:cs typeface="Calibri" pitchFamily="34" charset="-120"/>
               </a:rPr>
-              <a:t>Code-level evidence → architectural-level finding.</a:t>
+              <a:t>Code-level evidence → architectural-level finding</a:t>
             </a:r>
             <a:endParaRPr lang="en-US" sz="1100" dirty="0"/>
           </a:p>
@@ -9342,7 +9380,7 @@
                 <a:ea typeface="Calibri" pitchFamily="34" charset="-122"/>
                 <a:cs typeface="Calibri" pitchFamily="34" charset="-120"/>
               </a:rPr>
-              <a:t>All detectors are pluggable Strategy components with configurable thresholds.</a:t>
+              <a:t>All detectors are pluggable Strategy components with configurable thresholds</a:t>
             </a:r>
             <a:endParaRPr lang="en-US" sz="1100" dirty="0"/>
           </a:p>
@@ -10992,7 +11030,7 @@
                 <a:ea typeface="Calibri" pitchFamily="34" charset="-122"/>
                 <a:cs typeface="Calibri" pitchFamily="34" charset="-120"/>
               </a:rPr>
-              <a:t>Worked example: Train-Ticket (40 / F)</a:t>
+              <a:t>Worked example: microservice-recruit (40 / F)</a:t>
             </a:r>
             <a:endParaRPr lang="en-US" sz="2800" dirty="0"/>
           </a:p>
@@ -11045,8 +11083,8 @@
         </p:nvSpPr>
         <p:spPr>
           <a:xfrm>
-            <a:off x="457200" y="1207008"/>
-            <a:ext cx="4114800" cy="329184"/>
+            <a:off x="457200" y="1161288"/>
+            <a:ext cx="4114800" cy="283464"/>
           </a:xfrm>
           <a:prstGeom prst="rect">
             <a:avLst/>
@@ -11070,8 +11108,8 @@
         </p:nvSpPr>
         <p:spPr>
           <a:xfrm>
-            <a:off x="502920" y="1207008"/>
-            <a:ext cx="548640" cy="329184"/>
+            <a:off x="502920" y="1161288"/>
+            <a:ext cx="548640" cy="283464"/>
           </a:xfrm>
           <a:prstGeom prst="rect">
             <a:avLst/>
@@ -11087,7 +11125,7 @@
               <a:buNone/>
             </a:pPr>
             <a:r>
-              <a:rPr lang="en-US" sz="1300" b="1" dirty="0">
+              <a:rPr lang="en-US" sz="1200" b="1" dirty="0">
                 <a:solidFill>
                   <a:srgbClr val="DC2626"/>
                 </a:solidFill>
@@ -11095,9 +11133,9 @@
                 <a:ea typeface="Calibri" pitchFamily="34" charset="-122"/>
                 <a:cs typeface="Calibri" pitchFamily="34" charset="-120"/>
               </a:rPr>
-              <a:t>26×</a:t>
-            </a:r>
-            <a:endParaRPr lang="en-US" sz="1300" dirty="0"/>
+              <a:t>6×</a:t>
+            </a:r>
+            <a:endParaRPr lang="en-US" sz="1200" dirty="0"/>
           </a:p>
         </p:txBody>
       </p:sp>
@@ -11109,8 +11147,8 @@
         </p:nvSpPr>
         <p:spPr>
           <a:xfrm>
-            <a:off x="1097280" y="1207008"/>
-            <a:ext cx="2103120" cy="329184"/>
+            <a:off x="1097280" y="1161288"/>
+            <a:ext cx="2103120" cy="283464"/>
           </a:xfrm>
           <a:prstGeom prst="rect">
             <a:avLst/>
@@ -11134,7 +11172,7 @@
                 <a:ea typeface="Calibri" pitchFamily="34" charset="-122"/>
                 <a:cs typeface="Calibri" pitchFamily="34" charset="-120"/>
               </a:rPr>
-              <a:t>Hardcoded Endpoints</a:t>
+              <a:t>API Versioning Absence</a:t>
             </a:r>
             <a:endParaRPr lang="en-US" sz="1100" dirty="0"/>
           </a:p>
@@ -11148,8 +11186,8 @@
         </p:nvSpPr>
         <p:spPr>
           <a:xfrm>
-            <a:off x="3200400" y="1207008"/>
-            <a:ext cx="1325880" cy="329184"/>
+            <a:off x="3200400" y="1161288"/>
+            <a:ext cx="1325880" cy="283464"/>
           </a:xfrm>
           <a:prstGeom prst="rect">
             <a:avLst/>
@@ -11173,7 +11211,7 @@
                 <a:ea typeface="Calibri" pitchFamily="34" charset="-122"/>
                 <a:cs typeface="Calibri" pitchFamily="34" charset="-120"/>
               </a:rPr>
-              <a:t>−3 each = −78</a:t>
+              <a:t>−3 each = −18</a:t>
             </a:r>
             <a:endParaRPr lang="en-US" sz="1000" dirty="0"/>
           </a:p>
@@ -11187,8 +11225,8 @@
         </p:nvSpPr>
         <p:spPr>
           <a:xfrm>
-            <a:off x="457200" y="1572768"/>
-            <a:ext cx="4114800" cy="329184"/>
+            <a:off x="457200" y="1476756"/>
+            <a:ext cx="4114800" cy="283464"/>
           </a:xfrm>
           <a:prstGeom prst="rect">
             <a:avLst/>
@@ -11212,8 +11250,8 @@
         </p:nvSpPr>
         <p:spPr>
           <a:xfrm>
-            <a:off x="502920" y="1572768"/>
-            <a:ext cx="548640" cy="329184"/>
+            <a:off x="502920" y="1476756"/>
+            <a:ext cx="548640" cy="283464"/>
           </a:xfrm>
           <a:prstGeom prst="rect">
             <a:avLst/>
@@ -11229,7 +11267,7 @@
               <a:buNone/>
             </a:pPr>
             <a:r>
-              <a:rPr lang="en-US" sz="1300" b="1" dirty="0">
+              <a:rPr lang="en-US" sz="1200" b="1" dirty="0">
                 <a:solidFill>
                   <a:srgbClr val="DC2626"/>
                 </a:solidFill>
@@ -11237,9 +11275,9 @@
                 <a:ea typeface="Calibri" pitchFamily="34" charset="-122"/>
                 <a:cs typeface="Calibri" pitchFamily="34" charset="-120"/>
               </a:rPr>
-              <a:t>4×</a:t>
-            </a:r>
-            <a:endParaRPr lang="en-US" sz="1300" dirty="0"/>
+              <a:t>2×</a:t>
+            </a:r>
+            <a:endParaRPr lang="en-US" sz="1200" dirty="0"/>
           </a:p>
         </p:txBody>
       </p:sp>
@@ -11251,8 +11289,8 @@
         </p:nvSpPr>
         <p:spPr>
           <a:xfrm>
-            <a:off x="1097280" y="1572768"/>
-            <a:ext cx="2103120" cy="329184"/>
+            <a:off x="1097280" y="1476756"/>
+            <a:ext cx="2103120" cy="283464"/>
           </a:xfrm>
           <a:prstGeom prst="rect">
             <a:avLst/>
@@ -11276,7 +11314,7 @@
                 <a:ea typeface="Calibri" pitchFamily="34" charset="-122"/>
                 <a:cs typeface="Calibri" pitchFamily="34" charset="-120"/>
               </a:rPr>
-              <a:t>Chatty Service</a:t>
+              <a:t>ESB Misuse</a:t>
             </a:r>
             <a:endParaRPr lang="en-US" sz="1100" dirty="0"/>
           </a:p>
@@ -11290,8 +11328,8 @@
         </p:nvSpPr>
         <p:spPr>
           <a:xfrm>
-            <a:off x="3200400" y="1572768"/>
-            <a:ext cx="1325880" cy="329184"/>
+            <a:off x="3200400" y="1476756"/>
+            <a:ext cx="1325880" cy="283464"/>
           </a:xfrm>
           <a:prstGeom prst="rect">
             <a:avLst/>
@@ -11315,7 +11353,7 @@
                 <a:ea typeface="Calibri" pitchFamily="34" charset="-122"/>
                 <a:cs typeface="Calibri" pitchFamily="34" charset="-120"/>
               </a:rPr>
-              <a:t>−5 each = −20</a:t>
+              <a:t>−5 each = −10</a:t>
             </a:r>
             <a:endParaRPr lang="en-US" sz="1000" dirty="0"/>
           </a:p>
@@ -11329,8 +11367,8 @@
         </p:nvSpPr>
         <p:spPr>
           <a:xfrm>
-            <a:off x="457200" y="1938528"/>
-            <a:ext cx="4114800" cy="329184"/>
+            <a:off x="457200" y="1792224"/>
+            <a:ext cx="4114800" cy="283464"/>
           </a:xfrm>
           <a:prstGeom prst="rect">
             <a:avLst/>
@@ -11354,8 +11392,8 @@
         </p:nvSpPr>
         <p:spPr>
           <a:xfrm>
-            <a:off x="502920" y="1938528"/>
-            <a:ext cx="548640" cy="329184"/>
+            <a:off x="502920" y="1792224"/>
+            <a:ext cx="548640" cy="283464"/>
           </a:xfrm>
           <a:prstGeom prst="rect">
             <a:avLst/>
@@ -11371,7 +11409,7 @@
               <a:buNone/>
             </a:pPr>
             <a:r>
-              <a:rPr lang="en-US" sz="1300" b="1" dirty="0">
+              <a:rPr lang="en-US" sz="1200" b="1" dirty="0">
                 <a:solidFill>
                   <a:srgbClr val="DC2626"/>
                 </a:solidFill>
@@ -11379,22 +11417,164 @@
                 <a:ea typeface="Calibri" pitchFamily="34" charset="-122"/>
                 <a:cs typeface="Calibri" pitchFamily="34" charset="-120"/>
               </a:rPr>
+              <a:t>2×</a:t>
+            </a:r>
+            <a:endParaRPr lang="en-US" sz="1200" dirty="0"/>
+          </a:p>
+        </p:txBody>
+      </p:sp>
+      <p:sp>
+        <p:nvSpPr>
+          <p:cNvPr id="14" name="Text 12"/>
+          <p:cNvSpPr/>
+          <p:nvPr/>
+        </p:nvSpPr>
+        <p:spPr>
+          <a:xfrm>
+            <a:off x="1097280" y="1792224"/>
+            <a:ext cx="2103120" cy="283464"/>
+          </a:xfrm>
+          <a:prstGeom prst="rect">
+            <a:avLst/>
+          </a:prstGeom>
+          <a:noFill/>
+          <a:ln/>
+        </p:spPr>
+        <p:txBody>
+          <a:bodyPr wrap="square" lIns="0" tIns="0" rIns="0" bIns="0" rtlCol="0" anchor="ctr"/>
+          <a:lstStyle/>
+          <a:p>
+            <a:pPr marL="0" indent="0">
+              <a:buNone/>
+            </a:pPr>
+            <a:r>
+              <a:rPr lang="en-US" sz="1100" dirty="0">
+                <a:solidFill>
+                  <a:srgbClr val="1E293B"/>
+                </a:solidFill>
+                <a:latin typeface="Calibri" pitchFamily="34" charset="0"/>
+                <a:ea typeface="Calibri" pitchFamily="34" charset="-122"/>
+                <a:cs typeface="Calibri" pitchFamily="34" charset="-120"/>
+              </a:rPr>
+              <a:t>Wrong Cuts</a:t>
+            </a:r>
+            <a:endParaRPr lang="en-US" sz="1100" dirty="0"/>
+          </a:p>
+        </p:txBody>
+      </p:sp>
+      <p:sp>
+        <p:nvSpPr>
+          <p:cNvPr id="15" name="Text 13"/>
+          <p:cNvSpPr/>
+          <p:nvPr/>
+        </p:nvSpPr>
+        <p:spPr>
+          <a:xfrm>
+            <a:off x="3200400" y="1792224"/>
+            <a:ext cx="1325880" cy="283464"/>
+          </a:xfrm>
+          <a:prstGeom prst="rect">
+            <a:avLst/>
+          </a:prstGeom>
+          <a:noFill/>
+          <a:ln/>
+        </p:spPr>
+        <p:txBody>
+          <a:bodyPr wrap="square" lIns="0" tIns="0" rIns="0" bIns="0" rtlCol="0" anchor="ctr"/>
+          <a:lstStyle/>
+          <a:p>
+            <a:pPr marL="0" indent="0" algn="r">
+              <a:buNone/>
+            </a:pPr>
+            <a:r>
+              <a:rPr lang="en-US" sz="1000" i="1" dirty="0">
+                <a:solidFill>
+                  <a:srgbClr val="64748B"/>
+                </a:solidFill>
+                <a:latin typeface="Calibri" pitchFamily="34" charset="0"/>
+                <a:ea typeface="Calibri" pitchFamily="34" charset="-122"/>
+                <a:cs typeface="Calibri" pitchFamily="34" charset="-120"/>
+              </a:rPr>
+              <a:t>−5 each = −10</a:t>
+            </a:r>
+            <a:endParaRPr lang="en-US" sz="1000" dirty="0"/>
+          </a:p>
+        </p:txBody>
+      </p:sp>
+      <p:sp>
+        <p:nvSpPr>
+          <p:cNvPr id="16" name="Shape 14"/>
+          <p:cNvSpPr/>
+          <p:nvPr/>
+        </p:nvSpPr>
+        <p:spPr>
+          <a:xfrm>
+            <a:off x="457200" y="2107692"/>
+            <a:ext cx="4114800" cy="283464"/>
+          </a:xfrm>
+          <a:prstGeom prst="rect">
+            <a:avLst/>
+          </a:prstGeom>
+          <a:solidFill>
+            <a:srgbClr val="F8FAFC"/>
+          </a:solidFill>
+          <a:ln w="6350">
+            <a:solidFill>
+              <a:srgbClr val="E2E8F0"/>
+            </a:solidFill>
+            <a:prstDash val="solid"/>
+          </a:ln>
+        </p:spPr>
+      </p:sp>
+      <p:sp>
+        <p:nvSpPr>
+          <p:cNvPr id="17" name="Text 15"/>
+          <p:cNvSpPr/>
+          <p:nvPr/>
+        </p:nvSpPr>
+        <p:spPr>
+          <a:xfrm>
+            <a:off x="502920" y="2107692"/>
+            <a:ext cx="548640" cy="283464"/>
+          </a:xfrm>
+          <a:prstGeom prst="rect">
+            <a:avLst/>
+          </a:prstGeom>
+          <a:noFill/>
+          <a:ln/>
+        </p:spPr>
+        <p:txBody>
+          <a:bodyPr wrap="square" lIns="0" tIns="0" rIns="0" bIns="0" rtlCol="0" anchor="ctr"/>
+          <a:lstStyle/>
+          <a:p>
+            <a:pPr marL="0" indent="0" algn="ctr">
+              <a:buNone/>
+            </a:pPr>
+            <a:r>
+              <a:rPr lang="en-US" sz="1200" b="1" dirty="0">
+                <a:solidFill>
+                  <a:srgbClr val="DC2626"/>
+                </a:solidFill>
+                <a:latin typeface="Calibri" pitchFamily="34" charset="0"/>
+                <a:ea typeface="Calibri" pitchFamily="34" charset="-122"/>
+                <a:cs typeface="Calibri" pitchFamily="34" charset="-120"/>
+              </a:rPr>
               <a:t>1×</a:t>
             </a:r>
-            <a:endParaRPr lang="en-US" sz="1300" dirty="0"/>
-          </a:p>
-        </p:txBody>
-      </p:sp>
-      <p:sp>
-        <p:nvSpPr>
-          <p:cNvPr id="14" name="Text 12"/>
-          <p:cNvSpPr/>
-          <p:nvPr/>
-        </p:nvSpPr>
-        <p:spPr>
-          <a:xfrm>
-            <a:off x="1097280" y="1938528"/>
-            <a:ext cx="2103120" cy="329184"/>
+            <a:endParaRPr lang="en-US" sz="1200" dirty="0"/>
+          </a:p>
+        </p:txBody>
+      </p:sp>
+      <p:sp>
+        <p:nvSpPr>
+          <p:cNvPr id="18" name="Text 16"/>
+          <p:cNvSpPr/>
+          <p:nvPr/>
+        </p:nvSpPr>
+        <p:spPr>
+          <a:xfrm>
+            <a:off x="1097280" y="2107692"/>
+            <a:ext cx="2103120" cy="283464"/>
           </a:xfrm>
           <a:prstGeom prst="rect">
             <a:avLst/>
@@ -11418,7 +11598,7 @@
                 <a:ea typeface="Calibri" pitchFamily="34" charset="-122"/>
                 <a:cs typeface="Calibri" pitchFamily="34" charset="-120"/>
               </a:rPr>
-              <a:t>Shared Database</a:t>
+              <a:t>Cyclic Dependency</a:t>
             </a:r>
             <a:endParaRPr lang="en-US" sz="1100" dirty="0"/>
           </a:p>
@@ -11426,14 +11606,14 @@
       </p:sp>
       <p:sp>
         <p:nvSpPr>
-          <p:cNvPr id="15" name="Text 13"/>
-          <p:cNvSpPr/>
-          <p:nvPr/>
-        </p:nvSpPr>
-        <p:spPr>
-          <a:xfrm>
-            <a:off x="3200400" y="1938528"/>
-            <a:ext cx="1325880" cy="329184"/>
+          <p:cNvPr id="19" name="Text 17"/>
+          <p:cNvSpPr/>
+          <p:nvPr/>
+        </p:nvSpPr>
+        <p:spPr>
+          <a:xfrm>
+            <a:off x="3200400" y="2107692"/>
+            <a:ext cx="1325880" cy="283464"/>
           </a:xfrm>
           <a:prstGeom prst="rect">
             <a:avLst/>
@@ -11457,7 +11637,7 @@
                 <a:ea typeface="Calibri" pitchFamily="34" charset="-122"/>
                 <a:cs typeface="Calibri" pitchFamily="34" charset="-120"/>
               </a:rPr>
-              <a:t>−5 each = −5</a:t>
+              <a:t>−8 = −8</a:t>
             </a:r>
             <a:endParaRPr lang="en-US" sz="1000" dirty="0"/>
           </a:p>
@@ -11465,13 +11645,155 @@
       </p:sp>
       <p:sp>
         <p:nvSpPr>
-          <p:cNvPr id="16" name="Shape 14"/>
-          <p:cNvSpPr/>
-          <p:nvPr/>
-        </p:nvSpPr>
-        <p:spPr>
-          <a:xfrm>
-            <a:off x="457200" y="2697480"/>
+          <p:cNvPr id="20" name="Shape 18"/>
+          <p:cNvSpPr/>
+          <p:nvPr/>
+        </p:nvSpPr>
+        <p:spPr>
+          <a:xfrm>
+            <a:off x="457200" y="2423160"/>
+            <a:ext cx="4114800" cy="283464"/>
+          </a:xfrm>
+          <a:prstGeom prst="rect">
+            <a:avLst/>
+          </a:prstGeom>
+          <a:solidFill>
+            <a:srgbClr val="F8FAFC"/>
+          </a:solidFill>
+          <a:ln w="6350">
+            <a:solidFill>
+              <a:srgbClr val="E2E8F0"/>
+            </a:solidFill>
+            <a:prstDash val="solid"/>
+          </a:ln>
+        </p:spPr>
+      </p:sp>
+      <p:sp>
+        <p:nvSpPr>
+          <p:cNvPr id="21" name="Text 19"/>
+          <p:cNvSpPr/>
+          <p:nvPr/>
+        </p:nvSpPr>
+        <p:spPr>
+          <a:xfrm>
+            <a:off x="502920" y="2423160"/>
+            <a:ext cx="548640" cy="283464"/>
+          </a:xfrm>
+          <a:prstGeom prst="rect">
+            <a:avLst/>
+          </a:prstGeom>
+          <a:noFill/>
+          <a:ln/>
+        </p:spPr>
+        <p:txBody>
+          <a:bodyPr wrap="square" lIns="0" tIns="0" rIns="0" bIns="0" rtlCol="0" anchor="ctr"/>
+          <a:lstStyle/>
+          <a:p>
+            <a:pPr marL="0" indent="0" algn="ctr">
+              <a:buNone/>
+            </a:pPr>
+            <a:r>
+              <a:rPr lang="en-US" sz="1200" b="1" dirty="0">
+                <a:solidFill>
+                  <a:srgbClr val="DC2626"/>
+                </a:solidFill>
+                <a:latin typeface="Calibri" pitchFamily="34" charset="0"/>
+                <a:ea typeface="Calibri" pitchFamily="34" charset="-122"/>
+                <a:cs typeface="Calibri" pitchFamily="34" charset="-120"/>
+              </a:rPr>
+              <a:t>1×</a:t>
+            </a:r>
+            <a:endParaRPr lang="en-US" sz="1200" dirty="0"/>
+          </a:p>
+        </p:txBody>
+      </p:sp>
+      <p:sp>
+        <p:nvSpPr>
+          <p:cNvPr id="22" name="Text 20"/>
+          <p:cNvSpPr/>
+          <p:nvPr/>
+        </p:nvSpPr>
+        <p:spPr>
+          <a:xfrm>
+            <a:off x="1097280" y="2423160"/>
+            <a:ext cx="2103120" cy="283464"/>
+          </a:xfrm>
+          <a:prstGeom prst="rect">
+            <a:avLst/>
+          </a:prstGeom>
+          <a:noFill/>
+          <a:ln/>
+        </p:spPr>
+        <p:txBody>
+          <a:bodyPr wrap="square" lIns="0" tIns="0" rIns="0" bIns="0" rtlCol="0" anchor="ctr"/>
+          <a:lstStyle/>
+          <a:p>
+            <a:pPr marL="0" indent="0">
+              <a:buNone/>
+            </a:pPr>
+            <a:r>
+              <a:rPr lang="en-US" sz="1100" dirty="0">
+                <a:solidFill>
+                  <a:srgbClr val="1E293B"/>
+                </a:solidFill>
+                <a:latin typeface="Calibri" pitchFamily="34" charset="0"/>
+                <a:ea typeface="Calibri" pitchFamily="34" charset="-122"/>
+                <a:cs typeface="Calibri" pitchFamily="34" charset="-120"/>
+              </a:rPr>
+              <a:t>Hardcoded Endpoints</a:t>
+            </a:r>
+            <a:endParaRPr lang="en-US" sz="1100" dirty="0"/>
+          </a:p>
+        </p:txBody>
+      </p:sp>
+      <p:sp>
+        <p:nvSpPr>
+          <p:cNvPr id="23" name="Text 21"/>
+          <p:cNvSpPr/>
+          <p:nvPr/>
+        </p:nvSpPr>
+        <p:spPr>
+          <a:xfrm>
+            <a:off x="3200400" y="2423160"/>
+            <a:ext cx="1325880" cy="283464"/>
+          </a:xfrm>
+          <a:prstGeom prst="rect">
+            <a:avLst/>
+          </a:prstGeom>
+          <a:noFill/>
+          <a:ln/>
+        </p:spPr>
+        <p:txBody>
+          <a:bodyPr wrap="square" lIns="0" tIns="0" rIns="0" bIns="0" rtlCol="0" anchor="ctr"/>
+          <a:lstStyle/>
+          <a:p>
+            <a:pPr marL="0" indent="0" algn="r">
+              <a:buNone/>
+            </a:pPr>
+            <a:r>
+              <a:rPr lang="en-US" sz="1000" i="1" dirty="0">
+                <a:solidFill>
+                  <a:srgbClr val="64748B"/>
+                </a:solidFill>
+                <a:latin typeface="Calibri" pitchFamily="34" charset="0"/>
+                <a:ea typeface="Calibri" pitchFamily="34" charset="-122"/>
+                <a:cs typeface="Calibri" pitchFamily="34" charset="-120"/>
+              </a:rPr>
+              <a:t>−3 = −3</a:t>
+            </a:r>
+            <a:endParaRPr lang="en-US" sz="1000" dirty="0"/>
+          </a:p>
+        </p:txBody>
+      </p:sp>
+      <p:sp>
+        <p:nvSpPr>
+          <p:cNvPr id="24" name="Shape 22"/>
+          <p:cNvSpPr/>
+          <p:nvPr/>
+        </p:nvSpPr>
+        <p:spPr>
+          <a:xfrm>
+            <a:off x="457200" y="2779776"/>
             <a:ext cx="4114800" cy="411480"/>
           </a:xfrm>
           <a:prstGeom prst="rect">
@@ -11490,13 +11812,13 @@
       </p:sp>
       <p:sp>
         <p:nvSpPr>
-          <p:cNvPr id="17" name="Text 15"/>
-          <p:cNvSpPr/>
-          <p:nvPr/>
-        </p:nvSpPr>
-        <p:spPr>
-          <a:xfrm>
-            <a:off x="457200" y="2697480"/>
+          <p:cNvPr id="25" name="Text 23"/>
+          <p:cNvSpPr/>
+          <p:nvPr/>
+        </p:nvSpPr>
+        <p:spPr>
+          <a:xfrm>
+            <a:off x="457200" y="2779776"/>
             <a:ext cx="4114800" cy="411480"/>
           </a:xfrm>
           <a:prstGeom prst="rect">
@@ -11521,7 +11843,7 @@
                 <a:ea typeface="Calibri" pitchFamily="34" charset="-122"/>
                 <a:cs typeface="Calibri" pitchFamily="34" charset="-120"/>
               </a:rPr>
-              <a:t>Total penalty: 103   →   AP clamped at 0</a:t>
+              <a:t>Total penalty: 49   →   AP clamped at 0</a:t>
             </a:r>
             <a:endParaRPr lang="en-US" sz="1200" dirty="0"/>
           </a:p>
@@ -11529,7 +11851,7 @@
       </p:sp>
       <p:sp>
         <p:nvSpPr>
-          <p:cNvPr id="18" name="Text 16"/>
+          <p:cNvPr id="26" name="Text 24"/>
           <p:cNvSpPr/>
           <p:nvPr/>
         </p:nvSpPr>
@@ -11568,7 +11890,7 @@
       </p:sp>
       <p:sp>
         <p:nvSpPr>
-          <p:cNvPr id="19" name="Text 17"/>
+          <p:cNvPr id="27" name="Text 25"/>
           <p:cNvSpPr/>
           <p:nvPr/>
         </p:nvSpPr>
@@ -11607,7 +11929,7 @@
       </p:sp>
       <p:sp>
         <p:nvSpPr>
-          <p:cNvPr id="20" name="Shape 18"/>
+          <p:cNvPr id="28" name="Shape 26"/>
           <p:cNvSpPr/>
           <p:nvPr/>
         </p:nvSpPr>
@@ -11632,7 +11954,7 @@
       </p:sp>
       <p:sp>
         <p:nvSpPr>
-          <p:cNvPr id="21" name="Text 19"/>
+          <p:cNvPr id="29" name="Text 27"/>
           <p:cNvSpPr/>
           <p:nvPr/>
         </p:nvSpPr>
@@ -11671,7 +11993,7 @@
       </p:sp>
       <p:sp>
         <p:nvSpPr>
-          <p:cNvPr id="22" name="Text 20"/>
+          <p:cNvPr id="30" name="Text 28"/>
           <p:cNvSpPr/>
           <p:nvPr/>
         </p:nvSpPr>
@@ -11710,7 +12032,7 @@
       </p:sp>
       <p:sp>
         <p:nvSpPr>
-          <p:cNvPr id="23" name="Shape 21"/>
+          <p:cNvPr id="31" name="Shape 29"/>
           <p:cNvSpPr/>
           <p:nvPr/>
         </p:nvSpPr>
@@ -11735,14 +12057,14 @@
       </p:sp>
       <p:sp>
         <p:nvSpPr>
-          <p:cNvPr id="24" name="Shape 22"/>
+          <p:cNvPr id="32" name="Shape 30"/>
           <p:cNvSpPr/>
           <p:nvPr/>
         </p:nvSpPr>
         <p:spPr>
           <a:xfrm>
             <a:off x="6126480" y="1737360"/>
-            <a:ext cx="950976" cy="256032"/>
+            <a:ext cx="1426464" cy="256032"/>
           </a:xfrm>
           <a:prstGeom prst="rect">
             <a:avLst/>
@@ -11760,7 +12082,7 @@
       </p:sp>
       <p:sp>
         <p:nvSpPr>
-          <p:cNvPr id="25" name="Text 23"/>
+          <p:cNvPr id="33" name="Text 31"/>
           <p:cNvSpPr/>
           <p:nvPr/>
         </p:nvSpPr>
@@ -11791,7 +12113,7 @@
                 <a:ea typeface="Calibri" pitchFamily="34" charset="-122"/>
                 <a:cs typeface="Calibri" pitchFamily="34" charset="-120"/>
               </a:rPr>
-              <a:t>8 / 20</a:t>
+              <a:t>12 / 20</a:t>
             </a:r>
             <a:endParaRPr lang="en-US" sz="1000" dirty="0"/>
           </a:p>
@@ -11799,7 +12121,7 @@
       </p:sp>
       <p:sp>
         <p:nvSpPr>
-          <p:cNvPr id="26" name="Text 24"/>
+          <p:cNvPr id="34" name="Text 32"/>
           <p:cNvSpPr/>
           <p:nvPr/>
         </p:nvSpPr>
@@ -11838,7 +12160,7 @@
       </p:sp>
       <p:sp>
         <p:nvSpPr>
-          <p:cNvPr id="27" name="Shape 25"/>
+          <p:cNvPr id="35" name="Shape 33"/>
           <p:cNvSpPr/>
           <p:nvPr/>
         </p:nvSpPr>
@@ -11863,14 +12185,14 @@
       </p:sp>
       <p:sp>
         <p:nvSpPr>
-          <p:cNvPr id="28" name="Shape 26"/>
+          <p:cNvPr id="36" name="Shape 34"/>
           <p:cNvSpPr/>
           <p:nvPr/>
         </p:nvSpPr>
         <p:spPr>
           <a:xfrm>
             <a:off x="6126480" y="2240280"/>
-            <a:ext cx="2377440" cy="256032"/>
+            <a:ext cx="1521562" cy="256032"/>
           </a:xfrm>
           <a:prstGeom prst="rect">
             <a:avLst/>
@@ -11888,7 +12210,7 @@
       </p:sp>
       <p:sp>
         <p:nvSpPr>
-          <p:cNvPr id="29" name="Text 27"/>
+          <p:cNvPr id="37" name="Text 35"/>
           <p:cNvSpPr/>
           <p:nvPr/>
         </p:nvSpPr>
@@ -11919,7 +12241,7 @@
                 <a:ea typeface="Calibri" pitchFamily="34" charset="-122"/>
                 <a:cs typeface="Calibri" pitchFamily="34" charset="-120"/>
               </a:rPr>
-              <a:t>25 / 25</a:t>
+              <a:t>16 / 25</a:t>
             </a:r>
             <a:endParaRPr lang="en-US" sz="1000" dirty="0"/>
           </a:p>
@@ -11927,7 +12249,7 @@
       </p:sp>
       <p:sp>
         <p:nvSpPr>
-          <p:cNvPr id="30" name="Text 28"/>
+          <p:cNvPr id="38" name="Text 36"/>
           <p:cNvSpPr/>
           <p:nvPr/>
         </p:nvSpPr>
@@ -11966,7 +12288,7 @@
       </p:sp>
       <p:sp>
         <p:nvSpPr>
-          <p:cNvPr id="31" name="Shape 29"/>
+          <p:cNvPr id="39" name="Shape 37"/>
           <p:cNvSpPr/>
           <p:nvPr/>
         </p:nvSpPr>
@@ -11991,14 +12313,14 @@
       </p:sp>
       <p:sp>
         <p:nvSpPr>
-          <p:cNvPr id="32" name="Shape 30"/>
+          <p:cNvPr id="40" name="Shape 38"/>
           <p:cNvSpPr/>
           <p:nvPr/>
         </p:nvSpPr>
         <p:spPr>
           <a:xfrm>
             <a:off x="6126480" y="2743200"/>
-            <a:ext cx="1109472" cy="256032"/>
+            <a:ext cx="1901952" cy="256032"/>
           </a:xfrm>
           <a:prstGeom prst="rect">
             <a:avLst/>
@@ -12016,7 +12338,7 @@
       </p:sp>
       <p:sp>
         <p:nvSpPr>
-          <p:cNvPr id="33" name="Text 31"/>
+          <p:cNvPr id="41" name="Text 39"/>
           <p:cNvSpPr/>
           <p:nvPr/>
         </p:nvSpPr>
@@ -12047,7 +12369,7 @@
                 <a:ea typeface="Calibri" pitchFamily="34" charset="-122"/>
                 <a:cs typeface="Calibri" pitchFamily="34" charset="-120"/>
               </a:rPr>
-              <a:t>7 / 15</a:t>
+              <a:t>12 / 15</a:t>
             </a:r>
             <a:endParaRPr lang="en-US" sz="1000" dirty="0"/>
           </a:p>
@@ -12055,7 +12377,7 @@
       </p:sp>
       <p:sp>
         <p:nvSpPr>
-          <p:cNvPr id="34" name="Shape 32"/>
+          <p:cNvPr id="42" name="Shape 40"/>
           <p:cNvSpPr/>
           <p:nvPr/>
         </p:nvSpPr>
@@ -12080,7 +12402,7 @@
       </p:sp>
       <p:sp>
         <p:nvSpPr>
-          <p:cNvPr id="35" name="Text 33"/>
+          <p:cNvPr id="43" name="Text 41"/>
           <p:cNvSpPr/>
           <p:nvPr/>
         </p:nvSpPr>
@@ -12119,7 +12441,7 @@
       </p:sp>
       <p:sp>
         <p:nvSpPr>
-          <p:cNvPr id="36" name="Text 34"/>
+          <p:cNvPr id="44" name="Text 42"/>
           <p:cNvSpPr/>
           <p:nvPr/>
         </p:nvSpPr>
@@ -12158,7 +12480,7 @@
       </p:sp>
       <p:sp>
         <p:nvSpPr>
-          <p:cNvPr id="37" name="Text 35"/>
+          <p:cNvPr id="45" name="Text 43"/>
           <p:cNvSpPr/>
           <p:nvPr/>
         </p:nvSpPr>
@@ -12197,13 +12519,13 @@
       </p:sp>
       <p:sp>
         <p:nvSpPr>
-          <p:cNvPr id="38" name="Text 36"/>
-          <p:cNvSpPr/>
-          <p:nvPr/>
-        </p:nvSpPr>
-        <p:spPr>
-          <a:xfrm>
-            <a:off x="457200" y="3611880"/>
+          <p:cNvPr id="46" name="Text 44"/>
+          <p:cNvSpPr/>
+          <p:nvPr/>
+        </p:nvSpPr>
+        <p:spPr>
+          <a:xfrm>
+            <a:off x="457200" y="3703320"/>
             <a:ext cx="4114800" cy="914400"/>
           </a:xfrm>
           <a:prstGeom prst="rect">
@@ -12216,8 +12538,9 @@
           <a:bodyPr wrap="square" lIns="0" tIns="0" rIns="0" bIns="0" rtlCol="0" anchor="ctr"/>
           <a:lstStyle/>
           <a:p>
-            <a:pPr marL="0" indent="0">
-              <a:buNone/>
+            <a:pPr marL="171450" indent="-171450">
+              <a:buFont typeface="Arial" panose="020B0604020202020204" pitchFamily="34" charset="0"/>
+              <a:buChar char="•"/>
             </a:pPr>
             <a:r>
               <a:rPr lang="en-US" sz="1000" i="1" dirty="0">
@@ -12228,7 +12551,58 @@
                 <a:ea typeface="Calibri" pitchFamily="34" charset="-122"/>
                 <a:cs typeface="Calibri" pitchFamily="34" charset="-120"/>
               </a:rPr>
-              <a:t>Score driven by anti-pattern deductions (26 Hardcoded Endpoints + 4 Chatty Services). Service Sizing loses 8 pts to nano services; Code Quality adds a density-based deduction (8 / 20).</a:t>
+              <a:t>Deductions spread across all four categories: the anti-pattern load (penalty 49) clamps AP to 0</a:t>
+            </a:r>
+          </a:p>
+          <a:p>
+            <a:pPr marL="171450" indent="-171450">
+              <a:buFont typeface="Arial" panose="020B0604020202020204" pitchFamily="34" charset="0"/>
+              <a:buChar char="•"/>
+            </a:pPr>
+            <a:r>
+              <a:rPr lang="en-US" sz="1000" i="1" dirty="0">
+                <a:solidFill>
+                  <a:srgbClr val="64748B"/>
+                </a:solidFill>
+                <a:latin typeface="Calibri" pitchFamily="34" charset="0"/>
+                <a:ea typeface="Calibri" pitchFamily="34" charset="-122"/>
+                <a:cs typeface="Calibri" pitchFamily="34" charset="-120"/>
+              </a:rPr>
+              <a:t>Architecture loses 9 to dependency-graph coupling;</a:t>
+            </a:r>
+          </a:p>
+          <a:p>
+            <a:pPr marL="171450" indent="-171450">
+              <a:buFont typeface="Arial" panose="020B0604020202020204" pitchFamily="34" charset="0"/>
+              <a:buChar char="•"/>
+            </a:pPr>
+            <a:r>
+              <a:rPr lang="en-US" sz="1000" i="1" dirty="0">
+                <a:solidFill>
+                  <a:srgbClr val="64748B"/>
+                </a:solidFill>
+                <a:latin typeface="Calibri" pitchFamily="34" charset="0"/>
+                <a:ea typeface="Calibri" pitchFamily="34" charset="-122"/>
+                <a:cs typeface="Calibri" pitchFamily="34" charset="-120"/>
+              </a:rPr>
+              <a:t>Code Quality 8 to smell density</a:t>
+            </a:r>
+          </a:p>
+          <a:p>
+            <a:pPr marL="171450" indent="-171450">
+              <a:buFont typeface="Arial" panose="020B0604020202020204" pitchFamily="34" charset="0"/>
+              <a:buChar char="•"/>
+            </a:pPr>
+            <a:r>
+              <a:rPr lang="en-US" sz="1000" i="1" dirty="0">
+                <a:solidFill>
+                  <a:srgbClr val="64748B"/>
+                </a:solidFill>
+                <a:latin typeface="Calibri" pitchFamily="34" charset="0"/>
+                <a:ea typeface="Calibri" pitchFamily="34" charset="-122"/>
+                <a:cs typeface="Calibri" pitchFamily="34" charset="-120"/>
+              </a:rPr>
+              <a:t>Service Sizing 3 to one nano service</a:t>
             </a:r>
             <a:endParaRPr lang="en-US" sz="1000" dirty="0"/>
           </a:p>
@@ -12236,7 +12610,7 @@
       </p:sp>
       <p:sp>
         <p:nvSpPr>
-          <p:cNvPr id="39" name="Text 37"/>
+          <p:cNvPr id="47" name="Text 45"/>
           <p:cNvSpPr/>
           <p:nvPr/>
         </p:nvSpPr>
@@ -12275,7 +12649,7 @@
       </p:sp>
       <p:sp>
         <p:nvSpPr>
-          <p:cNvPr id="40" name="Text 38"/>
+          <p:cNvPr id="48" name="Text 46"/>
           <p:cNvSpPr/>
           <p:nvPr/>
         </p:nvSpPr>
@@ -13956,7 +14330,7 @@
         </p:nvSpPr>
         <p:spPr>
           <a:xfrm>
-            <a:off x="731520" y="4069080"/>
+            <a:off x="731520" y="4027932"/>
             <a:ext cx="7955280" cy="594360"/>
           </a:xfrm>
           <a:prstGeom prst="rect">
@@ -13985,7 +14359,27 @@
                 <a:ea typeface="Calibri" pitchFamily="34" charset="-122"/>
                 <a:cs typeface="Calibri" pitchFamily="34" charset="-120"/>
               </a:rPr>
-              <a:t>108 anti-pattern instances across 9 types. Hardcoded Endpoints (43) and API Versioning Absence (31) dominate.</a:t>
+              <a:t>108 anti-pattern instances across 9 types </a:t>
+            </a:r>
+          </a:p>
+          <a:p>
+            <a:pPr marL="800100" lvl="1" indent="-342900">
+              <a:spcAft>
+                <a:spcPts val="200"/>
+              </a:spcAft>
+              <a:buSzPct val="100000"/>
+              <a:buChar char="•"/>
+            </a:pPr>
+            <a:r>
+              <a:rPr lang="en-US" sz="1100" dirty="0">
+                <a:solidFill>
+                  <a:srgbClr val="1E293B"/>
+                </a:solidFill>
+                <a:latin typeface="Calibri" pitchFamily="34" charset="0"/>
+                <a:ea typeface="Calibri" pitchFamily="34" charset="-122"/>
+                <a:cs typeface="Calibri" pitchFamily="34" charset="-120"/>
+              </a:rPr>
+              <a:t>Hardcoded Endpoints (43) and API Versioning Absence (31) dominate</a:t>
             </a:r>
             <a:endParaRPr lang="en-US" sz="1100" dirty="0"/>
           </a:p>
@@ -14006,7 +14400,7 @@
                 <a:ea typeface="Calibri" pitchFamily="34" charset="-122"/>
                 <a:cs typeface="Calibri" pitchFamily="34" charset="-120"/>
               </a:rPr>
-              <a:t>Cyclic Dependency and Wrong Cuts detected in microservice-recruit — broader corpus exercises more detectors.</a:t>
+              <a:t>Cyclic Dependency and Wrong Cuts detected in microservice-recruit =&gt; broader corpus exercises more detectors</a:t>
             </a:r>
             <a:endParaRPr lang="en-US" sz="1100" dirty="0"/>
           </a:p>

</xml_diff>

<commit_message>
fix wrong cuts and god service detectors in code, thesis and presentation
</commit_message>
<xml_diff>
--- a/thesis/presentation/MSA_Detector_Defense.pptx
+++ b/thesis/presentation/MSA_Detector_Defense.pptx
@@ -12,8 +12,8 @@
     <p:sldId id="257" r:id="rId3"/>
     <p:sldId id="258" r:id="rId4"/>
     <p:sldId id="259" r:id="rId5"/>
-    <p:sldId id="261" r:id="rId6"/>
-    <p:sldId id="260" r:id="rId7"/>
+    <p:sldId id="260" r:id="rId6"/>
+    <p:sldId id="261" r:id="rId7"/>
     <p:sldId id="262" r:id="rId8"/>
     <p:sldId id="263" r:id="rId9"/>
     <p:sldId id="264" r:id="rId10"/>
@@ -308,7 +308,7 @@
           </c:val>
           <c:extLst>
             <c:ext xmlns:c16="http://schemas.microsoft.com/office/drawing/2014/chart" uri="{C3380CC4-5D6E-409C-BE32-E72D297353CC}">
-              <c16:uniqueId val="{00000000-31D1-4732-925F-56950074362D}"/>
+              <c16:uniqueId val="{00000000-553C-4958-82EF-F74EA1498A57}"/>
             </c:ext>
           </c:extLst>
         </c:ser>
@@ -470,7 +470,7 @@
     </p:spTree>
     <p:extLst>
       <p:ext uri="{BB962C8B-B14F-4D97-AF65-F5344CB8AC3E}">
-        <p14:creationId xmlns:p14="http://schemas.microsoft.com/office/powerpoint/2010/main" val="1494059793"/>
+        <p14:creationId xmlns:p14="http://schemas.microsoft.com/office/powerpoint/2010/main" val="3683202923"/>
       </p:ext>
     </p:extLst>
   </p:cSld>
@@ -624,10 +624,15 @@
             </a:r>
             <a:r>
               <a:rPr lang="en-US" dirty="0"/>
-              <a:t>
-The core idea is straightforward — as organisations adopt microservices, they often unknowingly introduce structural problems that erode the very benefits they were after. This tool helps catch those problems early, from a source code checkout, before they become production incidents
-Keep this short — about 30 seconds. Don't introduce content yet; that's the next slide.
-Breathe, slow down. The committee already knows your name from the schedule, so this is just orientation.</a:t>
+              <a:t>.
+</a:t>
+            </a:r>
+          </a:p>
+          <a:p>
+            <a:r>
+              <a:rPr lang="en-US" dirty="0"/>
+              <a:t>The core idea is straightforward — as organisations adopt microservices, they often unknowingly introduce structural problems that erode the very benefits they were after. This tool helps catch those problems early, from a source code checkout, before they become production incidents
+</a:t>
             </a:r>
           </a:p>
         </p:txBody>
@@ -909,7 +914,7 @@
           <a:p>
             <a:r>
               <a:rPr lang="en-US" dirty="0"/>
-              <a:t>'To recap: the MSA Detector is a multi-level static analysis tool for Java/Spring Boot microservices, with ten anti-pattern detectors, a composite health score, and evidence-based reporting. If there's one thing I'd like you to take away, it's that the bridge between code-level evidence and architectural-level findings is what makes this tool different — it doesn't just say something is wrong, it shows you exactly where in the code the problem lives. Thank you.’
+              <a:t>'To recap: the MSA Detector is a multi-level static analysis tool for Java/Spring Boot microservices, with ten anti-pattern detectors, a composite health score, and evidence-based reporting. The full implementation, evaluation data, and dissertation are available. 'If there's one thing I'd like you to take away, it's that the bridge between code-level evidence and architectural-level findings is what makes this tool different — it doesn't just say something is wrong, it shows you exactly where in the code the problem lives. Thank you.'
 Then SHUT UP. Don't fill the silence. Let the committee speak.
 When the first question comes:
 1. Listen to the whole question — don't start composing the answer mid-question.
@@ -1009,11 +1014,18 @@
             <a:r>
               <a:rPr lang="en-US" dirty="0"/>
               <a:t>• Microservices have become the default for new large systems. But tooling for architectural quality hasn't kept up.
-• Teams ship anti-patterns — shared DBs, cycles, services that are either too small or too big — and they only find out when deployment friction or cascading failures appear in production.
+• Teams ship anti-patterns — shared DBs, cycles, services that are either too small or too big — and they only find out when deployment friction or cascading failures appear in production. For instance, a shared database between two services looks harmless at first — both teams just point at the same Postgres instance. But over time, schema changes in one service silently break the other, and you've lost independent </a:t>
+            </a:r>
+            <a:r>
+              <a:rPr lang="en-US" dirty="0" err="1"/>
+              <a:t>deployability</a:t>
+            </a:r>
+            <a:r>
+              <a:rPr lang="en-US" dirty="0"/>
+              <a:t> — arguably the single biggest reason to use microservices in the first place.'
 • Existing academic tools each handle a slice: Arcan does code-level cycles, MicroART visualises architecture, MSANose detects some microservice smells. None combine code-level smells with architectural-level analysis.
 • Even when something IS detected, the output is usually an abstract warning. Developers don't act on warnings without code evidence and remediation guidance.
-For instance, a shared database between two services looks harmless at first — both teams just point at the same Postgres instance. But over time, schema changes in one service silently break the other, and you've lost independent deployability — arguably the single biggest reason to use microservices in the first place.
-So the goal of this work was a tool that bridges both levels and outputs actionable findings.</a:t>
+So the goal of this work was a tool that bridges both levels and outputs actionable findings.'</a:t>
             </a:r>
           </a:p>
         </p:txBody>
@@ -1100,12 +1112,13 @@
           <a:p>
             <a:r>
               <a:rPr lang="en-US" dirty="0"/>
-              <a:t>• 'The work has five contributions. The first is the multi-level analysis itself — using code-level signals like God Class frequency to flag architectural problems like God Service. That bridge between abstraction levels is the central novelty.'
+              <a:t>• 'The work has five contributions. The first is the multi-level analysis itself — using code-level structural metrics like class cohesion to flag architectural problems like God Service. That bridge between abstraction levels is the central novelty.'
 • 'Second, ten anti-patterns across four dimensions — broader coverage than any single existing tool.'
 • 'Third, automated microservice boundary detection via a three-signal deployability gate — framework entry points, Dockerfiles, and main methods — with confidence levels. Most existing tools require manual configuration.'
 • 'Fourth, a composite health score on 0–100, decomposed into four categories so you can see which dimension is dragging the score down.'
 • 'Fifth, evidence-based reporting — every finding includes the actual code that triggered it.'
-Bridge to next slide: 'To give you a clearer picture of how these pieces fit together, let me walk you through the analysis pipeline — from the moment a project is uploaded to the final report.'</a:t>
+'To give you a clearer picture of how these pieces fit together, let me walk you through the analysis pipeline — from the moment a project is uploaded to the final report.'
+</a:t>
             </a:r>
           </a:p>
         </p:txBody>
@@ -1192,43 +1205,13 @@
           <a:p>
             <a:r>
               <a:rPr lang="en-US" dirty="0"/>
-              <a:t>Walk left to right:
-• Ingest: user uploads a ZIP or pastes a Git URL. The system extracts/clones and creates an analysis job.
+              <a:t>• Ingest: user uploads a ZIP or pastes a Git URL. The system extracts/clones and creates an analysis job.
 • Service detection: scan for build files — pom.xml, build.gradle, build.gradle.kts. Filter out non-service modules using exclusion keywords and aggregator checks. Then apply a three-signal deployability gate: framework entry point (HIGH), Dockerfile (MEDIUM), main() method (LOW). Only candidates passing at least one signal are kept.
 • Intra-service analysis runs DesigniteJava as a subprocess for code smells. Inter-service uses Spoon AST to find @FeignClient, RestTemplate, WebClient calls and build the dependency graph.
 • Then ten detectors run over that graph + the smells. Each is a Spring component implementing a common interface — Strategy pattern.
 • Finally results are assembled, the health score is computed, the dependency graph is serialised to JSON, and everything is persisted.
-</a:t>
-            </a:r>
-          </a:p>
-          <a:p>
-            <a:r>
-              <a:rPr lang="en-US" dirty="0"/>
-              <a:t>The dependency graph construction is the most technically interesting part of this stage. Spoon parses the AST of every Java file and looks for inter-service communication annotations — @FeignClient declarations, </a:t>
-            </a:r>
-            <a:r>
-              <a:rPr lang="en-US" dirty="0" err="1"/>
-              <a:t>RestTemplate.exchange</a:t>
-            </a:r>
-            <a:r>
-              <a:rPr lang="en-US" dirty="0"/>
-              <a:t> calls, </a:t>
-            </a:r>
-            <a:r>
-              <a:rPr lang="en-US" dirty="0" err="1"/>
-              <a:t>WebClient</a:t>
-            </a:r>
-            <a:r>
-              <a:rPr lang="en-US" dirty="0"/>
-              <a:t> invocations — then resolves each target to a known service. The result is a directed weighted graph where edge weight represents the number of distinct call sites.
-</a:t>
-            </a:r>
-          </a:p>
-          <a:p>
-            <a:r>
-              <a:rPr lang="en-US" dirty="0"/>
-              <a:t>
 If asked about why async: 'Analyses on large projects like Activiti take several minutes. Blocking the HTTP request would time out. The frontend polls for status.'
+Worth mentioning: 'The dependency graph construction is the most technically interesting part of this stage. Spoon parses the AST of every Java file and looks for inter-service communication annotations — @FeignClient declarations, RestTemplate.exchange calls, WebClient invocations — then resolves each target to a known service. The result is a directed weighted graph where edge weight represents the number of distinct call sites.'
 Don't read the design-choices panel verbatim — mention one or two if you have time.</a:t>
             </a:r>
           </a:p>
@@ -1316,48 +1299,13 @@
           <a:p>
             <a:r>
               <a:rPr lang="en-US" dirty="0"/>
-              <a:t>• 'These are the ten detectors, organised by architectural dimension. Each is a Spring component implementing a common interface, so adding a new detector means writing one class — no orchestrator changes.'
-• 'Severities feed directly into the health score: critical issues cost 8 points, high cost 5, medium cost 3.'
-• I'll focus on the scoring mechanism next.
-</a:t>
-            </a:r>
-          </a:p>
-          <a:p>
-            <a:r>
-              <a:rPr lang="en-US" dirty="0"/>
-              <a:t>Worth saying aloud: 'The severity levels aren't arbitrary — they reflect how much damage the anti-pattern can cause. Cyclic Dependency and Distributed Monolith are critical because they undermine independent </a:t>
-            </a:r>
-            <a:r>
-              <a:rPr lang="en-US" dirty="0" err="1"/>
-              <a:t>deployability</a:t>
-            </a:r>
-            <a:r>
-              <a:rPr lang="en-US" dirty="0"/>
-              <a:t> entirely. Hardcoded Endpoints and API Versioning are medium because they're easier to fix and their impact is more </a:t>
-            </a:r>
-            <a:r>
-              <a:rPr lang="en-US" dirty="0" err="1"/>
-              <a:t>localised</a:t>
-            </a:r>
-            <a:r>
-              <a:rPr lang="en-US" dirty="0"/>
-              <a:t>.'</a:t>
-            </a:r>
-          </a:p>
-          <a:p>
-            <a:r>
-              <a:rPr lang="en-US" dirty="0"/>
-              <a:t>
-If a committee member asks about a specific detector:
-• Shared DB — group services by spring.datasource.url, flag groups of size &gt; 1
-• Cyclic Dependency — Tarjan's SCC on the dep graph, any SCC &gt; 1 vertex is a cycle
-• Chatty Service — call count per edge ≥ 10 OR a Feign interface with ≥ 10 methods
-• Hardcoded Endpoints — regex scan of .java for http://, localhost:, IP literals (with comment/test exclusions)
-• Distributed Monolith — composite rule on coupling coefficient, connected ratio, shared DB count
-• API Versioning — regex /v\d+[/.] on endpoint paths
-• ESB Misuse — caller/callee ratios + volume-based mediator ratio
-• Wrong Cuts — Feature Envy count OR bidirectional edges
-Don't get defensive about limitations. Acknowledging them is more impressive than glossing over them.</a:t>
+              <a:t>• 'I picked God Service as the example because it's the cleanest illustration of how code-level signals feed an architectural-level finding.'
+• Walk through left side: 'For each service, a Spoon-based analysis parses every class and computes structural metrics — field count, public method count, lines of code, import domains, constructor parameters, and class cohesion. The God Service detector flags any microservice containing at least one class identified as a God Class.'
+• Right side: 'A class is flagged as a God Class when it exceeds at least three of the six metrics. Pure data holders such as entities and DTOs are excluded first, since they naturally have many fields and low cohesion without being an anti-pattern.'
+• On TCC: 'Tight Class Cohesion measures the fraction of method pairs that share an instance field access. Low TCC means the methods operate on disjoint state — a sign of unrelated responsibilities packed into one class.'
+EXPECT THIS QUESTION: 'Why does one God Class flag a service?'
+Answer: 'The default is intentionally sensitive. False positives are cheap to dismiss. False negatives — architectural debt growing undetected — are expensive. The threshold is configurable; teams in production would calibrate it. Even one class concentrating that many responsibilities is worth a look.'
+If asked where DesigniteJava fits: 'DesigniteJava runs per service for code smells, but its catalogue is abstraction and modularization smells rather than a literal God Class. So God Service detection is driven by the Spoon structural metrics, and DesigniteJava smell density feeds the code-quality category of the health score instead.'</a:t>
             </a:r>
           </a:p>
         </p:txBody>
@@ -1444,13 +1392,46 @@
           <a:p>
             <a:r>
               <a:rPr lang="en-US" dirty="0"/>
-              <a:t>• 'I picked God Service as the example because it's the cleanest illustration of how code-level signals feed an architectural-level finding.'
-• Walk through left side: 'DesigniteJava detects God Class smells per class. Those are persisted as CodeSmell entities in the database. The God Service detector then queries that table and flags any microservice containing one or more God Classes.'
-• Right side: 'But what if DesigniteJava fails or is disabled? The detector falls back to its own Spoon-based analysis using six structural metrics. A class is flagged if it exceeds at least three.'
-• On TCC: 'Tight Class Cohesion measures the fraction of method pairs that share an instance field access. Low TCC means the methods operate on disjoint state — a sign of unrelated responsibilities packed into one class.'
-EXPECT THIS QUESTION: 'Why threshold = 1? One God Class shouldn't flag a service.'
-Answer: 'The default is intentionally sensitive. False positives are cheap to dismiss. False negatives — architectural debt growing undetected — are expensive. The threshold is configurable; teams in production would calibrate it. Even one God Class concentrates responsibilities enough to warrant a look.'
-You can also note: 'The dual-path approach — DesigniteJava primary, Spoon fallback — is a pattern I used across several detectors. It makes the tool resilient to external-tool failures and also lets us cross-validate results when both paths are available.'</a:t>
+              <a:t>• 'These are the ten detectors, organised by architectural dimension. Each is a Spring component implementing a common interface, so adding a new detector means writing one class — no orchestrator changes.'
+• 'Severities feed directly into the health score: critical issues cost 8 points, high cost 5, medium cost 3.'
+</a:t>
+            </a:r>
+          </a:p>
+          <a:p>
+            <a:r>
+              <a:rPr lang="en-US" dirty="0"/>
+              <a:t>'The severity levels aren't arbitrary — they reflect how much damage the anti-pattern can cause. Cyclic Dependency and Distributed Monolith are critical because they undermine independent </a:t>
+            </a:r>
+            <a:r>
+              <a:rPr lang="en-US" dirty="0" err="1"/>
+              <a:t>deployability</a:t>
+            </a:r>
+            <a:r>
+              <a:rPr lang="en-US" dirty="0"/>
+              <a:t> entirely. Hardcoded Endpoints and API Versioning are medium because they're easier to fix and their impact is more </a:t>
+            </a:r>
+            <a:r>
+              <a:rPr lang="en-US" dirty="0" err="1"/>
+              <a:t>localised</a:t>
+            </a:r>
+            <a:r>
+              <a:rPr lang="en-US" dirty="0"/>
+              <a:t>.'</a:t>
+            </a:r>
+          </a:p>
+          <a:p>
+            <a:r>
+              <a:rPr lang="en-US" dirty="0"/>
+              <a:t>
+If a committee member asks about a specific detector:
+• Shared DB — group services by spring.datasource.url, flag groups of size &gt; 1
+• Cyclic Dependency — Tarjan's SCC on the dep graph, any SCC &gt; 1 vertex is a cycle
+• Chatty Service — call count per edge ≥ 10 OR a Feign interface with ≥ 10 methods
+• Hardcoded Endpoints — regex scan of .java for http://, localhost:, IP literals (with comment/test exclusions)
+• Distributed Monolith — composite rule on coupling coefficient, connected ratio, shared DB count
+• API Versioning — regex /v\d+[/.] on endpoint paths
+• ESB Misuse — caller/callee ratios + volume-based mediator ratio
+• Wrong Cuts — bidirectional edges between a service pair</a:t>
             </a:r>
           </a:p>
         </p:txBody>
@@ -1547,14 +1528,14 @@
           <a:p>
             <a:r>
               <a:rPr lang="en-US" dirty="0"/>
-              <a:t>'The weights were informed by how other composite metrics work in the literature — SonarQube's maintainability rating, SQALE, and the ISO 25010 quality model. Anti-patterns get the largest budget because they represent architectural-level issues that are expensive to fix after deployment.'</a:t>
+              <a:t>'The weights were informed by how other composite metrics work in the literature — SonarQube's maintainability rating, SQALE, and the ISO 25010 quality model. Anti-patterns get the largest budget because they represent architectural-level issues that are expensive to fix after deployment.’
+</a:t>
             </a:r>
           </a:p>
           <a:p>
             <a:r>
               <a:rPr lang="en-US" dirty="0"/>
-              <a:t>
-EXPECT THIS QUESTION: 'Doesn't clamping at zero mean you lose discrimination between moderately bad and very bad projects?'
+              <a:t>EXPECT THIS QUESTION: 'Doesn't clamping at zero mean you lose discrimination between moderately bad and very bad projects?'
 Answer: 'Yes — that's a known limitation of the category-cap approach, which I note in the threats to validity. A team with 13 nano services and one with 50 would both see Anti-Patterns at zero. The Service Sizing breakdown still preserves the per-issue counts, so the full picture is still visible to the user. A scaled, density-style penalty in the AP category — similar to the Code Quality category — would address this in future work.'</a:t>
             </a:r>
           </a:p>
@@ -1647,9 +1628,17 @@
 • 'Architecture loses 9 points for the structural coupling of its dependency graph — leaving 16 of 25.'
 • 'Code Quality is scored by smell density: 260 smells over 8.3K LOC is 31.4 per KLOC, an 8-point deduction, leaving 12 of 20.'
 • 'The final composite is 0 + 12 + 16 + 12 = 40 — grade F. Unlike a project whose problems sit in one place, this one loses points in every dimension, which is exactly what the multi-level scoring is meant to surface.'
-What makes this example interesting is that the problems are spread across all four categories — it's not a project with one catastrophic issue, it's a project with consistent low-level neglect across every dimension. That's exactly the kind of systemic debt the multi-category decomposition is designed to surface.'
-EXPECT QUESTION: 'Only 8 points lost on Code Quality with 260 smells — why so little?'
-Answer: 'Code Quality is scored on smell density per 1000 LOC, not raw count, so a codebase isn't punished just for its size. The category is deliberately bounded so that architectural anti-patterns remain the dominant signal in the overall score.'</a:t>
+This demonstrates that the scoring is transparent and that the breakdown shows exactly what's wrong.
+'What makes this example interesting is that the problems are spread across all four categories — it's not a project with one catastrophic issue, it's a project with consistent low-level neglect across every dimension. That's exactly the kind of systemic debt the multi-category decomposition is designed to surface.’
+</a:t>
+            </a:r>
+          </a:p>
+          <a:p>
+            <a:r>
+              <a:rPr lang="en-US" dirty="0"/>
+              <a:t>EXPECT QUESTION: 'Only 8 points lost on Code Quality with 260 smells — why so little?'
+Answer: 'Code Quality is scored on smell density per 1000 LOC, not raw count, so a codebase isn't punished just for its size. The category is deliberately bounded so that architectural anti-patterns remain the dominant signal in the overall score.'
+</a:t>
             </a:r>
           </a:p>
         </p:txBody>
@@ -1738,9 +1727,9 @@
               <a:rPr lang="en-US" dirty="0"/>
               <a:t>• 'I evaluated on eleven open-source Spring Boot projects, spanning from piomin at 1.3k LOC to mall-swarm at 86k LOC. 130 microservices, about 274k LOC total.'
 • 'Health scores ranged from 40 to 83 — the scoring mechanism produces meaningful spread.'
-• 'The dominant findings are configuration and sizing issues: 43 hardcoded endpoints, 37 API versioning absences, 23 nano services. Cyclic Dependency and Wrong Cuts were detected in microservice-recruit. Adding PiggyMetrics and piomin broadened ESB Misuse and Nano Service coverage.'
+• 'The dominant findings are configuration and sizing issues: 43 hardcoded endpoints, 37 API versioning absences, 23 nano services. 
 • '126 total anti-pattern instances across 9 distinct types. Only Distributed Monolith was not detected — plausible given these projects' topologies.'
-You can add: 'The score range — 40 to 83 — shows that the metric has useful discriminating power. Projects known to be well-structured score highest; projects known to have issues like Train-Ticket and microservice-recruit score lowest. If every project scored 70, the metric wouldn't be telling us much.'
+You can add: 'The score range — 40 to 83 — shows that the metric has useful discriminating power. Projects known to be well-structured like MicroSocial score highest; projects known to have issues like Train-Ticket and microservice-recruit score lowest. If every project scored 70, the metric wouldn't be telling us much.'
 EXPECT: 'Only eleven projects, is that enough?'
 Answer: 'Not for a statistical claim. This evaluation is a feasibility demonstration across heterogeneous codebases. A full precision/recall study would need a labelled corpus, which doesn't exist for microservice anti-patterns — that's an open problem in the field. I note this in Threats to Validity.'</a:t>
             </a:r>
@@ -2144,13 +2133,6 @@
             <a:prstDash val="solid"/>
           </a:ln>
         </p:spPr>
-        <p:txBody>
-          <a:bodyPr/>
-          <a:lstStyle/>
-          <a:p>
-            <a:endParaRPr lang="en-US"/>
-          </a:p>
-        </p:txBody>
       </p:sp>
       <p:sp>
         <p:nvSpPr>
@@ -2176,13 +2158,6 @@
             <a:prstDash val="solid"/>
           </a:ln>
         </p:spPr>
-        <p:txBody>
-          <a:bodyPr/>
-          <a:lstStyle/>
-          <a:p>
-            <a:endParaRPr lang="en-US"/>
-          </a:p>
-        </p:txBody>
       </p:sp>
       <p:pic>
         <p:nvPicPr>
@@ -2372,13 +2347,6 @@
             <a:prstDash val="solid"/>
           </a:ln>
         </p:spPr>
-        <p:txBody>
-          <a:bodyPr/>
-          <a:lstStyle/>
-          <a:p>
-            <a:endParaRPr lang="en-US"/>
-          </a:p>
-        </p:txBody>
       </p:sp>
       <p:sp>
         <p:nvSpPr>
@@ -2527,13 +2495,6 @@
             <a:prstDash val="solid"/>
           </a:ln>
         </p:spPr>
-        <p:txBody>
-          <a:bodyPr/>
-          <a:lstStyle/>
-          <a:p>
-            <a:endParaRPr lang="en-US"/>
-          </a:p>
-        </p:txBody>
       </p:sp>
       <p:sp>
         <p:nvSpPr>
@@ -2621,8 +2582,8 @@
         </p:nvSpPr>
         <p:spPr>
           <a:xfrm>
-            <a:off x="604911" y="2399647"/>
-            <a:ext cx="5486401" cy="2305996"/>
+            <a:off x="685800" y="2528316"/>
+            <a:ext cx="5373255" cy="2148840"/>
           </a:xfrm>
           <a:prstGeom prst="rect">
             <a:avLst/>
@@ -2637,13 +2598,6 @@
             <a:prstDash val="solid"/>
           </a:ln>
         </p:spPr>
-        <p:txBody>
-          <a:bodyPr/>
-          <a:lstStyle/>
-          <a:p>
-            <a:endParaRPr lang="en-US"/>
-          </a:p>
-        </p:txBody>
       </p:sp>
       <p:sp>
         <p:nvSpPr>
@@ -2653,7 +2607,7 @@
         </p:nvSpPr>
         <p:spPr>
           <a:xfrm>
-            <a:off x="914400" y="2592977"/>
+            <a:off x="914400" y="2651760"/>
             <a:ext cx="384048" cy="384048"/>
           </a:xfrm>
           <a:prstGeom prst="ellipse">
@@ -2669,13 +2623,6 @@
             <a:prstDash val="solid"/>
           </a:ln>
         </p:spPr>
-        <p:txBody>
-          <a:bodyPr/>
-          <a:lstStyle/>
-          <a:p>
-            <a:endParaRPr lang="en-US"/>
-          </a:p>
-        </p:txBody>
       </p:sp>
       <p:sp>
         <p:nvSpPr>
@@ -2685,7 +2632,7 @@
         </p:nvSpPr>
         <p:spPr>
           <a:xfrm>
-            <a:off x="914400" y="2592977"/>
+            <a:off x="914400" y="2651760"/>
             <a:ext cx="384048" cy="384048"/>
           </a:xfrm>
           <a:prstGeom prst="rect">
@@ -2724,7 +2671,7 @@
         </p:nvSpPr>
         <p:spPr>
           <a:xfrm>
-            <a:off x="1463040" y="2565545"/>
+            <a:off x="1463040" y="2624328"/>
             <a:ext cx="6858000" cy="256032"/>
           </a:xfrm>
           <a:prstGeom prst="rect">
@@ -2763,7 +2710,7 @@
         </p:nvSpPr>
         <p:spPr>
           <a:xfrm>
-            <a:off x="1463040" y="2803289"/>
+            <a:off x="1463040" y="2862072"/>
             <a:ext cx="6858000" cy="237744"/>
           </a:xfrm>
           <a:prstGeom prst="rect">
@@ -2802,7 +2749,7 @@
         </p:nvSpPr>
         <p:spPr>
           <a:xfrm>
-            <a:off x="914400" y="3095897"/>
+            <a:off x="914400" y="3154680"/>
             <a:ext cx="384048" cy="384048"/>
           </a:xfrm>
           <a:prstGeom prst="ellipse">
@@ -2818,13 +2765,6 @@
             <a:prstDash val="solid"/>
           </a:ln>
         </p:spPr>
-        <p:txBody>
-          <a:bodyPr/>
-          <a:lstStyle/>
-          <a:p>
-            <a:endParaRPr lang="en-US"/>
-          </a:p>
-        </p:txBody>
       </p:sp>
       <p:sp>
         <p:nvSpPr>
@@ -2834,7 +2774,7 @@
         </p:nvSpPr>
         <p:spPr>
           <a:xfrm>
-            <a:off x="914400" y="3095897"/>
+            <a:off x="914400" y="3154680"/>
             <a:ext cx="384048" cy="384048"/>
           </a:xfrm>
           <a:prstGeom prst="rect">
@@ -2873,7 +2813,7 @@
         </p:nvSpPr>
         <p:spPr>
           <a:xfrm>
-            <a:off x="1463040" y="3068465"/>
+            <a:off x="1463040" y="3127248"/>
             <a:ext cx="6858000" cy="256032"/>
           </a:xfrm>
           <a:prstGeom prst="rect">
@@ -2912,7 +2852,7 @@
         </p:nvSpPr>
         <p:spPr>
           <a:xfrm>
-            <a:off x="1463040" y="3306209"/>
+            <a:off x="1463040" y="3364992"/>
             <a:ext cx="6858000" cy="237744"/>
           </a:xfrm>
           <a:prstGeom prst="rect">
@@ -2951,7 +2891,7 @@
         </p:nvSpPr>
         <p:spPr>
           <a:xfrm>
-            <a:off x="914400" y="3598817"/>
+            <a:off x="914400" y="3657600"/>
             <a:ext cx="384048" cy="384048"/>
           </a:xfrm>
           <a:prstGeom prst="ellipse">
@@ -2967,13 +2907,6 @@
             <a:prstDash val="solid"/>
           </a:ln>
         </p:spPr>
-        <p:txBody>
-          <a:bodyPr/>
-          <a:lstStyle/>
-          <a:p>
-            <a:endParaRPr lang="en-US"/>
-          </a:p>
-        </p:txBody>
       </p:sp>
       <p:sp>
         <p:nvSpPr>
@@ -2983,7 +2916,7 @@
         </p:nvSpPr>
         <p:spPr>
           <a:xfrm>
-            <a:off x="914400" y="3598817"/>
+            <a:off x="914400" y="3657600"/>
             <a:ext cx="384048" cy="384048"/>
           </a:xfrm>
           <a:prstGeom prst="rect">
@@ -3022,7 +2955,7 @@
         </p:nvSpPr>
         <p:spPr>
           <a:xfrm>
-            <a:off x="1463040" y="3571385"/>
+            <a:off x="1463040" y="3630168"/>
             <a:ext cx="6858000" cy="256032"/>
           </a:xfrm>
           <a:prstGeom prst="rect">
@@ -3061,7 +2994,7 @@
         </p:nvSpPr>
         <p:spPr>
           <a:xfrm>
-            <a:off x="1463040" y="3809129"/>
+            <a:off x="1463040" y="3867912"/>
             <a:ext cx="6858000" cy="237744"/>
           </a:xfrm>
           <a:prstGeom prst="rect">
@@ -3100,7 +3033,7 @@
         </p:nvSpPr>
         <p:spPr>
           <a:xfrm>
-            <a:off x="914400" y="4101737"/>
+            <a:off x="914400" y="4160520"/>
             <a:ext cx="384048" cy="384048"/>
           </a:xfrm>
           <a:prstGeom prst="ellipse">
@@ -3116,13 +3049,6 @@
             <a:prstDash val="solid"/>
           </a:ln>
         </p:spPr>
-        <p:txBody>
-          <a:bodyPr/>
-          <a:lstStyle/>
-          <a:p>
-            <a:endParaRPr lang="en-US"/>
-          </a:p>
-        </p:txBody>
       </p:sp>
       <p:sp>
         <p:nvSpPr>
@@ -3132,7 +3058,7 @@
         </p:nvSpPr>
         <p:spPr>
           <a:xfrm>
-            <a:off x="914400" y="4101737"/>
+            <a:off x="914400" y="4160520"/>
             <a:ext cx="384048" cy="384048"/>
           </a:xfrm>
           <a:prstGeom prst="rect">
@@ -3171,7 +3097,7 @@
         </p:nvSpPr>
         <p:spPr>
           <a:xfrm>
-            <a:off x="1463040" y="4074305"/>
+            <a:off x="1463040" y="4133088"/>
             <a:ext cx="6858000" cy="256032"/>
           </a:xfrm>
           <a:prstGeom prst="rect">
@@ -3210,7 +3136,7 @@
         </p:nvSpPr>
         <p:spPr>
           <a:xfrm>
-            <a:off x="1463040" y="4312049"/>
+            <a:off x="1463040" y="4370832"/>
             <a:ext cx="6858000" cy="237744"/>
           </a:xfrm>
           <a:prstGeom prst="rect">
@@ -3415,13 +3341,6 @@
             <a:prstDash val="solid"/>
           </a:ln>
         </p:spPr>
-        <p:txBody>
-          <a:bodyPr/>
-          <a:lstStyle/>
-          <a:p>
-            <a:endParaRPr lang="en-US" dirty="0"/>
-          </a:p>
-        </p:txBody>
       </p:sp>
       <p:sp>
         <p:nvSpPr>
@@ -3447,13 +3366,6 @@
             <a:prstDash val="solid"/>
           </a:ln>
         </p:spPr>
-        <p:txBody>
-          <a:bodyPr/>
-          <a:lstStyle/>
-          <a:p>
-            <a:endParaRPr lang="en-US"/>
-          </a:p>
-        </p:txBody>
       </p:sp>
       <p:sp>
         <p:nvSpPr>
@@ -3488,13 +3400,6 @@
             </a:outerShdw>
           </a:effectLst>
         </p:spPr>
-        <p:txBody>
-          <a:bodyPr/>
-          <a:lstStyle/>
-          <a:p>
-            <a:endParaRPr lang="en-US"/>
-          </a:p>
-        </p:txBody>
       </p:sp>
       <p:pic>
         <p:nvPicPr>
@@ -3710,13 +3615,6 @@
             <a:prstDash val="solid"/>
           </a:ln>
         </p:spPr>
-        <p:txBody>
-          <a:bodyPr/>
-          <a:lstStyle/>
-          <a:p>
-            <a:endParaRPr lang="en-US"/>
-          </a:p>
-        </p:txBody>
       </p:sp>
       <p:sp>
         <p:nvSpPr>
@@ -3742,13 +3640,6 @@
             <a:prstDash val="solid"/>
           </a:ln>
         </p:spPr>
-        <p:txBody>
-          <a:bodyPr/>
-          <a:lstStyle/>
-          <a:p>
-            <a:endParaRPr lang="en-US"/>
-          </a:p>
-        </p:txBody>
       </p:sp>
       <p:sp>
         <p:nvSpPr>
@@ -3783,13 +3674,6 @@
             </a:outerShdw>
           </a:effectLst>
         </p:spPr>
-        <p:txBody>
-          <a:bodyPr/>
-          <a:lstStyle/>
-          <a:p>
-            <a:endParaRPr lang="en-US"/>
-          </a:p>
-        </p:txBody>
       </p:sp>
       <p:pic>
         <p:nvPicPr>
@@ -4095,13 +3979,6 @@
             <a:prstDash val="solid"/>
           </a:ln>
         </p:spPr>
-        <p:txBody>
-          <a:bodyPr/>
-          <a:lstStyle/>
-          <a:p>
-            <a:endParaRPr lang="en-US"/>
-          </a:p>
-        </p:txBody>
       </p:sp>
       <p:sp>
         <p:nvSpPr>
@@ -4166,6 +4043,17 @@
             <a:pPr marL="0" indent="0">
               <a:buNone/>
             </a:pPr>
+            <a:r>
+              <a:rPr lang="en-US" sz="2000" i="1" dirty="0">
+                <a:solidFill>
+                  <a:srgbClr val="DBEAFE"/>
+                </a:solidFill>
+                <a:latin typeface="Calibri" pitchFamily="34" charset="0"/>
+                <a:ea typeface="Calibri" pitchFamily="34" charset="-122"/>
+                <a:cs typeface="Calibri" pitchFamily="34" charset="-120"/>
+              </a:rPr>
+              <a:t>Questions &amp; discussion</a:t>
+            </a:r>
             <a:endParaRPr lang="en-US" sz="2000" dirty="0"/>
           </a:p>
         </p:txBody>
@@ -4178,8 +4066,8 @@
         </p:nvSpPr>
         <p:spPr>
           <a:xfrm>
-            <a:off x="731520" y="2606040"/>
-            <a:ext cx="6126480" cy="1783080"/>
+            <a:off x="731520" y="2697479"/>
+            <a:ext cx="6241935" cy="1691641"/>
           </a:xfrm>
           <a:prstGeom prst="rect">
             <a:avLst/>
@@ -4194,13 +4082,6 @@
             <a:prstDash val="solid"/>
           </a:ln>
         </p:spPr>
-        <p:txBody>
-          <a:bodyPr/>
-          <a:lstStyle/>
-          <a:p>
-            <a:endParaRPr lang="en-US"/>
-          </a:p>
-        </p:txBody>
       </p:sp>
       <p:sp>
         <p:nvSpPr>
@@ -4249,7 +4130,7 @@
         </p:nvSpPr>
         <p:spPr>
           <a:xfrm>
-            <a:off x="1005840" y="2926080"/>
+            <a:off x="1097280" y="3017520"/>
             <a:ext cx="7315200" cy="1371600"/>
           </a:xfrm>
           <a:prstGeom prst="rect">
@@ -4521,13 +4402,6 @@
             <a:prstDash val="solid"/>
           </a:ln>
         </p:spPr>
-        <p:txBody>
-          <a:bodyPr/>
-          <a:lstStyle/>
-          <a:p>
-            <a:endParaRPr lang="en-US"/>
-          </a:p>
-        </p:txBody>
       </p:sp>
       <p:sp>
         <p:nvSpPr>
@@ -4553,13 +4427,6 @@
             <a:prstDash val="solid"/>
           </a:ln>
         </p:spPr>
-        <p:txBody>
-          <a:bodyPr/>
-          <a:lstStyle/>
-          <a:p>
-            <a:endParaRPr lang="en-US"/>
-          </a:p>
-        </p:txBody>
       </p:sp>
       <p:sp>
         <p:nvSpPr>
@@ -4594,13 +4461,6 @@
             </a:outerShdw>
           </a:effectLst>
         </p:spPr>
-        <p:txBody>
-          <a:bodyPr/>
-          <a:lstStyle/>
-          <a:p>
-            <a:endParaRPr lang="en-US"/>
-          </a:p>
-        </p:txBody>
       </p:sp>
       <p:pic>
         <p:nvPicPr>
@@ -4728,13 +4588,6 @@
             <a:prstDash val="solid"/>
           </a:ln>
         </p:spPr>
-        <p:txBody>
-          <a:bodyPr/>
-          <a:lstStyle/>
-          <a:p>
-            <a:endParaRPr lang="en-US"/>
-          </a:p>
-        </p:txBody>
       </p:sp>
       <p:sp>
         <p:nvSpPr>
@@ -4760,13 +4613,6 @@
             <a:prstDash val="solid"/>
           </a:ln>
         </p:spPr>
-        <p:txBody>
-          <a:bodyPr/>
-          <a:lstStyle/>
-          <a:p>
-            <a:endParaRPr lang="en-US"/>
-          </a:p>
-        </p:txBody>
       </p:sp>
       <p:sp>
         <p:nvSpPr>
@@ -4801,13 +4647,6 @@
             </a:outerShdw>
           </a:effectLst>
         </p:spPr>
-        <p:txBody>
-          <a:bodyPr/>
-          <a:lstStyle/>
-          <a:p>
-            <a:endParaRPr lang="en-US"/>
-          </a:p>
-        </p:txBody>
       </p:sp>
       <p:pic>
         <p:nvPicPr>
@@ -4935,13 +4774,6 @@
             <a:prstDash val="solid"/>
           </a:ln>
         </p:spPr>
-        <p:txBody>
-          <a:bodyPr/>
-          <a:lstStyle/>
-          <a:p>
-            <a:endParaRPr lang="en-US"/>
-          </a:p>
-        </p:txBody>
       </p:sp>
       <p:sp>
         <p:nvSpPr>
@@ -4967,13 +4799,6 @@
             <a:prstDash val="solid"/>
           </a:ln>
         </p:spPr>
-        <p:txBody>
-          <a:bodyPr/>
-          <a:lstStyle/>
-          <a:p>
-            <a:endParaRPr lang="en-US"/>
-          </a:p>
-        </p:txBody>
       </p:sp>
       <p:sp>
         <p:nvSpPr>
@@ -5008,13 +4833,6 @@
             </a:outerShdw>
           </a:effectLst>
         </p:spPr>
-        <p:txBody>
-          <a:bodyPr/>
-          <a:lstStyle/>
-          <a:p>
-            <a:endParaRPr lang="en-US"/>
-          </a:p>
-        </p:txBody>
       </p:sp>
       <p:pic>
         <p:nvPicPr>
@@ -5142,13 +4960,6 @@
             <a:prstDash val="solid"/>
           </a:ln>
         </p:spPr>
-        <p:txBody>
-          <a:bodyPr/>
-          <a:lstStyle/>
-          <a:p>
-            <a:endParaRPr lang="en-US"/>
-          </a:p>
-        </p:txBody>
       </p:sp>
       <p:sp>
         <p:nvSpPr>
@@ -5372,13 +5183,6 @@
             </a:outerShdw>
           </a:effectLst>
         </p:spPr>
-        <p:txBody>
-          <a:bodyPr/>
-          <a:lstStyle/>
-          <a:p>
-            <a:endParaRPr lang="en-US"/>
-          </a:p>
-        </p:txBody>
       </p:sp>
       <p:pic>
         <p:nvPicPr>
@@ -5476,7 +5280,7 @@
                 <a:ea typeface="Calibri" pitchFamily="34" charset="-122"/>
                 <a:cs typeface="Calibri" pitchFamily="34" charset="-120"/>
               </a:rPr>
-              <a:t>Combines intra-service code smells (DesigniteJava) with inter-service dependency analysis (Spoon + graphs)</a:t>
+              <a:t>Combines intra-service code analysis (DesigniteJava smells + Spoon structural metrics) with inter-service dependency analysis (graph algorithms)</a:t>
             </a:r>
             <a:endParaRPr lang="en-US" sz="1150" dirty="0"/>
           </a:p>
@@ -5515,13 +5319,6 @@
             </a:outerShdw>
           </a:effectLst>
         </p:spPr>
-        <p:txBody>
-          <a:bodyPr/>
-          <a:lstStyle/>
-          <a:p>
-            <a:endParaRPr lang="en-US"/>
-          </a:p>
-        </p:txBody>
       </p:sp>
       <p:pic>
         <p:nvPicPr>
@@ -5658,13 +5455,6 @@
             </a:outerShdw>
           </a:effectLst>
         </p:spPr>
-        <p:txBody>
-          <a:bodyPr/>
-          <a:lstStyle/>
-          <a:p>
-            <a:endParaRPr lang="en-US"/>
-          </a:p>
-        </p:txBody>
       </p:sp>
       <p:pic>
         <p:nvPicPr>
@@ -5801,13 +5591,6 @@
             </a:outerShdw>
           </a:effectLst>
         </p:spPr>
-        <p:txBody>
-          <a:bodyPr/>
-          <a:lstStyle/>
-          <a:p>
-            <a:endParaRPr lang="en-US"/>
-          </a:p>
-        </p:txBody>
       </p:sp>
       <p:pic>
         <p:nvPicPr>
@@ -5944,13 +5727,6 @@
             </a:outerShdw>
           </a:effectLst>
         </p:spPr>
-        <p:txBody>
-          <a:bodyPr/>
-          <a:lstStyle/>
-          <a:p>
-            <a:endParaRPr lang="en-US"/>
-          </a:p>
-        </p:txBody>
       </p:sp>
       <p:pic>
         <p:nvPicPr>
@@ -6228,13 +6004,6 @@
             <a:prstDash val="solid"/>
           </a:ln>
         </p:spPr>
-        <p:txBody>
-          <a:bodyPr/>
-          <a:lstStyle/>
-          <a:p>
-            <a:endParaRPr lang="en-US"/>
-          </a:p>
-        </p:txBody>
       </p:sp>
       <p:sp>
         <p:nvSpPr>
@@ -6260,13 +6029,6 @@
             <a:prstDash val="solid"/>
           </a:ln>
         </p:spPr>
-        <p:txBody>
-          <a:bodyPr/>
-          <a:lstStyle/>
-          <a:p>
-            <a:endParaRPr lang="en-US"/>
-          </a:p>
-        </p:txBody>
       </p:sp>
       <p:sp>
         <p:nvSpPr>
@@ -6301,13 +6063,6 @@
             </a:outerShdw>
           </a:effectLst>
         </p:spPr>
-        <p:txBody>
-          <a:bodyPr/>
-          <a:lstStyle/>
-          <a:p>
-            <a:endParaRPr lang="en-US"/>
-          </a:p>
-        </p:txBody>
       </p:sp>
       <p:pic>
         <p:nvPicPr>
@@ -6459,13 +6214,6 @@
             <a:prstDash val="solid"/>
           </a:ln>
         </p:spPr>
-        <p:txBody>
-          <a:bodyPr/>
-          <a:lstStyle/>
-          <a:p>
-            <a:endParaRPr lang="en-US"/>
-          </a:p>
-        </p:txBody>
       </p:sp>
       <p:sp>
         <p:nvSpPr>
@@ -6491,13 +6239,6 @@
             <a:prstDash val="solid"/>
           </a:ln>
         </p:spPr>
-        <p:txBody>
-          <a:bodyPr/>
-          <a:lstStyle/>
-          <a:p>
-            <a:endParaRPr lang="en-US"/>
-          </a:p>
-        </p:txBody>
       </p:sp>
       <p:sp>
         <p:nvSpPr>
@@ -6532,13 +6273,6 @@
             </a:outerShdw>
           </a:effectLst>
         </p:spPr>
-        <p:txBody>
-          <a:bodyPr/>
-          <a:lstStyle/>
-          <a:p>
-            <a:endParaRPr lang="en-US"/>
-          </a:p>
-        </p:txBody>
       </p:sp>
       <p:pic>
         <p:nvPicPr>
@@ -6690,13 +6424,6 @@
             <a:prstDash val="solid"/>
           </a:ln>
         </p:spPr>
-        <p:txBody>
-          <a:bodyPr/>
-          <a:lstStyle/>
-          <a:p>
-            <a:endParaRPr lang="en-US"/>
-          </a:p>
-        </p:txBody>
       </p:sp>
       <p:sp>
         <p:nvSpPr>
@@ -6722,13 +6449,6 @@
             <a:prstDash val="solid"/>
           </a:ln>
         </p:spPr>
-        <p:txBody>
-          <a:bodyPr/>
-          <a:lstStyle/>
-          <a:p>
-            <a:endParaRPr lang="en-US"/>
-          </a:p>
-        </p:txBody>
       </p:sp>
       <p:sp>
         <p:nvSpPr>
@@ -6763,13 +6483,6 @@
             </a:outerShdw>
           </a:effectLst>
         </p:spPr>
-        <p:txBody>
-          <a:bodyPr/>
-          <a:lstStyle/>
-          <a:p>
-            <a:endParaRPr lang="en-US"/>
-          </a:p>
-        </p:txBody>
       </p:sp>
       <p:pic>
         <p:nvPicPr>
@@ -6921,13 +6634,6 @@
             <a:prstDash val="solid"/>
           </a:ln>
         </p:spPr>
-        <p:txBody>
-          <a:bodyPr/>
-          <a:lstStyle/>
-          <a:p>
-            <a:endParaRPr lang="en-US"/>
-          </a:p>
-        </p:txBody>
       </p:sp>
       <p:sp>
         <p:nvSpPr>
@@ -6953,13 +6659,6 @@
             <a:prstDash val="solid"/>
           </a:ln>
         </p:spPr>
-        <p:txBody>
-          <a:bodyPr/>
-          <a:lstStyle/>
-          <a:p>
-            <a:endParaRPr lang="en-US"/>
-          </a:p>
-        </p:txBody>
       </p:sp>
       <p:sp>
         <p:nvSpPr>
@@ -6994,13 +6693,6 @@
             </a:outerShdw>
           </a:effectLst>
         </p:spPr>
-        <p:txBody>
-          <a:bodyPr/>
-          <a:lstStyle/>
-          <a:p>
-            <a:endParaRPr lang="en-US"/>
-          </a:p>
-        </p:txBody>
       </p:sp>
       <p:pic>
         <p:nvPicPr>
@@ -7152,13 +6844,6 @@
             <a:prstDash val="solid"/>
           </a:ln>
         </p:spPr>
-        <p:txBody>
-          <a:bodyPr/>
-          <a:lstStyle/>
-          <a:p>
-            <a:endParaRPr lang="en-US"/>
-          </a:p>
-        </p:txBody>
       </p:sp>
       <p:sp>
         <p:nvSpPr>
@@ -7184,13 +6869,6 @@
             <a:prstDash val="solid"/>
           </a:ln>
         </p:spPr>
-        <p:txBody>
-          <a:bodyPr/>
-          <a:lstStyle/>
-          <a:p>
-            <a:endParaRPr lang="en-US"/>
-          </a:p>
-        </p:txBody>
       </p:sp>
       <p:sp>
         <p:nvSpPr>
@@ -7225,13 +6903,6 @@
             </a:outerShdw>
           </a:effectLst>
         </p:spPr>
-        <p:txBody>
-          <a:bodyPr/>
-          <a:lstStyle/>
-          <a:p>
-            <a:endParaRPr lang="en-US"/>
-          </a:p>
-        </p:txBody>
       </p:sp>
       <p:pic>
         <p:nvPicPr>
@@ -7359,13 +7030,6 @@
             <a:prstDash val="solid"/>
           </a:ln>
         </p:spPr>
-        <p:txBody>
-          <a:bodyPr/>
-          <a:lstStyle/>
-          <a:p>
-            <a:endParaRPr lang="en-US"/>
-          </a:p>
-        </p:txBody>
       </p:sp>
       <p:sp>
         <p:nvSpPr>
@@ -7391,13 +7055,6 @@
             <a:prstDash val="solid"/>
           </a:ln>
         </p:spPr>
-        <p:txBody>
-          <a:bodyPr/>
-          <a:lstStyle/>
-          <a:p>
-            <a:endParaRPr lang="en-US"/>
-          </a:p>
-        </p:txBody>
       </p:sp>
       <p:sp>
         <p:nvSpPr>
@@ -7610,6 +7267,882 @@
 </file>
 
 <file path=ppt/slides/slide5.xml><?xml version="1.0" encoding="utf-8"?>
+<p:sld xmlns:a="http://schemas.openxmlformats.org/drawingml/2006/main" xmlns:r="http://schemas.openxmlformats.org/officeDocument/2006/relationships" xmlns:p="http://schemas.openxmlformats.org/presentationml/2006/main">
+  <p:cSld name="Slide 5">
+    <p:bg>
+      <p:bgPr>
+        <a:solidFill>
+          <a:srgbClr val="FFFFFF"/>
+        </a:solidFill>
+        <a:effectLst/>
+      </p:bgPr>
+    </p:bg>
+    <p:spTree>
+      <p:nvGrpSpPr>
+        <p:cNvPr id="1" name=""/>
+        <p:cNvGrpSpPr/>
+        <p:nvPr/>
+      </p:nvGrpSpPr>
+      <p:grpSpPr>
+        <a:xfrm>
+          <a:off x="0" y="0"/>
+          <a:ext cx="0" cy="0"/>
+          <a:chOff x="0" y="0"/>
+          <a:chExt cx="0" cy="0"/>
+        </a:xfrm>
+      </p:grpSpPr>
+      <p:sp>
+        <p:nvSpPr>
+          <p:cNvPr id="2" name="Text 0"/>
+          <p:cNvSpPr/>
+          <p:nvPr/>
+        </p:nvSpPr>
+        <p:spPr>
+          <a:xfrm>
+            <a:off x="457200" y="256032"/>
+            <a:ext cx="8229600" cy="548640"/>
+          </a:xfrm>
+          <a:prstGeom prst="rect">
+            <a:avLst/>
+          </a:prstGeom>
+          <a:noFill/>
+          <a:ln/>
+        </p:spPr>
+        <p:txBody>
+          <a:bodyPr wrap="square" lIns="0" tIns="0" rIns="0" bIns="0" rtlCol="0" anchor="ctr"/>
+          <a:lstStyle/>
+          <a:p>
+            <a:pPr marL="0" indent="0">
+              <a:buNone/>
+            </a:pPr>
+            <a:r>
+              <a:rPr lang="en-US" sz="2800" b="1" dirty="0">
+                <a:solidFill>
+                  <a:srgbClr val="0F2A44"/>
+                </a:solidFill>
+                <a:latin typeface="Calibri" pitchFamily="34" charset="0"/>
+                <a:ea typeface="Calibri" pitchFamily="34" charset="-122"/>
+                <a:cs typeface="Calibri" pitchFamily="34" charset="-120"/>
+              </a:rPr>
+              <a:t>Spotlight: God Service detection</a:t>
+            </a:r>
+            <a:endParaRPr lang="en-US" sz="2800" dirty="0"/>
+          </a:p>
+        </p:txBody>
+      </p:sp>
+      <p:sp>
+        <p:nvSpPr>
+          <p:cNvPr id="3" name="Text 1"/>
+          <p:cNvSpPr/>
+          <p:nvPr/>
+        </p:nvSpPr>
+        <p:spPr>
+          <a:xfrm>
+            <a:off x="457200" y="868680"/>
+            <a:ext cx="3931920" cy="320040"/>
+          </a:xfrm>
+          <a:prstGeom prst="rect">
+            <a:avLst/>
+          </a:prstGeom>
+          <a:noFill/>
+          <a:ln/>
+        </p:spPr>
+        <p:txBody>
+          <a:bodyPr wrap="square" lIns="0" tIns="0" rIns="0" bIns="0" rtlCol="0" anchor="ctr"/>
+          <a:lstStyle/>
+          <a:p>
+            <a:pPr marL="0" indent="0">
+              <a:buNone/>
+            </a:pPr>
+            <a:r>
+              <a:rPr lang="en-US" sz="1400" b="1" dirty="0">
+                <a:solidFill>
+                  <a:srgbClr val="0F2A44"/>
+                </a:solidFill>
+                <a:latin typeface="Calibri" pitchFamily="34" charset="0"/>
+                <a:ea typeface="Calibri" pitchFamily="34" charset="-122"/>
+                <a:cs typeface="Calibri" pitchFamily="34" charset="-120"/>
+              </a:rPr>
+              <a:t>Multi-level bridge in action</a:t>
+            </a:r>
+            <a:endParaRPr lang="en-US" sz="1400" dirty="0"/>
+          </a:p>
+        </p:txBody>
+      </p:sp>
+      <p:sp>
+        <p:nvSpPr>
+          <p:cNvPr id="4" name="Shape 2"/>
+          <p:cNvSpPr/>
+          <p:nvPr/>
+        </p:nvSpPr>
+        <p:spPr>
+          <a:xfrm>
+            <a:off x="457200" y="1280160"/>
+            <a:ext cx="3931920" cy="914400"/>
+          </a:xfrm>
+          <a:prstGeom prst="rect">
+            <a:avLst/>
+          </a:prstGeom>
+          <a:solidFill>
+            <a:srgbClr val="F8FAFC"/>
+          </a:solidFill>
+          <a:ln w="9525">
+            <a:solidFill>
+              <a:srgbClr val="E2E8F0"/>
+            </a:solidFill>
+            <a:prstDash val="solid"/>
+          </a:ln>
+        </p:spPr>
+      </p:sp>
+      <p:sp>
+        <p:nvSpPr>
+          <p:cNvPr id="5" name="Shape 3"/>
+          <p:cNvSpPr/>
+          <p:nvPr/>
+        </p:nvSpPr>
+        <p:spPr>
+          <a:xfrm>
+            <a:off x="457200" y="1280160"/>
+            <a:ext cx="54864" cy="914400"/>
+          </a:xfrm>
+          <a:prstGeom prst="rect">
+            <a:avLst/>
+          </a:prstGeom>
+          <a:solidFill>
+            <a:srgbClr val="1C4E80"/>
+          </a:solidFill>
+          <a:ln w="12700">
+            <a:solidFill>
+              <a:srgbClr val="1C4E80"/>
+            </a:solidFill>
+            <a:prstDash val="solid"/>
+          </a:ln>
+        </p:spPr>
+      </p:sp>
+      <p:sp>
+        <p:nvSpPr>
+          <p:cNvPr id="6" name="Text 4"/>
+          <p:cNvSpPr/>
+          <p:nvPr/>
+        </p:nvSpPr>
+        <p:spPr>
+          <a:xfrm>
+            <a:off x="640080" y="1325880"/>
+            <a:ext cx="3657600" cy="274320"/>
+          </a:xfrm>
+          <a:prstGeom prst="rect">
+            <a:avLst/>
+          </a:prstGeom>
+          <a:noFill/>
+          <a:ln/>
+        </p:spPr>
+        <p:txBody>
+          <a:bodyPr wrap="square" lIns="0" tIns="0" rIns="0" bIns="0" rtlCol="0" anchor="ctr"/>
+          <a:lstStyle/>
+          <a:p>
+            <a:pPr marL="0" indent="0">
+              <a:buNone/>
+            </a:pPr>
+            <a:r>
+              <a:rPr lang="en-US" sz="1100" b="1" dirty="0">
+                <a:solidFill>
+                  <a:srgbClr val="64748B"/>
+                </a:solidFill>
+                <a:latin typeface="Calibri" pitchFamily="34" charset="0"/>
+                <a:ea typeface="Calibri" pitchFamily="34" charset="-122"/>
+                <a:cs typeface="Calibri" pitchFamily="34" charset="-120"/>
+              </a:rPr>
+              <a:t>Code level</a:t>
+            </a:r>
+            <a:endParaRPr lang="en-US" sz="1100" dirty="0"/>
+          </a:p>
+        </p:txBody>
+      </p:sp>
+      <p:sp>
+        <p:nvSpPr>
+          <p:cNvPr id="7" name="Text 5"/>
+          <p:cNvSpPr/>
+          <p:nvPr/>
+        </p:nvSpPr>
+        <p:spPr>
+          <a:xfrm>
+            <a:off x="640080" y="1572768"/>
+            <a:ext cx="3657600" cy="292608"/>
+          </a:xfrm>
+          <a:prstGeom prst="rect">
+            <a:avLst/>
+          </a:prstGeom>
+          <a:noFill/>
+          <a:ln/>
+        </p:spPr>
+        <p:txBody>
+          <a:bodyPr wrap="square" lIns="0" tIns="0" rIns="0" bIns="0" rtlCol="0" anchor="ctr"/>
+          <a:lstStyle/>
+          <a:p>
+            <a:pPr marL="0" indent="0">
+              <a:buNone/>
+            </a:pPr>
+            <a:r>
+              <a:rPr lang="en-US" sz="1300" b="1" dirty="0">
+                <a:solidFill>
+                  <a:srgbClr val="1E293B"/>
+                </a:solidFill>
+                <a:latin typeface="Calibri" pitchFamily="34" charset="0"/>
+                <a:ea typeface="Calibri" pitchFamily="34" charset="-122"/>
+                <a:cs typeface="Calibri" pitchFamily="34" charset="-120"/>
+              </a:rPr>
+              <a:t>Structural class metrics (per class)</a:t>
+            </a:r>
+            <a:endParaRPr lang="en-US" sz="1300" dirty="0"/>
+          </a:p>
+        </p:txBody>
+      </p:sp>
+      <p:sp>
+        <p:nvSpPr>
+          <p:cNvPr id="8" name="Text 6"/>
+          <p:cNvSpPr/>
+          <p:nvPr/>
+        </p:nvSpPr>
+        <p:spPr>
+          <a:xfrm>
+            <a:off x="640080" y="1847088"/>
+            <a:ext cx="3657600" cy="320040"/>
+          </a:xfrm>
+          <a:prstGeom prst="rect">
+            <a:avLst/>
+          </a:prstGeom>
+          <a:noFill/>
+          <a:ln/>
+        </p:spPr>
+        <p:txBody>
+          <a:bodyPr wrap="square" lIns="0" tIns="0" rIns="0" bIns="0" rtlCol="0" anchor="ctr"/>
+          <a:lstStyle/>
+          <a:p>
+            <a:pPr marL="0" indent="0">
+              <a:buNone/>
+            </a:pPr>
+            <a:r>
+              <a:rPr lang="en-US" sz="1000" i="1" dirty="0">
+                <a:solidFill>
+                  <a:srgbClr val="64748B"/>
+                </a:solidFill>
+                <a:latin typeface="Calibri" pitchFamily="34" charset="0"/>
+                <a:ea typeface="Calibri" pitchFamily="34" charset="-122"/>
+                <a:cs typeface="Calibri" pitchFamily="34" charset="-120"/>
+              </a:rPr>
+              <a:t>Computed from the Spoon AST: fields, methods, LOC, cohesion</a:t>
+            </a:r>
+            <a:endParaRPr lang="en-US" sz="1000" dirty="0"/>
+          </a:p>
+        </p:txBody>
+      </p:sp>
+      <p:sp>
+        <p:nvSpPr>
+          <p:cNvPr id="9" name="Shape 7"/>
+          <p:cNvSpPr/>
+          <p:nvPr/>
+        </p:nvSpPr>
+        <p:spPr>
+          <a:xfrm>
+            <a:off x="2423160" y="2286000"/>
+            <a:ext cx="0" cy="320040"/>
+          </a:xfrm>
+          <a:prstGeom prst="line">
+            <a:avLst/>
+          </a:prstGeom>
+          <a:noFill/>
+          <a:ln w="31750">
+            <a:solidFill>
+              <a:srgbClr val="0D9488"/>
+            </a:solidFill>
+            <a:prstDash val="solid"/>
+            <a:tailEnd type="triangle"/>
+          </a:ln>
+        </p:spPr>
+      </p:sp>
+      <p:sp>
+        <p:nvSpPr>
+          <p:cNvPr id="10" name="Shape 8"/>
+          <p:cNvSpPr/>
+          <p:nvPr/>
+        </p:nvSpPr>
+        <p:spPr>
+          <a:xfrm>
+            <a:off x="457200" y="2697480"/>
+            <a:ext cx="3931920" cy="960120"/>
+          </a:xfrm>
+          <a:prstGeom prst="rect">
+            <a:avLst/>
+          </a:prstGeom>
+          <a:solidFill>
+            <a:srgbClr val="F8FAFC"/>
+          </a:solidFill>
+          <a:ln w="9525">
+            <a:solidFill>
+              <a:srgbClr val="E2E8F0"/>
+            </a:solidFill>
+            <a:prstDash val="solid"/>
+          </a:ln>
+        </p:spPr>
+      </p:sp>
+      <p:sp>
+        <p:nvSpPr>
+          <p:cNvPr id="11" name="Shape 9"/>
+          <p:cNvSpPr/>
+          <p:nvPr/>
+        </p:nvSpPr>
+        <p:spPr>
+          <a:xfrm>
+            <a:off x="457200" y="2697480"/>
+            <a:ext cx="54864" cy="960120"/>
+          </a:xfrm>
+          <a:prstGeom prst="rect">
+            <a:avLst/>
+          </a:prstGeom>
+          <a:solidFill>
+            <a:srgbClr val="0D9488"/>
+          </a:solidFill>
+          <a:ln w="12700">
+            <a:solidFill>
+              <a:srgbClr val="0D9488"/>
+            </a:solidFill>
+            <a:prstDash val="solid"/>
+          </a:ln>
+        </p:spPr>
+      </p:sp>
+      <p:sp>
+        <p:nvSpPr>
+          <p:cNvPr id="12" name="Text 10"/>
+          <p:cNvSpPr/>
+          <p:nvPr/>
+        </p:nvSpPr>
+        <p:spPr>
+          <a:xfrm>
+            <a:off x="640080" y="2743200"/>
+            <a:ext cx="3657600" cy="274320"/>
+          </a:xfrm>
+          <a:prstGeom prst="rect">
+            <a:avLst/>
+          </a:prstGeom>
+          <a:noFill/>
+          <a:ln/>
+        </p:spPr>
+        <p:txBody>
+          <a:bodyPr wrap="square" lIns="0" tIns="0" rIns="0" bIns="0" rtlCol="0" anchor="ctr"/>
+          <a:lstStyle/>
+          <a:p>
+            <a:pPr marL="0" indent="0">
+              <a:buNone/>
+            </a:pPr>
+            <a:r>
+              <a:rPr lang="en-US" sz="1100" b="1" dirty="0">
+                <a:solidFill>
+                  <a:srgbClr val="64748B"/>
+                </a:solidFill>
+                <a:latin typeface="Calibri" pitchFamily="34" charset="0"/>
+                <a:ea typeface="Calibri" pitchFamily="34" charset="-122"/>
+                <a:cs typeface="Calibri" pitchFamily="34" charset="-120"/>
+              </a:rPr>
+              <a:t>Architectural level</a:t>
+            </a:r>
+            <a:endParaRPr lang="en-US" sz="1100" dirty="0"/>
+          </a:p>
+        </p:txBody>
+      </p:sp>
+      <p:sp>
+        <p:nvSpPr>
+          <p:cNvPr id="13" name="Text 11"/>
+          <p:cNvSpPr/>
+          <p:nvPr/>
+        </p:nvSpPr>
+        <p:spPr>
+          <a:xfrm>
+            <a:off x="640080" y="2990088"/>
+            <a:ext cx="3657600" cy="292608"/>
+          </a:xfrm>
+          <a:prstGeom prst="rect">
+            <a:avLst/>
+          </a:prstGeom>
+          <a:noFill/>
+          <a:ln/>
+        </p:spPr>
+        <p:txBody>
+          <a:bodyPr wrap="square" lIns="0" tIns="0" rIns="0" bIns="0" rtlCol="0" anchor="ctr"/>
+          <a:lstStyle/>
+          <a:p>
+            <a:pPr marL="0" indent="0">
+              <a:buNone/>
+            </a:pPr>
+            <a:r>
+              <a:rPr lang="en-US" sz="1300" b="1" dirty="0">
+                <a:solidFill>
+                  <a:srgbClr val="1E293B"/>
+                </a:solidFill>
+                <a:latin typeface="Calibri" pitchFamily="34" charset="0"/>
+                <a:ea typeface="Calibri" pitchFamily="34" charset="-122"/>
+                <a:cs typeface="Calibri" pitchFamily="34" charset="-120"/>
+              </a:rPr>
+              <a:t>God Service (per microservice)</a:t>
+            </a:r>
+            <a:endParaRPr lang="en-US" sz="1300" dirty="0"/>
+          </a:p>
+        </p:txBody>
+      </p:sp>
+      <p:sp>
+        <p:nvSpPr>
+          <p:cNvPr id="14" name="Text 12"/>
+          <p:cNvSpPr/>
+          <p:nvPr/>
+        </p:nvSpPr>
+        <p:spPr>
+          <a:xfrm>
+            <a:off x="640080" y="3264408"/>
+            <a:ext cx="3657600" cy="365760"/>
+          </a:xfrm>
+          <a:prstGeom prst="rect">
+            <a:avLst/>
+          </a:prstGeom>
+          <a:noFill/>
+          <a:ln/>
+        </p:spPr>
+        <p:txBody>
+          <a:bodyPr wrap="square" lIns="0" tIns="0" rIns="0" bIns="0" rtlCol="0" anchor="ctr"/>
+          <a:lstStyle/>
+          <a:p>
+            <a:pPr marL="0" indent="0">
+              <a:buNone/>
+            </a:pPr>
+            <a:r>
+              <a:rPr lang="en-US" sz="1000" i="1" dirty="0">
+                <a:solidFill>
+                  <a:srgbClr val="64748B"/>
+                </a:solidFill>
+                <a:latin typeface="Calibri" pitchFamily="34" charset="0"/>
+                <a:ea typeface="Calibri" pitchFamily="34" charset="-122"/>
+                <a:cs typeface="Calibri" pitchFamily="34" charset="-120"/>
+              </a:rPr>
+              <a:t>Flag service if it contains at least one God Class</a:t>
+            </a:r>
+            <a:endParaRPr lang="en-US" sz="1000" dirty="0"/>
+          </a:p>
+        </p:txBody>
+      </p:sp>
+      <p:sp>
+        <p:nvSpPr>
+          <p:cNvPr id="15" name="Text 13"/>
+          <p:cNvSpPr/>
+          <p:nvPr/>
+        </p:nvSpPr>
+        <p:spPr>
+          <a:xfrm>
+            <a:off x="4663440" y="868680"/>
+            <a:ext cx="4023360" cy="320040"/>
+          </a:xfrm>
+          <a:prstGeom prst="rect">
+            <a:avLst/>
+          </a:prstGeom>
+          <a:noFill/>
+          <a:ln/>
+        </p:spPr>
+        <p:txBody>
+          <a:bodyPr wrap="square" lIns="0" tIns="0" rIns="0" bIns="0" rtlCol="0" anchor="ctr"/>
+          <a:lstStyle/>
+          <a:p>
+            <a:pPr marL="0" indent="0">
+              <a:buNone/>
+            </a:pPr>
+            <a:r>
+              <a:rPr lang="en-US" sz="1400" b="1" dirty="0">
+                <a:solidFill>
+                  <a:srgbClr val="0F2A44"/>
+                </a:solidFill>
+                <a:latin typeface="Calibri" pitchFamily="34" charset="0"/>
+                <a:ea typeface="Calibri" pitchFamily="34" charset="-122"/>
+                <a:cs typeface="Calibri" pitchFamily="34" charset="-120"/>
+              </a:rPr>
+              <a:t>Six structural metrics</a:t>
+            </a:r>
+            <a:endParaRPr lang="en-US" sz="1400" dirty="0"/>
+          </a:p>
+        </p:txBody>
+      </p:sp>
+      <p:sp>
+        <p:nvSpPr>
+          <p:cNvPr id="16" name="Text 14"/>
+          <p:cNvSpPr/>
+          <p:nvPr/>
+        </p:nvSpPr>
+        <p:spPr>
+          <a:xfrm>
+            <a:off x="4663440" y="1207008"/>
+            <a:ext cx="4023360" cy="594360"/>
+          </a:xfrm>
+          <a:prstGeom prst="rect">
+            <a:avLst/>
+          </a:prstGeom>
+          <a:noFill/>
+          <a:ln/>
+        </p:spPr>
+        <p:txBody>
+          <a:bodyPr wrap="square" lIns="0" tIns="0" rIns="0" bIns="0" rtlCol="0" anchor="ctr"/>
+          <a:lstStyle/>
+          <a:p>
+            <a:pPr marL="0" indent="0">
+              <a:buNone/>
+            </a:pPr>
+            <a:r>
+              <a:rPr lang="en-US" sz="1100" dirty="0">
+                <a:solidFill>
+                  <a:srgbClr val="1E293B"/>
+                </a:solidFill>
+                <a:latin typeface="Calibri" pitchFamily="34" charset="0"/>
+                <a:ea typeface="Calibri" pitchFamily="34" charset="-122"/>
+                <a:cs typeface="Calibri" pitchFamily="34" charset="-120"/>
+              </a:rPr>
+              <a:t>Each non-data class is evaluated against six structural metrics computed from its AST:</a:t>
+            </a:r>
+            <a:endParaRPr lang="en-US" sz="1100" dirty="0"/>
+          </a:p>
+        </p:txBody>
+      </p:sp>
+      <p:sp>
+        <p:nvSpPr>
+          <p:cNvPr id="17" name="Text 15"/>
+          <p:cNvSpPr/>
+          <p:nvPr/>
+        </p:nvSpPr>
+        <p:spPr>
+          <a:xfrm>
+            <a:off x="4846320" y="1783080"/>
+            <a:ext cx="3840480" cy="1920240"/>
+          </a:xfrm>
+          <a:prstGeom prst="rect">
+            <a:avLst/>
+          </a:prstGeom>
+          <a:noFill/>
+          <a:ln/>
+        </p:spPr>
+        <p:txBody>
+          <a:bodyPr wrap="square" lIns="0" tIns="0" rIns="0" bIns="0" rtlCol="0" anchor="ctr"/>
+          <a:lstStyle/>
+          <a:p>
+            <a:pPr marL="342900" indent="-342900">
+              <a:spcAft>
+                <a:spcPts val="100"/>
+              </a:spcAft>
+              <a:buSzPct val="100000"/>
+              <a:buChar char="•"/>
+            </a:pPr>
+            <a:r>
+              <a:rPr lang="en-US" sz="1100" dirty="0">
+                <a:solidFill>
+                  <a:srgbClr val="1E293B"/>
+                </a:solidFill>
+                <a:latin typeface="Calibri" pitchFamily="34" charset="0"/>
+                <a:ea typeface="Calibri" pitchFamily="34" charset="-122"/>
+                <a:cs typeface="Calibri" pitchFamily="34" charset="-120"/>
+              </a:rPr>
+              <a:t>≥ 25 fields</a:t>
+            </a:r>
+            <a:endParaRPr lang="en-US" sz="1100" dirty="0"/>
+          </a:p>
+          <a:p>
+            <a:pPr marL="342900" indent="-342900">
+              <a:spcAft>
+                <a:spcPts val="100"/>
+              </a:spcAft>
+              <a:buSzPct val="100000"/>
+              <a:buChar char="•"/>
+            </a:pPr>
+            <a:r>
+              <a:rPr lang="en-US" sz="1100" dirty="0">
+                <a:solidFill>
+                  <a:srgbClr val="1E293B"/>
+                </a:solidFill>
+                <a:latin typeface="Calibri" pitchFamily="34" charset="0"/>
+                <a:ea typeface="Calibri" pitchFamily="34" charset="-122"/>
+                <a:cs typeface="Calibri" pitchFamily="34" charset="-120"/>
+              </a:rPr>
+              <a:t>≥ 30 public methods</a:t>
+            </a:r>
+            <a:endParaRPr lang="en-US" sz="1100" dirty="0"/>
+          </a:p>
+          <a:p>
+            <a:pPr marL="342900" indent="-342900">
+              <a:spcAft>
+                <a:spcPts val="100"/>
+              </a:spcAft>
+              <a:buSzPct val="100000"/>
+              <a:buChar char="•"/>
+            </a:pPr>
+            <a:r>
+              <a:rPr lang="en-US" sz="1100" dirty="0">
+                <a:solidFill>
+                  <a:srgbClr val="1E293B"/>
+                </a:solidFill>
+                <a:latin typeface="Calibri" pitchFamily="34" charset="0"/>
+                <a:ea typeface="Calibri" pitchFamily="34" charset="-122"/>
+                <a:cs typeface="Calibri" pitchFamily="34" charset="-120"/>
+              </a:rPr>
+              <a:t>≥ 1000 lines of code</a:t>
+            </a:r>
+            <a:endParaRPr lang="en-US" sz="1100" dirty="0"/>
+          </a:p>
+          <a:p>
+            <a:pPr marL="342900" indent="-342900">
+              <a:spcAft>
+                <a:spcPts val="100"/>
+              </a:spcAft>
+              <a:buSzPct val="100000"/>
+              <a:buChar char="•"/>
+            </a:pPr>
+            <a:r>
+              <a:rPr lang="en-US" sz="1100" dirty="0">
+                <a:solidFill>
+                  <a:srgbClr val="1E293B"/>
+                </a:solidFill>
+                <a:latin typeface="Calibri" pitchFamily="34" charset="0"/>
+                <a:ea typeface="Calibri" pitchFamily="34" charset="-122"/>
+                <a:cs typeface="Calibri" pitchFamily="34" charset="-120"/>
+              </a:rPr>
+              <a:t>≥ 20 distinct import domains</a:t>
+            </a:r>
+            <a:endParaRPr lang="en-US" sz="1100" dirty="0"/>
+          </a:p>
+          <a:p>
+            <a:pPr marL="342900" indent="-342900">
+              <a:spcAft>
+                <a:spcPts val="100"/>
+              </a:spcAft>
+              <a:buSzPct val="100000"/>
+              <a:buChar char="•"/>
+            </a:pPr>
+            <a:r>
+              <a:rPr lang="en-US" sz="1100" dirty="0">
+                <a:solidFill>
+                  <a:srgbClr val="1E293B"/>
+                </a:solidFill>
+                <a:latin typeface="Calibri" pitchFamily="34" charset="0"/>
+                <a:ea typeface="Calibri" pitchFamily="34" charset="-122"/>
+                <a:cs typeface="Calibri" pitchFamily="34" charset="-120"/>
+              </a:rPr>
+              <a:t>≥ 12 constructor parameters</a:t>
+            </a:r>
+            <a:endParaRPr lang="en-US" sz="1100" dirty="0"/>
+          </a:p>
+          <a:p>
+            <a:pPr marL="342900" indent="-342900">
+              <a:spcAft>
+                <a:spcPts val="100"/>
+              </a:spcAft>
+              <a:buSzPct val="100000"/>
+              <a:buChar char="•"/>
+            </a:pPr>
+            <a:r>
+              <a:rPr lang="en-US" sz="1100" dirty="0">
+                <a:solidFill>
+                  <a:srgbClr val="1E293B"/>
+                </a:solidFill>
+                <a:latin typeface="Calibri" pitchFamily="34" charset="0"/>
+                <a:ea typeface="Calibri" pitchFamily="34" charset="-122"/>
+                <a:cs typeface="Calibri" pitchFamily="34" charset="-120"/>
+              </a:rPr>
+              <a:t>TCC &lt; 0.5  (Bieman &amp; Kang, 1995)</a:t>
+            </a:r>
+            <a:endParaRPr lang="en-US" sz="1100" dirty="0"/>
+          </a:p>
+        </p:txBody>
+      </p:sp>
+      <p:sp>
+        <p:nvSpPr>
+          <p:cNvPr id="18" name="Shape 16"/>
+          <p:cNvSpPr/>
+          <p:nvPr/>
+        </p:nvSpPr>
+        <p:spPr>
+          <a:xfrm>
+            <a:off x="4663440" y="3794760"/>
+            <a:ext cx="4023360" cy="502920"/>
+          </a:xfrm>
+          <a:prstGeom prst="rect">
+            <a:avLst/>
+          </a:prstGeom>
+          <a:solidFill>
+            <a:srgbClr val="0F2A44"/>
+          </a:solidFill>
+          <a:ln w="12700">
+            <a:solidFill>
+              <a:srgbClr val="0F2A44"/>
+            </a:solidFill>
+            <a:prstDash val="solid"/>
+          </a:ln>
+        </p:spPr>
+      </p:sp>
+      <p:sp>
+        <p:nvSpPr>
+          <p:cNvPr id="19" name="Text 17"/>
+          <p:cNvSpPr/>
+          <p:nvPr/>
+        </p:nvSpPr>
+        <p:spPr>
+          <a:xfrm>
+            <a:off x="4663440" y="3794760"/>
+            <a:ext cx="4023360" cy="502920"/>
+          </a:xfrm>
+          <a:prstGeom prst="rect">
+            <a:avLst/>
+          </a:prstGeom>
+          <a:noFill/>
+          <a:ln/>
+        </p:spPr>
+        <p:txBody>
+          <a:bodyPr wrap="square" lIns="0" tIns="0" rIns="0" bIns="0" rtlCol="0" anchor="ctr"/>
+          <a:lstStyle/>
+          <a:p>
+            <a:pPr marL="0" indent="0" algn="ctr">
+              <a:buNone/>
+            </a:pPr>
+            <a:r>
+              <a:rPr lang="en-US" sz="1100" i="1" dirty="0">
+                <a:solidFill>
+                  <a:srgbClr val="FFFFFF"/>
+                </a:solidFill>
+                <a:latin typeface="Calibri" pitchFamily="34" charset="0"/>
+                <a:ea typeface="Calibri" pitchFamily="34" charset="-122"/>
+                <a:cs typeface="Calibri" pitchFamily="34" charset="-120"/>
+              </a:rPr>
+              <a:t>Flag class as God Class if ≥ 3 of 6 thresholds exceeded</a:t>
+            </a:r>
+            <a:endParaRPr lang="en-US" sz="1100" dirty="0"/>
+          </a:p>
+        </p:txBody>
+      </p:sp>
+      <p:sp>
+        <p:nvSpPr>
+          <p:cNvPr id="20" name="Text 18"/>
+          <p:cNvSpPr/>
+          <p:nvPr/>
+        </p:nvSpPr>
+        <p:spPr>
+          <a:xfrm>
+            <a:off x="457200" y="3794760"/>
+            <a:ext cx="3931920" cy="502920"/>
+          </a:xfrm>
+          <a:prstGeom prst="rect">
+            <a:avLst/>
+          </a:prstGeom>
+          <a:noFill/>
+          <a:ln/>
+        </p:spPr>
+        <p:txBody>
+          <a:bodyPr wrap="square" lIns="0" tIns="0" rIns="0" bIns="0" rtlCol="0" anchor="ctr"/>
+          <a:lstStyle/>
+          <a:p>
+            <a:pPr marL="0" indent="0" algn="ctr">
+              <a:buNone/>
+            </a:pPr>
+            <a:r>
+              <a:rPr lang="en-US" sz="1100" i="1" dirty="0">
+                <a:solidFill>
+                  <a:srgbClr val="64748B"/>
+                </a:solidFill>
+                <a:latin typeface="Calibri" pitchFamily="34" charset="0"/>
+                <a:ea typeface="Calibri" pitchFamily="34" charset="-122"/>
+                <a:cs typeface="Calibri" pitchFamily="34" charset="-120"/>
+              </a:rPr>
+              <a:t>Code-level evidence → architectural-level finding</a:t>
+            </a:r>
+            <a:endParaRPr lang="en-US" sz="1100" dirty="0"/>
+          </a:p>
+        </p:txBody>
+      </p:sp>
+      <p:sp>
+        <p:nvSpPr>
+          <p:cNvPr id="21" name="Text 19"/>
+          <p:cNvSpPr/>
+          <p:nvPr/>
+        </p:nvSpPr>
+        <p:spPr>
+          <a:xfrm>
+            <a:off x="365760" y="4846320"/>
+            <a:ext cx="5486400" cy="228600"/>
+          </a:xfrm>
+          <a:prstGeom prst="rect">
+            <a:avLst/>
+          </a:prstGeom>
+          <a:noFill/>
+          <a:ln/>
+        </p:spPr>
+        <p:txBody>
+          <a:bodyPr wrap="square" rtlCol="0" anchor="ctr"/>
+          <a:lstStyle/>
+          <a:p>
+            <a:pPr marL="0" indent="0">
+              <a:buNone/>
+            </a:pPr>
+            <a:r>
+              <a:rPr lang="en-US" sz="900" dirty="0">
+                <a:solidFill>
+                  <a:srgbClr val="64748B"/>
+                </a:solidFill>
+                <a:latin typeface="Calibri" pitchFamily="34" charset="0"/>
+                <a:ea typeface="Calibri" pitchFamily="34" charset="-122"/>
+                <a:cs typeface="Calibri" pitchFamily="34" charset="-120"/>
+              </a:rPr>
+              <a:t>MSA Detector  •  Iacob Andrei  •  UBB FMI</a:t>
+            </a:r>
+            <a:endParaRPr lang="en-US" sz="900" dirty="0"/>
+          </a:p>
+        </p:txBody>
+      </p:sp>
+      <p:sp>
+        <p:nvSpPr>
+          <p:cNvPr id="22" name="Text 20"/>
+          <p:cNvSpPr/>
+          <p:nvPr/>
+        </p:nvSpPr>
+        <p:spPr>
+          <a:xfrm>
+            <a:off x="8046720" y="4846320"/>
+            <a:ext cx="731520" cy="228600"/>
+          </a:xfrm>
+          <a:prstGeom prst="rect">
+            <a:avLst/>
+          </a:prstGeom>
+          <a:noFill/>
+          <a:ln/>
+        </p:spPr>
+        <p:txBody>
+          <a:bodyPr wrap="square" rtlCol="0" anchor="ctr"/>
+          <a:lstStyle/>
+          <a:p>
+            <a:pPr marL="0" indent="0" algn="r">
+              <a:buNone/>
+            </a:pPr>
+            <a:r>
+              <a:rPr lang="en-US" sz="900" dirty="0">
+                <a:solidFill>
+                  <a:srgbClr val="64748B"/>
+                </a:solidFill>
+                <a:latin typeface="Calibri" pitchFamily="34" charset="0"/>
+                <a:ea typeface="Calibri" pitchFamily="34" charset="-122"/>
+                <a:cs typeface="Calibri" pitchFamily="34" charset="-120"/>
+              </a:rPr>
+              <a:t>5 / 12</a:t>
+            </a:r>
+            <a:endParaRPr lang="en-US" sz="900" dirty="0"/>
+          </a:p>
+        </p:txBody>
+      </p:sp>
+    </p:spTree>
+  </p:cSld>
+  <p:clrMapOvr>
+    <a:masterClrMapping/>
+  </p:clrMapOvr>
+</p:sld>
+</file>
+
+<file path=ppt/slides/slide6.xml><?xml version="1.0" encoding="utf-8"?>
 <p:sld xmlns:a="http://schemas.openxmlformats.org/drawingml/2006/main" xmlns:r="http://schemas.openxmlformats.org/officeDocument/2006/relationships" xmlns:p="http://schemas.openxmlformats.org/presentationml/2006/main">
   <p:cSld name="Slide 6">
     <p:bg>
@@ -7697,13 +8230,6 @@
             <a:prstDash val="solid"/>
           </a:ln>
         </p:spPr>
-        <p:txBody>
-          <a:bodyPr/>
-          <a:lstStyle/>
-          <a:p>
-            <a:endParaRPr lang="en-US"/>
-          </a:p>
-        </p:txBody>
       </p:sp>
       <p:sp>
         <p:nvSpPr>
@@ -7729,13 +8255,6 @@
             <a:prstDash val="solid"/>
           </a:ln>
         </p:spPr>
-        <p:txBody>
-          <a:bodyPr/>
-          <a:lstStyle/>
-          <a:p>
-            <a:endParaRPr lang="en-US"/>
-          </a:p>
-        </p:txBody>
       </p:sp>
       <p:sp>
         <p:nvSpPr>
@@ -7956,13 +8475,6 @@
             <a:prstDash val="solid"/>
           </a:ln>
         </p:spPr>
-        <p:txBody>
-          <a:bodyPr/>
-          <a:lstStyle/>
-          <a:p>
-            <a:endParaRPr lang="en-US"/>
-          </a:p>
-        </p:txBody>
       </p:sp>
       <p:sp>
         <p:nvSpPr>
@@ -7988,13 +8500,6 @@
             <a:prstDash val="solid"/>
           </a:ln>
         </p:spPr>
-        <p:txBody>
-          <a:bodyPr/>
-          <a:lstStyle/>
-          <a:p>
-            <a:endParaRPr lang="en-US"/>
-          </a:p>
-        </p:txBody>
       </p:sp>
       <p:sp>
         <p:nvSpPr>
@@ -8371,13 +8876,6 @@
             <a:prstDash val="solid"/>
           </a:ln>
         </p:spPr>
-        <p:txBody>
-          <a:bodyPr/>
-          <a:lstStyle/>
-          <a:p>
-            <a:endParaRPr lang="en-US"/>
-          </a:p>
-        </p:txBody>
       </p:sp>
       <p:sp>
         <p:nvSpPr>
@@ -8403,13 +8901,6 @@
             <a:prstDash val="solid"/>
           </a:ln>
         </p:spPr>
-        <p:txBody>
-          <a:bodyPr/>
-          <a:lstStyle/>
-          <a:p>
-            <a:endParaRPr lang="en-US"/>
-          </a:p>
-        </p:txBody>
       </p:sp>
       <p:sp>
         <p:nvSpPr>
@@ -8552,13 +9043,6 @@
             <a:prstDash val="solid"/>
           </a:ln>
         </p:spPr>
-        <p:txBody>
-          <a:bodyPr/>
-          <a:lstStyle/>
-          <a:p>
-            <a:endParaRPr lang="en-US"/>
-          </a:p>
-        </p:txBody>
       </p:sp>
       <p:sp>
         <p:nvSpPr>
@@ -8584,13 +9068,6 @@
             <a:prstDash val="solid"/>
           </a:ln>
         </p:spPr>
-        <p:txBody>
-          <a:bodyPr/>
-          <a:lstStyle/>
-          <a:p>
-            <a:endParaRPr lang="en-US"/>
-          </a:p>
-        </p:txBody>
       </p:sp>
       <p:sp>
         <p:nvSpPr>
@@ -8889,13 +9366,6 @@
             <a:prstDash val="solid"/>
           </a:ln>
         </p:spPr>
-        <p:txBody>
-          <a:bodyPr/>
-          <a:lstStyle/>
-          <a:p>
-            <a:endParaRPr lang="en-US"/>
-          </a:p>
-        </p:txBody>
       </p:sp>
       <p:sp>
         <p:nvSpPr>
@@ -9009,924 +9479,6 @@
                 <a:cs typeface="Calibri" pitchFamily="34" charset="-120"/>
               </a:rPr>
               <a:t>6 / 12</a:t>
-            </a:r>
-            <a:endParaRPr lang="en-US" sz="900" dirty="0"/>
-          </a:p>
-        </p:txBody>
-      </p:sp>
-    </p:spTree>
-  </p:cSld>
-  <p:clrMapOvr>
-    <a:masterClrMapping/>
-  </p:clrMapOvr>
-</p:sld>
-</file>
-
-<file path=ppt/slides/slide6.xml><?xml version="1.0" encoding="utf-8"?>
-<p:sld xmlns:a="http://schemas.openxmlformats.org/drawingml/2006/main" xmlns:r="http://schemas.openxmlformats.org/officeDocument/2006/relationships" xmlns:p="http://schemas.openxmlformats.org/presentationml/2006/main">
-  <p:cSld name="Slide 5">
-    <p:bg>
-      <p:bgPr>
-        <a:solidFill>
-          <a:srgbClr val="FFFFFF"/>
-        </a:solidFill>
-        <a:effectLst/>
-      </p:bgPr>
-    </p:bg>
-    <p:spTree>
-      <p:nvGrpSpPr>
-        <p:cNvPr id="1" name=""/>
-        <p:cNvGrpSpPr/>
-        <p:nvPr/>
-      </p:nvGrpSpPr>
-      <p:grpSpPr>
-        <a:xfrm>
-          <a:off x="0" y="0"/>
-          <a:ext cx="0" cy="0"/>
-          <a:chOff x="0" y="0"/>
-          <a:chExt cx="0" cy="0"/>
-        </a:xfrm>
-      </p:grpSpPr>
-      <p:sp>
-        <p:nvSpPr>
-          <p:cNvPr id="2" name="Text 0"/>
-          <p:cNvSpPr/>
-          <p:nvPr/>
-        </p:nvSpPr>
-        <p:spPr>
-          <a:xfrm>
-            <a:off x="457200" y="256032"/>
-            <a:ext cx="8229600" cy="548640"/>
-          </a:xfrm>
-          <a:prstGeom prst="rect">
-            <a:avLst/>
-          </a:prstGeom>
-          <a:noFill/>
-          <a:ln/>
-        </p:spPr>
-        <p:txBody>
-          <a:bodyPr wrap="square" lIns="0" tIns="0" rIns="0" bIns="0" rtlCol="0" anchor="ctr"/>
-          <a:lstStyle/>
-          <a:p>
-            <a:pPr marL="0" indent="0">
-              <a:buNone/>
-            </a:pPr>
-            <a:r>
-              <a:rPr lang="en-US" sz="2800" b="1" dirty="0">
-                <a:solidFill>
-                  <a:srgbClr val="0F2A44"/>
-                </a:solidFill>
-                <a:latin typeface="Calibri" pitchFamily="34" charset="0"/>
-                <a:ea typeface="Calibri" pitchFamily="34" charset="-122"/>
-                <a:cs typeface="Calibri" pitchFamily="34" charset="-120"/>
-              </a:rPr>
-              <a:t>Spotlight: God Service detection</a:t>
-            </a:r>
-            <a:endParaRPr lang="en-US" sz="2800" dirty="0"/>
-          </a:p>
-        </p:txBody>
-      </p:sp>
-      <p:sp>
-        <p:nvSpPr>
-          <p:cNvPr id="3" name="Text 1"/>
-          <p:cNvSpPr/>
-          <p:nvPr/>
-        </p:nvSpPr>
-        <p:spPr>
-          <a:xfrm>
-            <a:off x="457200" y="868680"/>
-            <a:ext cx="3931920" cy="320040"/>
-          </a:xfrm>
-          <a:prstGeom prst="rect">
-            <a:avLst/>
-          </a:prstGeom>
-          <a:noFill/>
-          <a:ln/>
-        </p:spPr>
-        <p:txBody>
-          <a:bodyPr wrap="square" lIns="0" tIns="0" rIns="0" bIns="0" rtlCol="0" anchor="ctr"/>
-          <a:lstStyle/>
-          <a:p>
-            <a:pPr marL="0" indent="0">
-              <a:buNone/>
-            </a:pPr>
-            <a:r>
-              <a:rPr lang="en-US" sz="1400" b="1" dirty="0">
-                <a:solidFill>
-                  <a:srgbClr val="0F2A44"/>
-                </a:solidFill>
-                <a:latin typeface="Calibri" pitchFamily="34" charset="0"/>
-                <a:ea typeface="Calibri" pitchFamily="34" charset="-122"/>
-                <a:cs typeface="Calibri" pitchFamily="34" charset="-120"/>
-              </a:rPr>
-              <a:t>Multi-level bridge in action</a:t>
-            </a:r>
-            <a:endParaRPr lang="en-US" sz="1400" dirty="0"/>
-          </a:p>
-        </p:txBody>
-      </p:sp>
-      <p:sp>
-        <p:nvSpPr>
-          <p:cNvPr id="4" name="Shape 2"/>
-          <p:cNvSpPr/>
-          <p:nvPr/>
-        </p:nvSpPr>
-        <p:spPr>
-          <a:xfrm>
-            <a:off x="457200" y="1280160"/>
-            <a:ext cx="3931920" cy="914400"/>
-          </a:xfrm>
-          <a:prstGeom prst="rect">
-            <a:avLst/>
-          </a:prstGeom>
-          <a:solidFill>
-            <a:srgbClr val="F8FAFC"/>
-          </a:solidFill>
-          <a:ln w="9525">
-            <a:solidFill>
-              <a:srgbClr val="E2E8F0"/>
-            </a:solidFill>
-            <a:prstDash val="solid"/>
-          </a:ln>
-        </p:spPr>
-        <p:txBody>
-          <a:bodyPr/>
-          <a:lstStyle/>
-          <a:p>
-            <a:endParaRPr lang="en-US"/>
-          </a:p>
-        </p:txBody>
-      </p:sp>
-      <p:sp>
-        <p:nvSpPr>
-          <p:cNvPr id="5" name="Shape 3"/>
-          <p:cNvSpPr/>
-          <p:nvPr/>
-        </p:nvSpPr>
-        <p:spPr>
-          <a:xfrm>
-            <a:off x="457200" y="1280160"/>
-            <a:ext cx="54864" cy="914400"/>
-          </a:xfrm>
-          <a:prstGeom prst="rect">
-            <a:avLst/>
-          </a:prstGeom>
-          <a:solidFill>
-            <a:srgbClr val="1C4E80"/>
-          </a:solidFill>
-          <a:ln w="12700">
-            <a:solidFill>
-              <a:srgbClr val="1C4E80"/>
-            </a:solidFill>
-            <a:prstDash val="solid"/>
-          </a:ln>
-        </p:spPr>
-        <p:txBody>
-          <a:bodyPr/>
-          <a:lstStyle/>
-          <a:p>
-            <a:endParaRPr lang="en-US"/>
-          </a:p>
-        </p:txBody>
-      </p:sp>
-      <p:sp>
-        <p:nvSpPr>
-          <p:cNvPr id="6" name="Text 4"/>
-          <p:cNvSpPr/>
-          <p:nvPr/>
-        </p:nvSpPr>
-        <p:spPr>
-          <a:xfrm>
-            <a:off x="640080" y="1325880"/>
-            <a:ext cx="3657600" cy="274320"/>
-          </a:xfrm>
-          <a:prstGeom prst="rect">
-            <a:avLst/>
-          </a:prstGeom>
-          <a:noFill/>
-          <a:ln/>
-        </p:spPr>
-        <p:txBody>
-          <a:bodyPr wrap="square" lIns="0" tIns="0" rIns="0" bIns="0" rtlCol="0" anchor="ctr"/>
-          <a:lstStyle/>
-          <a:p>
-            <a:pPr marL="0" indent="0">
-              <a:buNone/>
-            </a:pPr>
-            <a:r>
-              <a:rPr lang="en-US" sz="1100" b="1" dirty="0">
-                <a:solidFill>
-                  <a:srgbClr val="64748B"/>
-                </a:solidFill>
-                <a:latin typeface="Calibri" pitchFamily="34" charset="0"/>
-                <a:ea typeface="Calibri" pitchFamily="34" charset="-122"/>
-                <a:cs typeface="Calibri" pitchFamily="34" charset="-120"/>
-              </a:rPr>
-              <a:t>Code level</a:t>
-            </a:r>
-            <a:endParaRPr lang="en-US" sz="1100" dirty="0"/>
-          </a:p>
-        </p:txBody>
-      </p:sp>
-      <p:sp>
-        <p:nvSpPr>
-          <p:cNvPr id="7" name="Text 5"/>
-          <p:cNvSpPr/>
-          <p:nvPr/>
-        </p:nvSpPr>
-        <p:spPr>
-          <a:xfrm>
-            <a:off x="640080" y="1572768"/>
-            <a:ext cx="3657600" cy="292608"/>
-          </a:xfrm>
-          <a:prstGeom prst="rect">
-            <a:avLst/>
-          </a:prstGeom>
-          <a:noFill/>
-          <a:ln/>
-        </p:spPr>
-        <p:txBody>
-          <a:bodyPr wrap="square" lIns="0" tIns="0" rIns="0" bIns="0" rtlCol="0" anchor="ctr"/>
-          <a:lstStyle/>
-          <a:p>
-            <a:pPr marL="0" indent="0">
-              <a:buNone/>
-            </a:pPr>
-            <a:r>
-              <a:rPr lang="en-US" sz="1300" b="1" dirty="0">
-                <a:solidFill>
-                  <a:srgbClr val="1E293B"/>
-                </a:solidFill>
-                <a:latin typeface="Calibri" pitchFamily="34" charset="0"/>
-                <a:ea typeface="Calibri" pitchFamily="34" charset="-122"/>
-                <a:cs typeface="Calibri" pitchFamily="34" charset="-120"/>
-              </a:rPr>
-              <a:t>God Class smell (per class)</a:t>
-            </a:r>
-            <a:endParaRPr lang="en-US" sz="1300" dirty="0"/>
-          </a:p>
-        </p:txBody>
-      </p:sp>
-      <p:sp>
-        <p:nvSpPr>
-          <p:cNvPr id="8" name="Text 6"/>
-          <p:cNvSpPr/>
-          <p:nvPr/>
-        </p:nvSpPr>
-        <p:spPr>
-          <a:xfrm>
-            <a:off x="640080" y="1847088"/>
-            <a:ext cx="3657600" cy="320040"/>
-          </a:xfrm>
-          <a:prstGeom prst="rect">
-            <a:avLst/>
-          </a:prstGeom>
-          <a:noFill/>
-          <a:ln/>
-        </p:spPr>
-        <p:txBody>
-          <a:bodyPr wrap="square" lIns="0" tIns="0" rIns="0" bIns="0" rtlCol="0" anchor="ctr"/>
-          <a:lstStyle/>
-          <a:p>
-            <a:pPr marL="0" indent="0">
-              <a:buNone/>
-            </a:pPr>
-            <a:r>
-              <a:rPr lang="en-US" sz="1000" i="1" dirty="0">
-                <a:solidFill>
-                  <a:srgbClr val="64748B"/>
-                </a:solidFill>
-                <a:latin typeface="Calibri" pitchFamily="34" charset="0"/>
-                <a:ea typeface="Calibri" pitchFamily="34" charset="-122"/>
-                <a:cs typeface="Calibri" pitchFamily="34" charset="-120"/>
-              </a:rPr>
-              <a:t>Detected by DesigniteJava, persisted as CodeSmell entities</a:t>
-            </a:r>
-            <a:endParaRPr lang="en-US" sz="1000" dirty="0"/>
-          </a:p>
-        </p:txBody>
-      </p:sp>
-      <p:sp>
-        <p:nvSpPr>
-          <p:cNvPr id="9" name="Shape 7"/>
-          <p:cNvSpPr/>
-          <p:nvPr/>
-        </p:nvSpPr>
-        <p:spPr>
-          <a:xfrm>
-            <a:off x="2423160" y="2286000"/>
-            <a:ext cx="0" cy="320040"/>
-          </a:xfrm>
-          <a:prstGeom prst="line">
-            <a:avLst/>
-          </a:prstGeom>
-          <a:noFill/>
-          <a:ln w="31750">
-            <a:solidFill>
-              <a:srgbClr val="0D9488"/>
-            </a:solidFill>
-            <a:prstDash val="solid"/>
-            <a:tailEnd type="triangle"/>
-          </a:ln>
-        </p:spPr>
-        <p:txBody>
-          <a:bodyPr/>
-          <a:lstStyle/>
-          <a:p>
-            <a:endParaRPr lang="en-US"/>
-          </a:p>
-        </p:txBody>
-      </p:sp>
-      <p:sp>
-        <p:nvSpPr>
-          <p:cNvPr id="10" name="Shape 8"/>
-          <p:cNvSpPr/>
-          <p:nvPr/>
-        </p:nvSpPr>
-        <p:spPr>
-          <a:xfrm>
-            <a:off x="457200" y="2697480"/>
-            <a:ext cx="3931920" cy="960120"/>
-          </a:xfrm>
-          <a:prstGeom prst="rect">
-            <a:avLst/>
-          </a:prstGeom>
-          <a:solidFill>
-            <a:srgbClr val="F8FAFC"/>
-          </a:solidFill>
-          <a:ln w="9525">
-            <a:solidFill>
-              <a:srgbClr val="E2E8F0"/>
-            </a:solidFill>
-            <a:prstDash val="solid"/>
-          </a:ln>
-        </p:spPr>
-        <p:txBody>
-          <a:bodyPr/>
-          <a:lstStyle/>
-          <a:p>
-            <a:endParaRPr lang="en-US"/>
-          </a:p>
-        </p:txBody>
-      </p:sp>
-      <p:sp>
-        <p:nvSpPr>
-          <p:cNvPr id="11" name="Shape 9"/>
-          <p:cNvSpPr/>
-          <p:nvPr/>
-        </p:nvSpPr>
-        <p:spPr>
-          <a:xfrm>
-            <a:off x="457200" y="2697480"/>
-            <a:ext cx="54864" cy="960120"/>
-          </a:xfrm>
-          <a:prstGeom prst="rect">
-            <a:avLst/>
-          </a:prstGeom>
-          <a:solidFill>
-            <a:srgbClr val="0D9488"/>
-          </a:solidFill>
-          <a:ln w="12700">
-            <a:solidFill>
-              <a:srgbClr val="0D9488"/>
-            </a:solidFill>
-            <a:prstDash val="solid"/>
-          </a:ln>
-        </p:spPr>
-        <p:txBody>
-          <a:bodyPr/>
-          <a:lstStyle/>
-          <a:p>
-            <a:endParaRPr lang="en-US"/>
-          </a:p>
-        </p:txBody>
-      </p:sp>
-      <p:sp>
-        <p:nvSpPr>
-          <p:cNvPr id="12" name="Text 10"/>
-          <p:cNvSpPr/>
-          <p:nvPr/>
-        </p:nvSpPr>
-        <p:spPr>
-          <a:xfrm>
-            <a:off x="640080" y="2743200"/>
-            <a:ext cx="3657600" cy="274320"/>
-          </a:xfrm>
-          <a:prstGeom prst="rect">
-            <a:avLst/>
-          </a:prstGeom>
-          <a:noFill/>
-          <a:ln/>
-        </p:spPr>
-        <p:txBody>
-          <a:bodyPr wrap="square" lIns="0" tIns="0" rIns="0" bIns="0" rtlCol="0" anchor="ctr"/>
-          <a:lstStyle/>
-          <a:p>
-            <a:pPr marL="0" indent="0">
-              <a:buNone/>
-            </a:pPr>
-            <a:r>
-              <a:rPr lang="en-US" sz="1100" b="1" dirty="0">
-                <a:solidFill>
-                  <a:srgbClr val="64748B"/>
-                </a:solidFill>
-                <a:latin typeface="Calibri" pitchFamily="34" charset="0"/>
-                <a:ea typeface="Calibri" pitchFamily="34" charset="-122"/>
-                <a:cs typeface="Calibri" pitchFamily="34" charset="-120"/>
-              </a:rPr>
-              <a:t>Architectural level</a:t>
-            </a:r>
-            <a:endParaRPr lang="en-US" sz="1100" dirty="0"/>
-          </a:p>
-        </p:txBody>
-      </p:sp>
-      <p:sp>
-        <p:nvSpPr>
-          <p:cNvPr id="13" name="Text 11"/>
-          <p:cNvSpPr/>
-          <p:nvPr/>
-        </p:nvSpPr>
-        <p:spPr>
-          <a:xfrm>
-            <a:off x="640080" y="2990088"/>
-            <a:ext cx="3657600" cy="292608"/>
-          </a:xfrm>
-          <a:prstGeom prst="rect">
-            <a:avLst/>
-          </a:prstGeom>
-          <a:noFill/>
-          <a:ln/>
-        </p:spPr>
-        <p:txBody>
-          <a:bodyPr wrap="square" lIns="0" tIns="0" rIns="0" bIns="0" rtlCol="0" anchor="ctr"/>
-          <a:lstStyle/>
-          <a:p>
-            <a:pPr marL="0" indent="0">
-              <a:buNone/>
-            </a:pPr>
-            <a:r>
-              <a:rPr lang="en-US" sz="1300" b="1" dirty="0">
-                <a:solidFill>
-                  <a:srgbClr val="1E293B"/>
-                </a:solidFill>
-                <a:latin typeface="Calibri" pitchFamily="34" charset="0"/>
-                <a:ea typeface="Calibri" pitchFamily="34" charset="-122"/>
-                <a:cs typeface="Calibri" pitchFamily="34" charset="-120"/>
-              </a:rPr>
-              <a:t>God Service (per microservice)</a:t>
-            </a:r>
-            <a:endParaRPr lang="en-US" sz="1300" dirty="0"/>
-          </a:p>
-        </p:txBody>
-      </p:sp>
-      <p:sp>
-        <p:nvSpPr>
-          <p:cNvPr id="14" name="Text 12"/>
-          <p:cNvSpPr/>
-          <p:nvPr/>
-        </p:nvSpPr>
-        <p:spPr>
-          <a:xfrm>
-            <a:off x="640080" y="3264408"/>
-            <a:ext cx="3657600" cy="365760"/>
-          </a:xfrm>
-          <a:prstGeom prst="rect">
-            <a:avLst/>
-          </a:prstGeom>
-          <a:noFill/>
-          <a:ln/>
-        </p:spPr>
-        <p:txBody>
-          <a:bodyPr wrap="square" lIns="0" tIns="0" rIns="0" bIns="0" rtlCol="0" anchor="ctr"/>
-          <a:lstStyle/>
-          <a:p>
-            <a:pPr marL="0" indent="0">
-              <a:buNone/>
-            </a:pPr>
-            <a:r>
-              <a:rPr lang="en-US" sz="1000" i="1" dirty="0">
-                <a:solidFill>
-                  <a:srgbClr val="64748B"/>
-                </a:solidFill>
-                <a:latin typeface="Calibri" pitchFamily="34" charset="0"/>
-                <a:ea typeface="Calibri" pitchFamily="34" charset="-122"/>
-                <a:cs typeface="Calibri" pitchFamily="34" charset="-120"/>
-              </a:rPr>
-              <a:t>Flag service if ≥ θ_god God Classes detected (default = 1)</a:t>
-            </a:r>
-            <a:endParaRPr lang="en-US" sz="1000" dirty="0"/>
-          </a:p>
-        </p:txBody>
-      </p:sp>
-      <p:sp>
-        <p:nvSpPr>
-          <p:cNvPr id="15" name="Text 13"/>
-          <p:cNvSpPr/>
-          <p:nvPr/>
-        </p:nvSpPr>
-        <p:spPr>
-          <a:xfrm>
-            <a:off x="4663440" y="868680"/>
-            <a:ext cx="4023360" cy="320040"/>
-          </a:xfrm>
-          <a:prstGeom prst="rect">
-            <a:avLst/>
-          </a:prstGeom>
-          <a:noFill/>
-          <a:ln/>
-        </p:spPr>
-        <p:txBody>
-          <a:bodyPr wrap="square" lIns="0" tIns="0" rIns="0" bIns="0" rtlCol="0" anchor="ctr"/>
-          <a:lstStyle/>
-          <a:p>
-            <a:pPr marL="0" indent="0">
-              <a:buNone/>
-            </a:pPr>
-            <a:r>
-              <a:rPr lang="en-US" sz="1400" b="1" dirty="0">
-                <a:solidFill>
-                  <a:srgbClr val="0F2A44"/>
-                </a:solidFill>
-                <a:latin typeface="Calibri" pitchFamily="34" charset="0"/>
-                <a:ea typeface="Calibri" pitchFamily="34" charset="-122"/>
-                <a:cs typeface="Calibri" pitchFamily="34" charset="-120"/>
-              </a:rPr>
-              <a:t>Spoon-based fallback</a:t>
-            </a:r>
-            <a:endParaRPr lang="en-US" sz="1400" dirty="0"/>
-          </a:p>
-        </p:txBody>
-      </p:sp>
-      <p:sp>
-        <p:nvSpPr>
-          <p:cNvPr id="16" name="Text 14"/>
-          <p:cNvSpPr/>
-          <p:nvPr/>
-        </p:nvSpPr>
-        <p:spPr>
-          <a:xfrm>
-            <a:off x="4663440" y="1207008"/>
-            <a:ext cx="4023360" cy="594360"/>
-          </a:xfrm>
-          <a:prstGeom prst="rect">
-            <a:avLst/>
-          </a:prstGeom>
-          <a:noFill/>
-          <a:ln/>
-        </p:spPr>
-        <p:txBody>
-          <a:bodyPr wrap="square" lIns="0" tIns="0" rIns="0" bIns="0" rtlCol="0" anchor="ctr"/>
-          <a:lstStyle/>
-          <a:p>
-            <a:pPr marL="0" indent="0">
-              <a:buNone/>
-            </a:pPr>
-            <a:r>
-              <a:rPr lang="en-US" sz="1100" dirty="0">
-                <a:solidFill>
-                  <a:srgbClr val="1E293B"/>
-                </a:solidFill>
-                <a:latin typeface="Calibri" pitchFamily="34" charset="0"/>
-                <a:ea typeface="Calibri" pitchFamily="34" charset="-122"/>
-                <a:cs typeface="Calibri" pitchFamily="34" charset="-120"/>
-              </a:rPr>
-              <a:t>If DesigniteJava reports zero God Classes, a Spoon-based structural analysis evaluates each class against six metrics:</a:t>
-            </a:r>
-            <a:endParaRPr lang="en-US" sz="1100" dirty="0"/>
-          </a:p>
-        </p:txBody>
-      </p:sp>
-      <p:sp>
-        <p:nvSpPr>
-          <p:cNvPr id="17" name="Text 15"/>
-          <p:cNvSpPr/>
-          <p:nvPr/>
-        </p:nvSpPr>
-        <p:spPr>
-          <a:xfrm>
-            <a:off x="4846320" y="1783080"/>
-            <a:ext cx="3840480" cy="1920240"/>
-          </a:xfrm>
-          <a:prstGeom prst="rect">
-            <a:avLst/>
-          </a:prstGeom>
-          <a:noFill/>
-          <a:ln/>
-        </p:spPr>
-        <p:txBody>
-          <a:bodyPr wrap="square" lIns="0" tIns="0" rIns="0" bIns="0" rtlCol="0" anchor="ctr"/>
-          <a:lstStyle/>
-          <a:p>
-            <a:pPr marL="342900" indent="-342900">
-              <a:spcAft>
-                <a:spcPts val="100"/>
-              </a:spcAft>
-              <a:buSzPct val="100000"/>
-              <a:buChar char="•"/>
-            </a:pPr>
-            <a:r>
-              <a:rPr lang="en-US" sz="1100" dirty="0">
-                <a:solidFill>
-                  <a:srgbClr val="1E293B"/>
-                </a:solidFill>
-                <a:latin typeface="Calibri" pitchFamily="34" charset="0"/>
-                <a:ea typeface="Calibri" pitchFamily="34" charset="-122"/>
-                <a:cs typeface="Calibri" pitchFamily="34" charset="-120"/>
-              </a:rPr>
-              <a:t>≥ 25 fields</a:t>
-            </a:r>
-            <a:endParaRPr lang="en-US" sz="1100" dirty="0"/>
-          </a:p>
-          <a:p>
-            <a:pPr marL="342900" indent="-342900">
-              <a:spcAft>
-                <a:spcPts val="100"/>
-              </a:spcAft>
-              <a:buSzPct val="100000"/>
-              <a:buChar char="•"/>
-            </a:pPr>
-            <a:r>
-              <a:rPr lang="en-US" sz="1100" dirty="0">
-                <a:solidFill>
-                  <a:srgbClr val="1E293B"/>
-                </a:solidFill>
-                <a:latin typeface="Calibri" pitchFamily="34" charset="0"/>
-                <a:ea typeface="Calibri" pitchFamily="34" charset="-122"/>
-                <a:cs typeface="Calibri" pitchFamily="34" charset="-120"/>
-              </a:rPr>
-              <a:t>≥ 30 public methods</a:t>
-            </a:r>
-            <a:endParaRPr lang="en-US" sz="1100" dirty="0"/>
-          </a:p>
-          <a:p>
-            <a:pPr marL="342900" indent="-342900">
-              <a:spcAft>
-                <a:spcPts val="100"/>
-              </a:spcAft>
-              <a:buSzPct val="100000"/>
-              <a:buChar char="•"/>
-            </a:pPr>
-            <a:r>
-              <a:rPr lang="en-US" sz="1100" dirty="0">
-                <a:solidFill>
-                  <a:srgbClr val="1E293B"/>
-                </a:solidFill>
-                <a:latin typeface="Calibri" pitchFamily="34" charset="0"/>
-                <a:ea typeface="Calibri" pitchFamily="34" charset="-122"/>
-                <a:cs typeface="Calibri" pitchFamily="34" charset="-120"/>
-              </a:rPr>
-              <a:t>≥ 1000 lines of code</a:t>
-            </a:r>
-            <a:endParaRPr lang="en-US" sz="1100" dirty="0"/>
-          </a:p>
-          <a:p>
-            <a:pPr marL="342900" indent="-342900">
-              <a:spcAft>
-                <a:spcPts val="100"/>
-              </a:spcAft>
-              <a:buSzPct val="100000"/>
-              <a:buChar char="•"/>
-            </a:pPr>
-            <a:r>
-              <a:rPr lang="en-US" sz="1100" dirty="0">
-                <a:solidFill>
-                  <a:srgbClr val="1E293B"/>
-                </a:solidFill>
-                <a:latin typeface="Calibri" pitchFamily="34" charset="0"/>
-                <a:ea typeface="Calibri" pitchFamily="34" charset="-122"/>
-                <a:cs typeface="Calibri" pitchFamily="34" charset="-120"/>
-              </a:rPr>
-              <a:t>≥ 20 distinct import domains</a:t>
-            </a:r>
-            <a:endParaRPr lang="en-US" sz="1100" dirty="0"/>
-          </a:p>
-          <a:p>
-            <a:pPr marL="342900" indent="-342900">
-              <a:spcAft>
-                <a:spcPts val="100"/>
-              </a:spcAft>
-              <a:buSzPct val="100000"/>
-              <a:buChar char="•"/>
-            </a:pPr>
-            <a:r>
-              <a:rPr lang="en-US" sz="1100" dirty="0">
-                <a:solidFill>
-                  <a:srgbClr val="1E293B"/>
-                </a:solidFill>
-                <a:latin typeface="Calibri" pitchFamily="34" charset="0"/>
-                <a:ea typeface="Calibri" pitchFamily="34" charset="-122"/>
-                <a:cs typeface="Calibri" pitchFamily="34" charset="-120"/>
-              </a:rPr>
-              <a:t>≥ 12 constructor parameters</a:t>
-            </a:r>
-            <a:endParaRPr lang="en-US" sz="1100" dirty="0"/>
-          </a:p>
-          <a:p>
-            <a:pPr marL="342900" indent="-342900">
-              <a:spcAft>
-                <a:spcPts val="100"/>
-              </a:spcAft>
-              <a:buSzPct val="100000"/>
-              <a:buChar char="•"/>
-            </a:pPr>
-            <a:r>
-              <a:rPr lang="en-US" sz="1100" dirty="0">
-                <a:solidFill>
-                  <a:srgbClr val="1E293B"/>
-                </a:solidFill>
-                <a:latin typeface="Calibri" pitchFamily="34" charset="0"/>
-                <a:ea typeface="Calibri" pitchFamily="34" charset="-122"/>
-                <a:cs typeface="Calibri" pitchFamily="34" charset="-120"/>
-              </a:rPr>
-              <a:t>TCC &lt; 0.5  (Bieman &amp; Kang, 1995)</a:t>
-            </a:r>
-            <a:endParaRPr lang="en-US" sz="1100" dirty="0"/>
-          </a:p>
-        </p:txBody>
-      </p:sp>
-      <p:sp>
-        <p:nvSpPr>
-          <p:cNvPr id="18" name="Shape 16"/>
-          <p:cNvSpPr/>
-          <p:nvPr/>
-        </p:nvSpPr>
-        <p:spPr>
-          <a:xfrm>
-            <a:off x="4663440" y="3794760"/>
-            <a:ext cx="4023360" cy="502920"/>
-          </a:xfrm>
-          <a:prstGeom prst="rect">
-            <a:avLst/>
-          </a:prstGeom>
-          <a:solidFill>
-            <a:srgbClr val="0F2A44"/>
-          </a:solidFill>
-          <a:ln w="12700">
-            <a:solidFill>
-              <a:srgbClr val="0F2A44"/>
-            </a:solidFill>
-            <a:prstDash val="solid"/>
-          </a:ln>
-        </p:spPr>
-        <p:txBody>
-          <a:bodyPr/>
-          <a:lstStyle/>
-          <a:p>
-            <a:endParaRPr lang="en-US"/>
-          </a:p>
-        </p:txBody>
-      </p:sp>
-      <p:sp>
-        <p:nvSpPr>
-          <p:cNvPr id="19" name="Text 17"/>
-          <p:cNvSpPr/>
-          <p:nvPr/>
-        </p:nvSpPr>
-        <p:spPr>
-          <a:xfrm>
-            <a:off x="4663440" y="3794760"/>
-            <a:ext cx="4023360" cy="502920"/>
-          </a:xfrm>
-          <a:prstGeom prst="rect">
-            <a:avLst/>
-          </a:prstGeom>
-          <a:noFill/>
-          <a:ln/>
-        </p:spPr>
-        <p:txBody>
-          <a:bodyPr wrap="square" lIns="0" tIns="0" rIns="0" bIns="0" rtlCol="0" anchor="ctr"/>
-          <a:lstStyle/>
-          <a:p>
-            <a:pPr marL="0" indent="0" algn="ctr">
-              <a:buNone/>
-            </a:pPr>
-            <a:r>
-              <a:rPr lang="en-US" sz="1100" i="1" dirty="0">
-                <a:solidFill>
-                  <a:srgbClr val="FFFFFF"/>
-                </a:solidFill>
-                <a:latin typeface="Calibri" pitchFamily="34" charset="0"/>
-                <a:ea typeface="Calibri" pitchFamily="34" charset="-122"/>
-                <a:cs typeface="Calibri" pitchFamily="34" charset="-120"/>
-              </a:rPr>
-              <a:t>Flag class as God Class if ≥ 3 of 6 thresholds exceeded</a:t>
-            </a:r>
-            <a:endParaRPr lang="en-US" sz="1100" dirty="0"/>
-          </a:p>
-        </p:txBody>
-      </p:sp>
-      <p:sp>
-        <p:nvSpPr>
-          <p:cNvPr id="20" name="Text 18"/>
-          <p:cNvSpPr/>
-          <p:nvPr/>
-        </p:nvSpPr>
-        <p:spPr>
-          <a:xfrm>
-            <a:off x="457200" y="3794760"/>
-            <a:ext cx="3931920" cy="502920"/>
-          </a:xfrm>
-          <a:prstGeom prst="rect">
-            <a:avLst/>
-          </a:prstGeom>
-          <a:noFill/>
-          <a:ln/>
-        </p:spPr>
-        <p:txBody>
-          <a:bodyPr wrap="square" lIns="0" tIns="0" rIns="0" bIns="0" rtlCol="0" anchor="ctr"/>
-          <a:lstStyle/>
-          <a:p>
-            <a:pPr marL="0" indent="0" algn="ctr">
-              <a:buNone/>
-            </a:pPr>
-            <a:r>
-              <a:rPr lang="en-US" sz="1100" i="1" dirty="0">
-                <a:solidFill>
-                  <a:srgbClr val="64748B"/>
-                </a:solidFill>
-                <a:latin typeface="Calibri" pitchFamily="34" charset="0"/>
-                <a:ea typeface="Calibri" pitchFamily="34" charset="-122"/>
-                <a:cs typeface="Calibri" pitchFamily="34" charset="-120"/>
-              </a:rPr>
-              <a:t>Code-level evidence → architectural-level finding</a:t>
-            </a:r>
-            <a:endParaRPr lang="en-US" sz="1100" dirty="0"/>
-          </a:p>
-        </p:txBody>
-      </p:sp>
-      <p:sp>
-        <p:nvSpPr>
-          <p:cNvPr id="21" name="Text 19"/>
-          <p:cNvSpPr/>
-          <p:nvPr/>
-        </p:nvSpPr>
-        <p:spPr>
-          <a:xfrm>
-            <a:off x="365760" y="4846320"/>
-            <a:ext cx="5486400" cy="228600"/>
-          </a:xfrm>
-          <a:prstGeom prst="rect">
-            <a:avLst/>
-          </a:prstGeom>
-          <a:noFill/>
-          <a:ln/>
-        </p:spPr>
-        <p:txBody>
-          <a:bodyPr wrap="square" rtlCol="0" anchor="ctr"/>
-          <a:lstStyle/>
-          <a:p>
-            <a:pPr marL="0" indent="0">
-              <a:buNone/>
-            </a:pPr>
-            <a:r>
-              <a:rPr lang="en-US" sz="900" dirty="0">
-                <a:solidFill>
-                  <a:srgbClr val="64748B"/>
-                </a:solidFill>
-                <a:latin typeface="Calibri" pitchFamily="34" charset="0"/>
-                <a:ea typeface="Calibri" pitchFamily="34" charset="-122"/>
-                <a:cs typeface="Calibri" pitchFamily="34" charset="-120"/>
-              </a:rPr>
-              <a:t>MSA Detector  •  Iacob Andrei  •  UBB FMI</a:t>
-            </a:r>
-            <a:endParaRPr lang="en-US" sz="900" dirty="0"/>
-          </a:p>
-        </p:txBody>
-      </p:sp>
-      <p:sp>
-        <p:nvSpPr>
-          <p:cNvPr id="22" name="Text 20"/>
-          <p:cNvSpPr/>
-          <p:nvPr/>
-        </p:nvSpPr>
-        <p:spPr>
-          <a:xfrm>
-            <a:off x="8046720" y="4846320"/>
-            <a:ext cx="731520" cy="228600"/>
-          </a:xfrm>
-          <a:prstGeom prst="rect">
-            <a:avLst/>
-          </a:prstGeom>
-          <a:noFill/>
-          <a:ln/>
-        </p:spPr>
-        <p:txBody>
-          <a:bodyPr wrap="square" rtlCol="0" anchor="ctr"/>
-          <a:lstStyle/>
-          <a:p>
-            <a:pPr marL="0" indent="0" algn="r">
-              <a:buNone/>
-            </a:pPr>
-            <a:r>
-              <a:rPr lang="en-US" sz="900" dirty="0">
-                <a:solidFill>
-                  <a:srgbClr val="64748B"/>
-                </a:solidFill>
-                <a:latin typeface="Calibri" pitchFamily="34" charset="0"/>
-                <a:ea typeface="Calibri" pitchFamily="34" charset="-122"/>
-                <a:cs typeface="Calibri" pitchFamily="34" charset="-120"/>
-              </a:rPr>
-              <a:t>5 / 12</a:t>
             </a:r>
             <a:endParaRPr lang="en-US" sz="900" dirty="0"/>
           </a:p>
@@ -10028,13 +9580,6 @@
             <a:prstDash val="solid"/>
           </a:ln>
         </p:spPr>
-        <p:txBody>
-          <a:bodyPr/>
-          <a:lstStyle/>
-          <a:p>
-            <a:endParaRPr lang="en-US"/>
-          </a:p>
-        </p:txBody>
       </p:sp>
       <p:sp>
         <p:nvSpPr>
@@ -10060,13 +9605,6 @@
             <a:prstDash val="solid"/>
           </a:ln>
         </p:spPr>
-        <p:txBody>
-          <a:bodyPr/>
-          <a:lstStyle/>
-          <a:p>
-            <a:endParaRPr lang="en-US"/>
-          </a:p>
-        </p:txBody>
       </p:sp>
       <p:sp>
         <p:nvSpPr>
@@ -10209,13 +9747,6 @@
             <a:prstDash val="solid"/>
           </a:ln>
         </p:spPr>
-        <p:txBody>
-          <a:bodyPr/>
-          <a:lstStyle/>
-          <a:p>
-            <a:endParaRPr lang="en-US"/>
-          </a:p>
-        </p:txBody>
       </p:sp>
       <p:sp>
         <p:nvSpPr>
@@ -10241,13 +9772,6 @@
             <a:prstDash val="solid"/>
           </a:ln>
         </p:spPr>
-        <p:txBody>
-          <a:bodyPr/>
-          <a:lstStyle/>
-          <a:p>
-            <a:endParaRPr lang="en-US"/>
-          </a:p>
-        </p:txBody>
       </p:sp>
       <p:sp>
         <p:nvSpPr>
@@ -10390,13 +9914,6 @@
             <a:prstDash val="solid"/>
           </a:ln>
         </p:spPr>
-        <p:txBody>
-          <a:bodyPr/>
-          <a:lstStyle/>
-          <a:p>
-            <a:endParaRPr lang="en-US"/>
-          </a:p>
-        </p:txBody>
       </p:sp>
       <p:sp>
         <p:nvSpPr>
@@ -10422,13 +9939,6 @@
             <a:prstDash val="solid"/>
           </a:ln>
         </p:spPr>
-        <p:txBody>
-          <a:bodyPr/>
-          <a:lstStyle/>
-          <a:p>
-            <a:endParaRPr lang="en-US"/>
-          </a:p>
-        </p:txBody>
       </p:sp>
       <p:sp>
         <p:nvSpPr>
@@ -10571,13 +10081,6 @@
             <a:prstDash val="solid"/>
           </a:ln>
         </p:spPr>
-        <p:txBody>
-          <a:bodyPr/>
-          <a:lstStyle/>
-          <a:p>
-            <a:endParaRPr lang="en-US"/>
-          </a:p>
-        </p:txBody>
       </p:sp>
       <p:sp>
         <p:nvSpPr>
@@ -10603,13 +10106,6 @@
             <a:prstDash val="solid"/>
           </a:ln>
         </p:spPr>
-        <p:txBody>
-          <a:bodyPr/>
-          <a:lstStyle/>
-          <a:p>
-            <a:endParaRPr lang="en-US"/>
-          </a:p>
-        </p:txBody>
       </p:sp>
       <p:sp>
         <p:nvSpPr>
@@ -10791,13 +10287,6 @@
             <a:prstDash val="solid"/>
           </a:ln>
         </p:spPr>
-        <p:txBody>
-          <a:bodyPr/>
-          <a:lstStyle/>
-          <a:p>
-            <a:endParaRPr lang="en-US"/>
-          </a:p>
-        </p:txBody>
       </p:sp>
       <p:sp>
         <p:nvSpPr>
@@ -10901,13 +10390,6 @@
             <a:prstDash val="solid"/>
           </a:ln>
         </p:spPr>
-        <p:txBody>
-          <a:bodyPr/>
-          <a:lstStyle/>
-          <a:p>
-            <a:endParaRPr lang="en-US"/>
-          </a:p>
-        </p:txBody>
       </p:sp>
       <p:sp>
         <p:nvSpPr>
@@ -11011,13 +10493,6 @@
             <a:prstDash val="solid"/>
           </a:ln>
         </p:spPr>
-        <p:txBody>
-          <a:bodyPr/>
-          <a:lstStyle/>
-          <a:p>
-            <a:endParaRPr lang="en-US"/>
-          </a:p>
-        </p:txBody>
       </p:sp>
       <p:sp>
         <p:nvSpPr>
@@ -11121,13 +10596,6 @@
             <a:prstDash val="solid"/>
           </a:ln>
         </p:spPr>
-        <p:txBody>
-          <a:bodyPr/>
-          <a:lstStyle/>
-          <a:p>
-            <a:endParaRPr lang="en-US"/>
-          </a:p>
-        </p:txBody>
       </p:sp>
       <p:sp>
         <p:nvSpPr>
@@ -11231,13 +10699,6 @@
             <a:prstDash val="solid"/>
           </a:ln>
         </p:spPr>
-        <p:txBody>
-          <a:bodyPr/>
-          <a:lstStyle/>
-          <a:p>
-            <a:endParaRPr lang="en-US"/>
-          </a:p>
-        </p:txBody>
       </p:sp>
       <p:sp>
         <p:nvSpPr>
@@ -11326,7 +10787,7 @@
         <p:spPr>
           <a:xfrm>
             <a:off x="457200" y="3931920"/>
-            <a:ext cx="8229600" cy="777240"/>
+            <a:ext cx="8229600" cy="868680"/>
           </a:xfrm>
           <a:prstGeom prst="rect">
             <a:avLst/>
@@ -11358,7 +10819,7 @@
         <p:spPr>
           <a:xfrm>
             <a:off x="457200" y="3931920"/>
-            <a:ext cx="54864" cy="777240"/>
+            <a:ext cx="54864" cy="868680"/>
           </a:xfrm>
           <a:prstGeom prst="rect">
             <a:avLst/>
@@ -11373,13 +10834,6 @@
             <a:prstDash val="solid"/>
           </a:ln>
         </p:spPr>
-        <p:txBody>
-          <a:bodyPr/>
-          <a:lstStyle/>
-          <a:p>
-            <a:endParaRPr lang="en-US"/>
-          </a:p>
-        </p:txBody>
       </p:sp>
       <p:sp>
         <p:nvSpPr>
@@ -11441,8 +10895,9 @@
           <a:bodyPr wrap="square" lIns="0" tIns="0" rIns="0" bIns="0" rtlCol="0" anchor="ctr"/>
           <a:lstStyle/>
           <a:p>
-            <a:pPr marL="0" indent="0">
-              <a:buNone/>
+            <a:pPr marL="171450" indent="-171450">
+              <a:buFont typeface="Arial" panose="020B0604020202020204" pitchFamily="34" charset="0"/>
+              <a:buChar char="•"/>
             </a:pPr>
             <a:r>
               <a:rPr lang="en-US" sz="1050" dirty="0">
@@ -11453,7 +10908,41 @@
                 <a:ea typeface="Calibri" pitchFamily="34" charset="-122"/>
                 <a:cs typeface="Calibri" pitchFamily="34" charset="-120"/>
               </a:rPr>
-              <a:t>A single number tells teams whether quality is improving; per-category breakdown tells them WHICH dimension needs attention; both views are exposed via the analysis-diff feature for tracking over time</a:t>
+              <a:t>A single number tells teams whether quality is improving </a:t>
+            </a:r>
+          </a:p>
+          <a:p>
+            <a:pPr marL="171450" indent="-171450">
+              <a:buFont typeface="Arial" panose="020B0604020202020204" pitchFamily="34" charset="0"/>
+              <a:buChar char="•"/>
+            </a:pPr>
+            <a:r>
+              <a:rPr lang="en-US" sz="1050" dirty="0">
+                <a:solidFill>
+                  <a:srgbClr val="1E293B"/>
+                </a:solidFill>
+                <a:latin typeface="Calibri" pitchFamily="34" charset="0"/>
+                <a:ea typeface="Calibri" pitchFamily="34" charset="-122"/>
+                <a:cs typeface="Calibri" pitchFamily="34" charset="-120"/>
+              </a:rPr>
+              <a:t>per-category breakdown tells them WHICH dimension needs attention </a:t>
+            </a:r>
+          </a:p>
+          <a:p>
+            <a:pPr marL="171450" indent="-171450">
+              <a:buFont typeface="Arial" panose="020B0604020202020204" pitchFamily="34" charset="0"/>
+              <a:buChar char="•"/>
+            </a:pPr>
+            <a:r>
+              <a:rPr lang="en-US" sz="1050" dirty="0">
+                <a:solidFill>
+                  <a:srgbClr val="1E293B"/>
+                </a:solidFill>
+                <a:latin typeface="Calibri" pitchFamily="34" charset="0"/>
+                <a:ea typeface="Calibri" pitchFamily="34" charset="-122"/>
+                <a:cs typeface="Calibri" pitchFamily="34" charset="-120"/>
+              </a:rPr>
+              <a:t>both views are exposed via the analysis-diff feature for tracking over time</a:t>
             </a:r>
             <a:endParaRPr lang="en-US" sz="1050" dirty="0"/>
           </a:p>
@@ -11656,7 +11145,7 @@
         </p:nvSpPr>
         <p:spPr>
           <a:xfrm>
-            <a:off x="457200" y="1179576"/>
+            <a:off x="457200" y="1188720"/>
             <a:ext cx="4114800" cy="283464"/>
           </a:xfrm>
           <a:prstGeom prst="rect">
@@ -11672,13 +11161,6 @@
             <a:prstDash val="solid"/>
           </a:ln>
         </p:spPr>
-        <p:txBody>
-          <a:bodyPr/>
-          <a:lstStyle/>
-          <a:p>
-            <a:endParaRPr lang="en-US"/>
-          </a:p>
-        </p:txBody>
       </p:sp>
       <p:sp>
         <p:nvSpPr>
@@ -11688,7 +11170,7 @@
         </p:nvSpPr>
         <p:spPr>
           <a:xfrm>
-            <a:off x="502920" y="1179576"/>
+            <a:off x="502920" y="1188720"/>
             <a:ext cx="548640" cy="283464"/>
           </a:xfrm>
           <a:prstGeom prst="rect">
@@ -11727,7 +11209,7 @@
         </p:nvSpPr>
         <p:spPr>
           <a:xfrm>
-            <a:off x="1097280" y="1179576"/>
+            <a:off x="1097280" y="1188720"/>
             <a:ext cx="2103120" cy="283464"/>
           </a:xfrm>
           <a:prstGeom prst="rect">
@@ -11766,7 +11248,7 @@
         </p:nvSpPr>
         <p:spPr>
           <a:xfrm>
-            <a:off x="3200400" y="1179576"/>
+            <a:off x="3200400" y="1188720"/>
             <a:ext cx="1325880" cy="283464"/>
           </a:xfrm>
           <a:prstGeom prst="rect">
@@ -11805,7 +11287,7 @@
         </p:nvSpPr>
         <p:spPr>
           <a:xfrm>
-            <a:off x="457200" y="1495044"/>
+            <a:off x="457200" y="1504188"/>
             <a:ext cx="4114800" cy="283464"/>
           </a:xfrm>
           <a:prstGeom prst="rect">
@@ -11821,13 +11303,6 @@
             <a:prstDash val="solid"/>
           </a:ln>
         </p:spPr>
-        <p:txBody>
-          <a:bodyPr/>
-          <a:lstStyle/>
-          <a:p>
-            <a:endParaRPr lang="en-US"/>
-          </a:p>
-        </p:txBody>
       </p:sp>
       <p:sp>
         <p:nvSpPr>
@@ -11837,7 +11312,7 @@
         </p:nvSpPr>
         <p:spPr>
           <a:xfrm>
-            <a:off x="502920" y="1495044"/>
+            <a:off x="502920" y="1504188"/>
             <a:ext cx="548640" cy="283464"/>
           </a:xfrm>
           <a:prstGeom prst="rect">
@@ -11876,7 +11351,7 @@
         </p:nvSpPr>
         <p:spPr>
           <a:xfrm>
-            <a:off x="1097280" y="1495044"/>
+            <a:off x="1097280" y="1504188"/>
             <a:ext cx="2103120" cy="283464"/>
           </a:xfrm>
           <a:prstGeom prst="rect">
@@ -11915,7 +11390,7 @@
         </p:nvSpPr>
         <p:spPr>
           <a:xfrm>
-            <a:off x="3200400" y="1495044"/>
+            <a:off x="3200400" y="1504188"/>
             <a:ext cx="1325880" cy="283464"/>
           </a:xfrm>
           <a:prstGeom prst="rect">
@@ -11954,7 +11429,7 @@
         </p:nvSpPr>
         <p:spPr>
           <a:xfrm>
-            <a:off x="457200" y="1810512"/>
+            <a:off x="457200" y="1819656"/>
             <a:ext cx="4114800" cy="283464"/>
           </a:xfrm>
           <a:prstGeom prst="rect">
@@ -11970,13 +11445,6 @@
             <a:prstDash val="solid"/>
           </a:ln>
         </p:spPr>
-        <p:txBody>
-          <a:bodyPr/>
-          <a:lstStyle/>
-          <a:p>
-            <a:endParaRPr lang="en-US"/>
-          </a:p>
-        </p:txBody>
       </p:sp>
       <p:sp>
         <p:nvSpPr>
@@ -11986,7 +11454,7 @@
         </p:nvSpPr>
         <p:spPr>
           <a:xfrm>
-            <a:off x="502920" y="1810512"/>
+            <a:off x="502920" y="1819656"/>
             <a:ext cx="548640" cy="283464"/>
           </a:xfrm>
           <a:prstGeom prst="rect">
@@ -12025,7 +11493,7 @@
         </p:nvSpPr>
         <p:spPr>
           <a:xfrm>
-            <a:off x="1097280" y="1810512"/>
+            <a:off x="1097280" y="1819656"/>
             <a:ext cx="2103120" cy="283464"/>
           </a:xfrm>
           <a:prstGeom prst="rect">
@@ -12064,7 +11532,7 @@
         </p:nvSpPr>
         <p:spPr>
           <a:xfrm>
-            <a:off x="3200400" y="1810512"/>
+            <a:off x="3200400" y="1819656"/>
             <a:ext cx="1325880" cy="283464"/>
           </a:xfrm>
           <a:prstGeom prst="rect">
@@ -12103,7 +11571,7 @@
         </p:nvSpPr>
         <p:spPr>
           <a:xfrm>
-            <a:off x="457200" y="2125980"/>
+            <a:off x="457200" y="2135124"/>
             <a:ext cx="4114800" cy="283464"/>
           </a:xfrm>
           <a:prstGeom prst="rect">
@@ -12119,13 +11587,6 @@
             <a:prstDash val="solid"/>
           </a:ln>
         </p:spPr>
-        <p:txBody>
-          <a:bodyPr/>
-          <a:lstStyle/>
-          <a:p>
-            <a:endParaRPr lang="en-US"/>
-          </a:p>
-        </p:txBody>
       </p:sp>
       <p:sp>
         <p:nvSpPr>
@@ -12135,7 +11596,7 @@
         </p:nvSpPr>
         <p:spPr>
           <a:xfrm>
-            <a:off x="502920" y="2125980"/>
+            <a:off x="502920" y="2135124"/>
             <a:ext cx="548640" cy="283464"/>
           </a:xfrm>
           <a:prstGeom prst="rect">
@@ -12174,7 +11635,7 @@
         </p:nvSpPr>
         <p:spPr>
           <a:xfrm>
-            <a:off x="1097280" y="2125980"/>
+            <a:off x="1097280" y="2135124"/>
             <a:ext cx="2103120" cy="283464"/>
           </a:xfrm>
           <a:prstGeom prst="rect">
@@ -12213,7 +11674,7 @@
         </p:nvSpPr>
         <p:spPr>
           <a:xfrm>
-            <a:off x="3200400" y="2125980"/>
+            <a:off x="3200400" y="2135124"/>
             <a:ext cx="1325880" cy="283464"/>
           </a:xfrm>
           <a:prstGeom prst="rect">
@@ -12252,7 +11713,7 @@
         </p:nvSpPr>
         <p:spPr>
           <a:xfrm>
-            <a:off x="457200" y="2441448"/>
+            <a:off x="457200" y="2450592"/>
             <a:ext cx="4114800" cy="283464"/>
           </a:xfrm>
           <a:prstGeom prst="rect">
@@ -12268,13 +11729,6 @@
             <a:prstDash val="solid"/>
           </a:ln>
         </p:spPr>
-        <p:txBody>
-          <a:bodyPr/>
-          <a:lstStyle/>
-          <a:p>
-            <a:endParaRPr lang="en-US"/>
-          </a:p>
-        </p:txBody>
       </p:sp>
       <p:sp>
         <p:nvSpPr>
@@ -12284,7 +11738,7 @@
         </p:nvSpPr>
         <p:spPr>
           <a:xfrm>
-            <a:off x="502920" y="2441448"/>
+            <a:off x="502920" y="2450592"/>
             <a:ext cx="548640" cy="283464"/>
           </a:xfrm>
           <a:prstGeom prst="rect">
@@ -12323,7 +11777,7 @@
         </p:nvSpPr>
         <p:spPr>
           <a:xfrm>
-            <a:off x="1097280" y="2441448"/>
+            <a:off x="1097280" y="2450592"/>
             <a:ext cx="2103120" cy="283464"/>
           </a:xfrm>
           <a:prstGeom prst="rect">
@@ -12362,7 +11816,7 @@
         </p:nvSpPr>
         <p:spPr>
           <a:xfrm>
-            <a:off x="3200400" y="2441448"/>
+            <a:off x="3200400" y="2450592"/>
             <a:ext cx="1325880" cy="283464"/>
           </a:xfrm>
           <a:prstGeom prst="rect">
@@ -12401,7 +11855,7 @@
         </p:nvSpPr>
         <p:spPr>
           <a:xfrm>
-            <a:off x="457200" y="2798064"/>
+            <a:off x="457200" y="2807208"/>
             <a:ext cx="4114800" cy="411480"/>
           </a:xfrm>
           <a:prstGeom prst="rect">
@@ -12417,13 +11871,6 @@
             <a:prstDash val="solid"/>
           </a:ln>
         </p:spPr>
-        <p:txBody>
-          <a:bodyPr/>
-          <a:lstStyle/>
-          <a:p>
-            <a:endParaRPr lang="en-US"/>
-          </a:p>
-        </p:txBody>
       </p:sp>
       <p:sp>
         <p:nvSpPr>
@@ -12433,7 +11880,7 @@
         </p:nvSpPr>
         <p:spPr>
           <a:xfrm>
-            <a:off x="457200" y="2798064"/>
+            <a:off x="457200" y="2807208"/>
             <a:ext cx="4114800" cy="411480"/>
           </a:xfrm>
           <a:prstGeom prst="rect">
@@ -12566,13 +12013,6 @@
             <a:prstDash val="solid"/>
           </a:ln>
         </p:spPr>
-        <p:txBody>
-          <a:bodyPr/>
-          <a:lstStyle/>
-          <a:p>
-            <a:endParaRPr lang="en-US"/>
-          </a:p>
-        </p:txBody>
       </p:sp>
       <p:sp>
         <p:nvSpPr>
@@ -12676,13 +12116,6 @@
             <a:prstDash val="solid"/>
           </a:ln>
         </p:spPr>
-        <p:txBody>
-          <a:bodyPr/>
-          <a:lstStyle/>
-          <a:p>
-            <a:endParaRPr lang="en-US"/>
-          </a:p>
-        </p:txBody>
       </p:sp>
       <p:sp>
         <p:nvSpPr>
@@ -12708,13 +12141,6 @@
             <a:prstDash val="solid"/>
           </a:ln>
         </p:spPr>
-        <p:txBody>
-          <a:bodyPr/>
-          <a:lstStyle/>
-          <a:p>
-            <a:endParaRPr lang="en-US"/>
-          </a:p>
-        </p:txBody>
       </p:sp>
       <p:sp>
         <p:nvSpPr>
@@ -12818,13 +12244,6 @@
             <a:prstDash val="solid"/>
           </a:ln>
         </p:spPr>
-        <p:txBody>
-          <a:bodyPr/>
-          <a:lstStyle/>
-          <a:p>
-            <a:endParaRPr lang="en-US"/>
-          </a:p>
-        </p:txBody>
       </p:sp>
       <p:sp>
         <p:nvSpPr>
@@ -12850,13 +12269,6 @@
             <a:prstDash val="solid"/>
           </a:ln>
         </p:spPr>
-        <p:txBody>
-          <a:bodyPr/>
-          <a:lstStyle/>
-          <a:p>
-            <a:endParaRPr lang="en-US"/>
-          </a:p>
-        </p:txBody>
       </p:sp>
       <p:sp>
         <p:nvSpPr>
@@ -12960,13 +12372,6 @@
             <a:prstDash val="solid"/>
           </a:ln>
         </p:spPr>
-        <p:txBody>
-          <a:bodyPr/>
-          <a:lstStyle/>
-          <a:p>
-            <a:endParaRPr lang="en-US"/>
-          </a:p>
-        </p:txBody>
       </p:sp>
       <p:sp>
         <p:nvSpPr>
@@ -12992,13 +12397,6 @@
             <a:prstDash val="solid"/>
           </a:ln>
         </p:spPr>
-        <p:txBody>
-          <a:bodyPr/>
-          <a:lstStyle/>
-          <a:p>
-            <a:endParaRPr lang="en-US"/>
-          </a:p>
-        </p:txBody>
       </p:sp>
       <p:sp>
         <p:nvSpPr>
@@ -13063,13 +12461,6 @@
             <a:prstDash val="solid"/>
           </a:ln>
         </p:spPr>
-        <p:txBody>
-          <a:bodyPr/>
-          <a:lstStyle/>
-          <a:p>
-            <a:endParaRPr lang="en-US"/>
-          </a:p>
-        </p:txBody>
       </p:sp>
       <p:sp>
         <p:nvSpPr>
@@ -13157,7 +12548,7 @@
         </p:nvSpPr>
         <p:spPr>
           <a:xfrm>
-            <a:off x="457200" y="3346704"/>
+            <a:off x="457200" y="3282696"/>
             <a:ext cx="4114800" cy="365760"/>
           </a:xfrm>
           <a:prstGeom prst="rect">
@@ -13196,7 +12587,7 @@
         </p:nvSpPr>
         <p:spPr>
           <a:xfrm>
-            <a:off x="457200" y="3685032"/>
+            <a:off x="457200" y="3611880"/>
             <a:ext cx="4114800" cy="914400"/>
           </a:xfrm>
           <a:prstGeom prst="rect">
@@ -13238,7 +12629,7 @@
                 <a:ea typeface="Calibri" pitchFamily="34" charset="-122"/>
                 <a:cs typeface="Calibri" pitchFamily="34" charset="-120"/>
               </a:rPr>
-              <a:t>the anti-pattern load (penalty 49) clamps AP to 0</a:t>
+              <a:t>Anti-pattern load (penalty 49) clamps AP to 0</a:t>
             </a:r>
           </a:p>
           <a:p>
@@ -13469,7 +12860,7 @@
         </p:nvSpPr>
         <p:spPr>
           <a:xfrm>
-            <a:off x="6035040" y="757646"/>
+            <a:off x="6035040" y="795897"/>
             <a:ext cx="2743200" cy="274320"/>
           </a:xfrm>
           <a:prstGeom prst="rect">
@@ -13508,7 +12899,7 @@
         </p:nvSpPr>
         <p:spPr>
           <a:xfrm>
-            <a:off x="6035040" y="1077686"/>
+            <a:off x="6035040" y="1115937"/>
             <a:ext cx="2743200" cy="192024"/>
           </a:xfrm>
           <a:prstGeom prst="rect">
@@ -13524,13 +12915,6 @@
             <a:prstDash val="solid"/>
           </a:ln>
         </p:spPr>
-        <p:txBody>
-          <a:bodyPr/>
-          <a:lstStyle/>
-          <a:p>
-            <a:endParaRPr lang="en-US"/>
-          </a:p>
-        </p:txBody>
       </p:sp>
       <p:sp>
         <p:nvSpPr>
@@ -13540,7 +12924,7 @@
         </p:nvSpPr>
         <p:spPr>
           <a:xfrm>
-            <a:off x="6126480" y="1077686"/>
+            <a:off x="6126480" y="1115937"/>
             <a:ext cx="1280160" cy="192024"/>
           </a:xfrm>
           <a:prstGeom prst="rect">
@@ -13579,7 +12963,7 @@
         </p:nvSpPr>
         <p:spPr>
           <a:xfrm>
-            <a:off x="7406640" y="1077686"/>
+            <a:off x="7406640" y="1115937"/>
             <a:ext cx="457200" cy="192024"/>
           </a:xfrm>
           <a:prstGeom prst="rect">
@@ -13618,7 +13002,7 @@
         </p:nvSpPr>
         <p:spPr>
           <a:xfrm>
-            <a:off x="7863840" y="1077686"/>
+            <a:off x="7863840" y="1115937"/>
             <a:ext cx="868680" cy="192024"/>
           </a:xfrm>
           <a:prstGeom prst="rect">
@@ -13657,7 +13041,7 @@
         </p:nvSpPr>
         <p:spPr>
           <a:xfrm>
-            <a:off x="6035040" y="1297142"/>
+            <a:off x="6035040" y="1335393"/>
             <a:ext cx="2743200" cy="192024"/>
           </a:xfrm>
           <a:prstGeom prst="rect">
@@ -13673,13 +13057,6 @@
             <a:prstDash val="solid"/>
           </a:ln>
         </p:spPr>
-        <p:txBody>
-          <a:bodyPr/>
-          <a:lstStyle/>
-          <a:p>
-            <a:endParaRPr lang="en-US"/>
-          </a:p>
-        </p:txBody>
       </p:sp>
       <p:sp>
         <p:nvSpPr>
@@ -13689,7 +13066,7 @@
         </p:nvSpPr>
         <p:spPr>
           <a:xfrm>
-            <a:off x="6126480" y="1297142"/>
+            <a:off x="6126480" y="1335393"/>
             <a:ext cx="1280160" cy="192024"/>
           </a:xfrm>
           <a:prstGeom prst="rect">
@@ -13728,7 +13105,7 @@
         </p:nvSpPr>
         <p:spPr>
           <a:xfrm>
-            <a:off x="7406640" y="1297142"/>
+            <a:off x="7406640" y="1335393"/>
             <a:ext cx="457200" cy="192024"/>
           </a:xfrm>
           <a:prstGeom prst="rect">
@@ -13767,7 +13144,7 @@
         </p:nvSpPr>
         <p:spPr>
           <a:xfrm>
-            <a:off x="7863840" y="1297142"/>
+            <a:off x="7863840" y="1335393"/>
             <a:ext cx="868680" cy="192024"/>
           </a:xfrm>
           <a:prstGeom prst="rect">
@@ -13806,7 +13183,7 @@
         </p:nvSpPr>
         <p:spPr>
           <a:xfrm>
-            <a:off x="6035040" y="1516598"/>
+            <a:off x="6035040" y="1554849"/>
             <a:ext cx="2743200" cy="192024"/>
           </a:xfrm>
           <a:prstGeom prst="rect">
@@ -13822,13 +13199,6 @@
             <a:prstDash val="solid"/>
           </a:ln>
         </p:spPr>
-        <p:txBody>
-          <a:bodyPr/>
-          <a:lstStyle/>
-          <a:p>
-            <a:endParaRPr lang="en-US"/>
-          </a:p>
-        </p:txBody>
       </p:sp>
       <p:sp>
         <p:nvSpPr>
@@ -13838,7 +13208,7 @@
         </p:nvSpPr>
         <p:spPr>
           <a:xfrm>
-            <a:off x="6126480" y="1516598"/>
+            <a:off x="6126480" y="1554849"/>
             <a:ext cx="1280160" cy="192024"/>
           </a:xfrm>
           <a:prstGeom prst="rect">
@@ -13877,7 +13247,7 @@
         </p:nvSpPr>
         <p:spPr>
           <a:xfrm>
-            <a:off x="7406640" y="1516598"/>
+            <a:off x="7406640" y="1554849"/>
             <a:ext cx="457200" cy="192024"/>
           </a:xfrm>
           <a:prstGeom prst="rect">
@@ -13916,7 +13286,7 @@
         </p:nvSpPr>
         <p:spPr>
           <a:xfrm>
-            <a:off x="7863840" y="1516598"/>
+            <a:off x="7863840" y="1554849"/>
             <a:ext cx="868680" cy="192024"/>
           </a:xfrm>
           <a:prstGeom prst="rect">
@@ -13955,7 +13325,7 @@
         </p:nvSpPr>
         <p:spPr>
           <a:xfrm>
-            <a:off x="6035040" y="1736054"/>
+            <a:off x="6035040" y="1774305"/>
             <a:ext cx="2743200" cy="192024"/>
           </a:xfrm>
           <a:prstGeom prst="rect">
@@ -13971,13 +13341,6 @@
             <a:prstDash val="solid"/>
           </a:ln>
         </p:spPr>
-        <p:txBody>
-          <a:bodyPr/>
-          <a:lstStyle/>
-          <a:p>
-            <a:endParaRPr lang="en-US"/>
-          </a:p>
-        </p:txBody>
       </p:sp>
       <p:sp>
         <p:nvSpPr>
@@ -13987,7 +13350,7 @@
         </p:nvSpPr>
         <p:spPr>
           <a:xfrm>
-            <a:off x="6126480" y="1736054"/>
+            <a:off x="6126480" y="1774305"/>
             <a:ext cx="1280160" cy="192024"/>
           </a:xfrm>
           <a:prstGeom prst="rect">
@@ -14026,7 +13389,7 @@
         </p:nvSpPr>
         <p:spPr>
           <a:xfrm>
-            <a:off x="7406640" y="1736054"/>
+            <a:off x="7406640" y="1774305"/>
             <a:ext cx="457200" cy="192024"/>
           </a:xfrm>
           <a:prstGeom prst="rect">
@@ -14065,7 +13428,7 @@
         </p:nvSpPr>
         <p:spPr>
           <a:xfrm>
-            <a:off x="7863840" y="1736054"/>
+            <a:off x="7863840" y="1774305"/>
             <a:ext cx="868680" cy="192024"/>
           </a:xfrm>
           <a:prstGeom prst="rect">
@@ -14104,7 +13467,7 @@
         </p:nvSpPr>
         <p:spPr>
           <a:xfrm>
-            <a:off x="6035040" y="1955510"/>
+            <a:off x="6035040" y="1993761"/>
             <a:ext cx="2743200" cy="192024"/>
           </a:xfrm>
           <a:prstGeom prst="rect">
@@ -14120,13 +13483,6 @@
             <a:prstDash val="solid"/>
           </a:ln>
         </p:spPr>
-        <p:txBody>
-          <a:bodyPr/>
-          <a:lstStyle/>
-          <a:p>
-            <a:endParaRPr lang="en-US"/>
-          </a:p>
-        </p:txBody>
       </p:sp>
       <p:sp>
         <p:nvSpPr>
@@ -14136,7 +13492,7 @@
         </p:nvSpPr>
         <p:spPr>
           <a:xfrm>
-            <a:off x="6126480" y="1955510"/>
+            <a:off x="6126480" y="1993761"/>
             <a:ext cx="1280160" cy="192024"/>
           </a:xfrm>
           <a:prstGeom prst="rect">
@@ -14175,7 +13531,7 @@
         </p:nvSpPr>
         <p:spPr>
           <a:xfrm>
-            <a:off x="7406640" y="1955510"/>
+            <a:off x="7406640" y="1993761"/>
             <a:ext cx="457200" cy="192024"/>
           </a:xfrm>
           <a:prstGeom prst="rect">
@@ -14214,7 +13570,7 @@
         </p:nvSpPr>
         <p:spPr>
           <a:xfrm>
-            <a:off x="7863840" y="1955510"/>
+            <a:off x="7863840" y="1993761"/>
             <a:ext cx="868680" cy="192024"/>
           </a:xfrm>
           <a:prstGeom prst="rect">
@@ -14253,7 +13609,7 @@
         </p:nvSpPr>
         <p:spPr>
           <a:xfrm>
-            <a:off x="6035040" y="2174966"/>
+            <a:off x="6035040" y="2213217"/>
             <a:ext cx="2743200" cy="192024"/>
           </a:xfrm>
           <a:prstGeom prst="rect">
@@ -14269,13 +13625,6 @@
             <a:prstDash val="solid"/>
           </a:ln>
         </p:spPr>
-        <p:txBody>
-          <a:bodyPr/>
-          <a:lstStyle/>
-          <a:p>
-            <a:endParaRPr lang="en-US"/>
-          </a:p>
-        </p:txBody>
       </p:sp>
       <p:sp>
         <p:nvSpPr>
@@ -14285,7 +13634,7 @@
         </p:nvSpPr>
         <p:spPr>
           <a:xfrm>
-            <a:off x="6126480" y="2174966"/>
+            <a:off x="6126480" y="2213217"/>
             <a:ext cx="1280160" cy="192024"/>
           </a:xfrm>
           <a:prstGeom prst="rect">
@@ -14324,7 +13673,7 @@
         </p:nvSpPr>
         <p:spPr>
           <a:xfrm>
-            <a:off x="7406640" y="2174966"/>
+            <a:off x="7406640" y="2213217"/>
             <a:ext cx="457200" cy="192024"/>
           </a:xfrm>
           <a:prstGeom prst="rect">
@@ -14363,7 +13712,7 @@
         </p:nvSpPr>
         <p:spPr>
           <a:xfrm>
-            <a:off x="7863840" y="2174966"/>
+            <a:off x="7863840" y="2213217"/>
             <a:ext cx="868680" cy="192024"/>
           </a:xfrm>
           <a:prstGeom prst="rect">
@@ -14402,7 +13751,7 @@
         </p:nvSpPr>
         <p:spPr>
           <a:xfrm>
-            <a:off x="6035040" y="2394422"/>
+            <a:off x="6035040" y="2432673"/>
             <a:ext cx="2743200" cy="192024"/>
           </a:xfrm>
           <a:prstGeom prst="rect">
@@ -14418,13 +13767,6 @@
             <a:prstDash val="solid"/>
           </a:ln>
         </p:spPr>
-        <p:txBody>
-          <a:bodyPr/>
-          <a:lstStyle/>
-          <a:p>
-            <a:endParaRPr lang="en-US"/>
-          </a:p>
-        </p:txBody>
       </p:sp>
       <p:sp>
         <p:nvSpPr>
@@ -14434,7 +13776,7 @@
         </p:nvSpPr>
         <p:spPr>
           <a:xfrm>
-            <a:off x="6126480" y="2394422"/>
+            <a:off x="6126480" y="2432673"/>
             <a:ext cx="1280160" cy="192024"/>
           </a:xfrm>
           <a:prstGeom prst="rect">
@@ -14473,7 +13815,7 @@
         </p:nvSpPr>
         <p:spPr>
           <a:xfrm>
-            <a:off x="7406640" y="2394422"/>
+            <a:off x="7406640" y="2432673"/>
             <a:ext cx="457200" cy="192024"/>
           </a:xfrm>
           <a:prstGeom prst="rect">
@@ -14512,7 +13854,7 @@
         </p:nvSpPr>
         <p:spPr>
           <a:xfrm>
-            <a:off x="7863840" y="2394422"/>
+            <a:off x="7863840" y="2432673"/>
             <a:ext cx="868680" cy="192024"/>
           </a:xfrm>
           <a:prstGeom prst="rect">
@@ -14551,7 +13893,7 @@
         </p:nvSpPr>
         <p:spPr>
           <a:xfrm>
-            <a:off x="6035040" y="2613878"/>
+            <a:off x="6035040" y="2652129"/>
             <a:ext cx="2743200" cy="192024"/>
           </a:xfrm>
           <a:prstGeom prst="rect">
@@ -14567,13 +13909,6 @@
             <a:prstDash val="solid"/>
           </a:ln>
         </p:spPr>
-        <p:txBody>
-          <a:bodyPr/>
-          <a:lstStyle/>
-          <a:p>
-            <a:endParaRPr lang="en-US"/>
-          </a:p>
-        </p:txBody>
       </p:sp>
       <p:sp>
         <p:nvSpPr>
@@ -14583,7 +13918,7 @@
         </p:nvSpPr>
         <p:spPr>
           <a:xfrm>
-            <a:off x="6126480" y="2613878"/>
+            <a:off x="6126480" y="2652129"/>
             <a:ext cx="1280160" cy="192024"/>
           </a:xfrm>
           <a:prstGeom prst="rect">
@@ -14622,7 +13957,7 @@
         </p:nvSpPr>
         <p:spPr>
           <a:xfrm>
-            <a:off x="7406640" y="2613878"/>
+            <a:off x="7406640" y="2652129"/>
             <a:ext cx="457200" cy="192024"/>
           </a:xfrm>
           <a:prstGeom prst="rect">
@@ -14661,7 +13996,7 @@
         </p:nvSpPr>
         <p:spPr>
           <a:xfrm>
-            <a:off x="7863840" y="2613878"/>
+            <a:off x="7863840" y="2652129"/>
             <a:ext cx="868680" cy="192024"/>
           </a:xfrm>
           <a:prstGeom prst="rect">
@@ -14700,7 +14035,7 @@
         </p:nvSpPr>
         <p:spPr>
           <a:xfrm>
-            <a:off x="6035040" y="2833334"/>
+            <a:off x="6035040" y="2871585"/>
             <a:ext cx="2743200" cy="192024"/>
           </a:xfrm>
           <a:prstGeom prst="rect">
@@ -14716,13 +14051,6 @@
             <a:prstDash val="solid"/>
           </a:ln>
         </p:spPr>
-        <p:txBody>
-          <a:bodyPr/>
-          <a:lstStyle/>
-          <a:p>
-            <a:endParaRPr lang="en-US"/>
-          </a:p>
-        </p:txBody>
       </p:sp>
       <p:sp>
         <p:nvSpPr>
@@ -14732,7 +14060,7 @@
         </p:nvSpPr>
         <p:spPr>
           <a:xfrm>
-            <a:off x="6126480" y="2833334"/>
+            <a:off x="6126480" y="2871585"/>
             <a:ext cx="1280160" cy="192024"/>
           </a:xfrm>
           <a:prstGeom prst="rect">
@@ -14771,7 +14099,7 @@
         </p:nvSpPr>
         <p:spPr>
           <a:xfrm>
-            <a:off x="7406640" y="2833334"/>
+            <a:off x="7406640" y="2871585"/>
             <a:ext cx="457200" cy="192024"/>
           </a:xfrm>
           <a:prstGeom prst="rect">
@@ -14810,7 +14138,7 @@
         </p:nvSpPr>
         <p:spPr>
           <a:xfrm>
-            <a:off x="7863840" y="2833334"/>
+            <a:off x="7863840" y="2871585"/>
             <a:ext cx="868680" cy="192024"/>
           </a:xfrm>
           <a:prstGeom prst="rect">
@@ -14849,7 +14177,7 @@
         </p:nvSpPr>
         <p:spPr>
           <a:xfrm>
-            <a:off x="6035040" y="3052790"/>
+            <a:off x="6035040" y="3091041"/>
             <a:ext cx="2743200" cy="192024"/>
           </a:xfrm>
           <a:prstGeom prst="rect">
@@ -14865,13 +14193,6 @@
             <a:prstDash val="solid"/>
           </a:ln>
         </p:spPr>
-        <p:txBody>
-          <a:bodyPr/>
-          <a:lstStyle/>
-          <a:p>
-            <a:endParaRPr lang="en-US"/>
-          </a:p>
-        </p:txBody>
       </p:sp>
       <p:sp>
         <p:nvSpPr>
@@ -14881,7 +14202,7 @@
         </p:nvSpPr>
         <p:spPr>
           <a:xfrm>
-            <a:off x="6126480" y="3052790"/>
+            <a:off x="6126480" y="3091041"/>
             <a:ext cx="1280160" cy="192024"/>
           </a:xfrm>
           <a:prstGeom prst="rect">
@@ -14920,7 +14241,7 @@
         </p:nvSpPr>
         <p:spPr>
           <a:xfrm>
-            <a:off x="7406640" y="3052790"/>
+            <a:off x="7406640" y="3091041"/>
             <a:ext cx="457200" cy="192024"/>
           </a:xfrm>
           <a:prstGeom prst="rect">
@@ -14959,7 +14280,7 @@
         </p:nvSpPr>
         <p:spPr>
           <a:xfrm>
-            <a:off x="7863840" y="3052790"/>
+            <a:off x="7863840" y="3091041"/>
             <a:ext cx="868680" cy="192024"/>
           </a:xfrm>
           <a:prstGeom prst="rect">
@@ -14998,7 +14319,7 @@
         </p:nvSpPr>
         <p:spPr>
           <a:xfrm>
-            <a:off x="6035040" y="3272246"/>
+            <a:off x="6035040" y="3310497"/>
             <a:ext cx="2743200" cy="192024"/>
           </a:xfrm>
           <a:prstGeom prst="rect">
@@ -15014,13 +14335,6 @@
             <a:prstDash val="solid"/>
           </a:ln>
         </p:spPr>
-        <p:txBody>
-          <a:bodyPr/>
-          <a:lstStyle/>
-          <a:p>
-            <a:endParaRPr lang="en-US"/>
-          </a:p>
-        </p:txBody>
       </p:sp>
       <p:sp>
         <p:nvSpPr>
@@ -15030,7 +14344,7 @@
         </p:nvSpPr>
         <p:spPr>
           <a:xfrm>
-            <a:off x="6126480" y="3272246"/>
+            <a:off x="6126480" y="3310497"/>
             <a:ext cx="1280160" cy="192024"/>
           </a:xfrm>
           <a:prstGeom prst="rect">
@@ -15069,7 +14383,7 @@
         </p:nvSpPr>
         <p:spPr>
           <a:xfrm>
-            <a:off x="7406640" y="3272246"/>
+            <a:off x="7406640" y="3310497"/>
             <a:ext cx="457200" cy="192024"/>
           </a:xfrm>
           <a:prstGeom prst="rect">
@@ -15108,7 +14422,7 @@
         </p:nvSpPr>
         <p:spPr>
           <a:xfrm>
-            <a:off x="7863840" y="3272246"/>
+            <a:off x="7863840" y="3310497"/>
             <a:ext cx="868680" cy="192024"/>
           </a:xfrm>
           <a:prstGeom prst="rect">
@@ -15147,7 +14461,7 @@
         </p:nvSpPr>
         <p:spPr>
           <a:xfrm>
-            <a:off x="6035040" y="3491702"/>
+            <a:off x="6035040" y="3529953"/>
             <a:ext cx="2743200" cy="192024"/>
           </a:xfrm>
           <a:prstGeom prst="rect">
@@ -15163,13 +14477,6 @@
             <a:prstDash val="solid"/>
           </a:ln>
         </p:spPr>
-        <p:txBody>
-          <a:bodyPr/>
-          <a:lstStyle/>
-          <a:p>
-            <a:endParaRPr lang="en-US"/>
-          </a:p>
-        </p:txBody>
       </p:sp>
       <p:sp>
         <p:nvSpPr>
@@ -15179,7 +14486,7 @@
         </p:nvSpPr>
         <p:spPr>
           <a:xfrm>
-            <a:off x="6126480" y="3491702"/>
+            <a:off x="6126480" y="3529953"/>
             <a:ext cx="1280160" cy="192024"/>
           </a:xfrm>
           <a:prstGeom prst="rect">
@@ -15218,7 +14525,7 @@
         </p:nvSpPr>
         <p:spPr>
           <a:xfrm>
-            <a:off x="7406640" y="3491702"/>
+            <a:off x="7406640" y="3529953"/>
             <a:ext cx="457200" cy="192024"/>
           </a:xfrm>
           <a:prstGeom prst="rect">
@@ -15257,7 +14564,7 @@
         </p:nvSpPr>
         <p:spPr>
           <a:xfrm>
-            <a:off x="7863840" y="3491702"/>
+            <a:off x="7863840" y="3529953"/>
             <a:ext cx="868680" cy="192024"/>
           </a:xfrm>
           <a:prstGeom prst="rect">
@@ -15312,13 +14619,6 @@
             <a:prstDash val="solid"/>
           </a:ln>
         </p:spPr>
-        <p:txBody>
-          <a:bodyPr/>
-          <a:lstStyle/>
-          <a:p>
-            <a:endParaRPr lang="en-US"/>
-          </a:p>
-        </p:txBody>
       </p:sp>
       <p:sp>
         <p:nvSpPr>
@@ -15344,13 +14644,6 @@
             <a:prstDash val="solid"/>
           </a:ln>
         </p:spPr>
-        <p:txBody>
-          <a:bodyPr/>
-          <a:lstStyle/>
-          <a:p>
-            <a:endParaRPr lang="en-US"/>
-          </a:p>
-        </p:txBody>
       </p:sp>
       <p:sp>
         <p:nvSpPr>
@@ -15399,7 +14692,7 @@
         </p:nvSpPr>
         <p:spPr>
           <a:xfrm>
-            <a:off x="731520" y="4006378"/>
+            <a:off x="731520" y="4069080"/>
             <a:ext cx="7955280" cy="594360"/>
           </a:xfrm>
           <a:prstGeom prst="rect">
@@ -16128,10 +15421,4 @@
     </a:ext>
   </a:extLst>
 </a:theme>
-</file>
-
-<file path=docMetadata/LabelInfo.xml><?xml version="1.0" encoding="utf-8"?>
-<clbl:labelList xmlns:clbl="http://schemas.microsoft.com/office/2020/mipLabelMetadata">
-  <clbl:label id="{9d258917-277f-42cd-a3cd-14c4e9ee58bc}" enabled="1" method="Standard" siteId="{38ae3bcd-9579-4fd4-adda-b42e1495d55a}" contentBits="0" removed="0"/>
-</clbl:labelList>
 </file>
</xml_diff>

<commit_message>
fix hardcoded endpoints detector, thesis and presentation
</commit_message>
<xml_diff>
--- a/thesis/presentation/MSA_Detector_Defense.pptx
+++ b/thesis/presentation/MSA_Detector_Defense.pptx
@@ -238,25 +238,25 @@
                   <c:v>PiggyMetrics</c:v>
                 </c:pt>
                 <c:pt idx="3">
-                  <c:v>Site-Where</c:v>
+                  <c:v>RuoYi</c:v>
                 </c:pt>
                 <c:pt idx="4">
-                  <c:v>RuoYi</c:v>
+                  <c:v>Site-Where</c:v>
                 </c:pt>
                 <c:pt idx="5">
                   <c:v>design-pat.</c:v>
                 </c:pt>
                 <c:pt idx="6">
-                  <c:v>mall-swarm</c:v>
+                  <c:v>NetworkDisk</c:v>
                 </c:pt>
                 <c:pt idx="7">
-                  <c:v>NetworkDisk</c:v>
+                  <c:v>piomin</c:v>
                 </c:pt>
                 <c:pt idx="8">
-                  <c:v>piomin</c:v>
+                  <c:v>Train-Ticket</c:v>
                 </c:pt>
                 <c:pt idx="9">
-                  <c:v>Train-Ticket</c:v>
+                  <c:v>mall-swarm</c:v>
                 </c:pt>
                 <c:pt idx="10">
                   <c:v>recruit</c:v>
@@ -280,25 +280,25 @@
                   <c:v>71</c:v>
                 </c:pt>
                 <c:pt idx="3">
-                  <c:v>69</c:v>
+                  <c:v>71</c:v>
                 </c:pt>
                 <c:pt idx="4">
-                  <c:v>68</c:v>
+                  <c:v>69</c:v>
                 </c:pt>
                 <c:pt idx="5">
                   <c:v>60</c:v>
                 </c:pt>
                 <c:pt idx="6">
-                  <c:v>53</c:v>
+                  <c:v>59</c:v>
                 </c:pt>
                 <c:pt idx="7">
-                  <c:v>52</c:v>
+                  <c:v>55</c:v>
                 </c:pt>
                 <c:pt idx="8">
-                  <c:v>51</c:v>
+                  <c:v>54</c:v>
                 </c:pt>
                 <c:pt idx="9">
-                  <c:v>40</c:v>
+                  <c:v>53</c:v>
                 </c:pt>
                 <c:pt idx="10">
                   <c:v>40</c:v>
@@ -308,7 +308,7 @@
           </c:val>
           <c:extLst>
             <c:ext xmlns:c16="http://schemas.microsoft.com/office/drawing/2014/chart" uri="{C3380CC4-5D6E-409C-BE32-E72D297353CC}">
-              <c16:uniqueId val="{00000000-553C-4958-82EF-F74EA1498A57}"/>
+              <c16:uniqueId val="{00000000-CFF2-4573-9571-29A36389DD7E}"/>
             </c:ext>
           </c:extLst>
         </c:ser>
@@ -470,7 +470,7 @@
     </p:spTree>
     <p:extLst>
       <p:ext uri="{BB962C8B-B14F-4D97-AF65-F5344CB8AC3E}">
-        <p14:creationId xmlns:p14="http://schemas.microsoft.com/office/powerpoint/2010/main" val="3683202923"/>
+        <p14:creationId xmlns:p14="http://schemas.microsoft.com/office/powerpoint/2010/main" val="3229536906"/>
       </p:ext>
     </p:extLst>
   </p:cSld>
@@ -624,15 +624,14 @@
             </a:r>
             <a:r>
               <a:rPr lang="en-US" dirty="0"/>
-              <a:t>.
-</a:t>
+              <a:t>.</a:t>
             </a:r>
           </a:p>
           <a:p>
             <a:r>
               <a:rPr lang="en-US" dirty="0"/>
-              <a:t>The core idea is straightforward — as organisations adopt microservices, they often unknowingly introduce structural problems that erode the very benefits they were after. This tool helps catch those problems early, from a source code checkout, before they become production incidents
-</a:t>
+              <a:t>
+The core idea is straightforward — as organisations adopt microservices, they often unknowingly introduce structural problems that erode the very benefits they were after. This tool helps catch those problems early, from a source code checkout, before they become production incidents.</a:t>
             </a:r>
           </a:p>
         </p:txBody>
@@ -826,8 +825,7 @@
 • 'Static analysis trades precision for applicability. A distributed tracing approach would give exact runtime call counts but requires the system to be deployed and instrumented — which prevents the tool from running on a fresh checkout.'
 • 'The health score weights aren't empirically validated. They're engineering judgement informed by the literature. Different teams might want different weightings.'
 • 'Future work in priority order: multi-language support, then ML-based detection, then empirical calibration of thresholds.'
-You can add: 'The multi-language extension is actually partially designed already — Chapter 5 describes a roadmap where Docker Compose and Kubernetes manifests provide a language-agnostic dependency graph, and only the intra-service analysis needs per-language adapters. So the architecture is ready for it, even though the implementation is Java-only today.'
-Don't get defensive about limitations. Acknowledging them is more impressive than glossing over them.</a:t>
+You can add: 'The multi-language extension is actually partially designed already — Chapter 5 describes a roadmap where Docker Compose and Kubernetes manifests provide a language-agnostic dependency graph, and only the intra-service analysis needs per-language adapters. So the architecture is ready for it, even though the implementation is Java-only today.'</a:t>
             </a:r>
           </a:p>
         </p:txBody>
@@ -914,7 +912,7 @@
           <a:p>
             <a:r>
               <a:rPr lang="en-US" dirty="0"/>
-              <a:t>'To recap: the MSA Detector is a multi-level static analysis tool for Java/Spring Boot microservices, with ten anti-pattern detectors, a composite health score, and evidence-based reporting. The full implementation, evaluation data, and dissertation are available. 'If there's one thing I'd like you to take away, it's that the bridge between code-level evidence and architectural-level findings is what makes this tool different — it doesn't just say something is wrong, it shows you exactly where in the code the problem lives. Thank you.'
+              <a:t>To recap: the MSA Detector is a multi-level static analysis tool for Java/Spring Boot microservices, with ten anti-pattern detectors, a composite health score, and evidence-based reporting. The full implementation, evaluation data, and dissertation are available. If there's one thing I'd like you to take away, it's that the bridge between code-level evidence and architectural-level findings is what makes this tool different — it doesn't just say something is wrong, it shows you exactly where in the code the problem lives. Thank you.
 Then SHUT UP. Don't fill the silence. Let the committee speak.
 When the first question comes:
 1. Listen to the whole question — don't start composing the answer mid-question.
@@ -1011,6 +1009,10 @@
           <a:bodyPr/>
           <a:lstStyle/>
           <a:p>
+            <a:pPr marL="0" indent="0">
+              <a:buFont typeface="Arial" panose="020B0604020202020204" pitchFamily="34" charset="0"/>
+              <a:buNone/>
+            </a:pPr>
             <a:r>
               <a:rPr lang="en-US" dirty="0"/>
               <a:t>• Microservices have become the default for new large systems. But tooling for architectural quality hasn't kept up.
@@ -1022,10 +1024,19 @@
             </a:r>
             <a:r>
               <a:rPr lang="en-US" dirty="0"/>
-              <a:t> — arguably the single biggest reason to use microservices in the first place.'
-• Existing academic tools each handle a slice: Arcan does code-level cycles, MicroART visualises architecture, MSANose detects some microservice smells. None combine code-level smells with architectural-level analysis.
+              <a:t> — arguably the single biggest reason to use microservices in the first place.</a:t>
+            </a:r>
+          </a:p>
+          <a:p>
+            <a:pPr marL="0" indent="0">
+              <a:buFont typeface="Arial" panose="020B0604020202020204" pitchFamily="34" charset="0"/>
+              <a:buNone/>
+            </a:pPr>
+            <a:r>
+              <a:rPr lang="en-US" dirty="0"/>
+              <a:t>• Existing academic tools each handle a slice: Arcan does code-level cycles, MicroART visualises architecture, MSANose detects some microservice smells. None combine code-level smells with architectural-level analysis.
 • Even when something IS detected, the output is usually an abstract warning. Developers don't act on warnings without code evidence and remediation guidance.
-So the goal of this work was a tool that bridges both levels and outputs actionable findings.'</a:t>
+Pivot to next slide: 'So the goal of this work was a tool that bridges both levels and outputs actionable findings.'</a:t>
             </a:r>
           </a:p>
         </p:txBody>
@@ -1117,8 +1128,7 @@
 • 'Third, automated microservice boundary detection via a three-signal deployability gate — framework entry points, Dockerfiles, and main methods — with confidence levels. Most existing tools require manual configuration.'
 • 'Fourth, a composite health score on 0–100, decomposed into four categories so you can see which dimension is dragging the score down.'
 • 'Fifth, evidence-based reporting — every finding includes the actual code that triggered it.'
-'To give you a clearer picture of how these pieces fit together, let me walk you through the analysis pipeline — from the moment a project is uploaded to the final report.'
-</a:t>
+Bridge to next slide: 'To give you a clearer picture of how these pieces fit together, let me walk you through the analysis pipeline — from the moment a project is uploaded to the final report.'</a:t>
             </a:r>
           </a:p>
         </p:txBody>
@@ -1394,13 +1404,7 @@
               <a:rPr lang="en-US" dirty="0"/>
               <a:t>• 'These are the ten detectors, organised by architectural dimension. Each is a Spring component implementing a common interface, so adding a new detector means writing one class — no orchestrator changes.'
 • 'Severities feed directly into the health score: critical issues cost 8 points, high cost 5, medium cost 3.'
-</a:t>
-            </a:r>
-          </a:p>
-          <a:p>
-            <a:r>
-              <a:rPr lang="en-US" dirty="0"/>
-              <a:t>'The severity levels aren't arbitrary — they reflect how much damage the anti-pattern can cause. Cyclic Dependency and Distributed Monolith are critical because they undermine independent </a:t>
+'The severity levels aren't arbitrary — they reflect how much damage the anti-pattern can cause. Cyclic Dependency and Distributed Monolith are critical because they undermine independent </a:t>
             </a:r>
             <a:r>
               <a:rPr lang="en-US" dirty="0" err="1"/>
@@ -1416,7 +1420,7 @@
             </a:r>
             <a:r>
               <a:rPr lang="en-US" dirty="0"/>
-              <a:t>.'</a:t>
+              <a:t>.’</a:t>
             </a:r>
           </a:p>
           <a:p>
@@ -1528,14 +1532,14 @@
           <a:p>
             <a:r>
               <a:rPr lang="en-US" dirty="0"/>
-              <a:t>'The weights were informed by how other composite metrics work in the literature — SonarQube's maintainability rating, SQALE, and the ISO 25010 quality model. Anti-patterns get the largest budget because they represent architectural-level issues that are expensive to fix after deployment.’
-</a:t>
+              <a:t>'The weights were informed by how other composite metrics work in the literature — SonarQube's maintainability rating, SQALE, and the ISO 25010 quality model. Anti-patterns get the largest budget because they represent architectural-level issues that are expensive to fix after deployment.’</a:t>
             </a:r>
           </a:p>
           <a:p>
             <a:r>
               <a:rPr lang="en-US" dirty="0"/>
-              <a:t>EXPECT THIS QUESTION: 'Doesn't clamping at zero mean you lose discrimination between moderately bad and very bad projects?'
+              <a:t>
+EXPECT THIS QUESTION: 'Doesn't clamping at zero mean you lose discrimination between moderately bad and very bad projects?'
 Answer: 'Yes — that's a known limitation of the category-cap approach, which I note in the threats to validity. A team with 13 nano services and one with 50 would both see Anti-Patterns at zero. The Service Sizing breakdown still preserves the per-issue counts, so the full picture is still visible to the user. A scaled, density-style penalty in the AP category — similar to the Code Quality category — would address this in future work.'</a:t>
             </a:r>
           </a:p>
@@ -1627,18 +1631,23 @@
 • 'Its single nano service is scored under Service Sizing instead of the anti-pattern category, to avoid double counting — costing 3 points there, leaving 12 of 15.'
 • 'Architecture loses 9 points for the structural coupling of its dependency graph — leaving 16 of 25.'
 • 'Code Quality is scored by smell density: 260 smells over 8.3K LOC is 31.4 per KLOC, an 8-point deduction, leaving 12 of 20.'
-• 'The final composite is 0 + 12 + 16 + 12 = 40 — grade F. Unlike a project whose problems sit in one place, this one loses points in every dimension, which is exactly what the multi-level scoring is meant to surface.'
+• 'The final composite is 0 + 12 + 16 + 12 = 40 — grade F. Unlike a project whose problems sit in one place, this one loses points in every dimension, which is exactly what the multi-level scoring is meant to surface.’
+</a:t>
+            </a:r>
+          </a:p>
+          <a:p>
+            <a:r>
+              <a:rPr lang="en-US" dirty="0"/>
+              <a:t>'What makes this example interesting is that the problems are spread across all four categories — it's not a project with one catastrophic issue, it's a project with consistent low-level neglect across every dimension. That's exactly the kind of systemic debt the multi-category decomposition is designed to surface.’</a:t>
+            </a:r>
+          </a:p>
+          <a:p>
+            <a:r>
+              <a:rPr lang="en-US" dirty="0"/>
+              <a:t>
 This demonstrates that the scoring is transparent and that the breakdown shows exactly what's wrong.
-'What makes this example interesting is that the problems are spread across all four categories — it's not a project with one catastrophic issue, it's a project with consistent low-level neglect across every dimension. That's exactly the kind of systemic debt the multi-category decomposition is designed to surface.’
-</a:t>
-            </a:r>
-          </a:p>
-          <a:p>
-            <a:r>
-              <a:rPr lang="en-US" dirty="0"/>
-              <a:t>EXPECT QUESTION: 'Only 8 points lost on Code Quality with 260 smells — why so little?'
-Answer: 'Code Quality is scored on smell density per 1000 LOC, not raw count, so a codebase isn't punished just for its size. The category is deliberately bounded so that architectural anti-patterns remain the dominant signal in the overall score.'
-</a:t>
+EXPECT QUESTION: 'Only 8 points lost on Code Quality with 260 smells — why so little?'
+Answer: 'Code Quality is scored on smell density per 1000 LOC, not raw count, so a codebase isn't punished just for its size. The category is deliberately bounded so that architectural anti-patterns remain the dominant signal in the overall score.'</a:t>
             </a:r>
           </a:p>
         </p:txBody>
@@ -1727,8 +1736,8 @@
               <a:rPr lang="en-US" dirty="0"/>
               <a:t>• 'I evaluated on eleven open-source Spring Boot projects, spanning from piomin at 1.3k LOC to mall-swarm at 86k LOC. 130 microservices, about 274k LOC total.'
 • 'Health scores ranged from 40 to 83 — the scoring mechanism produces meaningful spread.'
-• 'The dominant findings are configuration and sizing issues: 43 hardcoded endpoints, 37 API versioning absences, 23 nano services. 
-• '126 total anti-pattern instances across 9 distinct types. Only Distributed Monolith was not detected — plausible given these projects' topologies.'
+• 'The dominant findings are configuration and sizing issues: 37 API versioning absences, 23 nano services, 15 hardcoded endpoints. Cyclic Dependency and Wrong Cuts were detected in microservice-recruit. Adding PiggyMetrics and piomin broadened ESB Misuse and Nano Service coverage.'
+• '98 total anti-pattern instances across 9 distinct types. Only Distributed Monolith was not detected — plausible given these projects' topologies.'
 You can add: 'The score range — 40 to 83 — shows that the metric has useful discriminating power. Projects known to be well-structured like MicroSocial score highest; projects known to have issues like Train-Ticket and microservice-recruit score lowest. If every project scored 70, the metric wouldn't be telling us much.'
 EXPECT: 'Only eleven projects, is that enough?'
 Answer: 'Not for a statistical claim. This evaluation is a feasibility demonstration across heterogeneous codebases. A full precision/recall study would need a labelled corpus, which doesn't exist for microservice anti-patterns — that's an open problem in the field. I note this in Threats to Validity.'</a:t>
@@ -2582,8 +2591,8 @@
         </p:nvSpPr>
         <p:spPr>
           <a:xfrm>
-            <a:off x="685800" y="2528316"/>
-            <a:ext cx="5373255" cy="2148840"/>
+            <a:off x="731520" y="2460819"/>
+            <a:ext cx="5361272" cy="2156901"/>
           </a:xfrm>
           <a:prstGeom prst="rect">
             <a:avLst/>
@@ -2607,7 +2616,7 @@
         </p:nvSpPr>
         <p:spPr>
           <a:xfrm>
-            <a:off x="914400" y="2651760"/>
+            <a:off x="914400" y="2595813"/>
             <a:ext cx="384048" cy="384048"/>
           </a:xfrm>
           <a:prstGeom prst="ellipse">
@@ -2632,7 +2641,7 @@
         </p:nvSpPr>
         <p:spPr>
           <a:xfrm>
-            <a:off x="914400" y="2651760"/>
+            <a:off x="914400" y="2595813"/>
             <a:ext cx="384048" cy="384048"/>
           </a:xfrm>
           <a:prstGeom prst="rect">
@@ -2671,7 +2680,7 @@
         </p:nvSpPr>
         <p:spPr>
           <a:xfrm>
-            <a:off x="1463040" y="2624328"/>
+            <a:off x="1463040" y="2568381"/>
             <a:ext cx="6858000" cy="256032"/>
           </a:xfrm>
           <a:prstGeom prst="rect">
@@ -2710,7 +2719,7 @@
         </p:nvSpPr>
         <p:spPr>
           <a:xfrm>
-            <a:off x="1463040" y="2862072"/>
+            <a:off x="1463040" y="2806125"/>
             <a:ext cx="6858000" cy="237744"/>
           </a:xfrm>
           <a:prstGeom prst="rect">
@@ -2749,7 +2758,7 @@
         </p:nvSpPr>
         <p:spPr>
           <a:xfrm>
-            <a:off x="914400" y="3154680"/>
+            <a:off x="914400" y="3098733"/>
             <a:ext cx="384048" cy="384048"/>
           </a:xfrm>
           <a:prstGeom prst="ellipse">
@@ -2774,7 +2783,7 @@
         </p:nvSpPr>
         <p:spPr>
           <a:xfrm>
-            <a:off x="914400" y="3154680"/>
+            <a:off x="914400" y="3098733"/>
             <a:ext cx="384048" cy="384048"/>
           </a:xfrm>
           <a:prstGeom prst="rect">
@@ -2813,7 +2822,7 @@
         </p:nvSpPr>
         <p:spPr>
           <a:xfrm>
-            <a:off x="1463040" y="3127248"/>
+            <a:off x="1463040" y="3071301"/>
             <a:ext cx="6858000" cy="256032"/>
           </a:xfrm>
           <a:prstGeom prst="rect">
@@ -2852,7 +2861,7 @@
         </p:nvSpPr>
         <p:spPr>
           <a:xfrm>
-            <a:off x="1463040" y="3364992"/>
+            <a:off x="1463040" y="3309045"/>
             <a:ext cx="6858000" cy="237744"/>
           </a:xfrm>
           <a:prstGeom prst="rect">
@@ -2891,7 +2900,7 @@
         </p:nvSpPr>
         <p:spPr>
           <a:xfrm>
-            <a:off x="914400" y="3657600"/>
+            <a:off x="914400" y="3601653"/>
             <a:ext cx="384048" cy="384048"/>
           </a:xfrm>
           <a:prstGeom prst="ellipse">
@@ -2916,7 +2925,7 @@
         </p:nvSpPr>
         <p:spPr>
           <a:xfrm>
-            <a:off x="914400" y="3657600"/>
+            <a:off x="914400" y="3601653"/>
             <a:ext cx="384048" cy="384048"/>
           </a:xfrm>
           <a:prstGeom prst="rect">
@@ -2955,7 +2964,7 @@
         </p:nvSpPr>
         <p:spPr>
           <a:xfrm>
-            <a:off x="1463040" y="3630168"/>
+            <a:off x="1463040" y="3574221"/>
             <a:ext cx="6858000" cy="256032"/>
           </a:xfrm>
           <a:prstGeom prst="rect">
@@ -2994,7 +3003,7 @@
         </p:nvSpPr>
         <p:spPr>
           <a:xfrm>
-            <a:off x="1463040" y="3867912"/>
+            <a:off x="1463040" y="3811965"/>
             <a:ext cx="6858000" cy="237744"/>
           </a:xfrm>
           <a:prstGeom prst="rect">
@@ -3033,7 +3042,7 @@
         </p:nvSpPr>
         <p:spPr>
           <a:xfrm>
-            <a:off x="914400" y="4160520"/>
+            <a:off x="914400" y="4104573"/>
             <a:ext cx="384048" cy="384048"/>
           </a:xfrm>
           <a:prstGeom prst="ellipse">
@@ -3058,7 +3067,7 @@
         </p:nvSpPr>
         <p:spPr>
           <a:xfrm>
-            <a:off x="914400" y="4160520"/>
+            <a:off x="914400" y="4104573"/>
             <a:ext cx="384048" cy="384048"/>
           </a:xfrm>
           <a:prstGeom prst="rect">
@@ -3097,7 +3106,7 @@
         </p:nvSpPr>
         <p:spPr>
           <a:xfrm>
-            <a:off x="1463040" y="4133088"/>
+            <a:off x="1463040" y="4077141"/>
             <a:ext cx="6858000" cy="256032"/>
           </a:xfrm>
           <a:prstGeom prst="rect">
@@ -3136,7 +3145,7 @@
         </p:nvSpPr>
         <p:spPr>
           <a:xfrm>
-            <a:off x="1463040" y="4370832"/>
+            <a:off x="1463040" y="4314885"/>
             <a:ext cx="6858000" cy="237744"/>
           </a:xfrm>
           <a:prstGeom prst="rect">
@@ -4021,53 +4030,14 @@
       </p:sp>
       <p:sp>
         <p:nvSpPr>
-          <p:cNvPr id="4" name="Text 2"/>
-          <p:cNvSpPr/>
-          <p:nvPr/>
-        </p:nvSpPr>
-        <p:spPr>
-          <a:xfrm>
-            <a:off x="731520" y="1737360"/>
-            <a:ext cx="7772400" cy="411480"/>
-          </a:xfrm>
-          <a:prstGeom prst="rect">
-            <a:avLst/>
-          </a:prstGeom>
-          <a:noFill/>
-          <a:ln/>
-        </p:spPr>
-        <p:txBody>
-          <a:bodyPr wrap="square" lIns="0" tIns="0" rIns="0" bIns="0" rtlCol="0" anchor="ctr"/>
-          <a:lstStyle/>
-          <a:p>
-            <a:pPr marL="0" indent="0">
-              <a:buNone/>
-            </a:pPr>
-            <a:r>
-              <a:rPr lang="en-US" sz="2000" i="1" dirty="0">
-                <a:solidFill>
-                  <a:srgbClr val="DBEAFE"/>
-                </a:solidFill>
-                <a:latin typeface="Calibri" pitchFamily="34" charset="0"/>
-                <a:ea typeface="Calibri" pitchFamily="34" charset="-122"/>
-                <a:cs typeface="Calibri" pitchFamily="34" charset="-120"/>
-              </a:rPr>
-              <a:t>Questions &amp; discussion</a:t>
-            </a:r>
-            <a:endParaRPr lang="en-US" sz="2000" dirty="0"/>
-          </a:p>
-        </p:txBody>
-      </p:sp>
-      <p:sp>
-        <p:nvSpPr>
           <p:cNvPr id="5" name="Shape 3"/>
           <p:cNvSpPr/>
           <p:nvPr/>
         </p:nvSpPr>
         <p:spPr>
           <a:xfrm>
-            <a:off x="731520" y="2697479"/>
-            <a:ext cx="6241935" cy="1691641"/>
+            <a:off x="837398" y="2125980"/>
+            <a:ext cx="6044665" cy="1783080"/>
           </a:xfrm>
           <a:prstGeom prst="rect">
             <a:avLst/>
@@ -4091,8 +4061,8 @@
         </p:nvSpPr>
         <p:spPr>
           <a:xfrm>
-            <a:off x="914400" y="2697480"/>
-            <a:ext cx="7498080" cy="320040"/>
+            <a:off x="1020278" y="2217420"/>
+            <a:ext cx="5496025" cy="320040"/>
           </a:xfrm>
           <a:prstGeom prst="rect">
             <a:avLst/>
@@ -4130,7 +4100,7 @@
         </p:nvSpPr>
         <p:spPr>
           <a:xfrm>
-            <a:off x="1097280" y="3017520"/>
+            <a:off x="1111718" y="2377440"/>
             <a:ext cx="7315200" cy="1371600"/>
           </a:xfrm>
           <a:prstGeom prst="rect">
@@ -10787,7 +10757,7 @@
         <p:spPr>
           <a:xfrm>
             <a:off x="457200" y="3931920"/>
-            <a:ext cx="8229600" cy="868680"/>
+            <a:ext cx="8229600" cy="777240"/>
           </a:xfrm>
           <a:prstGeom prst="rect">
             <a:avLst/>
@@ -10802,13 +10772,6 @@
             <a:prstDash val="solid"/>
           </a:ln>
         </p:spPr>
-        <p:txBody>
-          <a:bodyPr/>
-          <a:lstStyle/>
-          <a:p>
-            <a:endParaRPr lang="en-US"/>
-          </a:p>
-        </p:txBody>
       </p:sp>
       <p:sp>
         <p:nvSpPr>
@@ -10819,7 +10782,7 @@
         <p:spPr>
           <a:xfrm>
             <a:off x="457200" y="3931920"/>
-            <a:ext cx="54864" cy="868680"/>
+            <a:ext cx="54864" cy="777240"/>
           </a:xfrm>
           <a:prstGeom prst="rect">
             <a:avLst/>
@@ -10895,9 +10858,8 @@
           <a:bodyPr wrap="square" lIns="0" tIns="0" rIns="0" bIns="0" rtlCol="0" anchor="ctr"/>
           <a:lstStyle/>
           <a:p>
-            <a:pPr marL="171450" indent="-171450">
-              <a:buFont typeface="Arial" panose="020B0604020202020204" pitchFamily="34" charset="0"/>
-              <a:buChar char="•"/>
+            <a:pPr marL="0" indent="0">
+              <a:buNone/>
             </a:pPr>
             <a:r>
               <a:rPr lang="en-US" sz="1050" dirty="0">
@@ -10908,41 +10870,7 @@
                 <a:ea typeface="Calibri" pitchFamily="34" charset="-122"/>
                 <a:cs typeface="Calibri" pitchFamily="34" charset="-120"/>
               </a:rPr>
-              <a:t>A single number tells teams whether quality is improving </a:t>
-            </a:r>
-          </a:p>
-          <a:p>
-            <a:pPr marL="171450" indent="-171450">
-              <a:buFont typeface="Arial" panose="020B0604020202020204" pitchFamily="34" charset="0"/>
-              <a:buChar char="•"/>
-            </a:pPr>
-            <a:r>
-              <a:rPr lang="en-US" sz="1050" dirty="0">
-                <a:solidFill>
-                  <a:srgbClr val="1E293B"/>
-                </a:solidFill>
-                <a:latin typeface="Calibri" pitchFamily="34" charset="0"/>
-                <a:ea typeface="Calibri" pitchFamily="34" charset="-122"/>
-                <a:cs typeface="Calibri" pitchFamily="34" charset="-120"/>
-              </a:rPr>
-              <a:t>per-category breakdown tells them WHICH dimension needs attention </a:t>
-            </a:r>
-          </a:p>
-          <a:p>
-            <a:pPr marL="171450" indent="-171450">
-              <a:buFont typeface="Arial" panose="020B0604020202020204" pitchFamily="34" charset="0"/>
-              <a:buChar char="•"/>
-            </a:pPr>
-            <a:r>
-              <a:rPr lang="en-US" sz="1050" dirty="0">
-                <a:solidFill>
-                  <a:srgbClr val="1E293B"/>
-                </a:solidFill>
-                <a:latin typeface="Calibri" pitchFamily="34" charset="0"/>
-                <a:ea typeface="Calibri" pitchFamily="34" charset="-122"/>
-                <a:cs typeface="Calibri" pitchFamily="34" charset="-120"/>
-              </a:rPr>
-              <a:t>both views are exposed via the analysis-diff feature for tracking over time</a:t>
+              <a:t>A single number tells teams whether quality is improving; per-category breakdown tells them WHICH dimension needs attention; both views are exposed via the analysis-diff feature for tracking over time</a:t>
             </a:r>
             <a:endParaRPr lang="en-US" sz="1050" dirty="0"/>
           </a:p>
@@ -11145,7 +11073,7 @@
         </p:nvSpPr>
         <p:spPr>
           <a:xfrm>
-            <a:off x="457200" y="1188720"/>
+            <a:off x="427939" y="1161288"/>
             <a:ext cx="4114800" cy="283464"/>
           </a:xfrm>
           <a:prstGeom prst="rect">
@@ -11170,7 +11098,7 @@
         </p:nvSpPr>
         <p:spPr>
           <a:xfrm>
-            <a:off x="502920" y="1188720"/>
+            <a:off x="473659" y="1161288"/>
             <a:ext cx="548640" cy="283464"/>
           </a:xfrm>
           <a:prstGeom prst="rect">
@@ -11209,7 +11137,7 @@
         </p:nvSpPr>
         <p:spPr>
           <a:xfrm>
-            <a:off x="1097280" y="1188720"/>
+            <a:off x="1068019" y="1161288"/>
             <a:ext cx="2103120" cy="283464"/>
           </a:xfrm>
           <a:prstGeom prst="rect">
@@ -11248,7 +11176,7 @@
         </p:nvSpPr>
         <p:spPr>
           <a:xfrm>
-            <a:off x="3200400" y="1188720"/>
+            <a:off x="3171139" y="1161288"/>
             <a:ext cx="1325880" cy="283464"/>
           </a:xfrm>
           <a:prstGeom prst="rect">
@@ -11287,7 +11215,7 @@
         </p:nvSpPr>
         <p:spPr>
           <a:xfrm>
-            <a:off x="457200" y="1504188"/>
+            <a:off x="427939" y="1476756"/>
             <a:ext cx="4114800" cy="283464"/>
           </a:xfrm>
           <a:prstGeom prst="rect">
@@ -11312,7 +11240,7 @@
         </p:nvSpPr>
         <p:spPr>
           <a:xfrm>
-            <a:off x="502920" y="1504188"/>
+            <a:off x="473659" y="1476756"/>
             <a:ext cx="548640" cy="283464"/>
           </a:xfrm>
           <a:prstGeom prst="rect">
@@ -11351,7 +11279,7 @@
         </p:nvSpPr>
         <p:spPr>
           <a:xfrm>
-            <a:off x="1097280" y="1504188"/>
+            <a:off x="1068019" y="1476756"/>
             <a:ext cx="2103120" cy="283464"/>
           </a:xfrm>
           <a:prstGeom prst="rect">
@@ -11390,7 +11318,7 @@
         </p:nvSpPr>
         <p:spPr>
           <a:xfrm>
-            <a:off x="3200400" y="1504188"/>
+            <a:off x="3171139" y="1476756"/>
             <a:ext cx="1325880" cy="283464"/>
           </a:xfrm>
           <a:prstGeom prst="rect">
@@ -11429,7 +11357,7 @@
         </p:nvSpPr>
         <p:spPr>
           <a:xfrm>
-            <a:off x="457200" y="1819656"/>
+            <a:off x="427939" y="1792224"/>
             <a:ext cx="4114800" cy="283464"/>
           </a:xfrm>
           <a:prstGeom prst="rect">
@@ -11454,7 +11382,7 @@
         </p:nvSpPr>
         <p:spPr>
           <a:xfrm>
-            <a:off x="502920" y="1819656"/>
+            <a:off x="473659" y="1792224"/>
             <a:ext cx="548640" cy="283464"/>
           </a:xfrm>
           <a:prstGeom prst="rect">
@@ -11493,7 +11421,7 @@
         </p:nvSpPr>
         <p:spPr>
           <a:xfrm>
-            <a:off x="1097280" y="1819656"/>
+            <a:off x="1068019" y="1792224"/>
             <a:ext cx="2103120" cy="283464"/>
           </a:xfrm>
           <a:prstGeom prst="rect">
@@ -11532,7 +11460,7 @@
         </p:nvSpPr>
         <p:spPr>
           <a:xfrm>
-            <a:off x="3200400" y="1819656"/>
+            <a:off x="3171139" y="1792224"/>
             <a:ext cx="1325880" cy="283464"/>
           </a:xfrm>
           <a:prstGeom prst="rect">
@@ -11571,7 +11499,7 @@
         </p:nvSpPr>
         <p:spPr>
           <a:xfrm>
-            <a:off x="457200" y="2135124"/>
+            <a:off x="427939" y="2107692"/>
             <a:ext cx="4114800" cy="283464"/>
           </a:xfrm>
           <a:prstGeom prst="rect">
@@ -11596,7 +11524,7 @@
         </p:nvSpPr>
         <p:spPr>
           <a:xfrm>
-            <a:off x="502920" y="2135124"/>
+            <a:off x="473659" y="2107692"/>
             <a:ext cx="548640" cy="283464"/>
           </a:xfrm>
           <a:prstGeom prst="rect">
@@ -11635,7 +11563,7 @@
         </p:nvSpPr>
         <p:spPr>
           <a:xfrm>
-            <a:off x="1097280" y="2135124"/>
+            <a:off x="1068019" y="2107692"/>
             <a:ext cx="2103120" cy="283464"/>
           </a:xfrm>
           <a:prstGeom prst="rect">
@@ -11674,7 +11602,7 @@
         </p:nvSpPr>
         <p:spPr>
           <a:xfrm>
-            <a:off x="3200400" y="2135124"/>
+            <a:off x="3171139" y="2107692"/>
             <a:ext cx="1325880" cy="283464"/>
           </a:xfrm>
           <a:prstGeom prst="rect">
@@ -11713,7 +11641,7 @@
         </p:nvSpPr>
         <p:spPr>
           <a:xfrm>
-            <a:off x="457200" y="2450592"/>
+            <a:off x="427939" y="2423160"/>
             <a:ext cx="4114800" cy="283464"/>
           </a:xfrm>
           <a:prstGeom prst="rect">
@@ -11738,7 +11666,7 @@
         </p:nvSpPr>
         <p:spPr>
           <a:xfrm>
-            <a:off x="502920" y="2450592"/>
+            <a:off x="473659" y="2423160"/>
             <a:ext cx="548640" cy="283464"/>
           </a:xfrm>
           <a:prstGeom prst="rect">
@@ -11777,7 +11705,7 @@
         </p:nvSpPr>
         <p:spPr>
           <a:xfrm>
-            <a:off x="1097280" y="2450592"/>
+            <a:off x="1068019" y="2423160"/>
             <a:ext cx="2103120" cy="283464"/>
           </a:xfrm>
           <a:prstGeom prst="rect">
@@ -11816,7 +11744,7 @@
         </p:nvSpPr>
         <p:spPr>
           <a:xfrm>
-            <a:off x="3200400" y="2450592"/>
+            <a:off x="3171139" y="2423160"/>
             <a:ext cx="1325880" cy="283464"/>
           </a:xfrm>
           <a:prstGeom prst="rect">
@@ -11855,7 +11783,7 @@
         </p:nvSpPr>
         <p:spPr>
           <a:xfrm>
-            <a:off x="457200" y="2807208"/>
+            <a:off x="427939" y="2779776"/>
             <a:ext cx="4114800" cy="411480"/>
           </a:xfrm>
           <a:prstGeom prst="rect">
@@ -11880,7 +11808,7 @@
         </p:nvSpPr>
         <p:spPr>
           <a:xfrm>
-            <a:off x="457200" y="2807208"/>
+            <a:off x="427939" y="2779776"/>
             <a:ext cx="4114800" cy="411480"/>
           </a:xfrm>
           <a:prstGeom prst="rect">
@@ -12548,7 +12476,7 @@
         </p:nvSpPr>
         <p:spPr>
           <a:xfrm>
-            <a:off x="457200" y="3282696"/>
+            <a:off x="427939" y="3312053"/>
             <a:ext cx="4114800" cy="365760"/>
           </a:xfrm>
           <a:prstGeom prst="rect">
@@ -12629,7 +12557,7 @@
                 <a:ea typeface="Calibri" pitchFamily="34" charset="-122"/>
                 <a:cs typeface="Calibri" pitchFamily="34" charset="-120"/>
               </a:rPr>
-              <a:t>Anti-pattern load (penalty 49) clamps AP to 0</a:t>
+              <a:t>Anti-pattern load (penalty 49) clamps AP to 0 </a:t>
             </a:r>
           </a:p>
           <a:p>
@@ -12646,7 +12574,7 @@
                 <a:ea typeface="Calibri" pitchFamily="34" charset="-122"/>
                 <a:cs typeface="Calibri" pitchFamily="34" charset="-120"/>
               </a:rPr>
-              <a:t>Architecture loses 9 to dependency-graph coupling</a:t>
+              <a:t>Architecture loses 9 to dependency-graph coupling </a:t>
             </a:r>
           </a:p>
           <a:p>
@@ -12663,7 +12591,7 @@
                 <a:ea typeface="Calibri" pitchFamily="34" charset="-122"/>
                 <a:cs typeface="Calibri" pitchFamily="34" charset="-120"/>
               </a:rPr>
-              <a:t>Code Quality 8 to smell density</a:t>
+              <a:t>Code Quality 8 to smell density </a:t>
             </a:r>
           </a:p>
           <a:p>
@@ -12860,7 +12788,7 @@
         </p:nvSpPr>
         <p:spPr>
           <a:xfrm>
-            <a:off x="6035040" y="795897"/>
+            <a:off x="6080760" y="781571"/>
             <a:ext cx="2743200" cy="274320"/>
           </a:xfrm>
           <a:prstGeom prst="rect">
@@ -12899,7 +12827,7 @@
         </p:nvSpPr>
         <p:spPr>
           <a:xfrm>
-            <a:off x="6035040" y="1115937"/>
+            <a:off x="6080760" y="1101611"/>
             <a:ext cx="2743200" cy="192024"/>
           </a:xfrm>
           <a:prstGeom prst="rect">
@@ -12924,7 +12852,7 @@
         </p:nvSpPr>
         <p:spPr>
           <a:xfrm>
-            <a:off x="6126480" y="1115937"/>
+            <a:off x="6172200" y="1101611"/>
             <a:ext cx="1280160" cy="192024"/>
           </a:xfrm>
           <a:prstGeom prst="rect">
@@ -12963,7 +12891,7 @@
         </p:nvSpPr>
         <p:spPr>
           <a:xfrm>
-            <a:off x="7406640" y="1115937"/>
+            <a:off x="7452360" y="1101611"/>
             <a:ext cx="457200" cy="192024"/>
           </a:xfrm>
           <a:prstGeom prst="rect">
@@ -13002,7 +12930,7 @@
         </p:nvSpPr>
         <p:spPr>
           <a:xfrm>
-            <a:off x="7863840" y="1115937"/>
+            <a:off x="7909560" y="1101611"/>
             <a:ext cx="868680" cy="192024"/>
           </a:xfrm>
           <a:prstGeom prst="rect">
@@ -13041,7 +12969,7 @@
         </p:nvSpPr>
         <p:spPr>
           <a:xfrm>
-            <a:off x="6035040" y="1335393"/>
+            <a:off x="6080760" y="1321067"/>
             <a:ext cx="2743200" cy="192024"/>
           </a:xfrm>
           <a:prstGeom prst="rect">
@@ -13066,7 +12994,7 @@
         </p:nvSpPr>
         <p:spPr>
           <a:xfrm>
-            <a:off x="6126480" y="1335393"/>
+            <a:off x="6172200" y="1321067"/>
             <a:ext cx="1280160" cy="192024"/>
           </a:xfrm>
           <a:prstGeom prst="rect">
@@ -13105,7 +13033,7 @@
         </p:nvSpPr>
         <p:spPr>
           <a:xfrm>
-            <a:off x="7406640" y="1335393"/>
+            <a:off x="7452360" y="1321067"/>
             <a:ext cx="457200" cy="192024"/>
           </a:xfrm>
           <a:prstGeom prst="rect">
@@ -13144,7 +13072,7 @@
         </p:nvSpPr>
         <p:spPr>
           <a:xfrm>
-            <a:off x="7863840" y="1335393"/>
+            <a:off x="7909560" y="1321067"/>
             <a:ext cx="868680" cy="192024"/>
           </a:xfrm>
           <a:prstGeom prst="rect">
@@ -13183,7 +13111,7 @@
         </p:nvSpPr>
         <p:spPr>
           <a:xfrm>
-            <a:off x="6035040" y="1554849"/>
+            <a:off x="6080760" y="1540523"/>
             <a:ext cx="2743200" cy="192024"/>
           </a:xfrm>
           <a:prstGeom prst="rect">
@@ -13208,7 +13136,7 @@
         </p:nvSpPr>
         <p:spPr>
           <a:xfrm>
-            <a:off x="6126480" y="1554849"/>
+            <a:off x="6172200" y="1540523"/>
             <a:ext cx="1280160" cy="192024"/>
           </a:xfrm>
           <a:prstGeom prst="rect">
@@ -13247,7 +13175,7 @@
         </p:nvSpPr>
         <p:spPr>
           <a:xfrm>
-            <a:off x="7406640" y="1554849"/>
+            <a:off x="7452360" y="1540523"/>
             <a:ext cx="457200" cy="192024"/>
           </a:xfrm>
           <a:prstGeom prst="rect">
@@ -13286,7 +13214,7 @@
         </p:nvSpPr>
         <p:spPr>
           <a:xfrm>
-            <a:off x="7863840" y="1554849"/>
+            <a:off x="7909560" y="1540523"/>
             <a:ext cx="868680" cy="192024"/>
           </a:xfrm>
           <a:prstGeom prst="rect">
@@ -13325,7 +13253,7 @@
         </p:nvSpPr>
         <p:spPr>
           <a:xfrm>
-            <a:off x="6035040" y="1774305"/>
+            <a:off x="6080760" y="1759979"/>
             <a:ext cx="2743200" cy="192024"/>
           </a:xfrm>
           <a:prstGeom prst="rect">
@@ -13350,7 +13278,7 @@
         </p:nvSpPr>
         <p:spPr>
           <a:xfrm>
-            <a:off x="6126480" y="1774305"/>
+            <a:off x="6172200" y="1759979"/>
             <a:ext cx="1280160" cy="192024"/>
           </a:xfrm>
           <a:prstGeom prst="rect">
@@ -13389,7 +13317,7 @@
         </p:nvSpPr>
         <p:spPr>
           <a:xfrm>
-            <a:off x="7406640" y="1774305"/>
+            <a:off x="7452360" y="1759979"/>
             <a:ext cx="457200" cy="192024"/>
           </a:xfrm>
           <a:prstGeom prst="rect">
@@ -13428,7 +13356,7 @@
         </p:nvSpPr>
         <p:spPr>
           <a:xfrm>
-            <a:off x="7863840" y="1774305"/>
+            <a:off x="7909560" y="1759979"/>
             <a:ext cx="868680" cy="192024"/>
           </a:xfrm>
           <a:prstGeom prst="rect">
@@ -13467,7 +13395,7 @@
         </p:nvSpPr>
         <p:spPr>
           <a:xfrm>
-            <a:off x="6035040" y="1993761"/>
+            <a:off x="6080760" y="1979435"/>
             <a:ext cx="2743200" cy="192024"/>
           </a:xfrm>
           <a:prstGeom prst="rect">
@@ -13492,7 +13420,7 @@
         </p:nvSpPr>
         <p:spPr>
           <a:xfrm>
-            <a:off x="6126480" y="1993761"/>
+            <a:off x="6172200" y="1979435"/>
             <a:ext cx="1280160" cy="192024"/>
           </a:xfrm>
           <a:prstGeom prst="rect">
@@ -13531,7 +13459,7 @@
         </p:nvSpPr>
         <p:spPr>
           <a:xfrm>
-            <a:off x="7406640" y="1993761"/>
+            <a:off x="7452360" y="1979435"/>
             <a:ext cx="457200" cy="192024"/>
           </a:xfrm>
           <a:prstGeom prst="rect">
@@ -13570,7 +13498,7 @@
         </p:nvSpPr>
         <p:spPr>
           <a:xfrm>
-            <a:off x="7863840" y="1993761"/>
+            <a:off x="7909560" y="1979435"/>
             <a:ext cx="868680" cy="192024"/>
           </a:xfrm>
           <a:prstGeom prst="rect">
@@ -13609,7 +13537,7 @@
         </p:nvSpPr>
         <p:spPr>
           <a:xfrm>
-            <a:off x="6035040" y="2213217"/>
+            <a:off x="6080760" y="2198891"/>
             <a:ext cx="2743200" cy="192024"/>
           </a:xfrm>
           <a:prstGeom prst="rect">
@@ -13634,7 +13562,7 @@
         </p:nvSpPr>
         <p:spPr>
           <a:xfrm>
-            <a:off x="6126480" y="2213217"/>
+            <a:off x="6172200" y="2198891"/>
             <a:ext cx="1280160" cy="192024"/>
           </a:xfrm>
           <a:prstGeom prst="rect">
@@ -13673,7 +13601,7 @@
         </p:nvSpPr>
         <p:spPr>
           <a:xfrm>
-            <a:off x="7406640" y="2213217"/>
+            <a:off x="7452360" y="2198891"/>
             <a:ext cx="457200" cy="192024"/>
           </a:xfrm>
           <a:prstGeom prst="rect">
@@ -13712,7 +13640,7 @@
         </p:nvSpPr>
         <p:spPr>
           <a:xfrm>
-            <a:off x="7863840" y="2213217"/>
+            <a:off x="7909560" y="2198891"/>
             <a:ext cx="868680" cy="192024"/>
           </a:xfrm>
           <a:prstGeom prst="rect">
@@ -13751,7 +13679,7 @@
         </p:nvSpPr>
         <p:spPr>
           <a:xfrm>
-            <a:off x="6035040" y="2432673"/>
+            <a:off x="6080760" y="2418347"/>
             <a:ext cx="2743200" cy="192024"/>
           </a:xfrm>
           <a:prstGeom prst="rect">
@@ -13776,7 +13704,7 @@
         </p:nvSpPr>
         <p:spPr>
           <a:xfrm>
-            <a:off x="6126480" y="2432673"/>
+            <a:off x="6172200" y="2418347"/>
             <a:ext cx="1280160" cy="192024"/>
           </a:xfrm>
           <a:prstGeom prst="rect">
@@ -13815,7 +13743,7 @@
         </p:nvSpPr>
         <p:spPr>
           <a:xfrm>
-            <a:off x="7406640" y="2432673"/>
+            <a:off x="7452360" y="2418347"/>
             <a:ext cx="457200" cy="192024"/>
           </a:xfrm>
           <a:prstGeom prst="rect">
@@ -13854,7 +13782,7 @@
         </p:nvSpPr>
         <p:spPr>
           <a:xfrm>
-            <a:off x="7863840" y="2432673"/>
+            <a:off x="7909560" y="2418347"/>
             <a:ext cx="868680" cy="192024"/>
           </a:xfrm>
           <a:prstGeom prst="rect">
@@ -13893,7 +13821,7 @@
         </p:nvSpPr>
         <p:spPr>
           <a:xfrm>
-            <a:off x="6035040" y="2652129"/>
+            <a:off x="6080760" y="2637803"/>
             <a:ext cx="2743200" cy="192024"/>
           </a:xfrm>
           <a:prstGeom prst="rect">
@@ -13918,7 +13846,7 @@
         </p:nvSpPr>
         <p:spPr>
           <a:xfrm>
-            <a:off x="6126480" y="2652129"/>
+            <a:off x="6172200" y="2637803"/>
             <a:ext cx="1280160" cy="192024"/>
           </a:xfrm>
           <a:prstGeom prst="rect">
@@ -13957,7 +13885,7 @@
         </p:nvSpPr>
         <p:spPr>
           <a:xfrm>
-            <a:off x="7406640" y="2652129"/>
+            <a:off x="7452360" y="2637803"/>
             <a:ext cx="457200" cy="192024"/>
           </a:xfrm>
           <a:prstGeom prst="rect">
@@ -13996,7 +13924,7 @@
         </p:nvSpPr>
         <p:spPr>
           <a:xfrm>
-            <a:off x="7863840" y="2652129"/>
+            <a:off x="7909560" y="2637803"/>
             <a:ext cx="868680" cy="192024"/>
           </a:xfrm>
           <a:prstGeom prst="rect">
@@ -14035,7 +13963,7 @@
         </p:nvSpPr>
         <p:spPr>
           <a:xfrm>
-            <a:off x="6035040" y="2871585"/>
+            <a:off x="6080760" y="2857259"/>
             <a:ext cx="2743200" cy="192024"/>
           </a:xfrm>
           <a:prstGeom prst="rect">
@@ -14060,7 +13988,7 @@
         </p:nvSpPr>
         <p:spPr>
           <a:xfrm>
-            <a:off x="6126480" y="2871585"/>
+            <a:off x="6172200" y="2857259"/>
             <a:ext cx="1280160" cy="192024"/>
           </a:xfrm>
           <a:prstGeom prst="rect">
@@ -14099,7 +14027,7 @@
         </p:nvSpPr>
         <p:spPr>
           <a:xfrm>
-            <a:off x="7406640" y="2871585"/>
+            <a:off x="7452360" y="2857259"/>
             <a:ext cx="457200" cy="192024"/>
           </a:xfrm>
           <a:prstGeom prst="rect">
@@ -14138,7 +14066,7 @@
         </p:nvSpPr>
         <p:spPr>
           <a:xfrm>
-            <a:off x="7863840" y="2871585"/>
+            <a:off x="7909560" y="2857259"/>
             <a:ext cx="868680" cy="192024"/>
           </a:xfrm>
           <a:prstGeom prst="rect">
@@ -14177,7 +14105,7 @@
         </p:nvSpPr>
         <p:spPr>
           <a:xfrm>
-            <a:off x="6035040" y="3091041"/>
+            <a:off x="6080760" y="3076715"/>
             <a:ext cx="2743200" cy="192024"/>
           </a:xfrm>
           <a:prstGeom prst="rect">
@@ -14202,7 +14130,7 @@
         </p:nvSpPr>
         <p:spPr>
           <a:xfrm>
-            <a:off x="6126480" y="3091041"/>
+            <a:off x="6172200" y="3076715"/>
             <a:ext cx="1280160" cy="192024"/>
           </a:xfrm>
           <a:prstGeom prst="rect">
@@ -14241,7 +14169,7 @@
         </p:nvSpPr>
         <p:spPr>
           <a:xfrm>
-            <a:off x="7406640" y="3091041"/>
+            <a:off x="7452360" y="3076715"/>
             <a:ext cx="457200" cy="192024"/>
           </a:xfrm>
           <a:prstGeom prst="rect">
@@ -14280,7 +14208,7 @@
         </p:nvSpPr>
         <p:spPr>
           <a:xfrm>
-            <a:off x="7863840" y="3091041"/>
+            <a:off x="7909560" y="3076715"/>
             <a:ext cx="868680" cy="192024"/>
           </a:xfrm>
           <a:prstGeom prst="rect">
@@ -14319,7 +14247,7 @@
         </p:nvSpPr>
         <p:spPr>
           <a:xfrm>
-            <a:off x="6035040" y="3310497"/>
+            <a:off x="6080760" y="3296171"/>
             <a:ext cx="2743200" cy="192024"/>
           </a:xfrm>
           <a:prstGeom prst="rect">
@@ -14344,7 +14272,7 @@
         </p:nvSpPr>
         <p:spPr>
           <a:xfrm>
-            <a:off x="6126480" y="3310497"/>
+            <a:off x="6172200" y="3296171"/>
             <a:ext cx="1280160" cy="192024"/>
           </a:xfrm>
           <a:prstGeom prst="rect">
@@ -14383,7 +14311,7 @@
         </p:nvSpPr>
         <p:spPr>
           <a:xfrm>
-            <a:off x="7406640" y="3310497"/>
+            <a:off x="7452360" y="3296171"/>
             <a:ext cx="457200" cy="192024"/>
           </a:xfrm>
           <a:prstGeom prst="rect">
@@ -14422,7 +14350,7 @@
         </p:nvSpPr>
         <p:spPr>
           <a:xfrm>
-            <a:off x="7863840" y="3310497"/>
+            <a:off x="7909560" y="3296171"/>
             <a:ext cx="868680" cy="192024"/>
           </a:xfrm>
           <a:prstGeom prst="rect">
@@ -14461,7 +14389,7 @@
         </p:nvSpPr>
         <p:spPr>
           <a:xfrm>
-            <a:off x="6035040" y="3529953"/>
+            <a:off x="6080760" y="3515627"/>
             <a:ext cx="2743200" cy="192024"/>
           </a:xfrm>
           <a:prstGeom prst="rect">
@@ -14486,7 +14414,7 @@
         </p:nvSpPr>
         <p:spPr>
           <a:xfrm>
-            <a:off x="6126480" y="3529953"/>
+            <a:off x="6172200" y="3515627"/>
             <a:ext cx="1280160" cy="192024"/>
           </a:xfrm>
           <a:prstGeom prst="rect">
@@ -14525,7 +14453,7 @@
         </p:nvSpPr>
         <p:spPr>
           <a:xfrm>
-            <a:off x="7406640" y="3529953"/>
+            <a:off x="7452360" y="3515627"/>
             <a:ext cx="457200" cy="192024"/>
           </a:xfrm>
           <a:prstGeom prst="rect">
@@ -14564,7 +14492,7 @@
         </p:nvSpPr>
         <p:spPr>
           <a:xfrm>
-            <a:off x="7863840" y="3529953"/>
+            <a:off x="7909560" y="3515627"/>
             <a:ext cx="868680" cy="192024"/>
           </a:xfrm>
           <a:prstGeom prst="rect">
@@ -14721,7 +14649,7 @@
                 <a:ea typeface="Calibri" pitchFamily="34" charset="-122"/>
                 <a:cs typeface="Calibri" pitchFamily="34" charset="-120"/>
               </a:rPr>
-              <a:t>126 anti-pattern instances across 9 types</a:t>
+              <a:t>98 anti-pattern instances across 9 types</a:t>
             </a:r>
           </a:p>
           <a:p>
@@ -14741,7 +14669,7 @@
                 <a:ea typeface="Calibri" pitchFamily="34" charset="-122"/>
                 <a:cs typeface="Calibri" pitchFamily="34" charset="-120"/>
               </a:rPr>
-              <a:t>Hardcoded Endpoints (43) and API Versioning Absence (37) dominate</a:t>
+              <a:t>API Versioning Absence (37), Nano Service (23) and Hardcoded Endpoints (15) dominate</a:t>
             </a:r>
             <a:endParaRPr lang="en-US" sz="1100" dirty="0"/>
           </a:p>

</xml_diff>